<commit_message>
HUGE Renaming LLM_Bot to Tlamatini, by angelahack1
</commit_message>
<xml_diff>
--- a/Tlamatini_eXtended_Artificial_Intelligence_Humanly_Tempered.pptx
+++ b/Tlamatini_eXtended_Artificial_Intelligence_Humanly_Tempered.pptx
@@ -3346,7 +3346,7 @@
                 </a:solidFill>
                 <a:latin typeface="Aptos"/>
               </a:rPr>
-              <a:t>Complete operator guide: what the system is, how to run it from source, how to install Ollama and pull the required models, how to use chat and the Agentic Control Panel, how to build release executables, and how to extend the platform with new agents and MCP-backed capabilities.</a:t>
+              <a:t>Complete operator guide: what Tlamatini is, how to run it from source, how to install Ollama and pull the required models, how to use chat and the Agentic Control Panel, how to build release executables, and how to extend the platform with new agents and MCP-backed capabilities.</a:t>
             </a:r>
           </a:p>
         </p:txBody>
@@ -11770,16 +11770,16 @@
         <p:spPr>
           <a:xfrm>
             <a:off x="640080" y="1188720"/>
-            <a:ext cx="10972800" cy="4389120"/>
-          </a:xfrm>
-          <a:prstGeom prst="rect">
-            <a:avLst/>
-          </a:prstGeom>
-          <a:noFill/>
-        </p:spPr>
-        <p:txBody>
-          <a:bodyPr wrap="square">
-            <a:spAutoFit/>
+            <a:ext cx="6350000" cy="5200000"/>
+          </a:xfrm>
+          <a:prstGeom prst="rect">
+            <a:avLst/>
+          </a:prstGeom>
+          <a:noFill/>
+        </p:spPr>
+        <p:txBody>
+          <a:bodyPr wrap="square">
+            <a:normAutofit/>
           </a:bodyPr>
           <a:lstStyle/>
           <a:p>
@@ -11789,7 +11789,7 @@
               </a:spcAft>
             </a:pPr>
             <a:r>
-              <a:rPr sz="2000">
+              <a:rPr sz="1800">
                 <a:solidFill>
                   <a:srgbClr val="111827"/>
                 </a:solidFill>
@@ -11805,7 +11805,7 @@
               </a:spcAft>
             </a:pPr>
             <a:r>
-              <a:rPr sz="2000">
+              <a:rPr sz="1800">
                 <a:solidFill>
                   <a:srgbClr val="111827"/>
                 </a:solidFill>
@@ -11821,7 +11821,7 @@
               </a:spcAft>
             </a:pPr>
             <a:r>
-              <a:rPr sz="2000">
+              <a:rPr sz="1800">
                 <a:solidFill>
                   <a:srgbClr val="111827"/>
                 </a:solidFill>
@@ -11837,7 +11837,7 @@
               </a:spcAft>
             </a:pPr>
             <a:r>
-              <a:rPr sz="2000">
+              <a:rPr sz="1800">
                 <a:solidFill>
                   <a:srgbClr val="111827"/>
                 </a:solidFill>
@@ -11853,7 +11853,7 @@
               </a:spcAft>
             </a:pPr>
             <a:r>
-              <a:rPr sz="2000">
+              <a:rPr sz="1800">
                 <a:solidFill>
                   <a:srgbClr val="111827"/>
                 </a:solidFill>
@@ -11869,7 +11869,7 @@
               </a:spcAft>
             </a:pPr>
             <a:r>
-              <a:rPr sz="2000">
+              <a:rPr sz="1800">
                 <a:solidFill>
                   <a:srgbClr val="111827"/>
                 </a:solidFill>
@@ -11994,7 +11994,7 @@
                 </a:solidFill>
                 <a:latin typeface="Aptos"/>
               </a:rPr>
-              <a:t>Slides 3-5: understand the system.</a:t>
+              <a:t>Slides 3-5: understand Tlamatini.</a:t>
             </a:r>
           </a:p>
           <a:p>
@@ -16243,7 +16243,7 @@
         <p:spPr>
           <a:xfrm>
             <a:off x="5897880" y="1234440"/>
-            <a:ext cx="4983480" cy="2651760"/>
+            <a:ext cx="4983480" cy="3250000"/>
           </a:xfrm>
           <a:prstGeom prst="rect">
             <a:avLst/>
@@ -16323,16 +16323,16 @@
         <p:spPr>
           <a:xfrm>
             <a:off x="6016752" y="1783080"/>
-            <a:ext cx="4572000" cy="1828800"/>
-          </a:xfrm>
-          <a:prstGeom prst="rect">
-            <a:avLst/>
-          </a:prstGeom>
-          <a:noFill/>
-        </p:spPr>
-        <p:txBody>
-          <a:bodyPr wrap="square">
-            <a:spAutoFit/>
+            <a:ext cx="4572000" cy="2400000"/>
+          </a:xfrm>
+          <a:prstGeom prst="rect">
+            <a:avLst/>
+          </a:prstGeom>
+          <a:noFill/>
+        </p:spPr>
+        <p:txBody>
+          <a:bodyPr wrap="square">
+            <a:normAutofit/>
           </a:bodyPr>
           <a:lstStyle/>
           <a:p>
@@ -16342,7 +16342,7 @@
               </a:spcAft>
             </a:pPr>
             <a:r>
-              <a:rPr sz="1600">
+              <a:rPr sz="1500">
                 <a:solidFill>
                   <a:srgbClr val="111827"/>
                 </a:solidFill>
@@ -16358,13 +16358,13 @@
               </a:spcAft>
             </a:pPr>
             <a:r>
-              <a:rPr sz="1600">
+              <a:rPr sz="1500">
                 <a:solidFill>
                   <a:srgbClr val="111827"/>
                 </a:solidFill>
                 <a:latin typeface="Aptos"/>
               </a:rPr>
-              <a:t>The checked-in README and CLAUDE guide agree that the current system exposes 57 workflow-agent directories.</a:t>
+              <a:t>The checked-in README and CLAUDE guide agree that Tlamatini currently exposes 57 workflow-agent directories.</a:t>
             </a:r>
           </a:p>
           <a:p>
@@ -16374,7 +16374,7 @@
               </a:spcAft>
             </a:pPr>
             <a:r>
-              <a:rPr sz="1600">
+              <a:rPr sz="1500">
                 <a:solidFill>
                   <a:srgbClr val="111827"/>
                 </a:solidFill>
@@ -16393,8 +16393,8 @@
         </p:nvSpPr>
         <p:spPr>
           <a:xfrm>
-            <a:off x="5989320" y="4187952"/>
-            <a:ext cx="1508760" cy="713232"/>
+            <a:off x="5989320" y="4837952"/>
+            <a:ext cx="1508760" cy="920000"/>
           </a:xfrm>
           <a:prstGeom prst="rect">
             <a:avLst/>
@@ -16438,17 +16438,17 @@
         </p:nvSpPr>
         <p:spPr>
           <a:xfrm>
-            <a:off x="6099048" y="4261104"/>
-            <a:ext cx="1289304" cy="219456"/>
-          </a:xfrm>
-          <a:prstGeom prst="rect">
-            <a:avLst/>
-          </a:prstGeom>
-          <a:noFill/>
-        </p:spPr>
-        <p:txBody>
-          <a:bodyPr wrap="square">
-            <a:spAutoFit/>
+            <a:off x="6099048" y="4900000"/>
+            <a:ext cx="1289304" cy="210000"/>
+          </a:xfrm>
+          <a:prstGeom prst="rect">
+            <a:avLst/>
+          </a:prstGeom>
+          <a:noFill/>
+        </p:spPr>
+        <p:txBody>
+          <a:bodyPr wrap="square">
+            <a:normAutofit/>
           </a:bodyPr>
           <a:lstStyle/>
           <a:p>
@@ -16473,23 +16473,23 @@
         </p:nvSpPr>
         <p:spPr>
           <a:xfrm>
-            <a:off x="6099048" y="4443984"/>
-            <a:ext cx="1289304" cy="310896"/>
-          </a:xfrm>
-          <a:prstGeom prst="rect">
-            <a:avLst/>
-          </a:prstGeom>
-          <a:noFill/>
-        </p:spPr>
-        <p:txBody>
-          <a:bodyPr wrap="square">
-            <a:spAutoFit/>
+            <a:off x="6099048" y="5120000"/>
+            <a:ext cx="1289304" cy="420000"/>
+          </a:xfrm>
+          <a:prstGeom prst="rect">
+            <a:avLst/>
+          </a:prstGeom>
+          <a:noFill/>
+        </p:spPr>
+        <p:txBody>
+          <a:bodyPr wrap="square">
+            <a:normAutofit/>
           </a:bodyPr>
           <a:lstStyle/>
           <a:p>
             <a:pPr algn="l"/>
             <a:r>
-              <a:rPr sz="2000" b="1">
+              <a:rPr sz="1700" b="1">
                 <a:solidFill>
                   <a:srgbClr val="FFFFFF"/>
                 </a:solidFill>
@@ -16508,8 +16508,8 @@
         </p:nvSpPr>
         <p:spPr>
           <a:xfrm>
-            <a:off x="7726679" y="4187952"/>
-            <a:ext cx="1508760" cy="713232"/>
+            <a:off x="7726679" y="4837952"/>
+            <a:ext cx="1508760" cy="920000"/>
           </a:xfrm>
           <a:prstGeom prst="rect">
             <a:avLst/>
@@ -16553,17 +16553,17 @@
         </p:nvSpPr>
         <p:spPr>
           <a:xfrm>
-            <a:off x="7836407" y="4261104"/>
-            <a:ext cx="1289304" cy="219456"/>
-          </a:xfrm>
-          <a:prstGeom prst="rect">
-            <a:avLst/>
-          </a:prstGeom>
-          <a:noFill/>
-        </p:spPr>
-        <p:txBody>
-          <a:bodyPr wrap="square">
-            <a:spAutoFit/>
+            <a:off x="7836407" y="4900000"/>
+            <a:ext cx="1289304" cy="210000"/>
+          </a:xfrm>
+          <a:prstGeom prst="rect">
+            <a:avLst/>
+          </a:prstGeom>
+          <a:noFill/>
+        </p:spPr>
+        <p:txBody>
+          <a:bodyPr wrap="square">
+            <a:normAutofit/>
           </a:bodyPr>
           <a:lstStyle/>
           <a:p>
@@ -16588,23 +16588,23 @@
         </p:nvSpPr>
         <p:spPr>
           <a:xfrm>
-            <a:off x="7836407" y="4443984"/>
-            <a:ext cx="1289304" cy="310896"/>
-          </a:xfrm>
-          <a:prstGeom prst="rect">
-            <a:avLst/>
-          </a:prstGeom>
-          <a:noFill/>
-        </p:spPr>
-        <p:txBody>
-          <a:bodyPr wrap="square">
-            <a:spAutoFit/>
+            <a:off x="7836407" y="5120000"/>
+            <a:ext cx="1289304" cy="420000"/>
+          </a:xfrm>
+          <a:prstGeom prst="rect">
+            <a:avLst/>
+          </a:prstGeom>
+          <a:noFill/>
+        </p:spPr>
+        <p:txBody>
+          <a:bodyPr wrap="none" lIns="0" rIns="0">
+            <a:normAutofit/>
           </a:bodyPr>
           <a:lstStyle/>
           <a:p>
             <a:pPr algn="l"/>
             <a:r>
-              <a:rPr sz="2000" b="1">
+              <a:rPr sz="1200" b="1">
                 <a:solidFill>
                   <a:srgbClr val="FFFFFF"/>
                 </a:solidFill>
@@ -16623,8 +16623,8 @@
         </p:nvSpPr>
         <p:spPr>
           <a:xfrm>
-            <a:off x="9464040" y="4187952"/>
-            <a:ext cx="1325880" cy="713232"/>
+            <a:off x="9464040" y="4837952"/>
+            <a:ext cx="1325880" cy="920000"/>
           </a:xfrm>
           <a:prstGeom prst="rect">
             <a:avLst/>
@@ -16668,17 +16668,17 @@
         </p:nvSpPr>
         <p:spPr>
           <a:xfrm>
-            <a:off x="9573768" y="4261104"/>
-            <a:ext cx="1106424" cy="219456"/>
-          </a:xfrm>
-          <a:prstGeom prst="rect">
-            <a:avLst/>
-          </a:prstGeom>
-          <a:noFill/>
-        </p:spPr>
-        <p:txBody>
-          <a:bodyPr wrap="square">
-            <a:spAutoFit/>
+            <a:off x="9573768" y="4900000"/>
+            <a:ext cx="1106424" cy="210000"/>
+          </a:xfrm>
+          <a:prstGeom prst="rect">
+            <a:avLst/>
+          </a:prstGeom>
+          <a:noFill/>
+        </p:spPr>
+        <p:txBody>
+          <a:bodyPr wrap="square">
+            <a:normAutofit/>
           </a:bodyPr>
           <a:lstStyle/>
           <a:p>
@@ -16703,23 +16703,23 @@
         </p:nvSpPr>
         <p:spPr>
           <a:xfrm>
-            <a:off x="9573768" y="4443984"/>
-            <a:ext cx="1106424" cy="310896"/>
-          </a:xfrm>
-          <a:prstGeom prst="rect">
-            <a:avLst/>
-          </a:prstGeom>
-          <a:noFill/>
-        </p:spPr>
-        <p:txBody>
-          <a:bodyPr wrap="square">
-            <a:spAutoFit/>
+            <a:off x="9573768" y="5120000"/>
+            <a:ext cx="1106424" cy="420000"/>
+          </a:xfrm>
+          <a:prstGeom prst="rect">
+            <a:avLst/>
+          </a:prstGeom>
+          <a:noFill/>
+        </p:spPr>
+        <p:txBody>
+          <a:bodyPr wrap="square">
+            <a:normAutofit/>
           </a:bodyPr>
           <a:lstStyle/>
           <a:p>
             <a:pPr algn="l"/>
             <a:r>
-              <a:rPr sz="2000" b="1">
+              <a:rPr sz="1500" b="1">
                 <a:solidFill>
                   <a:srgbClr val="FFFFFF"/>
                 </a:solidFill>
@@ -16868,7 +16868,7 @@
                 </a:solidFill>
                 <a:latin typeface="Aptos"/>
               </a:rPr>
-              <a:t>System model</a:t>
+              <a:t>Tlamatini model</a:t>
             </a:r>
           </a:p>
         </p:txBody>

</xml_diff>

<commit_message>
Just sompptx framing, by angelahack1
</commit_message>
<xml_diff>
--- a/Tlamatini_eXtended_Artificial_Intelligence_Humanly_Tempered.pptx
+++ b/Tlamatini_eXtended_Artificial_Intelligence_Humanly_Tempered.pptx
@@ -5,40 +5,40 @@
     <p:sldMasterId id="2147483648" r:id="rId1"/>
   </p:sldMasterIdLst>
   <p:sldIdLst>
-    <p:sldId id="256" r:id="rId7"/>
-    <p:sldId id="257" r:id="rId8"/>
-    <p:sldId id="258" r:id="rId9"/>
-    <p:sldId id="259" r:id="rId10"/>
-    <p:sldId id="260" r:id="rId11"/>
-    <p:sldId id="261" r:id="rId12"/>
-    <p:sldId id="262" r:id="rId13"/>
-    <p:sldId id="263" r:id="rId14"/>
-    <p:sldId id="264" r:id="rId15"/>
-    <p:sldId id="265" r:id="rId16"/>
-    <p:sldId id="266" r:id="rId17"/>
-    <p:sldId id="267" r:id="rId18"/>
-    <p:sldId id="268" r:id="rId19"/>
-    <p:sldId id="269" r:id="rId20"/>
-    <p:sldId id="270" r:id="rId21"/>
-    <p:sldId id="271" r:id="rId22"/>
-    <p:sldId id="272" r:id="rId23"/>
-    <p:sldId id="273" r:id="rId24"/>
-    <p:sldId id="274" r:id="rId25"/>
-    <p:sldId id="275" r:id="rId26"/>
-    <p:sldId id="276" r:id="rId27"/>
-    <p:sldId id="277" r:id="rId28"/>
-    <p:sldId id="278" r:id="rId29"/>
-    <p:sldId id="279" r:id="rId30"/>
-    <p:sldId id="280" r:id="rId31"/>
-    <p:sldId id="281" r:id="rId32"/>
-    <p:sldId id="282" r:id="rId33"/>
-    <p:sldId id="283" r:id="rId34"/>
-    <p:sldId id="284" r:id="rId35"/>
-    <p:sldId id="285" r:id="rId36"/>
-    <p:sldId id="286" r:id="rId37"/>
-    <p:sldId id="287" r:id="rId38"/>
+    <p:sldId id="256" r:id="rId2"/>
+    <p:sldId id="257" r:id="rId3"/>
+    <p:sldId id="258" r:id="rId4"/>
+    <p:sldId id="259" r:id="rId5"/>
+    <p:sldId id="260" r:id="rId6"/>
+    <p:sldId id="261" r:id="rId7"/>
+    <p:sldId id="262" r:id="rId8"/>
+    <p:sldId id="263" r:id="rId9"/>
+    <p:sldId id="264" r:id="rId10"/>
+    <p:sldId id="265" r:id="rId11"/>
+    <p:sldId id="266" r:id="rId12"/>
+    <p:sldId id="267" r:id="rId13"/>
+    <p:sldId id="268" r:id="rId14"/>
+    <p:sldId id="269" r:id="rId15"/>
+    <p:sldId id="270" r:id="rId16"/>
+    <p:sldId id="271" r:id="rId17"/>
+    <p:sldId id="272" r:id="rId18"/>
+    <p:sldId id="273" r:id="rId19"/>
+    <p:sldId id="274" r:id="rId20"/>
+    <p:sldId id="275" r:id="rId21"/>
+    <p:sldId id="276" r:id="rId22"/>
+    <p:sldId id="277" r:id="rId23"/>
+    <p:sldId id="278" r:id="rId24"/>
+    <p:sldId id="279" r:id="rId25"/>
+    <p:sldId id="280" r:id="rId26"/>
+    <p:sldId id="281" r:id="rId27"/>
+    <p:sldId id="282" r:id="rId28"/>
+    <p:sldId id="283" r:id="rId29"/>
+    <p:sldId id="284" r:id="rId30"/>
+    <p:sldId id="285" r:id="rId31"/>
+    <p:sldId id="286" r:id="rId32"/>
+    <p:sldId id="287" r:id="rId33"/>
   </p:sldIdLst>
-  <p:sldSz cx="12191695" cy="6858000" type="screen4x3"/>
+  <p:sldSz cx="12192000" cy="6858000"/>
   <p:notesSz cx="6858000" cy="9144000"/>
   <p:defaultTextStyle>
     <a:defPPr>
@@ -135,6 +135,22 @@
       </a:defRPr>
     </a:lvl9pPr>
   </p:defaultTextStyle>
+  <p:extLst>
+    <p:ext uri="{EFAFB233-063F-42B5-8137-9DF3F51BA10A}">
+      <p15:sldGuideLst xmlns:p15="http://schemas.microsoft.com/office/powerpoint/2012/main">
+        <p15:guide id="1" orient="horz" pos="2160">
+          <p15:clr>
+            <a:srgbClr val="A4A3A4"/>
+          </p15:clr>
+        </p15:guide>
+        <p15:guide id="2" pos="2880">
+          <p15:clr>
+            <a:srgbClr val="A4A3A4"/>
+          </p15:clr>
+        </p15:guide>
+      </p15:sldGuideLst>
+    </p:ext>
+  </p:extLst>
 </p:presentation>
 </file>
 
@@ -176,10 +192,9 @@
           <a:lstStyle/>
           <a:p>
             <a:r>
-              <a:rPr lang="en-US" smtClean="0"/>
+              <a:rPr lang="en-US"/>
               <a:t>Click to edit Master title style</a:t>
             </a:r>
-            <a:endParaRPr lang="en-US"/>
           </a:p>
         </p:txBody>
       </p:sp>
@@ -295,10 +310,9 @@
           </a:lstStyle>
           <a:p>
             <a:r>
-              <a:rPr lang="en-US" smtClean="0"/>
+              <a:rPr lang="en-US"/>
               <a:t>Click to edit Master subtitle style</a:t>
             </a:r>
-            <a:endParaRPr lang="en-US"/>
           </a:p>
         </p:txBody>
       </p:sp>
@@ -319,7 +333,7 @@
           <a:p>
             <a:fld id="{5BCAD085-E8A6-8845-BD4E-CB4CCA059FC4}" type="datetimeFigureOut">
               <a:rPr lang="en-US" smtClean="0"/>
-              <a:t>1/27/13</a:t>
+              <a:t>4/18/2026</a:t>
             </a:fld>
             <a:endParaRPr lang="en-US"/>
           </a:p>
@@ -413,10 +427,9 @@
           <a:lstStyle/>
           <a:p>
             <a:r>
-              <a:rPr lang="en-US" smtClean="0"/>
+              <a:rPr lang="en-US"/>
               <a:t>Click to edit Master title style</a:t>
             </a:r>
-            <a:endParaRPr lang="en-US"/>
           </a:p>
         </p:txBody>
       </p:sp>
@@ -437,38 +450,37 @@
           <a:p>
             <a:pPr lvl="0"/>
             <a:r>
-              <a:rPr lang="en-US" smtClean="0"/>
+              <a:rPr lang="en-US"/>
               <a:t>Click to edit Master text styles</a:t>
             </a:r>
           </a:p>
           <a:p>
             <a:pPr lvl="1"/>
             <a:r>
-              <a:rPr lang="en-US" smtClean="0"/>
+              <a:rPr lang="en-US"/>
               <a:t>Second level</a:t>
             </a:r>
           </a:p>
           <a:p>
             <a:pPr lvl="2"/>
             <a:r>
-              <a:rPr lang="en-US" smtClean="0"/>
+              <a:rPr lang="en-US"/>
               <a:t>Third level</a:t>
             </a:r>
           </a:p>
           <a:p>
             <a:pPr lvl="3"/>
             <a:r>
-              <a:rPr lang="en-US" smtClean="0"/>
+              <a:rPr lang="en-US"/>
               <a:t>Fourth level</a:t>
             </a:r>
           </a:p>
           <a:p>
             <a:pPr lvl="4"/>
             <a:r>
-              <a:rPr lang="en-US" smtClean="0"/>
+              <a:rPr lang="en-US"/>
               <a:t>Fifth level</a:t>
             </a:r>
-            <a:endParaRPr lang="en-US"/>
           </a:p>
         </p:txBody>
       </p:sp>
@@ -489,7 +501,7 @@
           <a:p>
             <a:fld id="{5BCAD085-E8A6-8845-BD4E-CB4CCA059FC4}" type="datetimeFigureOut">
               <a:rPr lang="en-US" smtClean="0"/>
-              <a:t>1/27/13</a:t>
+              <a:t>4/18/2026</a:t>
             </a:fld>
             <a:endParaRPr lang="en-US"/>
           </a:p>
@@ -588,10 +600,9 @@
           <a:lstStyle/>
           <a:p>
             <a:r>
-              <a:rPr lang="en-US" smtClean="0"/>
+              <a:rPr lang="en-US"/>
               <a:t>Click to edit Master title style</a:t>
             </a:r>
-            <a:endParaRPr lang="en-US"/>
           </a:p>
         </p:txBody>
       </p:sp>
@@ -617,38 +628,37 @@
           <a:p>
             <a:pPr lvl="0"/>
             <a:r>
-              <a:rPr lang="en-US" smtClean="0"/>
+              <a:rPr lang="en-US"/>
               <a:t>Click to edit Master text styles</a:t>
             </a:r>
           </a:p>
           <a:p>
             <a:pPr lvl="1"/>
             <a:r>
-              <a:rPr lang="en-US" smtClean="0"/>
+              <a:rPr lang="en-US"/>
               <a:t>Second level</a:t>
             </a:r>
           </a:p>
           <a:p>
             <a:pPr lvl="2"/>
             <a:r>
-              <a:rPr lang="en-US" smtClean="0"/>
+              <a:rPr lang="en-US"/>
               <a:t>Third level</a:t>
             </a:r>
           </a:p>
           <a:p>
             <a:pPr lvl="3"/>
             <a:r>
-              <a:rPr lang="en-US" smtClean="0"/>
+              <a:rPr lang="en-US"/>
               <a:t>Fourth level</a:t>
             </a:r>
           </a:p>
           <a:p>
             <a:pPr lvl="4"/>
             <a:r>
-              <a:rPr lang="en-US" smtClean="0"/>
+              <a:rPr lang="en-US"/>
               <a:t>Fifth level</a:t>
             </a:r>
-            <a:endParaRPr lang="en-US"/>
           </a:p>
         </p:txBody>
       </p:sp>
@@ -669,7 +679,7 @@
           <a:p>
             <a:fld id="{5BCAD085-E8A6-8845-BD4E-CB4CCA059FC4}" type="datetimeFigureOut">
               <a:rPr lang="en-US" smtClean="0"/>
-              <a:t>1/27/13</a:t>
+              <a:t>4/18/2026</a:t>
             </a:fld>
             <a:endParaRPr lang="en-US"/>
           </a:p>
@@ -763,10 +773,9 @@
           <a:lstStyle/>
           <a:p>
             <a:r>
-              <a:rPr lang="en-US" smtClean="0"/>
+              <a:rPr lang="en-US"/>
               <a:t>Click to edit Master title style</a:t>
             </a:r>
-            <a:endParaRPr lang="en-US"/>
           </a:p>
         </p:txBody>
       </p:sp>
@@ -787,38 +796,37 @@
           <a:p>
             <a:pPr lvl="0"/>
             <a:r>
-              <a:rPr lang="en-US" smtClean="0"/>
+              <a:rPr lang="en-US"/>
               <a:t>Click to edit Master text styles</a:t>
             </a:r>
           </a:p>
           <a:p>
             <a:pPr lvl="1"/>
             <a:r>
-              <a:rPr lang="en-US" smtClean="0"/>
+              <a:rPr lang="en-US"/>
               <a:t>Second level</a:t>
             </a:r>
           </a:p>
           <a:p>
             <a:pPr lvl="2"/>
             <a:r>
-              <a:rPr lang="en-US" smtClean="0"/>
+              <a:rPr lang="en-US"/>
               <a:t>Third level</a:t>
             </a:r>
           </a:p>
           <a:p>
             <a:pPr lvl="3"/>
             <a:r>
-              <a:rPr lang="en-US" smtClean="0"/>
+              <a:rPr lang="en-US"/>
               <a:t>Fourth level</a:t>
             </a:r>
           </a:p>
           <a:p>
             <a:pPr lvl="4"/>
             <a:r>
-              <a:rPr lang="en-US" smtClean="0"/>
+              <a:rPr lang="en-US"/>
               <a:t>Fifth level</a:t>
             </a:r>
-            <a:endParaRPr lang="en-US"/>
           </a:p>
         </p:txBody>
       </p:sp>
@@ -839,7 +847,7 @@
           <a:p>
             <a:fld id="{5BCAD085-E8A6-8845-BD4E-CB4CCA059FC4}" type="datetimeFigureOut">
               <a:rPr lang="en-US" smtClean="0"/>
-              <a:t>1/27/13</a:t>
+              <a:t>4/18/2026</a:t>
             </a:fld>
             <a:endParaRPr lang="en-US"/>
           </a:p>
@@ -942,10 +950,9 @@
           </a:lstStyle>
           <a:p>
             <a:r>
-              <a:rPr lang="en-US" smtClean="0"/>
+              <a:rPr lang="en-US"/>
               <a:t>Click to edit Master title style</a:t>
             </a:r>
-            <a:endParaRPr lang="en-US"/>
           </a:p>
         </p:txBody>
       </p:sp>
@@ -1062,7 +1069,7 @@
           <a:p>
             <a:pPr lvl="0"/>
             <a:r>
-              <a:rPr lang="en-US" smtClean="0"/>
+              <a:rPr lang="en-US"/>
               <a:t>Click to edit Master text styles</a:t>
             </a:r>
           </a:p>
@@ -1085,7 +1092,7 @@
           <a:p>
             <a:fld id="{5BCAD085-E8A6-8845-BD4E-CB4CCA059FC4}" type="datetimeFigureOut">
               <a:rPr lang="en-US" smtClean="0"/>
-              <a:t>1/27/13</a:t>
+              <a:t>4/18/2026</a:t>
             </a:fld>
             <a:endParaRPr lang="en-US"/>
           </a:p>
@@ -1179,10 +1186,9 @@
           <a:lstStyle/>
           <a:p>
             <a:r>
-              <a:rPr lang="en-US" smtClean="0"/>
+              <a:rPr lang="en-US"/>
               <a:t>Click to edit Master title style</a:t>
             </a:r>
-            <a:endParaRPr lang="en-US"/>
           </a:p>
         </p:txBody>
       </p:sp>
@@ -1236,38 +1242,37 @@
           <a:p>
             <a:pPr lvl="0"/>
             <a:r>
-              <a:rPr lang="en-US" smtClean="0"/>
+              <a:rPr lang="en-US"/>
               <a:t>Click to edit Master text styles</a:t>
             </a:r>
           </a:p>
           <a:p>
             <a:pPr lvl="1"/>
             <a:r>
-              <a:rPr lang="en-US" smtClean="0"/>
+              <a:rPr lang="en-US"/>
               <a:t>Second level</a:t>
             </a:r>
           </a:p>
           <a:p>
             <a:pPr lvl="2"/>
             <a:r>
-              <a:rPr lang="en-US" smtClean="0"/>
+              <a:rPr lang="en-US"/>
               <a:t>Third level</a:t>
             </a:r>
           </a:p>
           <a:p>
             <a:pPr lvl="3"/>
             <a:r>
-              <a:rPr lang="en-US" smtClean="0"/>
+              <a:rPr lang="en-US"/>
               <a:t>Fourth level</a:t>
             </a:r>
           </a:p>
           <a:p>
             <a:pPr lvl="4"/>
             <a:r>
-              <a:rPr lang="en-US" smtClean="0"/>
+              <a:rPr lang="en-US"/>
               <a:t>Fifth level</a:t>
             </a:r>
-            <a:endParaRPr lang="en-US"/>
           </a:p>
         </p:txBody>
       </p:sp>
@@ -1321,38 +1326,37 @@
           <a:p>
             <a:pPr lvl="0"/>
             <a:r>
-              <a:rPr lang="en-US" smtClean="0"/>
+              <a:rPr lang="en-US"/>
               <a:t>Click to edit Master text styles</a:t>
             </a:r>
           </a:p>
           <a:p>
             <a:pPr lvl="1"/>
             <a:r>
-              <a:rPr lang="en-US" smtClean="0"/>
+              <a:rPr lang="en-US"/>
               <a:t>Second level</a:t>
             </a:r>
           </a:p>
           <a:p>
             <a:pPr lvl="2"/>
             <a:r>
-              <a:rPr lang="en-US" smtClean="0"/>
+              <a:rPr lang="en-US"/>
               <a:t>Third level</a:t>
             </a:r>
           </a:p>
           <a:p>
             <a:pPr lvl="3"/>
             <a:r>
-              <a:rPr lang="en-US" smtClean="0"/>
+              <a:rPr lang="en-US"/>
               <a:t>Fourth level</a:t>
             </a:r>
           </a:p>
           <a:p>
             <a:pPr lvl="4"/>
             <a:r>
-              <a:rPr lang="en-US" smtClean="0"/>
+              <a:rPr lang="en-US"/>
               <a:t>Fifth level</a:t>
             </a:r>
-            <a:endParaRPr lang="en-US"/>
           </a:p>
         </p:txBody>
       </p:sp>
@@ -1373,7 +1377,7 @@
           <a:p>
             <a:fld id="{5BCAD085-E8A6-8845-BD4E-CB4CCA059FC4}" type="datetimeFigureOut">
               <a:rPr lang="en-US" smtClean="0"/>
-              <a:t>1/27/13</a:t>
+              <a:t>4/18/2026</a:t>
             </a:fld>
             <a:endParaRPr lang="en-US"/>
           </a:p>
@@ -1471,10 +1475,9 @@
           </a:lstStyle>
           <a:p>
             <a:r>
-              <a:rPr lang="en-US" smtClean="0"/>
+              <a:rPr lang="en-US"/>
               <a:t>Click to edit Master title style</a:t>
             </a:r>
-            <a:endParaRPr lang="en-US"/>
           </a:p>
         </p:txBody>
       </p:sp>
@@ -1537,7 +1540,7 @@
           <a:p>
             <a:pPr lvl="0"/>
             <a:r>
-              <a:rPr lang="en-US" smtClean="0"/>
+              <a:rPr lang="en-US"/>
               <a:t>Click to edit Master text styles</a:t>
             </a:r>
           </a:p>
@@ -1593,38 +1596,37 @@
           <a:p>
             <a:pPr lvl="0"/>
             <a:r>
-              <a:rPr lang="en-US" smtClean="0"/>
+              <a:rPr lang="en-US"/>
               <a:t>Click to edit Master text styles</a:t>
             </a:r>
           </a:p>
           <a:p>
             <a:pPr lvl="1"/>
             <a:r>
-              <a:rPr lang="en-US" smtClean="0"/>
+              <a:rPr lang="en-US"/>
               <a:t>Second level</a:t>
             </a:r>
           </a:p>
           <a:p>
             <a:pPr lvl="2"/>
             <a:r>
-              <a:rPr lang="en-US" smtClean="0"/>
+              <a:rPr lang="en-US"/>
               <a:t>Third level</a:t>
             </a:r>
           </a:p>
           <a:p>
             <a:pPr lvl="3"/>
             <a:r>
-              <a:rPr lang="en-US" smtClean="0"/>
+              <a:rPr lang="en-US"/>
               <a:t>Fourth level</a:t>
             </a:r>
           </a:p>
           <a:p>
             <a:pPr lvl="4"/>
             <a:r>
-              <a:rPr lang="en-US" smtClean="0"/>
+              <a:rPr lang="en-US"/>
               <a:t>Fifth level</a:t>
             </a:r>
-            <a:endParaRPr lang="en-US"/>
           </a:p>
         </p:txBody>
       </p:sp>
@@ -1687,7 +1689,7 @@
           <a:p>
             <a:pPr lvl="0"/>
             <a:r>
-              <a:rPr lang="en-US" smtClean="0"/>
+              <a:rPr lang="en-US"/>
               <a:t>Click to edit Master text styles</a:t>
             </a:r>
           </a:p>
@@ -1743,38 +1745,37 @@
           <a:p>
             <a:pPr lvl="0"/>
             <a:r>
-              <a:rPr lang="en-US" smtClean="0"/>
+              <a:rPr lang="en-US"/>
               <a:t>Click to edit Master text styles</a:t>
             </a:r>
           </a:p>
           <a:p>
             <a:pPr lvl="1"/>
             <a:r>
-              <a:rPr lang="en-US" smtClean="0"/>
+              <a:rPr lang="en-US"/>
               <a:t>Second level</a:t>
             </a:r>
           </a:p>
           <a:p>
             <a:pPr lvl="2"/>
             <a:r>
-              <a:rPr lang="en-US" smtClean="0"/>
+              <a:rPr lang="en-US"/>
               <a:t>Third level</a:t>
             </a:r>
           </a:p>
           <a:p>
             <a:pPr lvl="3"/>
             <a:r>
-              <a:rPr lang="en-US" smtClean="0"/>
+              <a:rPr lang="en-US"/>
               <a:t>Fourth level</a:t>
             </a:r>
           </a:p>
           <a:p>
             <a:pPr lvl="4"/>
             <a:r>
-              <a:rPr lang="en-US" smtClean="0"/>
+              <a:rPr lang="en-US"/>
               <a:t>Fifth level</a:t>
             </a:r>
-            <a:endParaRPr lang="en-US"/>
           </a:p>
         </p:txBody>
       </p:sp>
@@ -1795,7 +1796,7 @@
           <a:p>
             <a:fld id="{5BCAD085-E8A6-8845-BD4E-CB4CCA059FC4}" type="datetimeFigureOut">
               <a:rPr lang="en-US" smtClean="0"/>
-              <a:t>1/27/13</a:t>
+              <a:t>4/18/2026</a:t>
             </a:fld>
             <a:endParaRPr lang="en-US"/>
           </a:p>
@@ -1889,10 +1890,9 @@
           <a:lstStyle/>
           <a:p>
             <a:r>
-              <a:rPr lang="en-US" smtClean="0"/>
+              <a:rPr lang="en-US"/>
               <a:t>Click to edit Master title style</a:t>
             </a:r>
-            <a:endParaRPr lang="en-US"/>
           </a:p>
         </p:txBody>
       </p:sp>
@@ -1913,7 +1913,7 @@
           <a:p>
             <a:fld id="{5BCAD085-E8A6-8845-BD4E-CB4CCA059FC4}" type="datetimeFigureOut">
               <a:rPr lang="en-US" smtClean="0"/>
-              <a:t>1/27/13</a:t>
+              <a:t>4/18/2026</a:t>
             </a:fld>
             <a:endParaRPr lang="en-US"/>
           </a:p>
@@ -2008,7 +2008,7 @@
           <a:p>
             <a:fld id="{5BCAD085-E8A6-8845-BD4E-CB4CCA059FC4}" type="datetimeFigureOut">
               <a:rPr lang="en-US" smtClean="0"/>
-              <a:t>1/27/13</a:t>
+              <a:t>4/18/2026</a:t>
             </a:fld>
             <a:endParaRPr lang="en-US"/>
           </a:p>
@@ -2111,10 +2111,9 @@
           </a:lstStyle>
           <a:p>
             <a:r>
-              <a:rPr lang="en-US" smtClean="0"/>
+              <a:rPr lang="en-US"/>
               <a:t>Click to edit Master title style</a:t>
             </a:r>
-            <a:endParaRPr lang="en-US"/>
           </a:p>
         </p:txBody>
       </p:sp>
@@ -2168,38 +2167,37 @@
           <a:p>
             <a:pPr lvl="0"/>
             <a:r>
-              <a:rPr lang="en-US" smtClean="0"/>
+              <a:rPr lang="en-US"/>
               <a:t>Click to edit Master text styles</a:t>
             </a:r>
           </a:p>
           <a:p>
             <a:pPr lvl="1"/>
             <a:r>
-              <a:rPr lang="en-US" smtClean="0"/>
+              <a:rPr lang="en-US"/>
               <a:t>Second level</a:t>
             </a:r>
           </a:p>
           <a:p>
             <a:pPr lvl="2"/>
             <a:r>
-              <a:rPr lang="en-US" smtClean="0"/>
+              <a:rPr lang="en-US"/>
               <a:t>Third level</a:t>
             </a:r>
           </a:p>
           <a:p>
             <a:pPr lvl="3"/>
             <a:r>
-              <a:rPr lang="en-US" smtClean="0"/>
+              <a:rPr lang="en-US"/>
               <a:t>Fourth level</a:t>
             </a:r>
           </a:p>
           <a:p>
             <a:pPr lvl="4"/>
             <a:r>
-              <a:rPr lang="en-US" smtClean="0"/>
+              <a:rPr lang="en-US"/>
               <a:t>Fifth level</a:t>
             </a:r>
-            <a:endParaRPr lang="en-US"/>
           </a:p>
         </p:txBody>
       </p:sp>
@@ -2262,7 +2260,7 @@
           <a:p>
             <a:pPr lvl="0"/>
             <a:r>
-              <a:rPr lang="en-US" smtClean="0"/>
+              <a:rPr lang="en-US"/>
               <a:t>Click to edit Master text styles</a:t>
             </a:r>
           </a:p>
@@ -2285,7 +2283,7 @@
           <a:p>
             <a:fld id="{5BCAD085-E8A6-8845-BD4E-CB4CCA059FC4}" type="datetimeFigureOut">
               <a:rPr lang="en-US" smtClean="0"/>
-              <a:t>1/27/13</a:t>
+              <a:t>4/18/2026</a:t>
             </a:fld>
             <a:endParaRPr lang="en-US"/>
           </a:p>
@@ -2388,10 +2386,9 @@
           </a:lstStyle>
           <a:p>
             <a:r>
-              <a:rPr lang="en-US" smtClean="0"/>
+              <a:rPr lang="en-US"/>
               <a:t>Click to edit Master title style</a:t>
             </a:r>
-            <a:endParaRPr lang="en-US"/>
           </a:p>
         </p:txBody>
       </p:sp>
@@ -2515,7 +2512,7 @@
           <a:p>
             <a:pPr lvl="0"/>
             <a:r>
-              <a:rPr lang="en-US" smtClean="0"/>
+              <a:rPr lang="en-US"/>
               <a:t>Click to edit Master text styles</a:t>
             </a:r>
           </a:p>
@@ -2538,7 +2535,7 @@
           <a:p>
             <a:fld id="{5BCAD085-E8A6-8845-BD4E-CB4CCA059FC4}" type="datetimeFigureOut">
               <a:rPr lang="en-US" smtClean="0"/>
-              <a:t>1/27/13</a:t>
+              <a:t>4/18/2026</a:t>
             </a:fld>
             <a:endParaRPr lang="en-US"/>
           </a:p>
@@ -2647,10 +2644,9 @@
           <a:lstStyle/>
           <a:p>
             <a:r>
-              <a:rPr lang="en-US" smtClean="0"/>
+              <a:rPr lang="en-US"/>
               <a:t>Click to edit Master title style</a:t>
             </a:r>
-            <a:endParaRPr lang="en-US"/>
           </a:p>
         </p:txBody>
       </p:sp>
@@ -2681,38 +2677,37 @@
           <a:p>
             <a:pPr lvl="0"/>
             <a:r>
-              <a:rPr lang="en-US" smtClean="0"/>
+              <a:rPr lang="en-US"/>
               <a:t>Click to edit Master text styles</a:t>
             </a:r>
           </a:p>
           <a:p>
             <a:pPr lvl="1"/>
             <a:r>
-              <a:rPr lang="en-US" smtClean="0"/>
+              <a:rPr lang="en-US"/>
               <a:t>Second level</a:t>
             </a:r>
           </a:p>
           <a:p>
             <a:pPr lvl="2"/>
             <a:r>
-              <a:rPr lang="en-US" smtClean="0"/>
+              <a:rPr lang="en-US"/>
               <a:t>Third level</a:t>
             </a:r>
           </a:p>
           <a:p>
             <a:pPr lvl="3"/>
             <a:r>
-              <a:rPr lang="en-US" smtClean="0"/>
+              <a:rPr lang="en-US"/>
               <a:t>Fourth level</a:t>
             </a:r>
           </a:p>
           <a:p>
             <a:pPr lvl="4"/>
             <a:r>
-              <a:rPr lang="en-US" smtClean="0"/>
+              <a:rPr lang="en-US"/>
               <a:t>Fifth level</a:t>
             </a:r>
-            <a:endParaRPr lang="en-US"/>
           </a:p>
         </p:txBody>
       </p:sp>
@@ -2751,7 +2746,7 @@
           <a:p>
             <a:fld id="{5BCAD085-E8A6-8845-BD4E-CB4CCA059FC4}" type="datetimeFigureOut">
               <a:rPr lang="en-US" smtClean="0"/>
-              <a:t>1/27/13</a:t>
+              <a:t>4/18/2026</a:t>
             </a:fld>
             <a:endParaRPr lang="en-US"/>
           </a:p>
@@ -3110,7 +3105,7 @@
 </file>
 
 <file path=ppt/slides/slide1.xml><?xml version="1.0" encoding="utf-8"?>
-<p:sld xmlns:a="http://schemas.openxmlformats.org/drawingml/2006/main" xmlns:p="http://schemas.openxmlformats.org/presentationml/2006/main" xmlns:r="http://schemas.openxmlformats.org/officeDocument/2006/relationships">
+<p:sld xmlns:a="http://schemas.openxmlformats.org/drawingml/2006/main" xmlns:r="http://schemas.openxmlformats.org/officeDocument/2006/relationships" xmlns:p="http://schemas.openxmlformats.org/presentationml/2006/main">
   <p:cSld>
     <p:spTree>
       <p:nvGrpSpPr>
@@ -3118,7 +3113,14 @@
         <p:cNvGrpSpPr/>
         <p:nvPr/>
       </p:nvGrpSpPr>
-      <p:grpSpPr/>
+      <p:grpSpPr>
+        <a:xfrm>
+          <a:off x="0" y="0"/>
+          <a:ext cx="0" cy="0"/>
+          <a:chOff x="0" y="0"/>
+          <a:chExt cx="0" cy="0"/>
+        </a:xfrm>
+      </p:grpSpPr>
       <p:pic>
         <p:nvPicPr>
           <p:cNvPr id="2" name="Picture 1" descr="image-1-1.png"/>
@@ -3183,6 +3185,7 @@
           <a:lstStyle/>
           <a:p>
             <a:pPr algn="ctr"/>
+            <a:endParaRPr/>
           </a:p>
         </p:txBody>
       </p:sp>
@@ -3226,6 +3229,7 @@
           <a:lstStyle/>
           <a:p>
             <a:pPr algn="ctr"/>
+            <a:endParaRPr/>
           </a:p>
         </p:txBody>
       </p:sp>
@@ -3269,6 +3273,7 @@
           <a:lstStyle/>
           <a:p>
             <a:pPr algn="ctr"/>
+            <a:endParaRPr/>
           </a:p>
         </p:txBody>
       </p:sp>
@@ -3312,6 +3317,7 @@
           <a:lstStyle/>
           <a:p>
             <a:pPr algn="ctr"/>
+            <a:endParaRPr/>
           </a:p>
         </p:txBody>
       </p:sp>
@@ -3355,6 +3361,7 @@
           <a:lstStyle/>
           <a:p>
             <a:pPr algn="ctr"/>
+            <a:endParaRPr/>
           </a:p>
         </p:txBody>
       </p:sp>
@@ -3540,6 +3547,7 @@
           <a:lstStyle/>
           <a:p>
             <a:pPr algn="ctr"/>
+            <a:endParaRPr/>
           </a:p>
         </p:txBody>
       </p:sp>
@@ -3655,6 +3663,7 @@
           <a:lstStyle/>
           <a:p>
             <a:pPr algn="ctr"/>
+            <a:endParaRPr/>
           </a:p>
         </p:txBody>
       </p:sp>
@@ -3770,6 +3779,7 @@
           <a:lstStyle/>
           <a:p>
             <a:pPr algn="ctr"/>
+            <a:endParaRPr/>
           </a:p>
         </p:txBody>
       </p:sp>
@@ -3887,7 +3897,7 @@
 </file>
 
 <file path=ppt/slides/slide10.xml><?xml version="1.0" encoding="utf-8"?>
-<p:sld xmlns:a="http://schemas.openxmlformats.org/drawingml/2006/main" xmlns:p="http://schemas.openxmlformats.org/presentationml/2006/main" xmlns:r="http://schemas.openxmlformats.org/officeDocument/2006/relationships">
+<p:sld xmlns:a="http://schemas.openxmlformats.org/drawingml/2006/main" xmlns:r="http://schemas.openxmlformats.org/officeDocument/2006/relationships" xmlns:p="http://schemas.openxmlformats.org/presentationml/2006/main">
   <p:cSld>
     <p:spTree>
       <p:nvGrpSpPr>
@@ -3895,7 +3905,14 @@
         <p:cNvGrpSpPr/>
         <p:nvPr/>
       </p:nvGrpSpPr>
-      <p:grpSpPr/>
+      <p:grpSpPr>
+        <a:xfrm>
+          <a:off x="0" y="0"/>
+          <a:ext cx="0" cy="0"/>
+          <a:chOff x="0" y="0"/>
+          <a:chExt cx="0" cy="0"/>
+        </a:xfrm>
+      </p:grpSpPr>
       <p:sp>
         <p:nvSpPr>
           <p:cNvPr id="2" name="Rectangle 1"/>
@@ -3936,6 +3953,7 @@
           <a:lstStyle/>
           <a:p>
             <a:pPr algn="ctr"/>
+            <a:endParaRPr/>
           </a:p>
         </p:txBody>
       </p:sp>
@@ -3979,6 +3997,7 @@
           <a:lstStyle/>
           <a:p>
             <a:pPr algn="ctr"/>
+            <a:endParaRPr/>
           </a:p>
         </p:txBody>
       </p:sp>
@@ -4022,6 +4041,7 @@
           <a:lstStyle/>
           <a:p>
             <a:pPr algn="ctr"/>
+            <a:endParaRPr/>
           </a:p>
         </p:txBody>
       </p:sp>
@@ -4065,6 +4085,7 @@
           <a:lstStyle/>
           <a:p>
             <a:pPr algn="ctr"/>
+            <a:endParaRPr/>
           </a:p>
         </p:txBody>
       </p:sp>
@@ -4108,6 +4129,7 @@
           <a:lstStyle/>
           <a:p>
             <a:pPr algn="ctr"/>
+            <a:endParaRPr/>
           </a:p>
         </p:txBody>
       </p:sp>
@@ -4223,6 +4245,7 @@
           <a:lstStyle/>
           <a:p>
             <a:pPr algn="ctr"/>
+            <a:endParaRPr/>
           </a:p>
         </p:txBody>
       </p:sp>
@@ -4266,6 +4289,7 @@
           <a:lstStyle/>
           <a:p>
             <a:pPr algn="ctr"/>
+            <a:endParaRPr/>
           </a:p>
         </p:txBody>
       </p:sp>
@@ -4321,7 +4345,7 @@
           <a:noFill/>
         </p:spPr>
         <p:txBody>
-          <a:bodyPr wrap="square" anchor="t" lIns="38100" rIns="38100" tIns="25400" bIns="25400">
+          <a:bodyPr wrap="square" lIns="38100" tIns="25400" rIns="38100" bIns="25400" anchor="t">
             <a:noAutofit/>
           </a:bodyPr>
           <a:lstStyle/>
@@ -4343,9 +4367,6 @@
               </a:rPr>
               <a:t>Run from source: create a virtual environment, install requirements, migrate, create a superuser, collect static files, and start Django.</a:t>
             </a:r>
-            <a:endParaRPr sz="1500" b="0" i="0">
-              <a:latin typeface="Calibri"/>
-            </a:endParaRPr>
           </a:p>
           <a:p>
             <a:pPr>
@@ -4365,9 +4386,6 @@
               </a:rPr>
               <a:t>Open `/agent/` for chat. Load a file or directory context before asking codebase-specific questions.</a:t>
             </a:r>
-            <a:endParaRPr sz="1500" b="0" i="0">
-              <a:latin typeface="Calibri"/>
-            </a:endParaRPr>
           </a:p>
           <a:p>
             <a:pPr>
@@ -4387,9 +4405,6 @@
               </a:rPr>
               <a:t>Keep Multi-Turn unchecked for direct Q&amp;A; enable Multi-Turn for tasks that need tools, wrapped agents, monitoring, or workflow seeding.</a:t>
             </a:r>
-            <a:endParaRPr sz="1500" b="0" i="0">
-              <a:latin typeface="Calibri"/>
-            </a:endParaRPr>
           </a:p>
         </p:txBody>
       </p:sp>
@@ -4435,6 +4450,7 @@
           <a:lstStyle/>
           <a:p>
             <a:pPr algn="ctr"/>
+            <a:endParaRPr/>
           </a:p>
         </p:txBody>
       </p:sp>
@@ -4478,6 +4494,7 @@
           <a:lstStyle/>
           <a:p>
             <a:pPr algn="ctr"/>
+            <a:endParaRPr/>
           </a:p>
         </p:txBody>
       </p:sp>
@@ -4533,7 +4550,7 @@
           <a:noFill/>
         </p:spPr>
         <p:txBody>
-          <a:bodyPr wrap="square" anchor="t" lIns="38100" rIns="38100" tIns="25400" bIns="25400">
+          <a:bodyPr wrap="square" lIns="38100" tIns="25400" rIns="38100" bIns="25400" anchor="t">
             <a:noAutofit/>
           </a:bodyPr>
           <a:lstStyle/>
@@ -4555,9 +4572,6 @@
               </a:rPr>
               <a:t>Open `/agentic_control_panel/` to drag agents, connect them, configure each node, validate, start, pause/resume, stop, and save `.flw` workflows.</a:t>
             </a:r>
-            <a:endParaRPr sz="1500" b="0" i="0">
-              <a:latin typeface="Calibri"/>
-            </a:endParaRPr>
           </a:p>
           <a:p>
             <a:pPr>
@@ -4577,9 +4591,6 @@
               </a:rPr>
               <a:t>Use `python build.py`, `python build_uninstaller.py`, and `python build_installer.py` only when producing a packaged Windows release.</a:t>
             </a:r>
-            <a:endParaRPr sz="1500" b="0" i="0">
-              <a:latin typeface="Calibri"/>
-            </a:endParaRPr>
           </a:p>
         </p:txBody>
       </p:sp>
@@ -4592,7 +4603,7 @@
 </file>
 
 <file path=ppt/slides/slide11.xml><?xml version="1.0" encoding="utf-8"?>
-<p:sld xmlns:a="http://schemas.openxmlformats.org/drawingml/2006/main" xmlns:p="http://schemas.openxmlformats.org/presentationml/2006/main" xmlns:r="http://schemas.openxmlformats.org/officeDocument/2006/relationships">
+<p:sld xmlns:a="http://schemas.openxmlformats.org/drawingml/2006/main" xmlns:r="http://schemas.openxmlformats.org/officeDocument/2006/relationships" xmlns:p="http://schemas.openxmlformats.org/presentationml/2006/main">
   <p:cSld>
     <p:spTree>
       <p:nvGrpSpPr>
@@ -4600,7 +4611,14 @@
         <p:cNvGrpSpPr/>
         <p:nvPr/>
       </p:nvGrpSpPr>
-      <p:grpSpPr/>
+      <p:grpSpPr>
+        <a:xfrm>
+          <a:off x="0" y="0"/>
+          <a:ext cx="0" cy="0"/>
+          <a:chOff x="0" y="0"/>
+          <a:chExt cx="0" cy="0"/>
+        </a:xfrm>
+      </p:grpSpPr>
       <p:sp>
         <p:nvSpPr>
           <p:cNvPr id="2" name="Rectangle 1"/>
@@ -4641,6 +4659,7 @@
           <a:lstStyle/>
           <a:p>
             <a:pPr algn="ctr"/>
+            <a:endParaRPr/>
           </a:p>
         </p:txBody>
       </p:sp>
@@ -4684,6 +4703,7 @@
           <a:lstStyle/>
           <a:p>
             <a:pPr algn="ctr"/>
+            <a:endParaRPr/>
           </a:p>
         </p:txBody>
       </p:sp>
@@ -4727,6 +4747,7 @@
           <a:lstStyle/>
           <a:p>
             <a:pPr algn="ctr"/>
+            <a:endParaRPr/>
           </a:p>
         </p:txBody>
       </p:sp>
@@ -4770,6 +4791,7 @@
           <a:lstStyle/>
           <a:p>
             <a:pPr algn="ctr"/>
+            <a:endParaRPr/>
           </a:p>
         </p:txBody>
       </p:sp>
@@ -4813,6 +4835,7 @@
           <a:lstStyle/>
           <a:p>
             <a:pPr algn="ctr"/>
+            <a:endParaRPr/>
           </a:p>
         </p:txBody>
       </p:sp>
@@ -4969,6 +4992,7 @@
           <a:lstStyle/>
           <a:p>
             <a:pPr algn="ctr"/>
+            <a:endParaRPr/>
           </a:p>
         </p:txBody>
       </p:sp>
@@ -5012,6 +5036,7 @@
           <a:lstStyle/>
           <a:p>
             <a:pPr algn="ctr"/>
+            <a:endParaRPr/>
           </a:p>
         </p:txBody>
       </p:sp>
@@ -5067,7 +5092,7 @@
           <a:noFill/>
         </p:spPr>
         <p:txBody>
-          <a:bodyPr wrap="square" anchor="t" lIns="38100" rIns="38100" tIns="25400" bIns="25400">
+          <a:bodyPr wrap="square" lIns="38100" tIns="25400" rIns="38100" bIns="25400" anchor="t">
             <a:noAutofit/>
           </a:bodyPr>
           <a:lstStyle/>
@@ -5089,9 +5114,6 @@
               </a:rPr>
               <a:t>Open the browser, log in with your source-mode superuser, load a context path, and decide whether the task needs Multi-Turn.</a:t>
             </a:r>
-            <a:endParaRPr sz="1400" b="0" i="0">
-              <a:latin typeface="Calibri"/>
-            </a:endParaRPr>
           </a:p>
         </p:txBody>
       </p:sp>
@@ -5104,7 +5126,7 @@
 </file>
 
 <file path=ppt/slides/slide12.xml><?xml version="1.0" encoding="utf-8"?>
-<p:sld xmlns:a="http://schemas.openxmlformats.org/drawingml/2006/main" xmlns:p="http://schemas.openxmlformats.org/presentationml/2006/main" xmlns:r="http://schemas.openxmlformats.org/officeDocument/2006/relationships">
+<p:sld xmlns:a="http://schemas.openxmlformats.org/drawingml/2006/main" xmlns:r="http://schemas.openxmlformats.org/officeDocument/2006/relationships" xmlns:p="http://schemas.openxmlformats.org/presentationml/2006/main">
   <p:cSld>
     <p:spTree>
       <p:nvGrpSpPr>
@@ -5112,7 +5134,14 @@
         <p:cNvGrpSpPr/>
         <p:nvPr/>
       </p:nvGrpSpPr>
-      <p:grpSpPr/>
+      <p:grpSpPr>
+        <a:xfrm>
+          <a:off x="0" y="0"/>
+          <a:ext cx="0" cy="0"/>
+          <a:chOff x="0" y="0"/>
+          <a:chExt cx="0" cy="0"/>
+        </a:xfrm>
+      </p:grpSpPr>
       <p:sp>
         <p:nvSpPr>
           <p:cNvPr id="2" name="Rectangle 1"/>
@@ -5153,6 +5182,7 @@
           <a:lstStyle/>
           <a:p>
             <a:pPr algn="ctr"/>
+            <a:endParaRPr/>
           </a:p>
         </p:txBody>
       </p:sp>
@@ -5196,6 +5226,7 @@
           <a:lstStyle/>
           <a:p>
             <a:pPr algn="ctr"/>
+            <a:endParaRPr/>
           </a:p>
         </p:txBody>
       </p:sp>
@@ -5239,6 +5270,7 @@
           <a:lstStyle/>
           <a:p>
             <a:pPr algn="ctr"/>
+            <a:endParaRPr/>
           </a:p>
         </p:txBody>
       </p:sp>
@@ -5282,6 +5314,7 @@
           <a:lstStyle/>
           <a:p>
             <a:pPr algn="ctr"/>
+            <a:endParaRPr/>
           </a:p>
         </p:txBody>
       </p:sp>
@@ -5325,6 +5358,7 @@
           <a:lstStyle/>
           <a:p>
             <a:pPr algn="ctr"/>
+            <a:endParaRPr/>
           </a:p>
         </p:txBody>
       </p:sp>
@@ -5440,6 +5474,7 @@
           <a:lstStyle/>
           <a:p>
             <a:pPr algn="ctr"/>
+            <a:endParaRPr/>
           </a:p>
         </p:txBody>
       </p:sp>
@@ -5555,6 +5590,7 @@
           <a:lstStyle/>
           <a:p>
             <a:pPr algn="ctr"/>
+            <a:endParaRPr/>
           </a:p>
         </p:txBody>
       </p:sp>
@@ -5670,6 +5706,7 @@
           <a:lstStyle/>
           <a:p>
             <a:pPr algn="ctr"/>
+            <a:endParaRPr/>
           </a:p>
         </p:txBody>
       </p:sp>
@@ -5785,6 +5822,7 @@
           <a:lstStyle/>
           <a:p>
             <a:pPr algn="ctr"/>
+            <a:endParaRPr/>
           </a:p>
         </p:txBody>
       </p:sp>
@@ -5900,6 +5938,7 @@
           <a:lstStyle/>
           <a:p>
             <a:pPr algn="ctr"/>
+            <a:endParaRPr/>
           </a:p>
         </p:txBody>
       </p:sp>
@@ -6015,6 +6054,7 @@
           <a:lstStyle/>
           <a:p>
             <a:pPr algn="ctr"/>
+            <a:endParaRPr/>
           </a:p>
         </p:txBody>
       </p:sp>
@@ -6095,6 +6135,7 @@
           <a:lstStyle/>
           <a:p>
             <a:pPr algn="ctr"/>
+            <a:endParaRPr/>
           </a:p>
         </p:txBody>
       </p:sp>
@@ -6138,6 +6179,7 @@
           <a:lstStyle/>
           <a:p>
             <a:pPr algn="ctr"/>
+            <a:endParaRPr/>
           </a:p>
         </p:txBody>
       </p:sp>
@@ -6193,7 +6235,7 @@
           <a:noFill/>
         </p:spPr>
         <p:txBody>
-          <a:bodyPr wrap="square" anchor="t" lIns="38100" rIns="38100" tIns="25400" bIns="25400">
+          <a:bodyPr wrap="square" lIns="38100" tIns="25400" rIns="38100" bIns="25400" anchor="t">
             <a:noAutofit/>
           </a:bodyPr>
           <a:lstStyle/>
@@ -6215,9 +6257,6 @@
               </a:rPr>
               <a:t>Run packaging only when preparing a Windows distribution.</a:t>
             </a:r>
-            <a:endParaRPr sz="1600" b="0" i="0">
-              <a:latin typeface="Calibri"/>
-            </a:endParaRPr>
           </a:p>
           <a:p>
             <a:pPr>
@@ -6237,9 +6276,6 @@
               </a:rPr>
               <a:t>The final distributable is the full `dist/Tlamatini_Release/` folder, not one executable copied out of context.</a:t>
             </a:r>
-            <a:endParaRPr sz="1600" b="0" i="0">
-              <a:latin typeface="Calibri"/>
-            </a:endParaRPr>
           </a:p>
           <a:p>
             <a:pPr>
@@ -6259,9 +6295,6 @@
               </a:rPr>
               <a:t>Installer scripts register shortcuts and `.flw` file associations and place the uninstaller next to the app.</a:t>
             </a:r>
-            <a:endParaRPr sz="1600" b="0" i="0">
-              <a:latin typeface="Calibri"/>
-            </a:endParaRPr>
           </a:p>
         </p:txBody>
       </p:sp>
@@ -6274,7 +6307,7 @@
 </file>
 
 <file path=ppt/slides/slide13.xml><?xml version="1.0" encoding="utf-8"?>
-<p:sld xmlns:a="http://schemas.openxmlformats.org/drawingml/2006/main" xmlns:p="http://schemas.openxmlformats.org/presentationml/2006/main" xmlns:r="http://schemas.openxmlformats.org/officeDocument/2006/relationships">
+<p:sld xmlns:a="http://schemas.openxmlformats.org/drawingml/2006/main" xmlns:r="http://schemas.openxmlformats.org/officeDocument/2006/relationships" xmlns:p="http://schemas.openxmlformats.org/presentationml/2006/main">
   <p:cSld>
     <p:spTree>
       <p:nvGrpSpPr>
@@ -6282,7 +6315,14 @@
         <p:cNvGrpSpPr/>
         <p:nvPr/>
       </p:nvGrpSpPr>
-      <p:grpSpPr/>
+      <p:grpSpPr>
+        <a:xfrm>
+          <a:off x="0" y="0"/>
+          <a:ext cx="0" cy="0"/>
+          <a:chOff x="0" y="0"/>
+          <a:chExt cx="0" cy="0"/>
+        </a:xfrm>
+      </p:grpSpPr>
       <p:sp>
         <p:nvSpPr>
           <p:cNvPr id="2" name="Rectangle 1"/>
@@ -6323,6 +6363,7 @@
           <a:lstStyle/>
           <a:p>
             <a:pPr algn="ctr"/>
+            <a:endParaRPr/>
           </a:p>
         </p:txBody>
       </p:sp>
@@ -6366,6 +6407,7 @@
           <a:lstStyle/>
           <a:p>
             <a:pPr algn="ctr"/>
+            <a:endParaRPr/>
           </a:p>
         </p:txBody>
       </p:sp>
@@ -6409,6 +6451,7 @@
           <a:lstStyle/>
           <a:p>
             <a:pPr algn="ctr"/>
+            <a:endParaRPr/>
           </a:p>
         </p:txBody>
       </p:sp>
@@ -6452,6 +6495,7 @@
           <a:lstStyle/>
           <a:p>
             <a:pPr algn="ctr"/>
+            <a:endParaRPr/>
           </a:p>
         </p:txBody>
       </p:sp>
@@ -6495,6 +6539,7 @@
           <a:lstStyle/>
           <a:p>
             <a:pPr algn="ctr"/>
+            <a:endParaRPr/>
           </a:p>
         </p:txBody>
       </p:sp>
@@ -6610,6 +6655,7 @@
           <a:lstStyle/>
           <a:p>
             <a:pPr algn="ctr"/>
+            <a:endParaRPr/>
           </a:p>
         </p:txBody>
       </p:sp>
@@ -6725,6 +6771,7 @@
           <a:lstStyle/>
           <a:p>
             <a:pPr algn="ctr"/>
+            <a:endParaRPr/>
           </a:p>
         </p:txBody>
       </p:sp>
@@ -6840,6 +6887,7 @@
           <a:lstStyle/>
           <a:p>
             <a:pPr algn="ctr"/>
+            <a:endParaRPr/>
           </a:p>
         </p:txBody>
       </p:sp>
@@ -6955,6 +7003,7 @@
           <a:lstStyle/>
           <a:p>
             <a:pPr algn="ctr"/>
+            <a:endParaRPr/>
           </a:p>
         </p:txBody>
       </p:sp>
@@ -7070,6 +7119,7 @@
           <a:lstStyle/>
           <a:p>
             <a:pPr algn="ctr"/>
+            <a:endParaRPr/>
           </a:p>
         </p:txBody>
       </p:sp>
@@ -7185,6 +7235,7 @@
           <a:lstStyle/>
           <a:p>
             <a:pPr algn="ctr"/>
+            <a:endParaRPr/>
           </a:p>
         </p:txBody>
       </p:sp>
@@ -7300,6 +7351,7 @@
           <a:lstStyle/>
           <a:p>
             <a:pPr algn="ctr"/>
+            <a:endParaRPr/>
           </a:p>
         </p:txBody>
       </p:sp>
@@ -7343,6 +7395,7 @@
           <a:lstStyle/>
           <a:p>
             <a:pPr algn="ctr"/>
+            <a:endParaRPr/>
           </a:p>
         </p:txBody>
       </p:sp>
@@ -7398,7 +7451,7 @@
           <a:noFill/>
         </p:spPr>
         <p:txBody>
-          <a:bodyPr wrap="square" anchor="t" lIns="38100" rIns="38100" tIns="25400" bIns="25400">
+          <a:bodyPr wrap="square" lIns="38100" tIns="25400" rIns="38100" bIns="25400" anchor="t">
             <a:noAutofit/>
           </a:bodyPr>
           <a:lstStyle/>
@@ -7420,9 +7473,6 @@
               </a:rPr>
               <a:t>3b6eb8e - Way too improving the execution chain with now "Exec report"!!, by angelahack1</a:t>
             </a:r>
-            <a:endParaRPr sz="1500" b="0" i="0">
-              <a:latin typeface="Calibri"/>
-            </a:endParaRPr>
           </a:p>
           <a:p>
             <a:pPr>
@@ -7442,9 +7492,6 @@
               </a:rPr>
               <a:t>Generated on April 17, 2026 11:50 PM UTC-0600</a:t>
             </a:r>
-            <a:endParaRPr sz="1500" b="0" i="0">
-              <a:latin typeface="Calibri"/>
-            </a:endParaRPr>
           </a:p>
           <a:p>
             <a:pPr>
@@ -7464,9 +7511,6 @@
               </a:rPr>
               <a:t>Python requirements: 62; binary or asset tracked files skipped from line count: 13</a:t>
             </a:r>
-            <a:endParaRPr sz="1500" b="0" i="0">
-              <a:latin typeface="Calibri"/>
-            </a:endParaRPr>
           </a:p>
         </p:txBody>
       </p:sp>
@@ -7479,7 +7523,7 @@
 </file>
 
 <file path=ppt/slides/slide14.xml><?xml version="1.0" encoding="utf-8"?>
-<p:sld xmlns:a="http://schemas.openxmlformats.org/drawingml/2006/main" xmlns:p="http://schemas.openxmlformats.org/presentationml/2006/main" xmlns:r="http://schemas.openxmlformats.org/officeDocument/2006/relationships">
+<p:sld xmlns:a="http://schemas.openxmlformats.org/drawingml/2006/main" xmlns:r="http://schemas.openxmlformats.org/officeDocument/2006/relationships" xmlns:p="http://schemas.openxmlformats.org/presentationml/2006/main">
   <p:cSld>
     <p:spTree>
       <p:nvGrpSpPr>
@@ -7487,7 +7531,14 @@
         <p:cNvGrpSpPr/>
         <p:nvPr/>
       </p:nvGrpSpPr>
-      <p:grpSpPr/>
+      <p:grpSpPr>
+        <a:xfrm>
+          <a:off x="0" y="0"/>
+          <a:ext cx="0" cy="0"/>
+          <a:chOff x="0" y="0"/>
+          <a:chExt cx="0" cy="0"/>
+        </a:xfrm>
+      </p:grpSpPr>
       <p:sp>
         <p:nvSpPr>
           <p:cNvPr id="2" name="Rectangle 1"/>
@@ -7528,6 +7579,7 @@
           <a:lstStyle/>
           <a:p>
             <a:pPr algn="ctr"/>
+            <a:endParaRPr/>
           </a:p>
         </p:txBody>
       </p:sp>
@@ -7571,6 +7623,7 @@
           <a:lstStyle/>
           <a:p>
             <a:pPr algn="ctr"/>
+            <a:endParaRPr/>
           </a:p>
         </p:txBody>
       </p:sp>
@@ -7614,6 +7667,7 @@
           <a:lstStyle/>
           <a:p>
             <a:pPr algn="ctr"/>
+            <a:endParaRPr/>
           </a:p>
         </p:txBody>
       </p:sp>
@@ -7657,6 +7711,7 @@
           <a:lstStyle/>
           <a:p>
             <a:pPr algn="ctr"/>
+            <a:endParaRPr/>
           </a:p>
         </p:txBody>
       </p:sp>
@@ -7700,6 +7755,7 @@
           <a:lstStyle/>
           <a:p>
             <a:pPr algn="ctr"/>
+            <a:endParaRPr/>
           </a:p>
         </p:txBody>
       </p:sp>
@@ -7815,6 +7871,7 @@
           <a:lstStyle/>
           <a:p>
             <a:pPr algn="ctr"/>
+            <a:endParaRPr/>
           </a:p>
         </p:txBody>
       </p:sp>
@@ -7930,6 +7987,7 @@
           <a:lstStyle/>
           <a:p>
             <a:pPr algn="ctr"/>
+            <a:endParaRPr/>
           </a:p>
         </p:txBody>
       </p:sp>
@@ -8045,6 +8103,7 @@
           <a:lstStyle/>
           <a:p>
             <a:pPr algn="ctr"/>
+            <a:endParaRPr/>
           </a:p>
         </p:txBody>
       </p:sp>
@@ -8176,7 +8235,7 @@
 </file>
 
 <file path=ppt/slides/slide15.xml><?xml version="1.0" encoding="utf-8"?>
-<p:sld xmlns:a="http://schemas.openxmlformats.org/drawingml/2006/main" xmlns:p="http://schemas.openxmlformats.org/presentationml/2006/main" xmlns:r="http://schemas.openxmlformats.org/officeDocument/2006/relationships">
+<p:sld xmlns:a="http://schemas.openxmlformats.org/drawingml/2006/main" xmlns:r="http://schemas.openxmlformats.org/officeDocument/2006/relationships" xmlns:p="http://schemas.openxmlformats.org/presentationml/2006/main">
   <p:cSld>
     <p:spTree>
       <p:nvGrpSpPr>
@@ -8184,7 +8243,14 @@
         <p:cNvGrpSpPr/>
         <p:nvPr/>
       </p:nvGrpSpPr>
-      <p:grpSpPr/>
+      <p:grpSpPr>
+        <a:xfrm>
+          <a:off x="0" y="0"/>
+          <a:ext cx="0" cy="0"/>
+          <a:chOff x="0" y="0"/>
+          <a:chExt cx="0" cy="0"/>
+        </a:xfrm>
+      </p:grpSpPr>
       <p:sp>
         <p:nvSpPr>
           <p:cNvPr id="2" name="Rectangle 1"/>
@@ -8225,6 +8291,7 @@
           <a:lstStyle/>
           <a:p>
             <a:pPr algn="ctr"/>
+            <a:endParaRPr/>
           </a:p>
         </p:txBody>
       </p:sp>
@@ -8268,6 +8335,7 @@
           <a:lstStyle/>
           <a:p>
             <a:pPr algn="ctr"/>
+            <a:endParaRPr/>
           </a:p>
         </p:txBody>
       </p:sp>
@@ -8311,6 +8379,7 @@
           <a:lstStyle/>
           <a:p>
             <a:pPr algn="ctr"/>
+            <a:endParaRPr/>
           </a:p>
         </p:txBody>
       </p:sp>
@@ -8354,6 +8423,7 @@
           <a:lstStyle/>
           <a:p>
             <a:pPr algn="ctr"/>
+            <a:endParaRPr/>
           </a:p>
         </p:txBody>
       </p:sp>
@@ -8397,6 +8467,7 @@
           <a:lstStyle/>
           <a:p>
             <a:pPr algn="ctr"/>
+            <a:endParaRPr/>
           </a:p>
         </p:txBody>
       </p:sp>
@@ -8528,7 +8599,7 @@
 </file>
 
 <file path=ppt/slides/slide16.xml><?xml version="1.0" encoding="utf-8"?>
-<p:sld xmlns:a="http://schemas.openxmlformats.org/drawingml/2006/main" xmlns:p="http://schemas.openxmlformats.org/presentationml/2006/main" xmlns:r="http://schemas.openxmlformats.org/officeDocument/2006/relationships">
+<p:sld xmlns:a="http://schemas.openxmlformats.org/drawingml/2006/main" xmlns:r="http://schemas.openxmlformats.org/officeDocument/2006/relationships" xmlns:p="http://schemas.openxmlformats.org/presentationml/2006/main">
   <p:cSld>
     <p:spTree>
       <p:nvGrpSpPr>
@@ -8536,7 +8607,14 @@
         <p:cNvGrpSpPr/>
         <p:nvPr/>
       </p:nvGrpSpPr>
-      <p:grpSpPr/>
+      <p:grpSpPr>
+        <a:xfrm>
+          <a:off x="0" y="0"/>
+          <a:ext cx="0" cy="0"/>
+          <a:chOff x="0" y="0"/>
+          <a:chExt cx="0" cy="0"/>
+        </a:xfrm>
+      </p:grpSpPr>
       <p:sp>
         <p:nvSpPr>
           <p:cNvPr id="2" name="Rectangle 1"/>
@@ -8577,6 +8655,7 @@
           <a:lstStyle/>
           <a:p>
             <a:pPr algn="ctr"/>
+            <a:endParaRPr/>
           </a:p>
         </p:txBody>
       </p:sp>
@@ -8620,6 +8699,7 @@
           <a:lstStyle/>
           <a:p>
             <a:pPr algn="ctr"/>
+            <a:endParaRPr/>
           </a:p>
         </p:txBody>
       </p:sp>
@@ -8663,6 +8743,7 @@
           <a:lstStyle/>
           <a:p>
             <a:pPr algn="ctr"/>
+            <a:endParaRPr/>
           </a:p>
         </p:txBody>
       </p:sp>
@@ -8706,6 +8787,7 @@
           <a:lstStyle/>
           <a:p>
             <a:pPr algn="ctr"/>
+            <a:endParaRPr/>
           </a:p>
         </p:txBody>
       </p:sp>
@@ -8749,6 +8831,7 @@
           <a:lstStyle/>
           <a:p>
             <a:pPr algn="ctr"/>
+            <a:endParaRPr/>
           </a:p>
         </p:txBody>
       </p:sp>
@@ -8864,6 +8947,7 @@
           <a:lstStyle/>
           <a:p>
             <a:pPr algn="ctr"/>
+            <a:endParaRPr/>
           </a:p>
         </p:txBody>
       </p:sp>
@@ -8907,6 +8991,7 @@
           <a:lstStyle/>
           <a:p>
             <a:pPr algn="ctr"/>
+            <a:endParaRPr/>
           </a:p>
         </p:txBody>
       </p:sp>
@@ -8962,7 +9047,7 @@
           <a:noFill/>
         </p:spPr>
         <p:txBody>
-          <a:bodyPr wrap="square" anchor="t" lIns="38100" rIns="38100" tIns="25400" bIns="25400">
+          <a:bodyPr wrap="square" lIns="38100" tIns="25400" rIns="38100" bIns="25400" anchor="t">
             <a:noAutofit/>
           </a:bodyPr>
           <a:lstStyle/>
@@ -8984,9 +9069,6 @@
               </a:rPr>
               <a:t>2026-04-17 | 3b6eb8e | Way too improving the execution chain with now "Exec report"!!, by angelahack1</a:t>
             </a:r>
-            <a:endParaRPr sz="1300" b="0" i="0">
-              <a:latin typeface="Calibri"/>
-            </a:endParaRPr>
           </a:p>
           <a:p>
             <a:pPr>
@@ -9006,9 +9088,6 @@
               </a:rPr>
               <a:t>2026-04-17 | d46ddbb | Fixing some drawbacks in frozen Tlamatini's runtime execution.</a:t>
             </a:r>
-            <a:endParaRPr sz="1300" b="0" i="0">
-              <a:latin typeface="Calibri"/>
-            </a:endParaRPr>
           </a:p>
           <a:p>
             <a:pPr>
@@ -9028,9 +9107,6 @@
               </a:rPr>
               <a:t>2026-04-17 | 17d5760 | Updating to a more graphical documentation</a:t>
             </a:r>
-            <a:endParaRPr sz="1300" b="0" i="0">
-              <a:latin typeface="Calibri"/>
-            </a:endParaRPr>
           </a:p>
           <a:p>
             <a:pPr>
@@ -9050,9 +9126,6 @@
               </a:rPr>
               <a:t>2026-04-17 | d7a8e66 | Update documentation with the laatest fixings, by angelahack1</a:t>
             </a:r>
-            <a:endParaRPr sz="1300" b="0" i="0">
-              <a:latin typeface="Calibri"/>
-            </a:endParaRPr>
           </a:p>
           <a:p>
             <a:pPr>
@@ -9072,9 +9145,6 @@
               </a:rPr>
               <a:t>2026-04-16 | 0249c76 | Improving multiturn, tested for installing assets, and added a new video, by angelahack1</a:t>
             </a:r>
-            <a:endParaRPr sz="1300" b="0" i="0">
-              <a:latin typeface="Calibri"/>
-            </a:endParaRPr>
           </a:p>
           <a:p>
             <a:pPr>
@@ -9094,9 +9164,6 @@
               </a:rPr>
               <a:t>2026-04-15 | 9abade4 | Adding video links to README.md, by angelahack1</a:t>
             </a:r>
-            <a:endParaRPr sz="1300" b="0" i="0">
-              <a:latin typeface="Calibri"/>
-            </a:endParaRPr>
           </a:p>
         </p:txBody>
       </p:sp>
@@ -9109,7 +9176,7 @@
 </file>
 
 <file path=ppt/slides/slide17.xml><?xml version="1.0" encoding="utf-8"?>
-<p:sld xmlns:a="http://schemas.openxmlformats.org/drawingml/2006/main" xmlns:p="http://schemas.openxmlformats.org/presentationml/2006/main" xmlns:r="http://schemas.openxmlformats.org/officeDocument/2006/relationships">
+<p:sld xmlns:a="http://schemas.openxmlformats.org/drawingml/2006/main" xmlns:r="http://schemas.openxmlformats.org/officeDocument/2006/relationships" xmlns:p="http://schemas.openxmlformats.org/presentationml/2006/main">
   <p:cSld>
     <p:spTree>
       <p:nvGrpSpPr>
@@ -9117,7 +9184,14 @@
         <p:cNvGrpSpPr/>
         <p:nvPr/>
       </p:nvGrpSpPr>
-      <p:grpSpPr/>
+      <p:grpSpPr>
+        <a:xfrm>
+          <a:off x="0" y="0"/>
+          <a:ext cx="0" cy="0"/>
+          <a:chOff x="0" y="0"/>
+          <a:chExt cx="0" cy="0"/>
+        </a:xfrm>
+      </p:grpSpPr>
       <p:sp>
         <p:nvSpPr>
           <p:cNvPr id="2" name="Rectangle 1"/>
@@ -9158,6 +9232,7 @@
           <a:lstStyle/>
           <a:p>
             <a:pPr algn="ctr"/>
+            <a:endParaRPr/>
           </a:p>
         </p:txBody>
       </p:sp>
@@ -9201,6 +9276,7 @@
           <a:lstStyle/>
           <a:p>
             <a:pPr algn="ctr"/>
+            <a:endParaRPr/>
           </a:p>
         </p:txBody>
       </p:sp>
@@ -9244,6 +9320,7 @@
           <a:lstStyle/>
           <a:p>
             <a:pPr algn="ctr"/>
+            <a:endParaRPr/>
           </a:p>
         </p:txBody>
       </p:sp>
@@ -9287,6 +9364,7 @@
           <a:lstStyle/>
           <a:p>
             <a:pPr algn="ctr"/>
+            <a:endParaRPr/>
           </a:p>
         </p:txBody>
       </p:sp>
@@ -9330,6 +9408,7 @@
           <a:lstStyle/>
           <a:p>
             <a:pPr algn="ctr"/>
+            <a:endParaRPr/>
           </a:p>
         </p:txBody>
       </p:sp>
@@ -9477,7 +9556,7 @@
 </file>
 
 <file path=ppt/slides/slide18.xml><?xml version="1.0" encoding="utf-8"?>
-<p:sld xmlns:a="http://schemas.openxmlformats.org/drawingml/2006/main" xmlns:p="http://schemas.openxmlformats.org/presentationml/2006/main" xmlns:r="http://schemas.openxmlformats.org/officeDocument/2006/relationships">
+<p:sld xmlns:a="http://schemas.openxmlformats.org/drawingml/2006/main" xmlns:r="http://schemas.openxmlformats.org/officeDocument/2006/relationships" xmlns:p="http://schemas.openxmlformats.org/presentationml/2006/main">
   <p:cSld>
     <p:spTree>
       <p:nvGrpSpPr>
@@ -9485,7 +9564,14 @@
         <p:cNvGrpSpPr/>
         <p:nvPr/>
       </p:nvGrpSpPr>
-      <p:grpSpPr/>
+      <p:grpSpPr>
+        <a:xfrm>
+          <a:off x="0" y="0"/>
+          <a:ext cx="0" cy="0"/>
+          <a:chOff x="0" y="0"/>
+          <a:chExt cx="0" cy="0"/>
+        </a:xfrm>
+      </p:grpSpPr>
       <p:sp>
         <p:nvSpPr>
           <p:cNvPr id="2" name="Rectangle 1"/>
@@ -9526,6 +9612,7 @@
           <a:lstStyle/>
           <a:p>
             <a:pPr algn="ctr"/>
+            <a:endParaRPr/>
           </a:p>
         </p:txBody>
       </p:sp>
@@ -9569,6 +9656,7 @@
           <a:lstStyle/>
           <a:p>
             <a:pPr algn="ctr"/>
+            <a:endParaRPr/>
           </a:p>
         </p:txBody>
       </p:sp>
@@ -9612,6 +9700,7 @@
           <a:lstStyle/>
           <a:p>
             <a:pPr algn="ctr"/>
+            <a:endParaRPr/>
           </a:p>
         </p:txBody>
       </p:sp>
@@ -9655,6 +9744,7 @@
           <a:lstStyle/>
           <a:p>
             <a:pPr algn="ctr"/>
+            <a:endParaRPr/>
           </a:p>
         </p:txBody>
       </p:sp>
@@ -9698,6 +9788,7 @@
           <a:lstStyle/>
           <a:p>
             <a:pPr algn="ctr"/>
+            <a:endParaRPr/>
           </a:p>
         </p:txBody>
       </p:sp>
@@ -9845,7 +9936,7 @@
 </file>
 
 <file path=ppt/slides/slide19.xml><?xml version="1.0" encoding="utf-8"?>
-<p:sld xmlns:a="http://schemas.openxmlformats.org/drawingml/2006/main" xmlns:p="http://schemas.openxmlformats.org/presentationml/2006/main" xmlns:r="http://schemas.openxmlformats.org/officeDocument/2006/relationships">
+<p:sld xmlns:a="http://schemas.openxmlformats.org/drawingml/2006/main" xmlns:r="http://schemas.openxmlformats.org/officeDocument/2006/relationships" xmlns:p="http://schemas.openxmlformats.org/presentationml/2006/main">
   <p:cSld>
     <p:spTree>
       <p:nvGrpSpPr>
@@ -9853,7 +9944,14 @@
         <p:cNvGrpSpPr/>
         <p:nvPr/>
       </p:nvGrpSpPr>
-      <p:grpSpPr/>
+      <p:grpSpPr>
+        <a:xfrm>
+          <a:off x="0" y="0"/>
+          <a:ext cx="0" cy="0"/>
+          <a:chOff x="0" y="0"/>
+          <a:chExt cx="0" cy="0"/>
+        </a:xfrm>
+      </p:grpSpPr>
       <p:sp>
         <p:nvSpPr>
           <p:cNvPr id="2" name="Rectangle 1"/>
@@ -9894,6 +9992,7 @@
           <a:lstStyle/>
           <a:p>
             <a:pPr algn="ctr"/>
+            <a:endParaRPr/>
           </a:p>
         </p:txBody>
       </p:sp>
@@ -9937,6 +10036,7 @@
           <a:lstStyle/>
           <a:p>
             <a:pPr algn="ctr"/>
+            <a:endParaRPr/>
           </a:p>
         </p:txBody>
       </p:sp>
@@ -9980,6 +10080,7 @@
           <a:lstStyle/>
           <a:p>
             <a:pPr algn="ctr"/>
+            <a:endParaRPr/>
           </a:p>
         </p:txBody>
       </p:sp>
@@ -10023,6 +10124,7 @@
           <a:lstStyle/>
           <a:p>
             <a:pPr algn="ctr"/>
+            <a:endParaRPr/>
           </a:p>
         </p:txBody>
       </p:sp>
@@ -10066,6 +10168,7 @@
           <a:lstStyle/>
           <a:p>
             <a:pPr algn="ctr"/>
+            <a:endParaRPr/>
           </a:p>
         </p:txBody>
       </p:sp>
@@ -10213,7 +10316,7 @@
 </file>
 
 <file path=ppt/slides/slide2.xml><?xml version="1.0" encoding="utf-8"?>
-<p:sld xmlns:a="http://schemas.openxmlformats.org/drawingml/2006/main" xmlns:p="http://schemas.openxmlformats.org/presentationml/2006/main" xmlns:r="http://schemas.openxmlformats.org/officeDocument/2006/relationships">
+<p:sld xmlns:a="http://schemas.openxmlformats.org/drawingml/2006/main" xmlns:r="http://schemas.openxmlformats.org/officeDocument/2006/relationships" xmlns:p="http://schemas.openxmlformats.org/presentationml/2006/main">
   <p:cSld>
     <p:spTree>
       <p:nvGrpSpPr>
@@ -10221,7 +10324,14 @@
         <p:cNvGrpSpPr/>
         <p:nvPr/>
       </p:nvGrpSpPr>
-      <p:grpSpPr/>
+      <p:grpSpPr>
+        <a:xfrm>
+          <a:off x="0" y="0"/>
+          <a:ext cx="0" cy="0"/>
+          <a:chOff x="0" y="0"/>
+          <a:chExt cx="0" cy="0"/>
+        </a:xfrm>
+      </p:grpSpPr>
       <p:sp>
         <p:nvSpPr>
           <p:cNvPr id="2" name="Rectangle 1"/>
@@ -10262,6 +10372,7 @@
           <a:lstStyle/>
           <a:p>
             <a:pPr algn="ctr"/>
+            <a:endParaRPr/>
           </a:p>
         </p:txBody>
       </p:sp>
@@ -10305,6 +10416,7 @@
           <a:lstStyle/>
           <a:p>
             <a:pPr algn="ctr"/>
+            <a:endParaRPr/>
           </a:p>
         </p:txBody>
       </p:sp>
@@ -10348,6 +10460,7 @@
           <a:lstStyle/>
           <a:p>
             <a:pPr algn="ctr"/>
+            <a:endParaRPr/>
           </a:p>
         </p:txBody>
       </p:sp>
@@ -10391,6 +10504,7 @@
           <a:lstStyle/>
           <a:p>
             <a:pPr algn="ctr"/>
+            <a:endParaRPr/>
           </a:p>
         </p:txBody>
       </p:sp>
@@ -10434,6 +10548,7 @@
           <a:lstStyle/>
           <a:p>
             <a:pPr algn="ctr"/>
+            <a:endParaRPr/>
           </a:p>
         </p:txBody>
       </p:sp>
@@ -10549,6 +10664,7 @@
           <a:lstStyle/>
           <a:p>
             <a:pPr algn="ctr"/>
+            <a:endParaRPr/>
           </a:p>
         </p:txBody>
       </p:sp>
@@ -10592,6 +10708,7 @@
           <a:lstStyle/>
           <a:p>
             <a:pPr algn="ctr"/>
+            <a:endParaRPr/>
           </a:p>
         </p:txBody>
       </p:sp>
@@ -10647,7 +10764,7 @@
           <a:noFill/>
         </p:spPr>
         <p:txBody>
-          <a:bodyPr wrap="square" anchor="t" lIns="38100" rIns="38100" tIns="25400" bIns="25400">
+          <a:bodyPr wrap="square" lIns="38100" tIns="25400" rIns="38100" bIns="25400" anchor="t">
             <a:noAutofit/>
           </a:bodyPr>
           <a:lstStyle/>
@@ -10669,9 +10786,6 @@
               </a:rPr>
               <a:t>Tlamatini is a local-first AI developer assistant built with Django, Django Channels, LangChain, LangGraph, FAISS/BM25 retrieval, and a large in-repository agent application.</a:t>
             </a:r>
-            <a:endParaRPr sz="1600" b="0" i="0">
-              <a:latin typeface="Calibri"/>
-            </a:endParaRPr>
           </a:p>
           <a:p>
             <a:pPr>
@@ -10691,9 +10805,6 @@
               </a:rPr>
               <a:t>It combines a browser chat surface, a Retrieval-Augmented Generation stack, a Multi-Turn tool executor, MCP-backed context providers, wrapped chat-agent runtimes, and a visual Agentic Control Panel for workflow design.</a:t>
             </a:r>
-            <a:endParaRPr sz="1600" b="0" i="0">
-              <a:latin typeface="Calibri"/>
-            </a:endParaRPr>
           </a:p>
           <a:p>
             <a:pPr>
@@ -10713,9 +10824,6 @@
               </a:rPr>
               <a:t>The platform is designed for development operations: codebase analysis, file and directory context, command execution, Python execution, screenshots, web/search helpers, notifications, DevOps tools, local model operation, and Windows packaging.</a:t>
             </a:r>
-            <a:endParaRPr sz="1600" b="0" i="0">
-              <a:latin typeface="Calibri"/>
-            </a:endParaRPr>
           </a:p>
         </p:txBody>
       </p:sp>
@@ -10761,6 +10869,7 @@
           <a:lstStyle/>
           <a:p>
             <a:pPr algn="ctr"/>
+            <a:endParaRPr/>
           </a:p>
         </p:txBody>
       </p:sp>
@@ -10804,6 +10913,7 @@
           <a:lstStyle/>
           <a:p>
             <a:pPr algn="ctr"/>
+            <a:endParaRPr/>
           </a:p>
         </p:txBody>
       </p:sp>
@@ -10859,7 +10969,7 @@
           <a:noFill/>
         </p:spPr>
         <p:txBody>
-          <a:bodyPr wrap="square" anchor="t" lIns="38100" rIns="38100" tIns="25400" bIns="25400">
+          <a:bodyPr wrap="square" lIns="38100" tIns="25400" rIns="38100" bIns="25400" anchor="t">
             <a:noAutofit/>
           </a:bodyPr>
           <a:lstStyle/>
@@ -10881,9 +10991,6 @@
               </a:rPr>
               <a:t>Chat page at `/agent/` for context-grounded Q&amp;A, code generation, tool calls, and Multi-Turn execution.</a:t>
             </a:r>
-            <a:endParaRPr sz="1600" b="0" i="0">
-              <a:latin typeface="Calibri"/>
-            </a:endParaRPr>
           </a:p>
           <a:p>
             <a:pPr>
@@ -10903,9 +11010,6 @@
               </a:rPr>
               <a:t>Agentic Control Panel at `/agentic_control_panel/` for visual workflow design.</a:t>
             </a:r>
-            <a:endParaRPr sz="1600" b="0" i="0">
-              <a:latin typeface="Calibri"/>
-            </a:endParaRPr>
           </a:p>
           <a:p>
             <a:pPr>
@@ -10925,9 +11029,6 @@
               </a:rPr>
               <a:t>Django admin and config dialogs for MCPs, tools, agents, users, and persistent settings.</a:t>
             </a:r>
-            <a:endParaRPr sz="1600" b="0" i="0">
-              <a:latin typeface="Calibri"/>
-            </a:endParaRPr>
           </a:p>
         </p:txBody>
       </p:sp>
@@ -10940,7 +11041,7 @@
 </file>
 
 <file path=ppt/slides/slide20.xml><?xml version="1.0" encoding="utf-8"?>
-<p:sld xmlns:a="http://schemas.openxmlformats.org/drawingml/2006/main" xmlns:p="http://schemas.openxmlformats.org/presentationml/2006/main" xmlns:r="http://schemas.openxmlformats.org/officeDocument/2006/relationships">
+<p:sld xmlns:a="http://schemas.openxmlformats.org/drawingml/2006/main" xmlns:r="http://schemas.openxmlformats.org/officeDocument/2006/relationships" xmlns:p="http://schemas.openxmlformats.org/presentationml/2006/main">
   <p:cSld>
     <p:spTree>
       <p:nvGrpSpPr>
@@ -10948,7 +11049,14 @@
         <p:cNvGrpSpPr/>
         <p:nvPr/>
       </p:nvGrpSpPr>
-      <p:grpSpPr/>
+      <p:grpSpPr>
+        <a:xfrm>
+          <a:off x="0" y="0"/>
+          <a:ext cx="0" cy="0"/>
+          <a:chOff x="0" y="0"/>
+          <a:chExt cx="0" cy="0"/>
+        </a:xfrm>
+      </p:grpSpPr>
       <p:sp>
         <p:nvSpPr>
           <p:cNvPr id="2" name="Rectangle 1"/>
@@ -10989,6 +11097,7 @@
           <a:lstStyle/>
           <a:p>
             <a:pPr algn="ctr"/>
+            <a:endParaRPr/>
           </a:p>
         </p:txBody>
       </p:sp>
@@ -11032,6 +11141,7 @@
           <a:lstStyle/>
           <a:p>
             <a:pPr algn="ctr"/>
+            <a:endParaRPr/>
           </a:p>
         </p:txBody>
       </p:sp>
@@ -11075,6 +11185,7 @@
           <a:lstStyle/>
           <a:p>
             <a:pPr algn="ctr"/>
+            <a:endParaRPr/>
           </a:p>
         </p:txBody>
       </p:sp>
@@ -11118,6 +11229,7 @@
           <a:lstStyle/>
           <a:p>
             <a:pPr algn="ctr"/>
+            <a:endParaRPr/>
           </a:p>
         </p:txBody>
       </p:sp>
@@ -11161,6 +11273,7 @@
           <a:lstStyle/>
           <a:p>
             <a:pPr algn="ctr"/>
+            <a:endParaRPr/>
           </a:p>
         </p:txBody>
       </p:sp>
@@ -11308,7 +11421,7 @@
 </file>
 
 <file path=ppt/slides/slide21.xml><?xml version="1.0" encoding="utf-8"?>
-<p:sld xmlns:a="http://schemas.openxmlformats.org/drawingml/2006/main" xmlns:p="http://schemas.openxmlformats.org/presentationml/2006/main" xmlns:r="http://schemas.openxmlformats.org/officeDocument/2006/relationships">
+<p:sld xmlns:a="http://schemas.openxmlformats.org/drawingml/2006/main" xmlns:r="http://schemas.openxmlformats.org/officeDocument/2006/relationships" xmlns:p="http://schemas.openxmlformats.org/presentationml/2006/main">
   <p:cSld>
     <p:spTree>
       <p:nvGrpSpPr>
@@ -11316,7 +11429,14 @@
         <p:cNvGrpSpPr/>
         <p:nvPr/>
       </p:nvGrpSpPr>
-      <p:grpSpPr/>
+      <p:grpSpPr>
+        <a:xfrm>
+          <a:off x="0" y="0"/>
+          <a:ext cx="0" cy="0"/>
+          <a:chOff x="0" y="0"/>
+          <a:chExt cx="0" cy="0"/>
+        </a:xfrm>
+      </p:grpSpPr>
       <p:sp>
         <p:nvSpPr>
           <p:cNvPr id="2" name="Rectangle 1"/>
@@ -11357,6 +11477,7 @@
           <a:lstStyle/>
           <a:p>
             <a:pPr algn="ctr"/>
+            <a:endParaRPr/>
           </a:p>
         </p:txBody>
       </p:sp>
@@ -11400,6 +11521,7 @@
           <a:lstStyle/>
           <a:p>
             <a:pPr algn="ctr"/>
+            <a:endParaRPr/>
           </a:p>
         </p:txBody>
       </p:sp>
@@ -11443,6 +11565,7 @@
           <a:lstStyle/>
           <a:p>
             <a:pPr algn="ctr"/>
+            <a:endParaRPr/>
           </a:p>
         </p:txBody>
       </p:sp>
@@ -11486,6 +11609,7 @@
           <a:lstStyle/>
           <a:p>
             <a:pPr algn="ctr"/>
+            <a:endParaRPr/>
           </a:p>
         </p:txBody>
       </p:sp>
@@ -11529,6 +11653,7 @@
           <a:lstStyle/>
           <a:p>
             <a:pPr algn="ctr"/>
+            <a:endParaRPr/>
           </a:p>
         </p:txBody>
       </p:sp>
@@ -11676,7 +11801,7 @@
 </file>
 
 <file path=ppt/slides/slide22.xml><?xml version="1.0" encoding="utf-8"?>
-<p:sld xmlns:a="http://schemas.openxmlformats.org/drawingml/2006/main" xmlns:p="http://schemas.openxmlformats.org/presentationml/2006/main" xmlns:r="http://schemas.openxmlformats.org/officeDocument/2006/relationships">
+<p:sld xmlns:a="http://schemas.openxmlformats.org/drawingml/2006/main" xmlns:r="http://schemas.openxmlformats.org/officeDocument/2006/relationships" xmlns:p="http://schemas.openxmlformats.org/presentationml/2006/main">
   <p:cSld>
     <p:spTree>
       <p:nvGrpSpPr>
@@ -11684,7 +11809,14 @@
         <p:cNvGrpSpPr/>
         <p:nvPr/>
       </p:nvGrpSpPr>
-      <p:grpSpPr/>
+      <p:grpSpPr>
+        <a:xfrm>
+          <a:off x="0" y="0"/>
+          <a:ext cx="0" cy="0"/>
+          <a:chOff x="0" y="0"/>
+          <a:chExt cx="0" cy="0"/>
+        </a:xfrm>
+      </p:grpSpPr>
       <p:sp>
         <p:nvSpPr>
           <p:cNvPr id="2" name="Rectangle 1"/>
@@ -11725,6 +11857,7 @@
           <a:lstStyle/>
           <a:p>
             <a:pPr algn="ctr"/>
+            <a:endParaRPr/>
           </a:p>
         </p:txBody>
       </p:sp>
@@ -11768,6 +11901,7 @@
           <a:lstStyle/>
           <a:p>
             <a:pPr algn="ctr"/>
+            <a:endParaRPr/>
           </a:p>
         </p:txBody>
       </p:sp>
@@ -11811,6 +11945,7 @@
           <a:lstStyle/>
           <a:p>
             <a:pPr algn="ctr"/>
+            <a:endParaRPr/>
           </a:p>
         </p:txBody>
       </p:sp>
@@ -11854,6 +11989,7 @@
           <a:lstStyle/>
           <a:p>
             <a:pPr algn="ctr"/>
+            <a:endParaRPr/>
           </a:p>
         </p:txBody>
       </p:sp>
@@ -11897,6 +12033,7 @@
           <a:lstStyle/>
           <a:p>
             <a:pPr algn="ctr"/>
+            <a:endParaRPr/>
           </a:p>
         </p:txBody>
       </p:sp>
@@ -12044,7 +12181,7 @@
 </file>
 
 <file path=ppt/slides/slide23.xml><?xml version="1.0" encoding="utf-8"?>
-<p:sld xmlns:a="http://schemas.openxmlformats.org/drawingml/2006/main" xmlns:p="http://schemas.openxmlformats.org/presentationml/2006/main" xmlns:r="http://schemas.openxmlformats.org/officeDocument/2006/relationships">
+<p:sld xmlns:a="http://schemas.openxmlformats.org/drawingml/2006/main" xmlns:r="http://schemas.openxmlformats.org/officeDocument/2006/relationships" xmlns:p="http://schemas.openxmlformats.org/presentationml/2006/main">
   <p:cSld>
     <p:spTree>
       <p:nvGrpSpPr>
@@ -12052,7 +12189,14 @@
         <p:cNvGrpSpPr/>
         <p:nvPr/>
       </p:nvGrpSpPr>
-      <p:grpSpPr/>
+      <p:grpSpPr>
+        <a:xfrm>
+          <a:off x="0" y="0"/>
+          <a:ext cx="0" cy="0"/>
+          <a:chOff x="0" y="0"/>
+          <a:chExt cx="0" cy="0"/>
+        </a:xfrm>
+      </p:grpSpPr>
       <p:sp>
         <p:nvSpPr>
           <p:cNvPr id="2" name="Rectangle 1"/>
@@ -12093,6 +12237,7 @@
           <a:lstStyle/>
           <a:p>
             <a:pPr algn="ctr"/>
+            <a:endParaRPr/>
           </a:p>
         </p:txBody>
       </p:sp>
@@ -12136,6 +12281,7 @@
           <a:lstStyle/>
           <a:p>
             <a:pPr algn="ctr"/>
+            <a:endParaRPr/>
           </a:p>
         </p:txBody>
       </p:sp>
@@ -12179,6 +12325,7 @@
           <a:lstStyle/>
           <a:p>
             <a:pPr algn="ctr"/>
+            <a:endParaRPr/>
           </a:p>
         </p:txBody>
       </p:sp>
@@ -12222,6 +12369,7 @@
           <a:lstStyle/>
           <a:p>
             <a:pPr algn="ctr"/>
+            <a:endParaRPr/>
           </a:p>
         </p:txBody>
       </p:sp>
@@ -12265,6 +12413,7 @@
           <a:lstStyle/>
           <a:p>
             <a:pPr algn="ctr"/>
+            <a:endParaRPr/>
           </a:p>
         </p:txBody>
       </p:sp>
@@ -12412,7 +12561,7 @@
 </file>
 
 <file path=ppt/slides/slide24.xml><?xml version="1.0" encoding="utf-8"?>
-<p:sld xmlns:a="http://schemas.openxmlformats.org/drawingml/2006/main" xmlns:p="http://schemas.openxmlformats.org/presentationml/2006/main" xmlns:r="http://schemas.openxmlformats.org/officeDocument/2006/relationships">
+<p:sld xmlns:a="http://schemas.openxmlformats.org/drawingml/2006/main" xmlns:r="http://schemas.openxmlformats.org/officeDocument/2006/relationships" xmlns:p="http://schemas.openxmlformats.org/presentationml/2006/main">
   <p:cSld>
     <p:spTree>
       <p:nvGrpSpPr>
@@ -12420,7 +12569,14 @@
         <p:cNvGrpSpPr/>
         <p:nvPr/>
       </p:nvGrpSpPr>
-      <p:grpSpPr/>
+      <p:grpSpPr>
+        <a:xfrm>
+          <a:off x="0" y="0"/>
+          <a:ext cx="0" cy="0"/>
+          <a:chOff x="0" y="0"/>
+          <a:chExt cx="0" cy="0"/>
+        </a:xfrm>
+      </p:grpSpPr>
       <p:sp>
         <p:nvSpPr>
           <p:cNvPr id="2" name="Rectangle 1"/>
@@ -12461,6 +12617,7 @@
           <a:lstStyle/>
           <a:p>
             <a:pPr algn="ctr"/>
+            <a:endParaRPr/>
           </a:p>
         </p:txBody>
       </p:sp>
@@ -12504,6 +12661,7 @@
           <a:lstStyle/>
           <a:p>
             <a:pPr algn="ctr"/>
+            <a:endParaRPr/>
           </a:p>
         </p:txBody>
       </p:sp>
@@ -12547,6 +12705,7 @@
           <a:lstStyle/>
           <a:p>
             <a:pPr algn="ctr"/>
+            <a:endParaRPr/>
           </a:p>
         </p:txBody>
       </p:sp>
@@ -12590,6 +12749,7 @@
           <a:lstStyle/>
           <a:p>
             <a:pPr algn="ctr"/>
+            <a:endParaRPr/>
           </a:p>
         </p:txBody>
       </p:sp>
@@ -12633,6 +12793,7 @@
           <a:lstStyle/>
           <a:p>
             <a:pPr algn="ctr"/>
+            <a:endParaRPr/>
           </a:p>
         </p:txBody>
       </p:sp>
@@ -12780,7 +12941,7 @@
 </file>
 
 <file path=ppt/slides/slide25.xml><?xml version="1.0" encoding="utf-8"?>
-<p:sld xmlns:a="http://schemas.openxmlformats.org/drawingml/2006/main" xmlns:p="http://schemas.openxmlformats.org/presentationml/2006/main" xmlns:r="http://schemas.openxmlformats.org/officeDocument/2006/relationships">
+<p:sld xmlns:a="http://schemas.openxmlformats.org/drawingml/2006/main" xmlns:r="http://schemas.openxmlformats.org/officeDocument/2006/relationships" xmlns:p="http://schemas.openxmlformats.org/presentationml/2006/main">
   <p:cSld>
     <p:spTree>
       <p:nvGrpSpPr>
@@ -12788,7 +12949,14 @@
         <p:cNvGrpSpPr/>
         <p:nvPr/>
       </p:nvGrpSpPr>
-      <p:grpSpPr/>
+      <p:grpSpPr>
+        <a:xfrm>
+          <a:off x="0" y="0"/>
+          <a:ext cx="0" cy="0"/>
+          <a:chOff x="0" y="0"/>
+          <a:chExt cx="0" cy="0"/>
+        </a:xfrm>
+      </p:grpSpPr>
       <p:sp>
         <p:nvSpPr>
           <p:cNvPr id="2" name="Rectangle 1"/>
@@ -12829,6 +12997,7 @@
           <a:lstStyle/>
           <a:p>
             <a:pPr algn="ctr"/>
+            <a:endParaRPr/>
           </a:p>
         </p:txBody>
       </p:sp>
@@ -12872,6 +13041,7 @@
           <a:lstStyle/>
           <a:p>
             <a:pPr algn="ctr"/>
+            <a:endParaRPr/>
           </a:p>
         </p:txBody>
       </p:sp>
@@ -12915,6 +13085,7 @@
           <a:lstStyle/>
           <a:p>
             <a:pPr algn="ctr"/>
+            <a:endParaRPr/>
           </a:p>
         </p:txBody>
       </p:sp>
@@ -12958,6 +13129,7 @@
           <a:lstStyle/>
           <a:p>
             <a:pPr algn="ctr"/>
+            <a:endParaRPr/>
           </a:p>
         </p:txBody>
       </p:sp>
@@ -13001,6 +13173,7 @@
           <a:lstStyle/>
           <a:p>
             <a:pPr algn="ctr"/>
+            <a:endParaRPr/>
           </a:p>
         </p:txBody>
       </p:sp>
@@ -13148,7 +13321,7 @@
 </file>
 
 <file path=ppt/slides/slide26.xml><?xml version="1.0" encoding="utf-8"?>
-<p:sld xmlns:a="http://schemas.openxmlformats.org/drawingml/2006/main" xmlns:p="http://schemas.openxmlformats.org/presentationml/2006/main" xmlns:r="http://schemas.openxmlformats.org/officeDocument/2006/relationships">
+<p:sld xmlns:a="http://schemas.openxmlformats.org/drawingml/2006/main" xmlns:r="http://schemas.openxmlformats.org/officeDocument/2006/relationships" xmlns:p="http://schemas.openxmlformats.org/presentationml/2006/main">
   <p:cSld>
     <p:spTree>
       <p:nvGrpSpPr>
@@ -13156,7 +13329,14 @@
         <p:cNvGrpSpPr/>
         <p:nvPr/>
       </p:nvGrpSpPr>
-      <p:grpSpPr/>
+      <p:grpSpPr>
+        <a:xfrm>
+          <a:off x="0" y="0"/>
+          <a:ext cx="0" cy="0"/>
+          <a:chOff x="0" y="0"/>
+          <a:chExt cx="0" cy="0"/>
+        </a:xfrm>
+      </p:grpSpPr>
       <p:sp>
         <p:nvSpPr>
           <p:cNvPr id="2" name="Rectangle 1"/>
@@ -13197,6 +13377,7 @@
           <a:lstStyle/>
           <a:p>
             <a:pPr algn="ctr"/>
+            <a:endParaRPr/>
           </a:p>
         </p:txBody>
       </p:sp>
@@ -13240,6 +13421,7 @@
           <a:lstStyle/>
           <a:p>
             <a:pPr algn="ctr"/>
+            <a:endParaRPr/>
           </a:p>
         </p:txBody>
       </p:sp>
@@ -13283,6 +13465,7 @@
           <a:lstStyle/>
           <a:p>
             <a:pPr algn="ctr"/>
+            <a:endParaRPr/>
           </a:p>
         </p:txBody>
       </p:sp>
@@ -13326,6 +13509,7 @@
           <a:lstStyle/>
           <a:p>
             <a:pPr algn="ctr"/>
+            <a:endParaRPr/>
           </a:p>
         </p:txBody>
       </p:sp>
@@ -13369,6 +13553,7 @@
           <a:lstStyle/>
           <a:p>
             <a:pPr algn="ctr"/>
+            <a:endParaRPr/>
           </a:p>
         </p:txBody>
       </p:sp>
@@ -13516,7 +13701,7 @@
 </file>
 
 <file path=ppt/slides/slide27.xml><?xml version="1.0" encoding="utf-8"?>
-<p:sld xmlns:a="http://schemas.openxmlformats.org/drawingml/2006/main" xmlns:p="http://schemas.openxmlformats.org/presentationml/2006/main" xmlns:r="http://schemas.openxmlformats.org/officeDocument/2006/relationships">
+<p:sld xmlns:a="http://schemas.openxmlformats.org/drawingml/2006/main" xmlns:r="http://schemas.openxmlformats.org/officeDocument/2006/relationships" xmlns:p="http://schemas.openxmlformats.org/presentationml/2006/main">
   <p:cSld>
     <p:spTree>
       <p:nvGrpSpPr>
@@ -13524,7 +13709,14 @@
         <p:cNvGrpSpPr/>
         <p:nvPr/>
       </p:nvGrpSpPr>
-      <p:grpSpPr/>
+      <p:grpSpPr>
+        <a:xfrm>
+          <a:off x="0" y="0"/>
+          <a:ext cx="0" cy="0"/>
+          <a:chOff x="0" y="0"/>
+          <a:chExt cx="0" cy="0"/>
+        </a:xfrm>
+      </p:grpSpPr>
       <p:sp>
         <p:nvSpPr>
           <p:cNvPr id="2" name="Rectangle 1"/>
@@ -13565,6 +13757,7 @@
           <a:lstStyle/>
           <a:p>
             <a:pPr algn="ctr"/>
+            <a:endParaRPr/>
           </a:p>
         </p:txBody>
       </p:sp>
@@ -13608,6 +13801,7 @@
           <a:lstStyle/>
           <a:p>
             <a:pPr algn="ctr"/>
+            <a:endParaRPr/>
           </a:p>
         </p:txBody>
       </p:sp>
@@ -13651,6 +13845,7 @@
           <a:lstStyle/>
           <a:p>
             <a:pPr algn="ctr"/>
+            <a:endParaRPr/>
           </a:p>
         </p:txBody>
       </p:sp>
@@ -13694,6 +13889,7 @@
           <a:lstStyle/>
           <a:p>
             <a:pPr algn="ctr"/>
+            <a:endParaRPr/>
           </a:p>
         </p:txBody>
       </p:sp>
@@ -13737,6 +13933,7 @@
           <a:lstStyle/>
           <a:p>
             <a:pPr algn="ctr"/>
+            <a:endParaRPr/>
           </a:p>
         </p:txBody>
       </p:sp>
@@ -13884,7 +14081,7 @@
 </file>
 
 <file path=ppt/slides/slide28.xml><?xml version="1.0" encoding="utf-8"?>
-<p:sld xmlns:a="http://schemas.openxmlformats.org/drawingml/2006/main" xmlns:p="http://schemas.openxmlformats.org/presentationml/2006/main" xmlns:r="http://schemas.openxmlformats.org/officeDocument/2006/relationships">
+<p:sld xmlns:a="http://schemas.openxmlformats.org/drawingml/2006/main" xmlns:r="http://schemas.openxmlformats.org/officeDocument/2006/relationships" xmlns:p="http://schemas.openxmlformats.org/presentationml/2006/main">
   <p:cSld>
     <p:spTree>
       <p:nvGrpSpPr>
@@ -13892,7 +14089,14 @@
         <p:cNvGrpSpPr/>
         <p:nvPr/>
       </p:nvGrpSpPr>
-      <p:grpSpPr/>
+      <p:grpSpPr>
+        <a:xfrm>
+          <a:off x="0" y="0"/>
+          <a:ext cx="0" cy="0"/>
+          <a:chOff x="0" y="0"/>
+          <a:chExt cx="0" cy="0"/>
+        </a:xfrm>
+      </p:grpSpPr>
       <p:sp>
         <p:nvSpPr>
           <p:cNvPr id="2" name="Rectangle 1"/>
@@ -13933,6 +14137,7 @@
           <a:lstStyle/>
           <a:p>
             <a:pPr algn="ctr"/>
+            <a:endParaRPr/>
           </a:p>
         </p:txBody>
       </p:sp>
@@ -13976,6 +14181,7 @@
           <a:lstStyle/>
           <a:p>
             <a:pPr algn="ctr"/>
+            <a:endParaRPr/>
           </a:p>
         </p:txBody>
       </p:sp>
@@ -14019,6 +14225,7 @@
           <a:lstStyle/>
           <a:p>
             <a:pPr algn="ctr"/>
+            <a:endParaRPr/>
           </a:p>
         </p:txBody>
       </p:sp>
@@ -14062,6 +14269,7 @@
           <a:lstStyle/>
           <a:p>
             <a:pPr algn="ctr"/>
+            <a:endParaRPr/>
           </a:p>
         </p:txBody>
       </p:sp>
@@ -14105,6 +14313,7 @@
           <a:lstStyle/>
           <a:p>
             <a:pPr algn="ctr"/>
+            <a:endParaRPr/>
           </a:p>
         </p:txBody>
       </p:sp>
@@ -14252,7 +14461,7 @@
 </file>
 
 <file path=ppt/slides/slide29.xml><?xml version="1.0" encoding="utf-8"?>
-<p:sld xmlns:a="http://schemas.openxmlformats.org/drawingml/2006/main" xmlns:p="http://schemas.openxmlformats.org/presentationml/2006/main" xmlns:r="http://schemas.openxmlformats.org/officeDocument/2006/relationships">
+<p:sld xmlns:a="http://schemas.openxmlformats.org/drawingml/2006/main" xmlns:r="http://schemas.openxmlformats.org/officeDocument/2006/relationships" xmlns:p="http://schemas.openxmlformats.org/presentationml/2006/main">
   <p:cSld>
     <p:spTree>
       <p:nvGrpSpPr>
@@ -14260,7 +14469,14 @@
         <p:cNvGrpSpPr/>
         <p:nvPr/>
       </p:nvGrpSpPr>
-      <p:grpSpPr/>
+      <p:grpSpPr>
+        <a:xfrm>
+          <a:off x="0" y="0"/>
+          <a:ext cx="0" cy="0"/>
+          <a:chOff x="0" y="0"/>
+          <a:chExt cx="0" cy="0"/>
+        </a:xfrm>
+      </p:grpSpPr>
       <p:sp>
         <p:nvSpPr>
           <p:cNvPr id="2" name="Rectangle 1"/>
@@ -14301,6 +14517,7 @@
           <a:lstStyle/>
           <a:p>
             <a:pPr algn="ctr"/>
+            <a:endParaRPr/>
           </a:p>
         </p:txBody>
       </p:sp>
@@ -14344,6 +14561,7 @@
           <a:lstStyle/>
           <a:p>
             <a:pPr algn="ctr"/>
+            <a:endParaRPr/>
           </a:p>
         </p:txBody>
       </p:sp>
@@ -14387,6 +14605,7 @@
           <a:lstStyle/>
           <a:p>
             <a:pPr algn="ctr"/>
+            <a:endParaRPr/>
           </a:p>
         </p:txBody>
       </p:sp>
@@ -14430,6 +14649,7 @@
           <a:lstStyle/>
           <a:p>
             <a:pPr algn="ctr"/>
+            <a:endParaRPr/>
           </a:p>
         </p:txBody>
       </p:sp>
@@ -14473,6 +14693,7 @@
           <a:lstStyle/>
           <a:p>
             <a:pPr algn="ctr"/>
+            <a:endParaRPr/>
           </a:p>
         </p:txBody>
       </p:sp>
@@ -14620,7 +14841,7 @@
 </file>
 
 <file path=ppt/slides/slide3.xml><?xml version="1.0" encoding="utf-8"?>
-<p:sld xmlns:a="http://schemas.openxmlformats.org/drawingml/2006/main" xmlns:p="http://schemas.openxmlformats.org/presentationml/2006/main" xmlns:r="http://schemas.openxmlformats.org/officeDocument/2006/relationships">
+<p:sld xmlns:a="http://schemas.openxmlformats.org/drawingml/2006/main" xmlns:r="http://schemas.openxmlformats.org/officeDocument/2006/relationships" xmlns:p="http://schemas.openxmlformats.org/presentationml/2006/main">
   <p:cSld>
     <p:spTree>
       <p:nvGrpSpPr>
@@ -14628,7 +14849,14 @@
         <p:cNvGrpSpPr/>
         <p:nvPr/>
       </p:nvGrpSpPr>
-      <p:grpSpPr/>
+      <p:grpSpPr>
+        <a:xfrm>
+          <a:off x="0" y="0"/>
+          <a:ext cx="0" cy="0"/>
+          <a:chOff x="0" y="0"/>
+          <a:chExt cx="0" cy="0"/>
+        </a:xfrm>
+      </p:grpSpPr>
       <p:sp>
         <p:nvSpPr>
           <p:cNvPr id="2" name="Rectangle 1"/>
@@ -14669,6 +14897,7 @@
           <a:lstStyle/>
           <a:p>
             <a:pPr algn="ctr"/>
+            <a:endParaRPr/>
           </a:p>
         </p:txBody>
       </p:sp>
@@ -14712,6 +14941,7 @@
           <a:lstStyle/>
           <a:p>
             <a:pPr algn="ctr"/>
+            <a:endParaRPr/>
           </a:p>
         </p:txBody>
       </p:sp>
@@ -14755,6 +14985,7 @@
           <a:lstStyle/>
           <a:p>
             <a:pPr algn="ctr"/>
+            <a:endParaRPr/>
           </a:p>
         </p:txBody>
       </p:sp>
@@ -14798,6 +15029,7 @@
           <a:lstStyle/>
           <a:p>
             <a:pPr algn="ctr"/>
+            <a:endParaRPr/>
           </a:p>
         </p:txBody>
       </p:sp>
@@ -14841,6 +15073,7 @@
           <a:lstStyle/>
           <a:p>
             <a:pPr algn="ctr"/>
+            <a:endParaRPr/>
           </a:p>
         </p:txBody>
       </p:sp>
@@ -14956,6 +15189,7 @@
           <a:lstStyle/>
           <a:p>
             <a:pPr algn="ctr"/>
+            <a:endParaRPr/>
           </a:p>
         </p:txBody>
       </p:sp>
@@ -14999,6 +15233,7 @@
           <a:lstStyle/>
           <a:p>
             <a:pPr algn="ctr"/>
+            <a:endParaRPr/>
           </a:p>
         </p:txBody>
       </p:sp>
@@ -15054,7 +15289,7 @@
           <a:noFill/>
         </p:spPr>
         <p:txBody>
-          <a:bodyPr wrap="square" anchor="t" lIns="38100" rIns="38100" tIns="25400" bIns="25400">
+          <a:bodyPr wrap="square" lIns="38100" tIns="25400" rIns="38100" bIns="25400" anchor="t">
             <a:noAutofit/>
           </a:bodyPr>
           <a:lstStyle/>
@@ -15076,9 +15311,6 @@
               </a:rPr>
               <a:t>Answers codebase questions with loaded file or directory context.</a:t>
             </a:r>
-            <a:endParaRPr sz="1500" b="0" i="0">
-              <a:latin typeface="Calibri"/>
-            </a:endParaRPr>
           </a:p>
           <a:p>
             <a:pPr>
@@ -15098,9 +15330,6 @@
               </a:rPr>
               <a:t>Uses hybrid retrieval to extract metadata, split content, rank source chunks, and respect context budgets.</a:t>
             </a:r>
-            <a:endParaRPr sz="1500" b="0" i="0">
-              <a:latin typeface="Calibri"/>
-            </a:endParaRPr>
           </a:p>
           <a:p>
             <a:pPr>
@@ -15120,9 +15349,6 @@
               </a:rPr>
               <a:t>Runs checked Multi-Turn requests through request-scoped planning, capability selection, tool calls, observations, monitoring, and final synthesis.</a:t>
             </a:r>
-            <a:endParaRPr sz="1500" b="0" i="0">
-              <a:latin typeface="Calibri"/>
-            </a:endParaRPr>
           </a:p>
         </p:txBody>
       </p:sp>
@@ -15168,6 +15394,7 @@
           <a:lstStyle/>
           <a:p>
             <a:pPr algn="ctr"/>
+            <a:endParaRPr/>
           </a:p>
         </p:txBody>
       </p:sp>
@@ -15211,6 +15438,7 @@
           <a:lstStyle/>
           <a:p>
             <a:pPr algn="ctr"/>
+            <a:endParaRPr/>
           </a:p>
         </p:txBody>
       </p:sp>
@@ -15266,7 +15494,7 @@
           <a:noFill/>
         </p:spPr>
         <p:txBody>
-          <a:bodyPr wrap="square" anchor="t" lIns="38100" rIns="38100" tIns="25400" bIns="25400">
+          <a:bodyPr wrap="square" lIns="38100" tIns="25400" rIns="38100" bIns="25400" anchor="t">
             <a:noAutofit/>
           </a:bodyPr>
           <a:lstStyle/>
@@ -15288,9 +15516,6 @@
               </a:rPr>
               <a:t>Launches wrapped copies of selected workflow agents in isolated runtime folders without mutating templates.</a:t>
             </a:r>
-            <a:endParaRPr sz="1500" b="0" i="0">
-              <a:latin typeface="Calibri"/>
-            </a:endParaRPr>
           </a:p>
           <a:p>
             <a:pPr>
@@ -15310,9 +15535,6 @@
               </a:rPr>
               <a:t>Lets users design, validate, save, pause, resume, and stop visual workflows through the Agentic Control Panel.</a:t>
             </a:r>
-            <a:endParaRPr sz="1500" b="0" i="0">
-              <a:latin typeface="Calibri"/>
-            </a:endParaRPr>
           </a:p>
         </p:txBody>
       </p:sp>
@@ -15358,6 +15580,7 @@
           <a:lstStyle/>
           <a:p>
             <a:pPr algn="ctr"/>
+            <a:endParaRPr/>
           </a:p>
         </p:txBody>
       </p:sp>
@@ -15401,6 +15624,7 @@
           <a:lstStyle/>
           <a:p>
             <a:pPr algn="ctr"/>
+            <a:endParaRPr/>
           </a:p>
         </p:txBody>
       </p:sp>
@@ -15456,7 +15680,7 @@
           <a:noFill/>
         </p:spPr>
         <p:txBody>
-          <a:bodyPr wrap="square" anchor="t" lIns="38100" rIns="38100" tIns="25400" bIns="25400">
+          <a:bodyPr wrap="square" lIns="38100" tIns="25400" rIns="38100" bIns="25400" anchor="t">
             <a:noAutofit/>
           </a:bodyPr>
           <a:lstStyle/>
@@ -15478,9 +15702,6 @@
               </a:rPr>
               <a:t>Turns successful Multi-Turn tool executions into starter `.flw` workflows that can be inspected and validated in ACP.</a:t>
             </a:r>
-            <a:endParaRPr sz="1500" b="0" i="0">
-              <a:latin typeface="Calibri"/>
-            </a:endParaRPr>
           </a:p>
           <a:p>
             <a:pPr>
@@ -15500,9 +15721,6 @@
               </a:rPr>
               <a:t>Packages the project into a distributable Windows release with installer and uninstaller tooling.</a:t>
             </a:r>
-            <a:endParaRPr sz="1500" b="0" i="0">
-              <a:latin typeface="Calibri"/>
-            </a:endParaRPr>
           </a:p>
         </p:txBody>
       </p:sp>
@@ -15515,7 +15733,7 @@
 </file>
 
 <file path=ppt/slides/slide30.xml><?xml version="1.0" encoding="utf-8"?>
-<p:sld xmlns:a="http://schemas.openxmlformats.org/drawingml/2006/main" xmlns:p="http://schemas.openxmlformats.org/presentationml/2006/main" xmlns:r="http://schemas.openxmlformats.org/officeDocument/2006/relationships">
+<p:sld xmlns:a="http://schemas.openxmlformats.org/drawingml/2006/main" xmlns:r="http://schemas.openxmlformats.org/officeDocument/2006/relationships" xmlns:p="http://schemas.openxmlformats.org/presentationml/2006/main">
   <p:cSld>
     <p:spTree>
       <p:nvGrpSpPr>
@@ -15523,7 +15741,14 @@
         <p:cNvGrpSpPr/>
         <p:nvPr/>
       </p:nvGrpSpPr>
-      <p:grpSpPr/>
+      <p:grpSpPr>
+        <a:xfrm>
+          <a:off x="0" y="0"/>
+          <a:ext cx="0" cy="0"/>
+          <a:chOff x="0" y="0"/>
+          <a:chExt cx="0" cy="0"/>
+        </a:xfrm>
+      </p:grpSpPr>
       <p:sp>
         <p:nvSpPr>
           <p:cNvPr id="2" name="Rectangle 1"/>
@@ -15564,6 +15789,7 @@
           <a:lstStyle/>
           <a:p>
             <a:pPr algn="ctr"/>
+            <a:endParaRPr/>
           </a:p>
         </p:txBody>
       </p:sp>
@@ -15607,6 +15833,7 @@
           <a:lstStyle/>
           <a:p>
             <a:pPr algn="ctr"/>
+            <a:endParaRPr/>
           </a:p>
         </p:txBody>
       </p:sp>
@@ -15650,6 +15877,7 @@
           <a:lstStyle/>
           <a:p>
             <a:pPr algn="ctr"/>
+            <a:endParaRPr/>
           </a:p>
         </p:txBody>
       </p:sp>
@@ -15693,6 +15921,7 @@
           <a:lstStyle/>
           <a:p>
             <a:pPr algn="ctr"/>
+            <a:endParaRPr/>
           </a:p>
         </p:txBody>
       </p:sp>
@@ -15736,6 +15965,7 @@
           <a:lstStyle/>
           <a:p>
             <a:pPr algn="ctr"/>
+            <a:endParaRPr/>
           </a:p>
         </p:txBody>
       </p:sp>
@@ -15883,7 +16113,7 @@
 </file>
 
 <file path=ppt/slides/slide31.xml><?xml version="1.0" encoding="utf-8"?>
-<p:sld xmlns:a="http://schemas.openxmlformats.org/drawingml/2006/main" xmlns:p="http://schemas.openxmlformats.org/presentationml/2006/main" xmlns:r="http://schemas.openxmlformats.org/officeDocument/2006/relationships">
+<p:sld xmlns:a="http://schemas.openxmlformats.org/drawingml/2006/main" xmlns:r="http://schemas.openxmlformats.org/officeDocument/2006/relationships" xmlns:p="http://schemas.openxmlformats.org/presentationml/2006/main">
   <p:cSld>
     <p:spTree>
       <p:nvGrpSpPr>
@@ -15891,7 +16121,14 @@
         <p:cNvGrpSpPr/>
         <p:nvPr/>
       </p:nvGrpSpPr>
-      <p:grpSpPr/>
+      <p:grpSpPr>
+        <a:xfrm>
+          <a:off x="0" y="0"/>
+          <a:ext cx="0" cy="0"/>
+          <a:chOff x="0" y="0"/>
+          <a:chExt cx="0" cy="0"/>
+        </a:xfrm>
+      </p:grpSpPr>
       <p:sp>
         <p:nvSpPr>
           <p:cNvPr id="2" name="Rectangle 1"/>
@@ -15932,6 +16169,7 @@
           <a:lstStyle/>
           <a:p>
             <a:pPr algn="ctr"/>
+            <a:endParaRPr/>
           </a:p>
         </p:txBody>
       </p:sp>
@@ -15975,6 +16213,7 @@
           <a:lstStyle/>
           <a:p>
             <a:pPr algn="ctr"/>
+            <a:endParaRPr/>
           </a:p>
         </p:txBody>
       </p:sp>
@@ -16018,6 +16257,7 @@
           <a:lstStyle/>
           <a:p>
             <a:pPr algn="ctr"/>
+            <a:endParaRPr/>
           </a:p>
         </p:txBody>
       </p:sp>
@@ -16061,6 +16301,7 @@
           <a:lstStyle/>
           <a:p>
             <a:pPr algn="ctr"/>
+            <a:endParaRPr/>
           </a:p>
         </p:txBody>
       </p:sp>
@@ -16104,6 +16345,7 @@
           <a:lstStyle/>
           <a:p>
             <a:pPr algn="ctr"/>
+            <a:endParaRPr/>
           </a:p>
         </p:txBody>
       </p:sp>
@@ -16225,7 +16467,7 @@
 </file>
 
 <file path=ppt/slides/slide32.xml><?xml version="1.0" encoding="utf-8"?>
-<p:sld xmlns:a="http://schemas.openxmlformats.org/drawingml/2006/main" xmlns:p="http://schemas.openxmlformats.org/presentationml/2006/main" xmlns:r="http://schemas.openxmlformats.org/officeDocument/2006/relationships">
+<p:sld xmlns:a="http://schemas.openxmlformats.org/drawingml/2006/main" xmlns:r="http://schemas.openxmlformats.org/officeDocument/2006/relationships" xmlns:p="http://schemas.openxmlformats.org/presentationml/2006/main">
   <p:cSld>
     <p:spTree>
       <p:nvGrpSpPr>
@@ -16233,7 +16475,14 @@
         <p:cNvGrpSpPr/>
         <p:nvPr/>
       </p:nvGrpSpPr>
-      <p:grpSpPr/>
+      <p:grpSpPr>
+        <a:xfrm>
+          <a:off x="0" y="0"/>
+          <a:ext cx="0" cy="0"/>
+          <a:chOff x="0" y="0"/>
+          <a:chExt cx="0" cy="0"/>
+        </a:xfrm>
+      </p:grpSpPr>
       <p:sp>
         <p:nvSpPr>
           <p:cNvPr id="2" name="Rectangle 1"/>
@@ -16274,6 +16523,7 @@
           <a:lstStyle/>
           <a:p>
             <a:pPr algn="ctr"/>
+            <a:endParaRPr/>
           </a:p>
         </p:txBody>
       </p:sp>
@@ -16317,6 +16567,7 @@
           <a:lstStyle/>
           <a:p>
             <a:pPr algn="ctr"/>
+            <a:endParaRPr/>
           </a:p>
         </p:txBody>
       </p:sp>
@@ -16360,6 +16611,7 @@
           <a:lstStyle/>
           <a:p>
             <a:pPr algn="ctr"/>
+            <a:endParaRPr/>
           </a:p>
         </p:txBody>
       </p:sp>
@@ -16403,6 +16655,7 @@
           <a:lstStyle/>
           <a:p>
             <a:pPr algn="ctr"/>
+            <a:endParaRPr/>
           </a:p>
         </p:txBody>
       </p:sp>
@@ -16446,6 +16699,7 @@
           <a:lstStyle/>
           <a:p>
             <a:pPr algn="ctr"/>
+            <a:endParaRPr/>
           </a:p>
         </p:txBody>
       </p:sp>
@@ -16561,6 +16815,7 @@
           <a:lstStyle/>
           <a:p>
             <a:pPr algn="ctr"/>
+            <a:endParaRPr/>
           </a:p>
         </p:txBody>
       </p:sp>
@@ -16604,6 +16859,7 @@
           <a:lstStyle/>
           <a:p>
             <a:pPr algn="ctr"/>
+            <a:endParaRPr/>
           </a:p>
         </p:txBody>
       </p:sp>
@@ -16659,7 +16915,7 @@
           <a:noFill/>
         </p:spPr>
         <p:txBody>
-          <a:bodyPr wrap="square" anchor="t" lIns="38100" rIns="38100" tIns="25400" bIns="25400">
+          <a:bodyPr wrap="square" lIns="38100" tIns="25400" rIns="38100" bIns="25400" anchor="t">
             <a:noAutofit/>
           </a:bodyPr>
           <a:lstStyle/>
@@ -16681,9 +16937,6 @@
               </a:rPr>
               <a:t>Regenerate the PDF and deck whenever README, architecture, agent catalog, line inventory, or packaging behavior changes.</a:t>
             </a:r>
-            <a:endParaRPr sz="1700" b="0" i="0">
-              <a:latin typeface="Calibri"/>
-            </a:endParaRPr>
           </a:p>
           <a:p>
             <a:pPr>
@@ -16703,9 +16956,6 @@
               </a:rPr>
               <a:t>Keep the PDF exhaustive and evidence-heavy; keep the PPT visual, split dense appendices, and audit geometry before delivery.</a:t>
             </a:r>
-            <a:endParaRPr sz="1700" b="0" i="0">
-              <a:latin typeface="Calibri"/>
-            </a:endParaRPr>
           </a:p>
           <a:p>
             <a:pPr>
@@ -16725,9 +16975,6 @@
               </a:rPr>
               <a:t>Use the new Skills in `.codex/skills/` so future refreshes follow the same no-overlap and full-dossier rules.</a:t>
             </a:r>
-            <a:endParaRPr sz="1700" b="0" i="0">
-              <a:latin typeface="Calibri"/>
-            </a:endParaRPr>
           </a:p>
         </p:txBody>
       </p:sp>
@@ -16740,7 +16987,7 @@
 </file>
 
 <file path=ppt/slides/slide4.xml><?xml version="1.0" encoding="utf-8"?>
-<p:sld xmlns:a="http://schemas.openxmlformats.org/drawingml/2006/main" xmlns:p="http://schemas.openxmlformats.org/presentationml/2006/main" xmlns:r="http://schemas.openxmlformats.org/officeDocument/2006/relationships">
+<p:sld xmlns:a="http://schemas.openxmlformats.org/drawingml/2006/main" xmlns:r="http://schemas.openxmlformats.org/officeDocument/2006/relationships" xmlns:p="http://schemas.openxmlformats.org/presentationml/2006/main">
   <p:cSld>
     <p:spTree>
       <p:nvGrpSpPr>
@@ -16748,7 +16995,14 @@
         <p:cNvGrpSpPr/>
         <p:nvPr/>
       </p:nvGrpSpPr>
-      <p:grpSpPr/>
+      <p:grpSpPr>
+        <a:xfrm>
+          <a:off x="0" y="0"/>
+          <a:ext cx="0" cy="0"/>
+          <a:chOff x="0" y="0"/>
+          <a:chExt cx="0" cy="0"/>
+        </a:xfrm>
+      </p:grpSpPr>
       <p:sp>
         <p:nvSpPr>
           <p:cNvPr id="2" name="Rectangle 1"/>
@@ -16789,6 +17043,7 @@
           <a:lstStyle/>
           <a:p>
             <a:pPr algn="ctr"/>
+            <a:endParaRPr/>
           </a:p>
         </p:txBody>
       </p:sp>
@@ -16832,6 +17087,7 @@
           <a:lstStyle/>
           <a:p>
             <a:pPr algn="ctr"/>
+            <a:endParaRPr/>
           </a:p>
         </p:txBody>
       </p:sp>
@@ -16875,6 +17131,7 @@
           <a:lstStyle/>
           <a:p>
             <a:pPr algn="ctr"/>
+            <a:endParaRPr/>
           </a:p>
         </p:txBody>
       </p:sp>
@@ -16918,6 +17175,7 @@
           <a:lstStyle/>
           <a:p>
             <a:pPr algn="ctr"/>
+            <a:endParaRPr/>
           </a:p>
         </p:txBody>
       </p:sp>
@@ -16961,6 +17219,7 @@
           <a:lstStyle/>
           <a:p>
             <a:pPr algn="ctr"/>
+            <a:endParaRPr/>
           </a:p>
         </p:txBody>
       </p:sp>
@@ -17076,6 +17335,7 @@
           <a:lstStyle/>
           <a:p>
             <a:pPr algn="ctr"/>
+            <a:endParaRPr/>
           </a:p>
         </p:txBody>
       </p:sp>
@@ -17191,6 +17451,7 @@
           <a:lstStyle/>
           <a:p>
             <a:pPr algn="ctr"/>
+            <a:endParaRPr/>
           </a:p>
         </p:txBody>
       </p:sp>
@@ -17306,6 +17567,7 @@
           <a:lstStyle/>
           <a:p>
             <a:pPr algn="ctr"/>
+            <a:endParaRPr/>
           </a:p>
         </p:txBody>
       </p:sp>
@@ -17421,6 +17683,7 @@
           <a:lstStyle/>
           <a:p>
             <a:pPr algn="ctr"/>
+            <a:endParaRPr/>
           </a:p>
         </p:txBody>
       </p:sp>
@@ -17536,6 +17799,7 @@
           <a:lstStyle/>
           <a:p>
             <a:pPr algn="ctr"/>
+            <a:endParaRPr/>
           </a:p>
         </p:txBody>
       </p:sp>
@@ -17651,6 +17915,7 @@
           <a:lstStyle/>
           <a:p>
             <a:pPr algn="ctr"/>
+            <a:endParaRPr/>
           </a:p>
         </p:txBody>
       </p:sp>
@@ -17697,8 +17962,8 @@
         </p:nvSpPr>
         <p:spPr>
           <a:xfrm>
-            <a:off x="713232" y="2971800"/>
-            <a:ext cx="5349240" cy="2788920"/>
+            <a:off x="713232" y="2991026"/>
+            <a:ext cx="5349240" cy="3053157"/>
           </a:xfrm>
           <a:prstGeom prst="roundRect">
             <a:avLst/>
@@ -17731,6 +17996,7 @@
           <a:lstStyle/>
           <a:p>
             <a:pPr algn="ctr"/>
+            <a:endParaRPr/>
           </a:p>
         </p:txBody>
       </p:sp>
@@ -17774,6 +18040,7 @@
           <a:lstStyle/>
           <a:p>
             <a:pPr algn="ctr"/>
+            <a:endParaRPr/>
           </a:p>
         </p:txBody>
       </p:sp>
@@ -17820,7 +18087,7 @@
         </p:nvSpPr>
         <p:spPr>
           <a:xfrm>
-            <a:off x="914400" y="3630168"/>
+            <a:off x="914400" y="3685032"/>
             <a:ext cx="4946903" cy="1984248"/>
           </a:xfrm>
           <a:prstGeom prst="rect">
@@ -17829,7 +18096,7 @@
           <a:noFill/>
         </p:spPr>
         <p:txBody>
-          <a:bodyPr wrap="square" anchor="t" lIns="38100" rIns="38100" tIns="25400" bIns="25400">
+          <a:bodyPr wrap="square" lIns="38100" tIns="25400" rIns="38100" bIns="25400" anchor="t">
             <a:noAutofit/>
           </a:bodyPr>
           <a:lstStyle/>
@@ -17851,9 +18118,6 @@
               </a:rPr>
               <a:t>Browser UI sends chat and workflow requests through Django views and Channels WebSockets.</a:t>
             </a:r>
-            <a:endParaRPr sz="1500" b="0" i="0">
-              <a:latin typeface="Calibri"/>
-            </a:endParaRPr>
           </a:p>
           <a:p>
             <a:pPr>
@@ -17873,9 +18137,6 @@
               </a:rPr>
               <a:t>RAG chains load selected file/directory context, retrieve relevant chunks, and build answer prompts.</a:t>
             </a:r>
-            <a:endParaRPr sz="1500" b="0" i="0">
-              <a:latin typeface="Calibri"/>
-            </a:endParaRPr>
           </a:p>
           <a:p>
             <a:pPr>
@@ -17895,9 +18156,6 @@
               </a:rPr>
               <a:t>When Multi-Turn is enabled, the global planner selects context and tool stages before the executor binds only the relevant tools.</a:t>
             </a:r>
-            <a:endParaRPr sz="1500" b="0" i="0">
-              <a:latin typeface="Calibri"/>
-            </a:endParaRPr>
           </a:p>
         </p:txBody>
       </p:sp>
@@ -17910,7 +18168,7 @@
         <p:spPr>
           <a:xfrm>
             <a:off x="6327648" y="2971800"/>
-            <a:ext cx="5074920" cy="2788920"/>
+            <a:ext cx="5074920" cy="3072384"/>
           </a:xfrm>
           <a:prstGeom prst="roundRect">
             <a:avLst/>
@@ -17943,6 +18201,7 @@
           <a:lstStyle/>
           <a:p>
             <a:pPr algn="ctr"/>
+            <a:endParaRPr/>
           </a:p>
         </p:txBody>
       </p:sp>
@@ -17986,6 +18245,7 @@
           <a:lstStyle/>
           <a:p>
             <a:pPr algn="ctr"/>
+            <a:endParaRPr/>
           </a:p>
         </p:txBody>
       </p:sp>
@@ -18041,7 +18301,7 @@
           <a:noFill/>
         </p:spPr>
         <p:txBody>
-          <a:bodyPr wrap="square" anchor="t" lIns="38100" rIns="38100" tIns="25400" bIns="25400">
+          <a:bodyPr wrap="square" lIns="38100" tIns="25400" rIns="38100" bIns="25400" anchor="t">
             <a:noAutofit/>
           </a:bodyPr>
           <a:lstStyle/>
@@ -18058,14 +18318,23 @@
               </a:defRPr>
             </a:pPr>
             <a:r>
-              <a:rPr sz="1500" b="0" i="0">
+              <a:rPr sz="1500" b="0" i="0" dirty="0">
                 <a:latin typeface="Calibri"/>
               </a:rPr>
-              <a:t>Tool calls execute in the backend, append observations, and may create wrapped runtime copies under `agent/agents/pools/_chat_runs_/`.</a:t>
-            </a:r>
-            <a:endParaRPr sz="1500" b="0" i="0">
-              <a:latin typeface="Calibri"/>
-            </a:endParaRPr>
+              <a:t>Tool calls execute in the backend, append observations, and may create wrapped runtime copies under `agent/agents/pools/_</a:t>
+            </a:r>
+            <a:r>
+              <a:rPr sz="1500" b="0" i="0" dirty="0" err="1">
+                <a:latin typeface="Calibri"/>
+              </a:rPr>
+              <a:t>chat_runs</a:t>
+            </a:r>
+            <a:r>
+              <a:rPr sz="1500" b="0" i="0" dirty="0">
+                <a:latin typeface="Calibri"/>
+              </a:rPr>
+              <a:t>_/`.</a:t>
+            </a:r>
           </a:p>
           <a:p>
             <a:pPr>
@@ -18080,14 +18349,23 @@
               </a:defRPr>
             </a:pPr>
             <a:r>
-              <a:rPr sz="1500" b="0" i="0">
+              <a:rPr sz="1500" b="0" i="0" dirty="0">
                 <a:latin typeface="Calibri"/>
               </a:rPr>
-              <a:t>ACP flows deploy session-scoped pool instances, wire config values, validate NxN graph rules, and execute through Starter-driven flow semantics.</a:t>
-            </a:r>
-            <a:endParaRPr sz="1500" b="0" i="0">
-              <a:latin typeface="Calibri"/>
-            </a:endParaRPr>
+              <a:t>ACP flows deploy session-scoped pool instances, wire config values, validate </a:t>
+            </a:r>
+            <a:r>
+              <a:rPr sz="1500" b="0" i="0" dirty="0" err="1">
+                <a:latin typeface="Calibri"/>
+              </a:rPr>
+              <a:t>NxN</a:t>
+            </a:r>
+            <a:r>
+              <a:rPr sz="1500" b="0" i="0" dirty="0">
+                <a:latin typeface="Calibri"/>
+              </a:rPr>
+              <a:t> graph rules, and execute through Starter-driven flow semantics.</a:t>
+            </a:r>
           </a:p>
           <a:p>
             <a:pPr>
@@ -18102,14 +18380,35 @@
               </a:defRPr>
             </a:pPr>
             <a:r>
-              <a:rPr sz="1500" b="0" i="0">
+              <a:rPr sz="1500" b="0" i="0" dirty="0">
                 <a:latin typeface="Calibri"/>
               </a:rPr>
-              <a:t>Build scripts collect static assets, bundle Django/Python resources, add agent templates, and assemble `pkg.zip`, `Uninstaller.exe`, and `dist/Tlamatini_Release/`.</a:t>
-            </a:r>
-            <a:endParaRPr sz="1500" b="0" i="0">
-              <a:latin typeface="Calibri"/>
-            </a:endParaRPr>
+              <a:t>Build scripts collect static assets, bundle Django/Python resources, add agent templates, and assemble `pkg.zip`, `Uninstaller.exe`, and `</a:t>
+            </a:r>
+            <a:r>
+              <a:rPr sz="1500" b="0" i="0" dirty="0" err="1">
+                <a:latin typeface="Calibri"/>
+              </a:rPr>
+              <a:t>dist</a:t>
+            </a:r>
+            <a:r>
+              <a:rPr sz="1500" b="0" i="0" dirty="0">
+                <a:latin typeface="Calibri"/>
+              </a:rPr>
+              <a:t>/</a:t>
+            </a:r>
+            <a:r>
+              <a:rPr sz="1500" b="0" i="0" dirty="0" err="1">
+                <a:latin typeface="Calibri"/>
+              </a:rPr>
+              <a:t>Tlamatini_Release</a:t>
+            </a:r>
+            <a:r>
+              <a:rPr sz="1500" b="0" i="0" dirty="0">
+                <a:latin typeface="Calibri"/>
+              </a:rPr>
+              <a:t>/`.</a:t>
+            </a:r>
           </a:p>
         </p:txBody>
       </p:sp>
@@ -18122,7 +18421,7 @@
 </file>
 
 <file path=ppt/slides/slide5.xml><?xml version="1.0" encoding="utf-8"?>
-<p:sld xmlns:a="http://schemas.openxmlformats.org/drawingml/2006/main" xmlns:p="http://schemas.openxmlformats.org/presentationml/2006/main" xmlns:r="http://schemas.openxmlformats.org/officeDocument/2006/relationships">
+<p:sld xmlns:a="http://schemas.openxmlformats.org/drawingml/2006/main" xmlns:r="http://schemas.openxmlformats.org/officeDocument/2006/relationships" xmlns:p="http://schemas.openxmlformats.org/presentationml/2006/main">
   <p:cSld>
     <p:spTree>
       <p:nvGrpSpPr>
@@ -18130,7 +18429,14 @@
         <p:cNvGrpSpPr/>
         <p:nvPr/>
       </p:nvGrpSpPr>
-      <p:grpSpPr/>
+      <p:grpSpPr>
+        <a:xfrm>
+          <a:off x="0" y="0"/>
+          <a:ext cx="0" cy="0"/>
+          <a:chOff x="0" y="0"/>
+          <a:chExt cx="0" cy="0"/>
+        </a:xfrm>
+      </p:grpSpPr>
       <p:sp>
         <p:nvSpPr>
           <p:cNvPr id="2" name="Rectangle 1"/>
@@ -18171,6 +18477,7 @@
           <a:lstStyle/>
           <a:p>
             <a:pPr algn="ctr"/>
+            <a:endParaRPr/>
           </a:p>
         </p:txBody>
       </p:sp>
@@ -18214,6 +18521,7 @@
           <a:lstStyle/>
           <a:p>
             <a:pPr algn="ctr"/>
+            <a:endParaRPr/>
           </a:p>
         </p:txBody>
       </p:sp>
@@ -18257,6 +18565,7 @@
           <a:lstStyle/>
           <a:p>
             <a:pPr algn="ctr"/>
+            <a:endParaRPr/>
           </a:p>
         </p:txBody>
       </p:sp>
@@ -18300,6 +18609,7 @@
           <a:lstStyle/>
           <a:p>
             <a:pPr algn="ctr"/>
+            <a:endParaRPr/>
           </a:p>
         </p:txBody>
       </p:sp>
@@ -18343,6 +18653,7 @@
           <a:lstStyle/>
           <a:p>
             <a:pPr algn="ctr"/>
+            <a:endParaRPr/>
           </a:p>
         </p:txBody>
       </p:sp>
@@ -18458,6 +18769,7 @@
           <a:lstStyle/>
           <a:p>
             <a:pPr algn="ctr"/>
+            <a:endParaRPr/>
           </a:p>
         </p:txBody>
       </p:sp>
@@ -18501,6 +18813,7 @@
           <a:lstStyle/>
           <a:p>
             <a:pPr algn="ctr"/>
+            <a:endParaRPr/>
           </a:p>
         </p:txBody>
       </p:sp>
@@ -18556,7 +18869,7 @@
           <a:noFill/>
         </p:spPr>
         <p:txBody>
-          <a:bodyPr wrap="square" anchor="t" lIns="38100" rIns="38100" tIns="25400" bIns="25400">
+          <a:bodyPr wrap="square" lIns="38100" tIns="25400" rIns="38100" bIns="25400" anchor="t">
             <a:noAutofit/>
           </a:bodyPr>
           <a:lstStyle/>
@@ -18578,9 +18891,6 @@
               </a:rPr>
               <a:t>Load selected file or directory context from the chat interface.</a:t>
             </a:r>
-            <a:endParaRPr sz="1500" b="0" i="0">
-              <a:latin typeface="Calibri"/>
-            </a:endParaRPr>
           </a:p>
           <a:p>
             <a:pPr>
@@ -18600,9 +18910,6 @@
               </a:rPr>
               <a:t>Extract metadata, split text, rank chunks with hybrid retrieval, and respect context budgets.</a:t>
             </a:r>
-            <a:endParaRPr sz="1500" b="0" i="0">
-              <a:latin typeface="Calibri"/>
-            </a:endParaRPr>
           </a:p>
           <a:p>
             <a:pPr>
@@ -18622,9 +18929,6 @@
               </a:rPr>
               <a:t>Fallback to explicit loaded files when retrieval cannot provide enough memory.</a:t>
             </a:r>
-            <a:endParaRPr sz="1500" b="0" i="0">
-              <a:latin typeface="Calibri"/>
-            </a:endParaRPr>
           </a:p>
           <a:p>
             <a:pPr>
@@ -18644,9 +18948,6 @@
               </a:rPr>
               <a:t>Preserve the difference between direct one-shot chat and checked Multi-Turn orchestration.</a:t>
             </a:r>
-            <a:endParaRPr sz="1500" b="0" i="0">
-              <a:latin typeface="Calibri"/>
-            </a:endParaRPr>
           </a:p>
         </p:txBody>
       </p:sp>
@@ -18692,6 +18993,7 @@
           <a:lstStyle/>
           <a:p>
             <a:pPr algn="ctr"/>
+            <a:endParaRPr/>
           </a:p>
         </p:txBody>
       </p:sp>
@@ -18735,6 +19037,7 @@
           <a:lstStyle/>
           <a:p>
             <a:pPr algn="ctr"/>
+            <a:endParaRPr/>
           </a:p>
         </p:txBody>
       </p:sp>
@@ -18790,7 +19093,7 @@
           <a:noFill/>
         </p:spPr>
         <p:txBody>
-          <a:bodyPr wrap="square" anchor="t" lIns="38100" rIns="38100" tIns="25400" bIns="25400">
+          <a:bodyPr wrap="square" lIns="38100" tIns="25400" rIns="38100" bIns="25400" anchor="t">
             <a:noAutofit/>
           </a:bodyPr>
           <a:lstStyle/>
@@ -18812,9 +19115,6 @@
               </a:rPr>
               <a:t>The assistant answers from project evidence instead of generic memory.</a:t>
             </a:r>
-            <a:endParaRPr sz="1600" b="0" i="0">
-              <a:latin typeface="Calibri"/>
-            </a:endParaRPr>
           </a:p>
           <a:p>
             <a:pPr>
@@ -18834,9 +19134,6 @@
               </a:rPr>
               <a:t>Large codebases remain navigable without injecting the whole repository into every prompt.</a:t>
             </a:r>
-            <a:endParaRPr sz="1600" b="0" i="0">
-              <a:latin typeface="Calibri"/>
-            </a:endParaRPr>
           </a:p>
           <a:p>
             <a:pPr>
@@ -18856,9 +19153,6 @@
               </a:rPr>
               <a:t>Multi-Turn can prefetch only the contexts required by the current execution plan.</a:t>
             </a:r>
-            <a:endParaRPr sz="1600" b="0" i="0">
-              <a:latin typeface="Calibri"/>
-            </a:endParaRPr>
           </a:p>
         </p:txBody>
       </p:sp>
@@ -18871,7 +19165,7 @@
 </file>
 
 <file path=ppt/slides/slide6.xml><?xml version="1.0" encoding="utf-8"?>
-<p:sld xmlns:a="http://schemas.openxmlformats.org/drawingml/2006/main" xmlns:p="http://schemas.openxmlformats.org/presentationml/2006/main" xmlns:r="http://schemas.openxmlformats.org/officeDocument/2006/relationships">
+<p:sld xmlns:a="http://schemas.openxmlformats.org/drawingml/2006/main" xmlns:r="http://schemas.openxmlformats.org/officeDocument/2006/relationships" xmlns:p="http://schemas.openxmlformats.org/presentationml/2006/main">
   <p:cSld>
     <p:spTree>
       <p:nvGrpSpPr>
@@ -18879,7 +19173,14 @@
         <p:cNvGrpSpPr/>
         <p:nvPr/>
       </p:nvGrpSpPr>
-      <p:grpSpPr/>
+      <p:grpSpPr>
+        <a:xfrm>
+          <a:off x="0" y="0"/>
+          <a:ext cx="0" cy="0"/>
+          <a:chOff x="0" y="0"/>
+          <a:chExt cx="0" cy="0"/>
+        </a:xfrm>
+      </p:grpSpPr>
       <p:sp>
         <p:nvSpPr>
           <p:cNvPr id="2" name="Rectangle 1"/>
@@ -18920,6 +19221,7 @@
           <a:lstStyle/>
           <a:p>
             <a:pPr algn="ctr"/>
+            <a:endParaRPr/>
           </a:p>
         </p:txBody>
       </p:sp>
@@ -18963,6 +19265,7 @@
           <a:lstStyle/>
           <a:p>
             <a:pPr algn="ctr"/>
+            <a:endParaRPr/>
           </a:p>
         </p:txBody>
       </p:sp>
@@ -19006,6 +19309,7 @@
           <a:lstStyle/>
           <a:p>
             <a:pPr algn="ctr"/>
+            <a:endParaRPr/>
           </a:p>
         </p:txBody>
       </p:sp>
@@ -19049,6 +19353,7 @@
           <a:lstStyle/>
           <a:p>
             <a:pPr algn="ctr"/>
+            <a:endParaRPr/>
           </a:p>
         </p:txBody>
       </p:sp>
@@ -19092,6 +19397,7 @@
           <a:lstStyle/>
           <a:p>
             <a:pPr algn="ctr"/>
+            <a:endParaRPr/>
           </a:p>
         </p:txBody>
       </p:sp>
@@ -19207,6 +19513,7 @@
           <a:lstStyle/>
           <a:p>
             <a:pPr algn="ctr"/>
+            <a:endParaRPr/>
           </a:p>
         </p:txBody>
       </p:sp>
@@ -19250,6 +19557,7 @@
           <a:lstStyle/>
           <a:p>
             <a:pPr algn="ctr"/>
+            <a:endParaRPr/>
           </a:p>
         </p:txBody>
       </p:sp>
@@ -19305,7 +19613,7 @@
           <a:noFill/>
         </p:spPr>
         <p:txBody>
-          <a:bodyPr wrap="square" anchor="t" lIns="38100" rIns="38100" tIns="25400" bIns="25400">
+          <a:bodyPr wrap="square" lIns="38100" tIns="25400" rIns="38100" bIns="25400" anchor="t">
             <a:noAutofit/>
           </a:bodyPr>
           <a:lstStyle/>
@@ -19327,9 +19635,6 @@
               </a:rPr>
               <a:t>Capability registry scores context providers, tools, and wrapped agents for the current request.</a:t>
             </a:r>
-            <a:endParaRPr sz="1500" b="0" i="0">
-              <a:latin typeface="Calibri"/>
-            </a:endParaRPr>
           </a:p>
           <a:p>
             <a:pPr>
@@ -19349,9 +19654,6 @@
               </a:rPr>
               <a:t>Global planner builds prefetch, execute, monitor, and answer stages.</a:t>
             </a:r>
-            <a:endParaRPr sz="1500" b="0" i="0">
-              <a:latin typeface="Calibri"/>
-            </a:endParaRPr>
           </a:p>
           <a:p>
             <a:pPr>
@@ -19371,9 +19673,6 @@
               </a:rPr>
               <a:t>Explicit tool loop runs tool calls, appends observations, and asks again until final answer or limit.</a:t>
             </a:r>
-            <a:endParaRPr sz="1500" b="0" i="0">
-              <a:latin typeface="Calibri"/>
-            </a:endParaRPr>
           </a:p>
           <a:p>
             <a:pPr>
@@ -19393,9 +19692,6 @@
               </a:rPr>
               <a:t>Answer Analizer classifies success so the UI can expose Create Flow only when useful.</a:t>
             </a:r>
-            <a:endParaRPr sz="1500" b="0" i="0">
-              <a:latin typeface="Calibri"/>
-            </a:endParaRPr>
           </a:p>
         </p:txBody>
       </p:sp>
@@ -19441,6 +19737,7 @@
           <a:lstStyle/>
           <a:p>
             <a:pPr algn="ctr"/>
+            <a:endParaRPr/>
           </a:p>
         </p:txBody>
       </p:sp>
@@ -19484,6 +19781,7 @@
           <a:lstStyle/>
           <a:p>
             <a:pPr algn="ctr"/>
+            <a:endParaRPr/>
           </a:p>
         </p:txBody>
       </p:sp>
@@ -19539,7 +19837,7 @@
           <a:noFill/>
         </p:spPr>
         <p:txBody>
-          <a:bodyPr wrap="square" anchor="t" lIns="38100" rIns="38100" tIns="25400" bIns="25400">
+          <a:bodyPr wrap="square" lIns="38100" tIns="25400" rIns="38100" bIns="25400" anchor="t">
             <a:noAutofit/>
           </a:bodyPr>
           <a:lstStyle/>
@@ -19561,9 +19859,6 @@
               </a:rPr>
               <a:t>Keeps the original prompt validation and legacy prefetch behavior.</a:t>
             </a:r>
-            <a:endParaRPr sz="1600" b="0" i="0">
-              <a:latin typeface="Calibri"/>
-            </a:endParaRPr>
           </a:p>
           <a:p>
             <a:pPr>
@@ -19583,9 +19878,6 @@
               </a:rPr>
               <a:t>Maintains compatibility for fast Q&amp;A and simple context-grounded answers.</a:t>
             </a:r>
-            <a:endParaRPr sz="1600" b="0" i="0">
-              <a:latin typeface="Calibri"/>
-            </a:endParaRPr>
           </a:p>
           <a:p>
             <a:pPr>
@@ -19605,9 +19897,6 @@
               </a:rPr>
               <a:t>Avoids forcing every chat request into agentic execution.</a:t>
             </a:r>
-            <a:endParaRPr sz="1600" b="0" i="0">
-              <a:latin typeface="Calibri"/>
-            </a:endParaRPr>
           </a:p>
         </p:txBody>
       </p:sp>
@@ -19620,7 +19909,7 @@
 </file>
 
 <file path=ppt/slides/slide7.xml><?xml version="1.0" encoding="utf-8"?>
-<p:sld xmlns:a="http://schemas.openxmlformats.org/drawingml/2006/main" xmlns:p="http://schemas.openxmlformats.org/presentationml/2006/main" xmlns:r="http://schemas.openxmlformats.org/officeDocument/2006/relationships">
+<p:sld xmlns:a="http://schemas.openxmlformats.org/drawingml/2006/main" xmlns:r="http://schemas.openxmlformats.org/officeDocument/2006/relationships" xmlns:p="http://schemas.openxmlformats.org/presentationml/2006/main">
   <p:cSld>
     <p:spTree>
       <p:nvGrpSpPr>
@@ -19628,7 +19917,14 @@
         <p:cNvGrpSpPr/>
         <p:nvPr/>
       </p:nvGrpSpPr>
-      <p:grpSpPr/>
+      <p:grpSpPr>
+        <a:xfrm>
+          <a:off x="0" y="0"/>
+          <a:ext cx="0" cy="0"/>
+          <a:chOff x="0" y="0"/>
+          <a:chExt cx="0" cy="0"/>
+        </a:xfrm>
+      </p:grpSpPr>
       <p:sp>
         <p:nvSpPr>
           <p:cNvPr id="2" name="Rectangle 1"/>
@@ -19669,6 +19965,7 @@
           <a:lstStyle/>
           <a:p>
             <a:pPr algn="ctr"/>
+            <a:endParaRPr/>
           </a:p>
         </p:txBody>
       </p:sp>
@@ -19712,6 +20009,7 @@
           <a:lstStyle/>
           <a:p>
             <a:pPr algn="ctr"/>
+            <a:endParaRPr/>
           </a:p>
         </p:txBody>
       </p:sp>
@@ -19755,6 +20053,7 @@
           <a:lstStyle/>
           <a:p>
             <a:pPr algn="ctr"/>
+            <a:endParaRPr/>
           </a:p>
         </p:txBody>
       </p:sp>
@@ -19798,6 +20097,7 @@
           <a:lstStyle/>
           <a:p>
             <a:pPr algn="ctr"/>
+            <a:endParaRPr/>
           </a:p>
         </p:txBody>
       </p:sp>
@@ -19841,6 +20141,7 @@
           <a:lstStyle/>
           <a:p>
             <a:pPr algn="ctr"/>
+            <a:endParaRPr/>
           </a:p>
         </p:txBody>
       </p:sp>
@@ -19956,6 +20257,7 @@
           <a:lstStyle/>
           <a:p>
             <a:pPr algn="ctr"/>
+            <a:endParaRPr/>
           </a:p>
         </p:txBody>
       </p:sp>
@@ -19999,6 +20301,7 @@
           <a:lstStyle/>
           <a:p>
             <a:pPr algn="ctr"/>
+            <a:endParaRPr/>
           </a:p>
         </p:txBody>
       </p:sp>
@@ -20054,7 +20357,7 @@
           <a:noFill/>
         </p:spPr>
         <p:txBody>
-          <a:bodyPr wrap="square" anchor="t" lIns="38100" rIns="38100" tIns="25400" bIns="25400">
+          <a:bodyPr wrap="square" lIns="38100" tIns="25400" rIns="38100" bIns="25400" anchor="t">
             <a:noAutofit/>
           </a:bodyPr>
           <a:lstStyle/>
@@ -20076,9 +20379,6 @@
               </a:rPr>
               <a:t>Drag prebuilt agents onto the canvas and connect them visually.</a:t>
             </a:r>
-            <a:endParaRPr sz="1500" b="0" i="0">
-              <a:latin typeface="Calibri"/>
-            </a:endParaRPr>
           </a:p>
           <a:p>
             <a:pPr>
@@ -20098,9 +20398,6 @@
               </a:rPr>
               <a:t>Configure deployed pool instances, not only static template folders.</a:t>
             </a:r>
-            <a:endParaRPr sz="1500" b="0" i="0">
-              <a:latin typeface="Calibri"/>
-            </a:endParaRPr>
           </a:p>
           <a:p>
             <a:pPr>
@@ -20120,9 +20417,6 @@
               </a:rPr>
               <a:t>Validate structural rules before execution.</a:t>
             </a:r>
-            <a:endParaRPr sz="1500" b="0" i="0">
-              <a:latin typeface="Calibri"/>
-            </a:endParaRPr>
           </a:p>
           <a:p>
             <a:pPr>
@@ -20142,9 +20436,6 @@
               </a:rPr>
               <a:t>Start through Starter, pause/resume through reanimation state, and stop through Ender semantics.</a:t>
             </a:r>
-            <a:endParaRPr sz="1500" b="0" i="0">
-              <a:latin typeface="Calibri"/>
-            </a:endParaRPr>
           </a:p>
         </p:txBody>
       </p:sp>
@@ -20190,6 +20481,7 @@
           <a:lstStyle/>
           <a:p>
             <a:pPr algn="ctr"/>
+            <a:endParaRPr/>
           </a:p>
         </p:txBody>
       </p:sp>
@@ -20233,6 +20525,7 @@
           <a:lstStyle/>
           <a:p>
             <a:pPr algn="ctr"/>
+            <a:endParaRPr/>
           </a:p>
         </p:txBody>
       </p:sp>
@@ -20288,7 +20581,7 @@
           <a:noFill/>
         </p:spPr>
         <p:txBody>
-          <a:bodyPr wrap="square" anchor="t" lIns="38100" rIns="38100" tIns="25400" bIns="25400">
+          <a:bodyPr wrap="square" lIns="38100" tIns="25400" rIns="38100" bIns="25400" anchor="t">
             <a:noAutofit/>
           </a:bodyPr>
           <a:lstStyle/>
@@ -20310,9 +20603,6 @@
               </a:rPr>
               <a:t>Workflows save and load as `.flw` files.</a:t>
             </a:r>
-            <a:endParaRPr sz="1600" b="0" i="0">
-              <a:latin typeface="Calibri"/>
-            </a:endParaRPr>
           </a:p>
           <a:p>
             <a:pPr>
@@ -20332,9 +20622,6 @@
               </a:rPr>
               <a:t>Generated flows from chat are starter drafts, not a replacement for ACP validation.</a:t>
             </a:r>
-            <a:endParaRPr sz="1600" b="0" i="0">
-              <a:latin typeface="Calibri"/>
-            </a:endParaRPr>
           </a:p>
           <a:p>
             <a:pPr>
@@ -20354,9 +20641,6 @@
               </a:rPr>
               <a:t>LED indicators and logs show runtime health across the session pool.</a:t>
             </a:r>
-            <a:endParaRPr sz="1600" b="0" i="0">
-              <a:latin typeface="Calibri"/>
-            </a:endParaRPr>
           </a:p>
         </p:txBody>
       </p:sp>
@@ -20369,7 +20653,7 @@
 </file>
 
 <file path=ppt/slides/slide8.xml><?xml version="1.0" encoding="utf-8"?>
-<p:sld xmlns:a="http://schemas.openxmlformats.org/drawingml/2006/main" xmlns:p="http://schemas.openxmlformats.org/presentationml/2006/main" xmlns:r="http://schemas.openxmlformats.org/officeDocument/2006/relationships">
+<p:sld xmlns:a="http://schemas.openxmlformats.org/drawingml/2006/main" xmlns:r="http://schemas.openxmlformats.org/officeDocument/2006/relationships" xmlns:p="http://schemas.openxmlformats.org/presentationml/2006/main">
   <p:cSld>
     <p:spTree>
       <p:nvGrpSpPr>
@@ -20377,7 +20661,14 @@
         <p:cNvGrpSpPr/>
         <p:nvPr/>
       </p:nvGrpSpPr>
-      <p:grpSpPr/>
+      <p:grpSpPr>
+        <a:xfrm>
+          <a:off x="0" y="0"/>
+          <a:ext cx="0" cy="0"/>
+          <a:chOff x="0" y="0"/>
+          <a:chExt cx="0" cy="0"/>
+        </a:xfrm>
+      </p:grpSpPr>
       <p:sp>
         <p:nvSpPr>
           <p:cNvPr id="2" name="Rectangle 1"/>
@@ -20418,6 +20709,7 @@
           <a:lstStyle/>
           <a:p>
             <a:pPr algn="ctr"/>
+            <a:endParaRPr/>
           </a:p>
         </p:txBody>
       </p:sp>
@@ -20461,6 +20753,7 @@
           <a:lstStyle/>
           <a:p>
             <a:pPr algn="ctr"/>
+            <a:endParaRPr/>
           </a:p>
         </p:txBody>
       </p:sp>
@@ -20504,6 +20797,7 @@
           <a:lstStyle/>
           <a:p>
             <a:pPr algn="ctr"/>
+            <a:endParaRPr/>
           </a:p>
         </p:txBody>
       </p:sp>
@@ -20547,6 +20841,7 @@
           <a:lstStyle/>
           <a:p>
             <a:pPr algn="ctr"/>
+            <a:endParaRPr/>
           </a:p>
         </p:txBody>
       </p:sp>
@@ -20590,6 +20885,7 @@
           <a:lstStyle/>
           <a:p>
             <a:pPr algn="ctr"/>
+            <a:endParaRPr/>
           </a:p>
         </p:txBody>
       </p:sp>
@@ -20705,6 +21001,7 @@
           <a:lstStyle/>
           <a:p>
             <a:pPr algn="ctr"/>
+            <a:endParaRPr/>
           </a:p>
         </p:txBody>
       </p:sp>
@@ -20748,6 +21045,7 @@
           <a:lstStyle/>
           <a:p>
             <a:pPr algn="ctr"/>
+            <a:endParaRPr/>
           </a:p>
         </p:txBody>
       </p:sp>
@@ -20803,7 +21101,7 @@
           <a:noFill/>
         </p:spPr>
         <p:txBody>
-          <a:bodyPr wrap="square" anchor="t" lIns="38100" rIns="38100" tIns="25400" bIns="25400">
+          <a:bodyPr wrap="square" lIns="38100" tIns="25400" rIns="38100" bIns="25400" anchor="t">
             <a:noAutofit/>
           </a:bodyPr>
           <a:lstStyle/>
@@ -20825,9 +21123,6 @@
               </a:rPr>
               <a:t>Control: starter, ender, stopper, cleaner, barrier, flowbacker</a:t>
             </a:r>
-            <a:endParaRPr sz="1300" b="0" i="0">
-              <a:latin typeface="Calibri"/>
-            </a:endParaRPr>
           </a:p>
           <a:p>
             <a:pPr>
@@ -20847,9 +21142,6 @@
               </a:rPr>
               <a:t>Execution and files: executer, pythonxer, pser, file_creator, file_extractor, file_interpreter, mover, deleter</a:t>
             </a:r>
-            <a:endParaRPr sz="1300" b="0" i="0">
-              <a:latin typeface="Calibri"/>
-            </a:endParaRPr>
           </a:p>
           <a:p>
             <a:pPr>
@@ -20869,9 +21161,6 @@
               </a:rPr>
               <a:t>DevOps and infra: gitter, dockerer, kuberneter, jenkinser, ssher, scper</a:t>
             </a:r>
-            <a:endParaRPr sz="1300" b="0" i="0">
-              <a:latin typeface="Calibri"/>
-            </a:endParaRPr>
           </a:p>
           <a:p>
             <a:pPr>
@@ -20891,9 +21180,6 @@
               </a:rPr>
               <a:t>Data and APIs: sqler, mongoxer, apirer, crawler, googler</a:t>
             </a:r>
-            <a:endParaRPr sz="1300" b="0" i="0">
-              <a:latin typeface="Calibri"/>
-            </a:endParaRPr>
           </a:p>
         </p:txBody>
       </p:sp>
@@ -20939,6 +21225,7 @@
           <a:lstStyle/>
           <a:p>
             <a:pPr algn="ctr"/>
+            <a:endParaRPr/>
           </a:p>
         </p:txBody>
       </p:sp>
@@ -20982,6 +21269,7 @@
           <a:lstStyle/>
           <a:p>
             <a:pPr algn="ctr"/>
+            <a:endParaRPr/>
           </a:p>
         </p:txBody>
       </p:sp>
@@ -21037,7 +21325,7 @@
           <a:noFill/>
         </p:spPr>
         <p:txBody>
-          <a:bodyPr wrap="square" anchor="t" lIns="38100" rIns="38100" tIns="25400" bIns="25400">
+          <a:bodyPr wrap="square" lIns="38100" tIns="25400" rIns="38100" bIns="25400" anchor="t">
             <a:noAutofit/>
           </a:bodyPr>
           <a:lstStyle/>
@@ -21059,9 +21347,6 @@
               </a:rPr>
               <a:t>Monitoring and routing: monitor_log, monitor_netstat, flowhypervisor, forker, asker, counter, and, or</a:t>
             </a:r>
-            <a:endParaRPr sz="1300" b="0" i="0">
-              <a:latin typeface="Calibri"/>
-            </a:endParaRPr>
           </a:p>
           <a:p>
             <a:pPr>
@@ -21081,9 +21366,6 @@
               </a:rPr>
               <a:t>Communication: notifier, emailer, recmailer, telegramer, telegramrx, whatsapper</a:t>
             </a:r>
-            <a:endParaRPr sz="1300" b="0" i="0">
-              <a:latin typeface="Calibri"/>
-            </a:endParaRPr>
           </a:p>
           <a:p>
             <a:pPr>
@@ -21103,9 +21385,6 @@
               </a:rPr>
               <a:t>Security and media: kyber_keygen, kyber_cipher, kyber_decipher, image_interpreter, shoter, j_decompiler</a:t>
             </a:r>
-            <a:endParaRPr sz="1300" b="0" i="0">
-              <a:latin typeface="Calibri"/>
-            </a:endParaRPr>
           </a:p>
           <a:p>
             <a:pPr>
@@ -21125,9 +21404,6 @@
               </a:rPr>
               <a:t>Workflow intelligence: flowcreator, gatewayer, gateway_relayer, node_manager, parametrizer, prompter, summarizer</a:t>
             </a:r>
-            <a:endParaRPr sz="1300" b="0" i="0">
-              <a:latin typeface="Calibri"/>
-            </a:endParaRPr>
           </a:p>
         </p:txBody>
       </p:sp>
@@ -21140,7 +21416,7 @@
 </file>
 
 <file path=ppt/slides/slide9.xml><?xml version="1.0" encoding="utf-8"?>
-<p:sld xmlns:a="http://schemas.openxmlformats.org/drawingml/2006/main" xmlns:p="http://schemas.openxmlformats.org/presentationml/2006/main" xmlns:r="http://schemas.openxmlformats.org/officeDocument/2006/relationships">
+<p:sld xmlns:a="http://schemas.openxmlformats.org/drawingml/2006/main" xmlns:r="http://schemas.openxmlformats.org/officeDocument/2006/relationships" xmlns:p="http://schemas.openxmlformats.org/presentationml/2006/main">
   <p:cSld>
     <p:spTree>
       <p:nvGrpSpPr>
@@ -21148,7 +21424,14 @@
         <p:cNvGrpSpPr/>
         <p:nvPr/>
       </p:nvGrpSpPr>
-      <p:grpSpPr/>
+      <p:grpSpPr>
+        <a:xfrm>
+          <a:off x="0" y="0"/>
+          <a:ext cx="0" cy="0"/>
+          <a:chOff x="0" y="0"/>
+          <a:chExt cx="0" cy="0"/>
+        </a:xfrm>
+      </p:grpSpPr>
       <p:sp>
         <p:nvSpPr>
           <p:cNvPr id="2" name="Rectangle 1"/>
@@ -21189,6 +21472,7 @@
           <a:lstStyle/>
           <a:p>
             <a:pPr algn="ctr"/>
+            <a:endParaRPr/>
           </a:p>
         </p:txBody>
       </p:sp>
@@ -21232,6 +21516,7 @@
           <a:lstStyle/>
           <a:p>
             <a:pPr algn="ctr"/>
+            <a:endParaRPr/>
           </a:p>
         </p:txBody>
       </p:sp>
@@ -21275,6 +21560,7 @@
           <a:lstStyle/>
           <a:p>
             <a:pPr algn="ctr"/>
+            <a:endParaRPr/>
           </a:p>
         </p:txBody>
       </p:sp>
@@ -21318,6 +21604,7 @@
           <a:lstStyle/>
           <a:p>
             <a:pPr algn="ctr"/>
+            <a:endParaRPr/>
           </a:p>
         </p:txBody>
       </p:sp>
@@ -21361,6 +21648,7 @@
           <a:lstStyle/>
           <a:p>
             <a:pPr algn="ctr"/>
+            <a:endParaRPr/>
           </a:p>
         </p:txBody>
       </p:sp>
@@ -21476,6 +21764,7 @@
           <a:lstStyle/>
           <a:p>
             <a:pPr algn="ctr"/>
+            <a:endParaRPr/>
           </a:p>
         </p:txBody>
       </p:sp>
@@ -21519,6 +21808,7 @@
           <a:lstStyle/>
           <a:p>
             <a:pPr algn="ctr"/>
+            <a:endParaRPr/>
           </a:p>
         </p:txBody>
       </p:sp>
@@ -21574,7 +21864,7 @@
           <a:noFill/>
         </p:spPr>
         <p:txBody>
-          <a:bodyPr wrap="square" anchor="t" lIns="38100" rIns="38100" tIns="25400" bIns="25400">
+          <a:bodyPr wrap="square" lIns="38100" tIns="25400" rIns="38100" bIns="25400" anchor="t">
             <a:noAutofit/>
           </a:bodyPr>
           <a:lstStyle/>
@@ -21596,9 +21886,6 @@
               </a:rPr>
               <a:t>Receives HTTP webhook events or optional folder-drop files.</a:t>
             </a:r>
-            <a:endParaRPr sz="1500" b="0" i="0">
-              <a:latin typeface="Calibri"/>
-            </a:endParaRPr>
           </a:p>
           <a:p>
             <a:pPr>
@@ -21618,9 +21905,6 @@
               </a:rPr>
               <a:t>Normalizes, persists, queues, and dispatches events into downstream workflow agents.</a:t>
             </a:r>
-            <a:endParaRPr sz="1500" b="0" i="0">
-              <a:latin typeface="Calibri"/>
-            </a:endParaRPr>
           </a:p>
           <a:p>
             <a:pPr>
@@ -21640,9 +21924,6 @@
               </a:rPr>
               <a:t>Supports bearer/HMAC-style auth patterns, IP allowlists, dedup files, and crash recovery state.</a:t>
             </a:r>
-            <a:endParaRPr sz="1500" b="0" i="0">
-              <a:latin typeface="Calibri"/>
-            </a:endParaRPr>
           </a:p>
         </p:txBody>
       </p:sp>
@@ -21688,6 +21969,7 @@
           <a:lstStyle/>
           <a:p>
             <a:pPr algn="ctr"/>
+            <a:endParaRPr/>
           </a:p>
         </p:txBody>
       </p:sp>
@@ -21731,6 +22013,7 @@
           <a:lstStyle/>
           <a:p>
             <a:pPr algn="ctr"/>
+            <a:endParaRPr/>
           </a:p>
         </p:txBody>
       </p:sp>
@@ -21786,7 +22069,7 @@
           <a:noFill/>
         </p:spPr>
         <p:txBody>
-          <a:bodyPr wrap="square" anchor="t" lIns="38100" rIns="38100" tIns="25400" bIns="25400">
+          <a:bodyPr wrap="square" lIns="38100" tIns="25400" rIns="38100" bIns="25400" anchor="t">
             <a:noAutofit/>
           </a:bodyPr>
           <a:lstStyle/>
@@ -21808,9 +22091,6 @@
               </a:rPr>
               <a:t>Gatewayer is a workflow trigger, not a chat-router clone.</a:t>
             </a:r>
-            <a:endParaRPr sz="1600" b="0" i="0">
-              <a:latin typeface="Calibri"/>
-            </a:endParaRPr>
           </a:p>
           <a:p>
             <a:pPr>
@@ -21830,9 +22110,6 @@
               </a:rPr>
               <a:t>Declared config fields are now documented with clear caveats where enforcement is not complete.</a:t>
             </a:r>
-            <a:endParaRPr sz="1600" b="0" i="0">
-              <a:latin typeface="Calibri"/>
-            </a:endParaRPr>
           </a:p>
           <a:p>
             <a:pPr>
@@ -21852,9 +22129,6 @@
               </a:rPr>
               <a:t>Stable log markers let Monitor Log and Summarizer watch gateway health.</a:t>
             </a:r>
-            <a:endParaRPr sz="1600" b="0" i="0">
-              <a:latin typeface="Calibri"/>
-            </a:endParaRPr>
           </a:p>
         </p:txBody>
       </p:sp>

</xml_diff>

<commit_message>
Udating PPTX and PDF general documentation, by angelahack1
</commit_message>
<xml_diff>
--- a/Tlamatini_eXtended_Artificial_Intelligence_Humanly_Tempered.pptx
+++ b/Tlamatini_eXtended_Artificial_Intelligence_Humanly_Tempered.pptx
@@ -5,40 +5,40 @@
     <p:sldMasterId id="2147483648" r:id="rId1"/>
   </p:sldMasterIdLst>
   <p:sldIdLst>
-    <p:sldId id="256" r:id="rId2"/>
-    <p:sldId id="257" r:id="rId3"/>
-    <p:sldId id="258" r:id="rId4"/>
-    <p:sldId id="259" r:id="rId5"/>
-    <p:sldId id="260" r:id="rId6"/>
-    <p:sldId id="261" r:id="rId7"/>
-    <p:sldId id="262" r:id="rId8"/>
-    <p:sldId id="263" r:id="rId9"/>
-    <p:sldId id="264" r:id="rId10"/>
-    <p:sldId id="265" r:id="rId11"/>
-    <p:sldId id="266" r:id="rId12"/>
-    <p:sldId id="267" r:id="rId13"/>
-    <p:sldId id="268" r:id="rId14"/>
-    <p:sldId id="269" r:id="rId15"/>
-    <p:sldId id="270" r:id="rId16"/>
-    <p:sldId id="271" r:id="rId17"/>
-    <p:sldId id="272" r:id="rId18"/>
-    <p:sldId id="273" r:id="rId19"/>
-    <p:sldId id="274" r:id="rId20"/>
-    <p:sldId id="275" r:id="rId21"/>
-    <p:sldId id="276" r:id="rId22"/>
-    <p:sldId id="277" r:id="rId23"/>
-    <p:sldId id="278" r:id="rId24"/>
-    <p:sldId id="279" r:id="rId25"/>
-    <p:sldId id="280" r:id="rId26"/>
-    <p:sldId id="281" r:id="rId27"/>
-    <p:sldId id="282" r:id="rId28"/>
-    <p:sldId id="283" r:id="rId29"/>
-    <p:sldId id="284" r:id="rId30"/>
-    <p:sldId id="285" r:id="rId31"/>
-    <p:sldId id="286" r:id="rId32"/>
-    <p:sldId id="287" r:id="rId33"/>
+    <p:sldId id="256" r:id="rId7"/>
+    <p:sldId id="257" r:id="rId8"/>
+    <p:sldId id="258" r:id="rId9"/>
+    <p:sldId id="259" r:id="rId10"/>
+    <p:sldId id="260" r:id="rId11"/>
+    <p:sldId id="261" r:id="rId12"/>
+    <p:sldId id="262" r:id="rId13"/>
+    <p:sldId id="263" r:id="rId14"/>
+    <p:sldId id="264" r:id="rId15"/>
+    <p:sldId id="265" r:id="rId16"/>
+    <p:sldId id="266" r:id="rId17"/>
+    <p:sldId id="267" r:id="rId18"/>
+    <p:sldId id="268" r:id="rId19"/>
+    <p:sldId id="269" r:id="rId20"/>
+    <p:sldId id="270" r:id="rId21"/>
+    <p:sldId id="271" r:id="rId22"/>
+    <p:sldId id="272" r:id="rId23"/>
+    <p:sldId id="273" r:id="rId24"/>
+    <p:sldId id="274" r:id="rId25"/>
+    <p:sldId id="275" r:id="rId26"/>
+    <p:sldId id="276" r:id="rId27"/>
+    <p:sldId id="277" r:id="rId28"/>
+    <p:sldId id="278" r:id="rId29"/>
+    <p:sldId id="279" r:id="rId30"/>
+    <p:sldId id="280" r:id="rId31"/>
+    <p:sldId id="281" r:id="rId32"/>
+    <p:sldId id="282" r:id="rId33"/>
+    <p:sldId id="283" r:id="rId34"/>
+    <p:sldId id="284" r:id="rId35"/>
+    <p:sldId id="285" r:id="rId36"/>
+    <p:sldId id="286" r:id="rId37"/>
+    <p:sldId id="287" r:id="rId38"/>
   </p:sldIdLst>
-  <p:sldSz cx="12192000" cy="6858000"/>
+  <p:sldSz cx="12191695" cy="6858000" type="screen4x3"/>
   <p:notesSz cx="6858000" cy="9144000"/>
   <p:defaultTextStyle>
     <a:defPPr>
@@ -135,22 +135,6 @@
       </a:defRPr>
     </a:lvl9pPr>
   </p:defaultTextStyle>
-  <p:extLst>
-    <p:ext uri="{EFAFB233-063F-42B5-8137-9DF3F51BA10A}">
-      <p15:sldGuideLst xmlns:p15="http://schemas.microsoft.com/office/powerpoint/2012/main">
-        <p15:guide id="1" orient="horz" pos="2160">
-          <p15:clr>
-            <a:srgbClr val="A4A3A4"/>
-          </p15:clr>
-        </p15:guide>
-        <p15:guide id="2" pos="2880">
-          <p15:clr>
-            <a:srgbClr val="A4A3A4"/>
-          </p15:clr>
-        </p15:guide>
-      </p15:sldGuideLst>
-    </p:ext>
-  </p:extLst>
 </p:presentation>
 </file>
 
@@ -192,9 +176,10 @@
           <a:lstStyle/>
           <a:p>
             <a:r>
-              <a:rPr lang="en-US"/>
+              <a:rPr lang="en-US" smtClean="0"/>
               <a:t>Click to edit Master title style</a:t>
             </a:r>
+            <a:endParaRPr lang="en-US"/>
           </a:p>
         </p:txBody>
       </p:sp>
@@ -310,9 +295,10 @@
           </a:lstStyle>
           <a:p>
             <a:r>
-              <a:rPr lang="en-US"/>
+              <a:rPr lang="en-US" smtClean="0"/>
               <a:t>Click to edit Master subtitle style</a:t>
             </a:r>
+            <a:endParaRPr lang="en-US"/>
           </a:p>
         </p:txBody>
       </p:sp>
@@ -333,7 +319,7 @@
           <a:p>
             <a:fld id="{5BCAD085-E8A6-8845-BD4E-CB4CCA059FC4}" type="datetimeFigureOut">
               <a:rPr lang="en-US" smtClean="0"/>
-              <a:t>4/18/2026</a:t>
+              <a:t>1/27/13</a:t>
             </a:fld>
             <a:endParaRPr lang="en-US"/>
           </a:p>
@@ -427,9 +413,10 @@
           <a:lstStyle/>
           <a:p>
             <a:r>
-              <a:rPr lang="en-US"/>
+              <a:rPr lang="en-US" smtClean="0"/>
               <a:t>Click to edit Master title style</a:t>
             </a:r>
+            <a:endParaRPr lang="en-US"/>
           </a:p>
         </p:txBody>
       </p:sp>
@@ -450,37 +437,38 @@
           <a:p>
             <a:pPr lvl="0"/>
             <a:r>
-              <a:rPr lang="en-US"/>
+              <a:rPr lang="en-US" smtClean="0"/>
               <a:t>Click to edit Master text styles</a:t>
             </a:r>
           </a:p>
           <a:p>
             <a:pPr lvl="1"/>
             <a:r>
-              <a:rPr lang="en-US"/>
+              <a:rPr lang="en-US" smtClean="0"/>
               <a:t>Second level</a:t>
             </a:r>
           </a:p>
           <a:p>
             <a:pPr lvl="2"/>
             <a:r>
-              <a:rPr lang="en-US"/>
+              <a:rPr lang="en-US" smtClean="0"/>
               <a:t>Third level</a:t>
             </a:r>
           </a:p>
           <a:p>
             <a:pPr lvl="3"/>
             <a:r>
-              <a:rPr lang="en-US"/>
+              <a:rPr lang="en-US" smtClean="0"/>
               <a:t>Fourth level</a:t>
             </a:r>
           </a:p>
           <a:p>
             <a:pPr lvl="4"/>
             <a:r>
-              <a:rPr lang="en-US"/>
+              <a:rPr lang="en-US" smtClean="0"/>
               <a:t>Fifth level</a:t>
             </a:r>
+            <a:endParaRPr lang="en-US"/>
           </a:p>
         </p:txBody>
       </p:sp>
@@ -501,7 +489,7 @@
           <a:p>
             <a:fld id="{5BCAD085-E8A6-8845-BD4E-CB4CCA059FC4}" type="datetimeFigureOut">
               <a:rPr lang="en-US" smtClean="0"/>
-              <a:t>4/18/2026</a:t>
+              <a:t>1/27/13</a:t>
             </a:fld>
             <a:endParaRPr lang="en-US"/>
           </a:p>
@@ -600,9 +588,10 @@
           <a:lstStyle/>
           <a:p>
             <a:r>
-              <a:rPr lang="en-US"/>
+              <a:rPr lang="en-US" smtClean="0"/>
               <a:t>Click to edit Master title style</a:t>
             </a:r>
+            <a:endParaRPr lang="en-US"/>
           </a:p>
         </p:txBody>
       </p:sp>
@@ -628,37 +617,38 @@
           <a:p>
             <a:pPr lvl="0"/>
             <a:r>
-              <a:rPr lang="en-US"/>
+              <a:rPr lang="en-US" smtClean="0"/>
               <a:t>Click to edit Master text styles</a:t>
             </a:r>
           </a:p>
           <a:p>
             <a:pPr lvl="1"/>
             <a:r>
-              <a:rPr lang="en-US"/>
+              <a:rPr lang="en-US" smtClean="0"/>
               <a:t>Second level</a:t>
             </a:r>
           </a:p>
           <a:p>
             <a:pPr lvl="2"/>
             <a:r>
-              <a:rPr lang="en-US"/>
+              <a:rPr lang="en-US" smtClean="0"/>
               <a:t>Third level</a:t>
             </a:r>
           </a:p>
           <a:p>
             <a:pPr lvl="3"/>
             <a:r>
-              <a:rPr lang="en-US"/>
+              <a:rPr lang="en-US" smtClean="0"/>
               <a:t>Fourth level</a:t>
             </a:r>
           </a:p>
           <a:p>
             <a:pPr lvl="4"/>
             <a:r>
-              <a:rPr lang="en-US"/>
+              <a:rPr lang="en-US" smtClean="0"/>
               <a:t>Fifth level</a:t>
             </a:r>
+            <a:endParaRPr lang="en-US"/>
           </a:p>
         </p:txBody>
       </p:sp>
@@ -679,7 +669,7 @@
           <a:p>
             <a:fld id="{5BCAD085-E8A6-8845-BD4E-CB4CCA059FC4}" type="datetimeFigureOut">
               <a:rPr lang="en-US" smtClean="0"/>
-              <a:t>4/18/2026</a:t>
+              <a:t>1/27/13</a:t>
             </a:fld>
             <a:endParaRPr lang="en-US"/>
           </a:p>
@@ -773,9 +763,10 @@
           <a:lstStyle/>
           <a:p>
             <a:r>
-              <a:rPr lang="en-US"/>
+              <a:rPr lang="en-US" smtClean="0"/>
               <a:t>Click to edit Master title style</a:t>
             </a:r>
+            <a:endParaRPr lang="en-US"/>
           </a:p>
         </p:txBody>
       </p:sp>
@@ -796,37 +787,38 @@
           <a:p>
             <a:pPr lvl="0"/>
             <a:r>
-              <a:rPr lang="en-US"/>
+              <a:rPr lang="en-US" smtClean="0"/>
               <a:t>Click to edit Master text styles</a:t>
             </a:r>
           </a:p>
           <a:p>
             <a:pPr lvl="1"/>
             <a:r>
-              <a:rPr lang="en-US"/>
+              <a:rPr lang="en-US" smtClean="0"/>
               <a:t>Second level</a:t>
             </a:r>
           </a:p>
           <a:p>
             <a:pPr lvl="2"/>
             <a:r>
-              <a:rPr lang="en-US"/>
+              <a:rPr lang="en-US" smtClean="0"/>
               <a:t>Third level</a:t>
             </a:r>
           </a:p>
           <a:p>
             <a:pPr lvl="3"/>
             <a:r>
-              <a:rPr lang="en-US"/>
+              <a:rPr lang="en-US" smtClean="0"/>
               <a:t>Fourth level</a:t>
             </a:r>
           </a:p>
           <a:p>
             <a:pPr lvl="4"/>
             <a:r>
-              <a:rPr lang="en-US"/>
+              <a:rPr lang="en-US" smtClean="0"/>
               <a:t>Fifth level</a:t>
             </a:r>
+            <a:endParaRPr lang="en-US"/>
           </a:p>
         </p:txBody>
       </p:sp>
@@ -847,7 +839,7 @@
           <a:p>
             <a:fld id="{5BCAD085-E8A6-8845-BD4E-CB4CCA059FC4}" type="datetimeFigureOut">
               <a:rPr lang="en-US" smtClean="0"/>
-              <a:t>4/18/2026</a:t>
+              <a:t>1/27/13</a:t>
             </a:fld>
             <a:endParaRPr lang="en-US"/>
           </a:p>
@@ -950,9 +942,10 @@
           </a:lstStyle>
           <a:p>
             <a:r>
-              <a:rPr lang="en-US"/>
+              <a:rPr lang="en-US" smtClean="0"/>
               <a:t>Click to edit Master title style</a:t>
             </a:r>
+            <a:endParaRPr lang="en-US"/>
           </a:p>
         </p:txBody>
       </p:sp>
@@ -1069,7 +1062,7 @@
           <a:p>
             <a:pPr lvl="0"/>
             <a:r>
-              <a:rPr lang="en-US"/>
+              <a:rPr lang="en-US" smtClean="0"/>
               <a:t>Click to edit Master text styles</a:t>
             </a:r>
           </a:p>
@@ -1092,7 +1085,7 @@
           <a:p>
             <a:fld id="{5BCAD085-E8A6-8845-BD4E-CB4CCA059FC4}" type="datetimeFigureOut">
               <a:rPr lang="en-US" smtClean="0"/>
-              <a:t>4/18/2026</a:t>
+              <a:t>1/27/13</a:t>
             </a:fld>
             <a:endParaRPr lang="en-US"/>
           </a:p>
@@ -1186,9 +1179,10 @@
           <a:lstStyle/>
           <a:p>
             <a:r>
-              <a:rPr lang="en-US"/>
+              <a:rPr lang="en-US" smtClean="0"/>
               <a:t>Click to edit Master title style</a:t>
             </a:r>
+            <a:endParaRPr lang="en-US"/>
           </a:p>
         </p:txBody>
       </p:sp>
@@ -1242,37 +1236,38 @@
           <a:p>
             <a:pPr lvl="0"/>
             <a:r>
-              <a:rPr lang="en-US"/>
+              <a:rPr lang="en-US" smtClean="0"/>
               <a:t>Click to edit Master text styles</a:t>
             </a:r>
           </a:p>
           <a:p>
             <a:pPr lvl="1"/>
             <a:r>
-              <a:rPr lang="en-US"/>
+              <a:rPr lang="en-US" smtClean="0"/>
               <a:t>Second level</a:t>
             </a:r>
           </a:p>
           <a:p>
             <a:pPr lvl="2"/>
             <a:r>
-              <a:rPr lang="en-US"/>
+              <a:rPr lang="en-US" smtClean="0"/>
               <a:t>Third level</a:t>
             </a:r>
           </a:p>
           <a:p>
             <a:pPr lvl="3"/>
             <a:r>
-              <a:rPr lang="en-US"/>
+              <a:rPr lang="en-US" smtClean="0"/>
               <a:t>Fourth level</a:t>
             </a:r>
           </a:p>
           <a:p>
             <a:pPr lvl="4"/>
             <a:r>
-              <a:rPr lang="en-US"/>
+              <a:rPr lang="en-US" smtClean="0"/>
               <a:t>Fifth level</a:t>
             </a:r>
+            <a:endParaRPr lang="en-US"/>
           </a:p>
         </p:txBody>
       </p:sp>
@@ -1326,37 +1321,38 @@
           <a:p>
             <a:pPr lvl="0"/>
             <a:r>
-              <a:rPr lang="en-US"/>
+              <a:rPr lang="en-US" smtClean="0"/>
               <a:t>Click to edit Master text styles</a:t>
             </a:r>
           </a:p>
           <a:p>
             <a:pPr lvl="1"/>
             <a:r>
-              <a:rPr lang="en-US"/>
+              <a:rPr lang="en-US" smtClean="0"/>
               <a:t>Second level</a:t>
             </a:r>
           </a:p>
           <a:p>
             <a:pPr lvl="2"/>
             <a:r>
-              <a:rPr lang="en-US"/>
+              <a:rPr lang="en-US" smtClean="0"/>
               <a:t>Third level</a:t>
             </a:r>
           </a:p>
           <a:p>
             <a:pPr lvl="3"/>
             <a:r>
-              <a:rPr lang="en-US"/>
+              <a:rPr lang="en-US" smtClean="0"/>
               <a:t>Fourth level</a:t>
             </a:r>
           </a:p>
           <a:p>
             <a:pPr lvl="4"/>
             <a:r>
-              <a:rPr lang="en-US"/>
+              <a:rPr lang="en-US" smtClean="0"/>
               <a:t>Fifth level</a:t>
             </a:r>
+            <a:endParaRPr lang="en-US"/>
           </a:p>
         </p:txBody>
       </p:sp>
@@ -1377,7 +1373,7 @@
           <a:p>
             <a:fld id="{5BCAD085-E8A6-8845-BD4E-CB4CCA059FC4}" type="datetimeFigureOut">
               <a:rPr lang="en-US" smtClean="0"/>
-              <a:t>4/18/2026</a:t>
+              <a:t>1/27/13</a:t>
             </a:fld>
             <a:endParaRPr lang="en-US"/>
           </a:p>
@@ -1475,9 +1471,10 @@
           </a:lstStyle>
           <a:p>
             <a:r>
-              <a:rPr lang="en-US"/>
+              <a:rPr lang="en-US" smtClean="0"/>
               <a:t>Click to edit Master title style</a:t>
             </a:r>
+            <a:endParaRPr lang="en-US"/>
           </a:p>
         </p:txBody>
       </p:sp>
@@ -1540,7 +1537,7 @@
           <a:p>
             <a:pPr lvl="0"/>
             <a:r>
-              <a:rPr lang="en-US"/>
+              <a:rPr lang="en-US" smtClean="0"/>
               <a:t>Click to edit Master text styles</a:t>
             </a:r>
           </a:p>
@@ -1596,37 +1593,38 @@
           <a:p>
             <a:pPr lvl="0"/>
             <a:r>
-              <a:rPr lang="en-US"/>
+              <a:rPr lang="en-US" smtClean="0"/>
               <a:t>Click to edit Master text styles</a:t>
             </a:r>
           </a:p>
           <a:p>
             <a:pPr lvl="1"/>
             <a:r>
-              <a:rPr lang="en-US"/>
+              <a:rPr lang="en-US" smtClean="0"/>
               <a:t>Second level</a:t>
             </a:r>
           </a:p>
           <a:p>
             <a:pPr lvl="2"/>
             <a:r>
-              <a:rPr lang="en-US"/>
+              <a:rPr lang="en-US" smtClean="0"/>
               <a:t>Third level</a:t>
             </a:r>
           </a:p>
           <a:p>
             <a:pPr lvl="3"/>
             <a:r>
-              <a:rPr lang="en-US"/>
+              <a:rPr lang="en-US" smtClean="0"/>
               <a:t>Fourth level</a:t>
             </a:r>
           </a:p>
           <a:p>
             <a:pPr lvl="4"/>
             <a:r>
-              <a:rPr lang="en-US"/>
+              <a:rPr lang="en-US" smtClean="0"/>
               <a:t>Fifth level</a:t>
             </a:r>
+            <a:endParaRPr lang="en-US"/>
           </a:p>
         </p:txBody>
       </p:sp>
@@ -1689,7 +1687,7 @@
           <a:p>
             <a:pPr lvl="0"/>
             <a:r>
-              <a:rPr lang="en-US"/>
+              <a:rPr lang="en-US" smtClean="0"/>
               <a:t>Click to edit Master text styles</a:t>
             </a:r>
           </a:p>
@@ -1745,37 +1743,38 @@
           <a:p>
             <a:pPr lvl="0"/>
             <a:r>
-              <a:rPr lang="en-US"/>
+              <a:rPr lang="en-US" smtClean="0"/>
               <a:t>Click to edit Master text styles</a:t>
             </a:r>
           </a:p>
           <a:p>
             <a:pPr lvl="1"/>
             <a:r>
-              <a:rPr lang="en-US"/>
+              <a:rPr lang="en-US" smtClean="0"/>
               <a:t>Second level</a:t>
             </a:r>
           </a:p>
           <a:p>
             <a:pPr lvl="2"/>
             <a:r>
-              <a:rPr lang="en-US"/>
+              <a:rPr lang="en-US" smtClean="0"/>
               <a:t>Third level</a:t>
             </a:r>
           </a:p>
           <a:p>
             <a:pPr lvl="3"/>
             <a:r>
-              <a:rPr lang="en-US"/>
+              <a:rPr lang="en-US" smtClean="0"/>
               <a:t>Fourth level</a:t>
             </a:r>
           </a:p>
           <a:p>
             <a:pPr lvl="4"/>
             <a:r>
-              <a:rPr lang="en-US"/>
+              <a:rPr lang="en-US" smtClean="0"/>
               <a:t>Fifth level</a:t>
             </a:r>
+            <a:endParaRPr lang="en-US"/>
           </a:p>
         </p:txBody>
       </p:sp>
@@ -1796,7 +1795,7 @@
           <a:p>
             <a:fld id="{5BCAD085-E8A6-8845-BD4E-CB4CCA059FC4}" type="datetimeFigureOut">
               <a:rPr lang="en-US" smtClean="0"/>
-              <a:t>4/18/2026</a:t>
+              <a:t>1/27/13</a:t>
             </a:fld>
             <a:endParaRPr lang="en-US"/>
           </a:p>
@@ -1890,9 +1889,10 @@
           <a:lstStyle/>
           <a:p>
             <a:r>
-              <a:rPr lang="en-US"/>
+              <a:rPr lang="en-US" smtClean="0"/>
               <a:t>Click to edit Master title style</a:t>
             </a:r>
+            <a:endParaRPr lang="en-US"/>
           </a:p>
         </p:txBody>
       </p:sp>
@@ -1913,7 +1913,7 @@
           <a:p>
             <a:fld id="{5BCAD085-E8A6-8845-BD4E-CB4CCA059FC4}" type="datetimeFigureOut">
               <a:rPr lang="en-US" smtClean="0"/>
-              <a:t>4/18/2026</a:t>
+              <a:t>1/27/13</a:t>
             </a:fld>
             <a:endParaRPr lang="en-US"/>
           </a:p>
@@ -2008,7 +2008,7 @@
           <a:p>
             <a:fld id="{5BCAD085-E8A6-8845-BD4E-CB4CCA059FC4}" type="datetimeFigureOut">
               <a:rPr lang="en-US" smtClean="0"/>
-              <a:t>4/18/2026</a:t>
+              <a:t>1/27/13</a:t>
             </a:fld>
             <a:endParaRPr lang="en-US"/>
           </a:p>
@@ -2111,9 +2111,10 @@
           </a:lstStyle>
           <a:p>
             <a:r>
-              <a:rPr lang="en-US"/>
+              <a:rPr lang="en-US" smtClean="0"/>
               <a:t>Click to edit Master title style</a:t>
             </a:r>
+            <a:endParaRPr lang="en-US"/>
           </a:p>
         </p:txBody>
       </p:sp>
@@ -2167,37 +2168,38 @@
           <a:p>
             <a:pPr lvl="0"/>
             <a:r>
-              <a:rPr lang="en-US"/>
+              <a:rPr lang="en-US" smtClean="0"/>
               <a:t>Click to edit Master text styles</a:t>
             </a:r>
           </a:p>
           <a:p>
             <a:pPr lvl="1"/>
             <a:r>
-              <a:rPr lang="en-US"/>
+              <a:rPr lang="en-US" smtClean="0"/>
               <a:t>Second level</a:t>
             </a:r>
           </a:p>
           <a:p>
             <a:pPr lvl="2"/>
             <a:r>
-              <a:rPr lang="en-US"/>
+              <a:rPr lang="en-US" smtClean="0"/>
               <a:t>Third level</a:t>
             </a:r>
           </a:p>
           <a:p>
             <a:pPr lvl="3"/>
             <a:r>
-              <a:rPr lang="en-US"/>
+              <a:rPr lang="en-US" smtClean="0"/>
               <a:t>Fourth level</a:t>
             </a:r>
           </a:p>
           <a:p>
             <a:pPr lvl="4"/>
             <a:r>
-              <a:rPr lang="en-US"/>
+              <a:rPr lang="en-US" smtClean="0"/>
               <a:t>Fifth level</a:t>
             </a:r>
+            <a:endParaRPr lang="en-US"/>
           </a:p>
         </p:txBody>
       </p:sp>
@@ -2260,7 +2262,7 @@
           <a:p>
             <a:pPr lvl="0"/>
             <a:r>
-              <a:rPr lang="en-US"/>
+              <a:rPr lang="en-US" smtClean="0"/>
               <a:t>Click to edit Master text styles</a:t>
             </a:r>
           </a:p>
@@ -2283,7 +2285,7 @@
           <a:p>
             <a:fld id="{5BCAD085-E8A6-8845-BD4E-CB4CCA059FC4}" type="datetimeFigureOut">
               <a:rPr lang="en-US" smtClean="0"/>
-              <a:t>4/18/2026</a:t>
+              <a:t>1/27/13</a:t>
             </a:fld>
             <a:endParaRPr lang="en-US"/>
           </a:p>
@@ -2386,9 +2388,10 @@
           </a:lstStyle>
           <a:p>
             <a:r>
-              <a:rPr lang="en-US"/>
+              <a:rPr lang="en-US" smtClean="0"/>
               <a:t>Click to edit Master title style</a:t>
             </a:r>
+            <a:endParaRPr lang="en-US"/>
           </a:p>
         </p:txBody>
       </p:sp>
@@ -2512,7 +2515,7 @@
           <a:p>
             <a:pPr lvl="0"/>
             <a:r>
-              <a:rPr lang="en-US"/>
+              <a:rPr lang="en-US" smtClean="0"/>
               <a:t>Click to edit Master text styles</a:t>
             </a:r>
           </a:p>
@@ -2535,7 +2538,7 @@
           <a:p>
             <a:fld id="{5BCAD085-E8A6-8845-BD4E-CB4CCA059FC4}" type="datetimeFigureOut">
               <a:rPr lang="en-US" smtClean="0"/>
-              <a:t>4/18/2026</a:t>
+              <a:t>1/27/13</a:t>
             </a:fld>
             <a:endParaRPr lang="en-US"/>
           </a:p>
@@ -2644,9 +2647,10 @@
           <a:lstStyle/>
           <a:p>
             <a:r>
-              <a:rPr lang="en-US"/>
+              <a:rPr lang="en-US" smtClean="0"/>
               <a:t>Click to edit Master title style</a:t>
             </a:r>
+            <a:endParaRPr lang="en-US"/>
           </a:p>
         </p:txBody>
       </p:sp>
@@ -2677,37 +2681,38 @@
           <a:p>
             <a:pPr lvl="0"/>
             <a:r>
-              <a:rPr lang="en-US"/>
+              <a:rPr lang="en-US" smtClean="0"/>
               <a:t>Click to edit Master text styles</a:t>
             </a:r>
           </a:p>
           <a:p>
             <a:pPr lvl="1"/>
             <a:r>
-              <a:rPr lang="en-US"/>
+              <a:rPr lang="en-US" smtClean="0"/>
               <a:t>Second level</a:t>
             </a:r>
           </a:p>
           <a:p>
             <a:pPr lvl="2"/>
             <a:r>
-              <a:rPr lang="en-US"/>
+              <a:rPr lang="en-US" smtClean="0"/>
               <a:t>Third level</a:t>
             </a:r>
           </a:p>
           <a:p>
             <a:pPr lvl="3"/>
             <a:r>
-              <a:rPr lang="en-US"/>
+              <a:rPr lang="en-US" smtClean="0"/>
               <a:t>Fourth level</a:t>
             </a:r>
           </a:p>
           <a:p>
             <a:pPr lvl="4"/>
             <a:r>
-              <a:rPr lang="en-US"/>
+              <a:rPr lang="en-US" smtClean="0"/>
               <a:t>Fifth level</a:t>
             </a:r>
+            <a:endParaRPr lang="en-US"/>
           </a:p>
         </p:txBody>
       </p:sp>
@@ -2746,7 +2751,7 @@
           <a:p>
             <a:fld id="{5BCAD085-E8A6-8845-BD4E-CB4CCA059FC4}" type="datetimeFigureOut">
               <a:rPr lang="en-US" smtClean="0"/>
-              <a:t>4/18/2026</a:t>
+              <a:t>1/27/13</a:t>
             </a:fld>
             <a:endParaRPr lang="en-US"/>
           </a:p>
@@ -3105,7 +3110,7 @@
 </file>
 
 <file path=ppt/slides/slide1.xml><?xml version="1.0" encoding="utf-8"?>
-<p:sld xmlns:a="http://schemas.openxmlformats.org/drawingml/2006/main" xmlns:r="http://schemas.openxmlformats.org/officeDocument/2006/relationships" xmlns:p="http://schemas.openxmlformats.org/presentationml/2006/main">
+<p:sld xmlns:a="http://schemas.openxmlformats.org/drawingml/2006/main" xmlns:p="http://schemas.openxmlformats.org/presentationml/2006/main" xmlns:r="http://schemas.openxmlformats.org/officeDocument/2006/relationships">
   <p:cSld>
     <p:spTree>
       <p:nvGrpSpPr>
@@ -3113,14 +3118,7 @@
         <p:cNvGrpSpPr/>
         <p:nvPr/>
       </p:nvGrpSpPr>
-      <p:grpSpPr>
-        <a:xfrm>
-          <a:off x="0" y="0"/>
-          <a:ext cx="0" cy="0"/>
-          <a:chOff x="0" y="0"/>
-          <a:chExt cx="0" cy="0"/>
-        </a:xfrm>
-      </p:grpSpPr>
+      <p:grpSpPr/>
       <p:pic>
         <p:nvPicPr>
           <p:cNvPr id="2" name="Picture 1" descr="image-1-1.png"/>
@@ -3185,7 +3183,6 @@
           <a:lstStyle/>
           <a:p>
             <a:pPr algn="ctr"/>
-            <a:endParaRPr/>
           </a:p>
         </p:txBody>
       </p:sp>
@@ -3229,7 +3226,6 @@
           <a:lstStyle/>
           <a:p>
             <a:pPr algn="ctr"/>
-            <a:endParaRPr/>
           </a:p>
         </p:txBody>
       </p:sp>
@@ -3273,7 +3269,6 @@
           <a:lstStyle/>
           <a:p>
             <a:pPr algn="ctr"/>
-            <a:endParaRPr/>
           </a:p>
         </p:txBody>
       </p:sp>
@@ -3317,7 +3312,6 @@
           <a:lstStyle/>
           <a:p>
             <a:pPr algn="ctr"/>
-            <a:endParaRPr/>
           </a:p>
         </p:txBody>
       </p:sp>
@@ -3361,7 +3355,6 @@
           <a:lstStyle/>
           <a:p>
             <a:pPr algn="ctr"/>
-            <a:endParaRPr/>
           </a:p>
         </p:txBody>
       </p:sp>
@@ -3547,7 +3540,6 @@
           <a:lstStyle/>
           <a:p>
             <a:pPr algn="ctr"/>
-            <a:endParaRPr/>
           </a:p>
         </p:txBody>
       </p:sp>
@@ -3616,7 +3608,7 @@
                 </a:solidFill>
                 <a:latin typeface="Aptos"/>
               </a:rPr>
-              <a:t>347</a:t>
+              <a:t>348</a:t>
             </a:r>
           </a:p>
         </p:txBody>
@@ -3663,7 +3655,6 @@
           <a:lstStyle/>
           <a:p>
             <a:pPr algn="ctr"/>
-            <a:endParaRPr/>
           </a:p>
         </p:txBody>
       </p:sp>
@@ -3779,7 +3770,6 @@
           <a:lstStyle/>
           <a:p>
             <a:pPr algn="ctr"/>
-            <a:endParaRPr/>
           </a:p>
         </p:txBody>
       </p:sp>
@@ -3848,7 +3838,7 @@
                 </a:solidFill>
                 <a:latin typeface="Aptos"/>
               </a:rPr>
-              <a:t>71,382</a:t>
+              <a:t>71,562</a:t>
             </a:r>
           </a:p>
         </p:txBody>
@@ -3883,7 +3873,7 @@
                 </a:solidFill>
                 <a:latin typeface="Aptos"/>
               </a:rPr>
-              <a:t>Generated April 17, 2026 11:50 PM UTC-0600 at HEAD 3b6eb8e</a:t>
+              <a:t>Generated April 19, 2026 12:07 AM UTC-0600 at HEAD 6063109</a:t>
             </a:r>
           </a:p>
         </p:txBody>
@@ -3897,7 +3887,7 @@
 </file>
 
 <file path=ppt/slides/slide10.xml><?xml version="1.0" encoding="utf-8"?>
-<p:sld xmlns:a="http://schemas.openxmlformats.org/drawingml/2006/main" xmlns:r="http://schemas.openxmlformats.org/officeDocument/2006/relationships" xmlns:p="http://schemas.openxmlformats.org/presentationml/2006/main">
+<p:sld xmlns:a="http://schemas.openxmlformats.org/drawingml/2006/main" xmlns:p="http://schemas.openxmlformats.org/presentationml/2006/main" xmlns:r="http://schemas.openxmlformats.org/officeDocument/2006/relationships">
   <p:cSld>
     <p:spTree>
       <p:nvGrpSpPr>
@@ -3905,14 +3895,7 @@
         <p:cNvGrpSpPr/>
         <p:nvPr/>
       </p:nvGrpSpPr>
-      <p:grpSpPr>
-        <a:xfrm>
-          <a:off x="0" y="0"/>
-          <a:ext cx="0" cy="0"/>
-          <a:chOff x="0" y="0"/>
-          <a:chExt cx="0" cy="0"/>
-        </a:xfrm>
-      </p:grpSpPr>
+      <p:grpSpPr/>
       <p:sp>
         <p:nvSpPr>
           <p:cNvPr id="2" name="Rectangle 1"/>
@@ -3953,7 +3936,6 @@
           <a:lstStyle/>
           <a:p>
             <a:pPr algn="ctr"/>
-            <a:endParaRPr/>
           </a:p>
         </p:txBody>
       </p:sp>
@@ -3997,7 +3979,6 @@
           <a:lstStyle/>
           <a:p>
             <a:pPr algn="ctr"/>
-            <a:endParaRPr/>
           </a:p>
         </p:txBody>
       </p:sp>
@@ -4041,7 +4022,6 @@
           <a:lstStyle/>
           <a:p>
             <a:pPr algn="ctr"/>
-            <a:endParaRPr/>
           </a:p>
         </p:txBody>
       </p:sp>
@@ -4085,7 +4065,6 @@
           <a:lstStyle/>
           <a:p>
             <a:pPr algn="ctr"/>
-            <a:endParaRPr/>
           </a:p>
         </p:txBody>
       </p:sp>
@@ -4129,7 +4108,6 @@
           <a:lstStyle/>
           <a:p>
             <a:pPr algn="ctr"/>
-            <a:endParaRPr/>
           </a:p>
         </p:txBody>
       </p:sp>
@@ -4245,7 +4223,6 @@
           <a:lstStyle/>
           <a:p>
             <a:pPr algn="ctr"/>
-            <a:endParaRPr/>
           </a:p>
         </p:txBody>
       </p:sp>
@@ -4289,7 +4266,6 @@
           <a:lstStyle/>
           <a:p>
             <a:pPr algn="ctr"/>
-            <a:endParaRPr/>
           </a:p>
         </p:txBody>
       </p:sp>
@@ -4345,7 +4321,7 @@
           <a:noFill/>
         </p:spPr>
         <p:txBody>
-          <a:bodyPr wrap="square" lIns="38100" tIns="25400" rIns="38100" bIns="25400" anchor="t">
+          <a:bodyPr wrap="square" anchor="t" lIns="38100" rIns="38100" tIns="25400" bIns="25400">
             <a:noAutofit/>
           </a:bodyPr>
           <a:lstStyle/>
@@ -4367,6 +4343,9 @@
               </a:rPr>
               <a:t>Run from source: create a virtual environment, install requirements, migrate, create a superuser, collect static files, and start Django.</a:t>
             </a:r>
+            <a:endParaRPr sz="1500" b="0" i="0">
+              <a:latin typeface="Calibri"/>
+            </a:endParaRPr>
           </a:p>
           <a:p>
             <a:pPr>
@@ -4386,6 +4365,9 @@
               </a:rPr>
               <a:t>Open `/agent/` for chat. Load a file or directory context before asking codebase-specific questions.</a:t>
             </a:r>
+            <a:endParaRPr sz="1500" b="0" i="0">
+              <a:latin typeface="Calibri"/>
+            </a:endParaRPr>
           </a:p>
           <a:p>
             <a:pPr>
@@ -4405,6 +4387,9 @@
               </a:rPr>
               <a:t>Keep Multi-Turn unchecked for direct Q&amp;A; enable Multi-Turn for tasks that need tools, wrapped agents, monitoring, or workflow seeding.</a:t>
             </a:r>
+            <a:endParaRPr sz="1500" b="0" i="0">
+              <a:latin typeface="Calibri"/>
+            </a:endParaRPr>
           </a:p>
         </p:txBody>
       </p:sp>
@@ -4450,7 +4435,6 @@
           <a:lstStyle/>
           <a:p>
             <a:pPr algn="ctr"/>
-            <a:endParaRPr/>
           </a:p>
         </p:txBody>
       </p:sp>
@@ -4494,7 +4478,6 @@
           <a:lstStyle/>
           <a:p>
             <a:pPr algn="ctr"/>
-            <a:endParaRPr/>
           </a:p>
         </p:txBody>
       </p:sp>
@@ -4550,7 +4533,7 @@
           <a:noFill/>
         </p:spPr>
         <p:txBody>
-          <a:bodyPr wrap="square" lIns="38100" tIns="25400" rIns="38100" bIns="25400" anchor="t">
+          <a:bodyPr wrap="square" anchor="t" lIns="38100" rIns="38100" tIns="25400" bIns="25400">
             <a:noAutofit/>
           </a:bodyPr>
           <a:lstStyle/>
@@ -4572,6 +4555,9 @@
               </a:rPr>
               <a:t>Open `/agentic_control_panel/` to drag agents, connect them, configure each node, validate, start, pause/resume, stop, and save `.flw` workflows.</a:t>
             </a:r>
+            <a:endParaRPr sz="1500" b="0" i="0">
+              <a:latin typeface="Calibri"/>
+            </a:endParaRPr>
           </a:p>
           <a:p>
             <a:pPr>
@@ -4591,6 +4577,9 @@
               </a:rPr>
               <a:t>Use `python build.py`, `python build_uninstaller.py`, and `python build_installer.py` only when producing a packaged Windows release.</a:t>
             </a:r>
+            <a:endParaRPr sz="1500" b="0" i="0">
+              <a:latin typeface="Calibri"/>
+            </a:endParaRPr>
           </a:p>
         </p:txBody>
       </p:sp>
@@ -4603,7 +4592,7 @@
 </file>
 
 <file path=ppt/slides/slide11.xml><?xml version="1.0" encoding="utf-8"?>
-<p:sld xmlns:a="http://schemas.openxmlformats.org/drawingml/2006/main" xmlns:r="http://schemas.openxmlformats.org/officeDocument/2006/relationships" xmlns:p="http://schemas.openxmlformats.org/presentationml/2006/main">
+<p:sld xmlns:a="http://schemas.openxmlformats.org/drawingml/2006/main" xmlns:p="http://schemas.openxmlformats.org/presentationml/2006/main" xmlns:r="http://schemas.openxmlformats.org/officeDocument/2006/relationships">
   <p:cSld>
     <p:spTree>
       <p:nvGrpSpPr>
@@ -4611,14 +4600,7 @@
         <p:cNvGrpSpPr/>
         <p:nvPr/>
       </p:nvGrpSpPr>
-      <p:grpSpPr>
-        <a:xfrm>
-          <a:off x="0" y="0"/>
-          <a:ext cx="0" cy="0"/>
-          <a:chOff x="0" y="0"/>
-          <a:chExt cx="0" cy="0"/>
-        </a:xfrm>
-      </p:grpSpPr>
+      <p:grpSpPr/>
       <p:sp>
         <p:nvSpPr>
           <p:cNvPr id="2" name="Rectangle 1"/>
@@ -4659,7 +4641,6 @@
           <a:lstStyle/>
           <a:p>
             <a:pPr algn="ctr"/>
-            <a:endParaRPr/>
           </a:p>
         </p:txBody>
       </p:sp>
@@ -4703,7 +4684,6 @@
           <a:lstStyle/>
           <a:p>
             <a:pPr algn="ctr"/>
-            <a:endParaRPr/>
           </a:p>
         </p:txBody>
       </p:sp>
@@ -4747,7 +4727,6 @@
           <a:lstStyle/>
           <a:p>
             <a:pPr algn="ctr"/>
-            <a:endParaRPr/>
           </a:p>
         </p:txBody>
       </p:sp>
@@ -4791,7 +4770,6 @@
           <a:lstStyle/>
           <a:p>
             <a:pPr algn="ctr"/>
-            <a:endParaRPr/>
           </a:p>
         </p:txBody>
       </p:sp>
@@ -4835,7 +4813,6 @@
           <a:lstStyle/>
           <a:p>
             <a:pPr algn="ctr"/>
-            <a:endParaRPr/>
           </a:p>
         </p:txBody>
       </p:sp>
@@ -4992,7 +4969,6 @@
           <a:lstStyle/>
           <a:p>
             <a:pPr algn="ctr"/>
-            <a:endParaRPr/>
           </a:p>
         </p:txBody>
       </p:sp>
@@ -5036,7 +5012,6 @@
           <a:lstStyle/>
           <a:p>
             <a:pPr algn="ctr"/>
-            <a:endParaRPr/>
           </a:p>
         </p:txBody>
       </p:sp>
@@ -5092,7 +5067,7 @@
           <a:noFill/>
         </p:spPr>
         <p:txBody>
-          <a:bodyPr wrap="square" lIns="38100" tIns="25400" rIns="38100" bIns="25400" anchor="t">
+          <a:bodyPr wrap="square" anchor="t" lIns="38100" rIns="38100" tIns="25400" bIns="25400">
             <a:noAutofit/>
           </a:bodyPr>
           <a:lstStyle/>
@@ -5114,6 +5089,9 @@
               </a:rPr>
               <a:t>Open the browser, log in with your source-mode superuser, load a context path, and decide whether the task needs Multi-Turn.</a:t>
             </a:r>
+            <a:endParaRPr sz="1400" b="0" i="0">
+              <a:latin typeface="Calibri"/>
+            </a:endParaRPr>
           </a:p>
         </p:txBody>
       </p:sp>
@@ -5126,7 +5104,7 @@
 </file>
 
 <file path=ppt/slides/slide12.xml><?xml version="1.0" encoding="utf-8"?>
-<p:sld xmlns:a="http://schemas.openxmlformats.org/drawingml/2006/main" xmlns:r="http://schemas.openxmlformats.org/officeDocument/2006/relationships" xmlns:p="http://schemas.openxmlformats.org/presentationml/2006/main">
+<p:sld xmlns:a="http://schemas.openxmlformats.org/drawingml/2006/main" xmlns:p="http://schemas.openxmlformats.org/presentationml/2006/main" xmlns:r="http://schemas.openxmlformats.org/officeDocument/2006/relationships">
   <p:cSld>
     <p:spTree>
       <p:nvGrpSpPr>
@@ -5134,14 +5112,7 @@
         <p:cNvGrpSpPr/>
         <p:nvPr/>
       </p:nvGrpSpPr>
-      <p:grpSpPr>
-        <a:xfrm>
-          <a:off x="0" y="0"/>
-          <a:ext cx="0" cy="0"/>
-          <a:chOff x="0" y="0"/>
-          <a:chExt cx="0" cy="0"/>
-        </a:xfrm>
-      </p:grpSpPr>
+      <p:grpSpPr/>
       <p:sp>
         <p:nvSpPr>
           <p:cNvPr id="2" name="Rectangle 1"/>
@@ -5182,7 +5153,6 @@
           <a:lstStyle/>
           <a:p>
             <a:pPr algn="ctr"/>
-            <a:endParaRPr/>
           </a:p>
         </p:txBody>
       </p:sp>
@@ -5226,7 +5196,6 @@
           <a:lstStyle/>
           <a:p>
             <a:pPr algn="ctr"/>
-            <a:endParaRPr/>
           </a:p>
         </p:txBody>
       </p:sp>
@@ -5270,7 +5239,6 @@
           <a:lstStyle/>
           <a:p>
             <a:pPr algn="ctr"/>
-            <a:endParaRPr/>
           </a:p>
         </p:txBody>
       </p:sp>
@@ -5314,7 +5282,6 @@
           <a:lstStyle/>
           <a:p>
             <a:pPr algn="ctr"/>
-            <a:endParaRPr/>
           </a:p>
         </p:txBody>
       </p:sp>
@@ -5358,7 +5325,6 @@
           <a:lstStyle/>
           <a:p>
             <a:pPr algn="ctr"/>
-            <a:endParaRPr/>
           </a:p>
         </p:txBody>
       </p:sp>
@@ -5474,7 +5440,6 @@
           <a:lstStyle/>
           <a:p>
             <a:pPr algn="ctr"/>
-            <a:endParaRPr/>
           </a:p>
         </p:txBody>
       </p:sp>
@@ -5590,7 +5555,6 @@
           <a:lstStyle/>
           <a:p>
             <a:pPr algn="ctr"/>
-            <a:endParaRPr/>
           </a:p>
         </p:txBody>
       </p:sp>
@@ -5706,7 +5670,6 @@
           <a:lstStyle/>
           <a:p>
             <a:pPr algn="ctr"/>
-            <a:endParaRPr/>
           </a:p>
         </p:txBody>
       </p:sp>
@@ -5822,7 +5785,6 @@
           <a:lstStyle/>
           <a:p>
             <a:pPr algn="ctr"/>
-            <a:endParaRPr/>
           </a:p>
         </p:txBody>
       </p:sp>
@@ -5938,7 +5900,6 @@
           <a:lstStyle/>
           <a:p>
             <a:pPr algn="ctr"/>
-            <a:endParaRPr/>
           </a:p>
         </p:txBody>
       </p:sp>
@@ -6054,7 +6015,6 @@
           <a:lstStyle/>
           <a:p>
             <a:pPr algn="ctr"/>
-            <a:endParaRPr/>
           </a:p>
         </p:txBody>
       </p:sp>
@@ -6135,7 +6095,6 @@
           <a:lstStyle/>
           <a:p>
             <a:pPr algn="ctr"/>
-            <a:endParaRPr/>
           </a:p>
         </p:txBody>
       </p:sp>
@@ -6179,7 +6138,6 @@
           <a:lstStyle/>
           <a:p>
             <a:pPr algn="ctr"/>
-            <a:endParaRPr/>
           </a:p>
         </p:txBody>
       </p:sp>
@@ -6235,7 +6193,7 @@
           <a:noFill/>
         </p:spPr>
         <p:txBody>
-          <a:bodyPr wrap="square" lIns="38100" tIns="25400" rIns="38100" bIns="25400" anchor="t">
+          <a:bodyPr wrap="square" anchor="t" lIns="38100" rIns="38100" tIns="25400" bIns="25400">
             <a:noAutofit/>
           </a:bodyPr>
           <a:lstStyle/>
@@ -6257,6 +6215,9 @@
               </a:rPr>
               <a:t>Run packaging only when preparing a Windows distribution.</a:t>
             </a:r>
+            <a:endParaRPr sz="1600" b="0" i="0">
+              <a:latin typeface="Calibri"/>
+            </a:endParaRPr>
           </a:p>
           <a:p>
             <a:pPr>
@@ -6276,6 +6237,9 @@
               </a:rPr>
               <a:t>The final distributable is the full `dist/Tlamatini_Release/` folder, not one executable copied out of context.</a:t>
             </a:r>
+            <a:endParaRPr sz="1600" b="0" i="0">
+              <a:latin typeface="Calibri"/>
+            </a:endParaRPr>
           </a:p>
           <a:p>
             <a:pPr>
@@ -6295,6 +6259,9 @@
               </a:rPr>
               <a:t>Installer scripts register shortcuts and `.flw` file associations and place the uninstaller next to the app.</a:t>
             </a:r>
+            <a:endParaRPr sz="1600" b="0" i="0">
+              <a:latin typeface="Calibri"/>
+            </a:endParaRPr>
           </a:p>
         </p:txBody>
       </p:sp>
@@ -6307,7 +6274,7 @@
 </file>
 
 <file path=ppt/slides/slide13.xml><?xml version="1.0" encoding="utf-8"?>
-<p:sld xmlns:a="http://schemas.openxmlformats.org/drawingml/2006/main" xmlns:r="http://schemas.openxmlformats.org/officeDocument/2006/relationships" xmlns:p="http://schemas.openxmlformats.org/presentationml/2006/main">
+<p:sld xmlns:a="http://schemas.openxmlformats.org/drawingml/2006/main" xmlns:p="http://schemas.openxmlformats.org/presentationml/2006/main" xmlns:r="http://schemas.openxmlformats.org/officeDocument/2006/relationships">
   <p:cSld>
     <p:spTree>
       <p:nvGrpSpPr>
@@ -6315,14 +6282,7 @@
         <p:cNvGrpSpPr/>
         <p:nvPr/>
       </p:nvGrpSpPr>
-      <p:grpSpPr>
-        <a:xfrm>
-          <a:off x="0" y="0"/>
-          <a:ext cx="0" cy="0"/>
-          <a:chOff x="0" y="0"/>
-          <a:chExt cx="0" cy="0"/>
-        </a:xfrm>
-      </p:grpSpPr>
+      <p:grpSpPr/>
       <p:sp>
         <p:nvSpPr>
           <p:cNvPr id="2" name="Rectangle 1"/>
@@ -6363,7 +6323,6 @@
           <a:lstStyle/>
           <a:p>
             <a:pPr algn="ctr"/>
-            <a:endParaRPr/>
           </a:p>
         </p:txBody>
       </p:sp>
@@ -6407,7 +6366,6 @@
           <a:lstStyle/>
           <a:p>
             <a:pPr algn="ctr"/>
-            <a:endParaRPr/>
           </a:p>
         </p:txBody>
       </p:sp>
@@ -6451,7 +6409,6 @@
           <a:lstStyle/>
           <a:p>
             <a:pPr algn="ctr"/>
-            <a:endParaRPr/>
           </a:p>
         </p:txBody>
       </p:sp>
@@ -6495,7 +6452,6 @@
           <a:lstStyle/>
           <a:p>
             <a:pPr algn="ctr"/>
-            <a:endParaRPr/>
           </a:p>
         </p:txBody>
       </p:sp>
@@ -6539,7 +6495,6 @@
           <a:lstStyle/>
           <a:p>
             <a:pPr algn="ctr"/>
-            <a:endParaRPr/>
           </a:p>
         </p:txBody>
       </p:sp>
@@ -6655,7 +6610,6 @@
           <a:lstStyle/>
           <a:p>
             <a:pPr algn="ctr"/>
-            <a:endParaRPr/>
           </a:p>
         </p:txBody>
       </p:sp>
@@ -6724,7 +6678,7 @@
                 </a:solidFill>
                 <a:latin typeface="Aptos"/>
               </a:rPr>
-              <a:t>347</a:t>
+              <a:t>348</a:t>
             </a:r>
           </a:p>
         </p:txBody>
@@ -6771,7 +6725,6 @@
           <a:lstStyle/>
           <a:p>
             <a:pPr algn="ctr"/>
-            <a:endParaRPr/>
           </a:p>
         </p:txBody>
       </p:sp>
@@ -6887,7 +6840,6 @@
           <a:lstStyle/>
           <a:p>
             <a:pPr algn="ctr"/>
-            <a:endParaRPr/>
           </a:p>
         </p:txBody>
       </p:sp>
@@ -7003,7 +6955,6 @@
           <a:lstStyle/>
           <a:p>
             <a:pPr algn="ctr"/>
-            <a:endParaRPr/>
           </a:p>
         </p:txBody>
       </p:sp>
@@ -7119,7 +7070,6 @@
           <a:lstStyle/>
           <a:p>
             <a:pPr algn="ctr"/>
-            <a:endParaRPr/>
           </a:p>
         </p:txBody>
       </p:sp>
@@ -7235,7 +7185,6 @@
           <a:lstStyle/>
           <a:p>
             <a:pPr algn="ctr"/>
-            <a:endParaRPr/>
           </a:p>
         </p:txBody>
       </p:sp>
@@ -7351,7 +7300,6 @@
           <a:lstStyle/>
           <a:p>
             <a:pPr algn="ctr"/>
-            <a:endParaRPr/>
           </a:p>
         </p:txBody>
       </p:sp>
@@ -7395,7 +7343,6 @@
           <a:lstStyle/>
           <a:p>
             <a:pPr algn="ctr"/>
-            <a:endParaRPr/>
           </a:p>
         </p:txBody>
       </p:sp>
@@ -7451,7 +7398,7 @@
           <a:noFill/>
         </p:spPr>
         <p:txBody>
-          <a:bodyPr wrap="square" lIns="38100" tIns="25400" rIns="38100" bIns="25400" anchor="t">
+          <a:bodyPr wrap="square" anchor="t" lIns="38100" rIns="38100" tIns="25400" bIns="25400">
             <a:noAutofit/>
           </a:bodyPr>
           <a:lstStyle/>
@@ -7471,8 +7418,11 @@
               <a:rPr sz="1500" b="0" i="0">
                 <a:latin typeface="Calibri"/>
               </a:rPr>
-              <a:t>3b6eb8e - Way too improving the execution chain with now "Exec report"!!, by angelahack1</a:t>
-            </a:r>
+              <a:t>6063109 - Updating documentation, by angelahack1</a:t>
+            </a:r>
+            <a:endParaRPr sz="1500" b="0" i="0">
+              <a:latin typeface="Calibri"/>
+            </a:endParaRPr>
           </a:p>
           <a:p>
             <a:pPr>
@@ -7490,8 +7440,11 @@
               <a:rPr sz="1500" b="0" i="0">
                 <a:latin typeface="Calibri"/>
               </a:rPr>
-              <a:t>Generated on April 17, 2026 11:50 PM UTC-0600</a:t>
-            </a:r>
+              <a:t>Generated on April 19, 2026 12:07 AM UTC-0600</a:t>
+            </a:r>
+            <a:endParaRPr sz="1500" b="0" i="0">
+              <a:latin typeface="Calibri"/>
+            </a:endParaRPr>
           </a:p>
           <a:p>
             <a:pPr>
@@ -7509,8 +7462,11 @@
               <a:rPr sz="1500" b="0" i="0">
                 <a:latin typeface="Calibri"/>
               </a:rPr>
-              <a:t>Python requirements: 62; binary or asset tracked files skipped from line count: 13</a:t>
-            </a:r>
+              <a:t>Python requirements: 62; binary or asset tracked files skipped from line count: 14</a:t>
+            </a:r>
+            <a:endParaRPr sz="1500" b="0" i="0">
+              <a:latin typeface="Calibri"/>
+            </a:endParaRPr>
           </a:p>
         </p:txBody>
       </p:sp>
@@ -7523,7 +7479,7 @@
 </file>
 
 <file path=ppt/slides/slide14.xml><?xml version="1.0" encoding="utf-8"?>
-<p:sld xmlns:a="http://schemas.openxmlformats.org/drawingml/2006/main" xmlns:r="http://schemas.openxmlformats.org/officeDocument/2006/relationships" xmlns:p="http://schemas.openxmlformats.org/presentationml/2006/main">
+<p:sld xmlns:a="http://schemas.openxmlformats.org/drawingml/2006/main" xmlns:p="http://schemas.openxmlformats.org/presentationml/2006/main" xmlns:r="http://schemas.openxmlformats.org/officeDocument/2006/relationships">
   <p:cSld>
     <p:spTree>
       <p:nvGrpSpPr>
@@ -7531,14 +7487,7 @@
         <p:cNvGrpSpPr/>
         <p:nvPr/>
       </p:nvGrpSpPr>
-      <p:grpSpPr>
-        <a:xfrm>
-          <a:off x="0" y="0"/>
-          <a:ext cx="0" cy="0"/>
-          <a:chOff x="0" y="0"/>
-          <a:chExt cx="0" cy="0"/>
-        </a:xfrm>
-      </p:grpSpPr>
+      <p:grpSpPr/>
       <p:sp>
         <p:nvSpPr>
           <p:cNvPr id="2" name="Rectangle 1"/>
@@ -7579,7 +7528,6 @@
           <a:lstStyle/>
           <a:p>
             <a:pPr algn="ctr"/>
-            <a:endParaRPr/>
           </a:p>
         </p:txBody>
       </p:sp>
@@ -7623,7 +7571,6 @@
           <a:lstStyle/>
           <a:p>
             <a:pPr algn="ctr"/>
-            <a:endParaRPr/>
           </a:p>
         </p:txBody>
       </p:sp>
@@ -7667,7 +7614,6 @@
           <a:lstStyle/>
           <a:p>
             <a:pPr algn="ctr"/>
-            <a:endParaRPr/>
           </a:p>
         </p:txBody>
       </p:sp>
@@ -7711,7 +7657,6 @@
           <a:lstStyle/>
           <a:p>
             <a:pPr algn="ctr"/>
-            <a:endParaRPr/>
           </a:p>
         </p:txBody>
       </p:sp>
@@ -7755,7 +7700,6 @@
           <a:lstStyle/>
           <a:p>
             <a:pPr algn="ctr"/>
-            <a:endParaRPr/>
           </a:p>
         </p:txBody>
       </p:sp>
@@ -7871,7 +7815,6 @@
           <a:lstStyle/>
           <a:p>
             <a:pPr algn="ctr"/>
-            <a:endParaRPr/>
           </a:p>
         </p:txBody>
       </p:sp>
@@ -7940,7 +7883,7 @@
                 </a:solidFill>
                 <a:latin typeface="Aptos"/>
               </a:rPr>
-              <a:t>71,382</a:t>
+              <a:t>71,562</a:t>
             </a:r>
           </a:p>
         </p:txBody>
@@ -7987,7 +7930,6 @@
           <a:lstStyle/>
           <a:p>
             <a:pPr algn="ctr"/>
-            <a:endParaRPr/>
           </a:p>
         </p:txBody>
       </p:sp>
@@ -8056,7 +7998,7 @@
                 </a:solidFill>
                 <a:latin typeface="Aptos"/>
               </a:rPr>
-              <a:t>96,784</a:t>
+              <a:t>97,039</a:t>
             </a:r>
           </a:p>
         </p:txBody>
@@ -8103,7 +8045,6 @@
           <a:lstStyle/>
           <a:p>
             <a:pPr algn="ctr"/>
-            <a:endParaRPr/>
           </a:p>
         </p:txBody>
       </p:sp>
@@ -8208,13 +8149,13 @@
                 <a:latin typeface="Cascadia Mono"/>
               </a:rPr>
               <a:t>LANGUAGE                 FILES   EFFECTIVE      TOTAL   SHARE
-Python                   208      46,433     64,687  65.0%
-JavaScript                24      10,412     13,187  14.6%
-Markdown                  13       8,375     10,568  11.7%
-CSS                        5       2,644      3,286   3.7%
+Python                   208      46,525     64,806  65.0%
+JavaScript                24      10,440     13,240  14.6%
+Markdown                  13       8,403     10,608  11.7%
+CSS                        5       2,674      3,327   3.7%
 Other text                 3         778        955   1.1%
 YAML                      59         753      1,709   1.1%
-HTML                       4         592        610   0.8%
+HTML                       4         594        612   0.8%
 PowerShell                 5         408        616   0.6%
 JavaScript module          1         323        390   0.5%
 Prompt template            2         272        341   0.4%
@@ -8235,7 +8176,7 @@
 </file>
 
 <file path=ppt/slides/slide15.xml><?xml version="1.0" encoding="utf-8"?>
-<p:sld xmlns:a="http://schemas.openxmlformats.org/drawingml/2006/main" xmlns:r="http://schemas.openxmlformats.org/officeDocument/2006/relationships" xmlns:p="http://schemas.openxmlformats.org/presentationml/2006/main">
+<p:sld xmlns:a="http://schemas.openxmlformats.org/drawingml/2006/main" xmlns:p="http://schemas.openxmlformats.org/presentationml/2006/main" xmlns:r="http://schemas.openxmlformats.org/officeDocument/2006/relationships">
   <p:cSld>
     <p:spTree>
       <p:nvGrpSpPr>
@@ -8243,14 +8184,7 @@
         <p:cNvGrpSpPr/>
         <p:nvPr/>
       </p:nvGrpSpPr>
-      <p:grpSpPr>
-        <a:xfrm>
-          <a:off x="0" y="0"/>
-          <a:ext cx="0" cy="0"/>
-          <a:chOff x="0" y="0"/>
-          <a:chExt cx="0" cy="0"/>
-        </a:xfrm>
-      </p:grpSpPr>
+      <p:grpSpPr/>
       <p:sp>
         <p:nvSpPr>
           <p:cNvPr id="2" name="Rectangle 1"/>
@@ -8291,7 +8225,6 @@
           <a:lstStyle/>
           <a:p>
             <a:pPr algn="ctr"/>
-            <a:endParaRPr/>
           </a:p>
         </p:txBody>
       </p:sp>
@@ -8335,7 +8268,6 @@
           <a:lstStyle/>
           <a:p>
             <a:pPr algn="ctr"/>
-            <a:endParaRPr/>
           </a:p>
         </p:txBody>
       </p:sp>
@@ -8379,7 +8311,6 @@
           <a:lstStyle/>
           <a:p>
             <a:pPr algn="ctr"/>
-            <a:endParaRPr/>
           </a:p>
         </p:txBody>
       </p:sp>
@@ -8423,7 +8354,6 @@
           <a:lstStyle/>
           <a:p>
             <a:pPr algn="ctr"/>
-            <a:endParaRPr/>
           </a:p>
         </p:txBody>
       </p:sp>
@@ -8467,7 +8397,6 @@
           <a:lstStyle/>
           <a:p>
             <a:pPr algn="ctr"/>
-            <a:endParaRPr/>
           </a:p>
         </p:txBody>
       </p:sp>
@@ -8573,18 +8502,18 @@
               </a:rPr>
               <a:t>PATH                                                     LANGUAGE     EFFECTIVE   TOTAL
 Tlamatini/agent/views.py                                Python         5,862   8,411
-README.md                                               Markdown       3,550   4,471
+README.md                                               Markdown       3,564   4,491
 Tlamatini/agent/tools.py                                Python         1,841   2,483
 Tlamatini/agent/agents/flowcreator/agentic_skill.md     Markdown       1,694   1,889
-Tlamatini/agent/tests.py                                Python         1,574   1,927
-...ini/agent/static/agent/css/agentic_control_panel.css CSS            1,551   2,018
-Tlamatini/agent/static/agent/js/acp-canvas-core.js      JavaScript     1,235   1,529
+Tlamatini/agent/tests.py                                Python         1,666   2,042
+...ini/agent/static/agent/css/agentic_control_panel.css CSS            1,581   2,059
+Tlamatini/agent/static/agent/js/acp-canvas-core.js      JavaScript     1,233   1,538
 Tlamatini/agent/consumers.py                            Python         1,092   1,300
 Tlamatini/agent/doc_generation/complete_project_docs.py Python         1,040   1,191
 Tlamatini/agent/static/agent/js/acp-agent-connectors.js JavaScript     1,019   1,154
 Tlamatini/agent/static/agent/js/acp-control-buttons.js  JavaScript     1,000   1,301
 Tlamatini/agent/static/agent/css/agent_page.css         CSS              942   1,091
-Tlamatini/agent/static/agent/js/canvas_item_dialog.js   JavaScript       896   1,163
+Tlamatini/agent/static/agent/js/canvas_item_dialog.js   JavaScript       898   1,165
 Tlamatini/agent/agents/crawler/crawler.py               Python           881   1,261</a:t>
             </a:r>
           </a:p>
@@ -8599,7 +8528,7 @@
 </file>
 
 <file path=ppt/slides/slide16.xml><?xml version="1.0" encoding="utf-8"?>
-<p:sld xmlns:a="http://schemas.openxmlformats.org/drawingml/2006/main" xmlns:r="http://schemas.openxmlformats.org/officeDocument/2006/relationships" xmlns:p="http://schemas.openxmlformats.org/presentationml/2006/main">
+<p:sld xmlns:a="http://schemas.openxmlformats.org/drawingml/2006/main" xmlns:p="http://schemas.openxmlformats.org/presentationml/2006/main" xmlns:r="http://schemas.openxmlformats.org/officeDocument/2006/relationships">
   <p:cSld>
     <p:spTree>
       <p:nvGrpSpPr>
@@ -8607,14 +8536,7 @@
         <p:cNvGrpSpPr/>
         <p:nvPr/>
       </p:nvGrpSpPr>
-      <p:grpSpPr>
-        <a:xfrm>
-          <a:off x="0" y="0"/>
-          <a:ext cx="0" cy="0"/>
-          <a:chOff x="0" y="0"/>
-          <a:chExt cx="0" cy="0"/>
-        </a:xfrm>
-      </p:grpSpPr>
+      <p:grpSpPr/>
       <p:sp>
         <p:nvSpPr>
           <p:cNvPr id="2" name="Rectangle 1"/>
@@ -8655,7 +8577,6 @@
           <a:lstStyle/>
           <a:p>
             <a:pPr algn="ctr"/>
-            <a:endParaRPr/>
           </a:p>
         </p:txBody>
       </p:sp>
@@ -8699,7 +8620,6 @@
           <a:lstStyle/>
           <a:p>
             <a:pPr algn="ctr"/>
-            <a:endParaRPr/>
           </a:p>
         </p:txBody>
       </p:sp>
@@ -8743,7 +8663,6 @@
           <a:lstStyle/>
           <a:p>
             <a:pPr algn="ctr"/>
-            <a:endParaRPr/>
           </a:p>
         </p:txBody>
       </p:sp>
@@ -8787,7 +8706,6 @@
           <a:lstStyle/>
           <a:p>
             <a:pPr algn="ctr"/>
-            <a:endParaRPr/>
           </a:p>
         </p:txBody>
       </p:sp>
@@ -8831,7 +8749,6 @@
           <a:lstStyle/>
           <a:p>
             <a:pPr algn="ctr"/>
-            <a:endParaRPr/>
           </a:p>
         </p:txBody>
       </p:sp>
@@ -8947,7 +8864,6 @@
           <a:lstStyle/>
           <a:p>
             <a:pPr algn="ctr"/>
-            <a:endParaRPr/>
           </a:p>
         </p:txBody>
       </p:sp>
@@ -8991,7 +8907,6 @@
           <a:lstStyle/>
           <a:p>
             <a:pPr algn="ctr"/>
-            <a:endParaRPr/>
           </a:p>
         </p:txBody>
       </p:sp>
@@ -9047,7 +8962,7 @@
           <a:noFill/>
         </p:spPr>
         <p:txBody>
-          <a:bodyPr wrap="square" lIns="38100" tIns="25400" rIns="38100" bIns="25400" anchor="t">
+          <a:bodyPr wrap="square" anchor="t" lIns="38100" rIns="38100" tIns="25400" bIns="25400">
             <a:noAutofit/>
           </a:bodyPr>
           <a:lstStyle/>
@@ -9067,8 +8982,11 @@
               <a:rPr sz="1300" b="0" i="0">
                 <a:latin typeface="Calibri"/>
               </a:rPr>
-              <a:t>2026-04-17 | 3b6eb8e | Way too improving the execution chain with now "Exec report"!!, by angelahack1</a:t>
-            </a:r>
+              <a:t>2026-04-19 | 6063109 | Updating documentation, by angelahack1</a:t>
+            </a:r>
+            <a:endParaRPr sz="1300" b="0" i="0">
+              <a:latin typeface="Calibri"/>
+            </a:endParaRPr>
           </a:p>
           <a:p>
             <a:pPr>
@@ -9086,8 +9004,11 @@
               <a:rPr sz="1300" b="0" i="0">
                 <a:latin typeface="Calibri"/>
               </a:rPr>
-              <a:t>2026-04-17 | d46ddbb | Fixing some drawbacks in frozen Tlamatini's runtime execution.</a:t>
-            </a:r>
+              <a:t>2026-04-18 | 9249349 | Implementing scrolling in agentic_control_panel.html's canvas, by angelahack1</a:t>
+            </a:r>
+            <a:endParaRPr sz="1300" b="0" i="0">
+              <a:latin typeface="Calibri"/>
+            </a:endParaRPr>
           </a:p>
           <a:p>
             <a:pPr>
@@ -9105,8 +9026,11 @@
               <a:rPr sz="1300" b="0" i="0">
                 <a:latin typeface="Calibri"/>
               </a:rPr>
-              <a:t>2026-04-17 | 17d5760 | Updating to a more graphical documentation</a:t>
-            </a:r>
+              <a:t>2026-04-18 | e99d2b8 | Making Multi-turn execution tables persistent, by angelahack1</a:t>
+            </a:r>
+            <a:endParaRPr sz="1300" b="0" i="0">
+              <a:latin typeface="Calibri"/>
+            </a:endParaRPr>
           </a:p>
           <a:p>
             <a:pPr>
@@ -9124,8 +9048,11 @@
               <a:rPr sz="1300" b="0" i="0">
                 <a:latin typeface="Calibri"/>
               </a:rPr>
-              <a:t>2026-04-17 | d7a8e66 | Update documentation with the laatest fixings, by angelahack1</a:t>
-            </a:r>
+              <a:t>2026-04-18 | fad8002 | Just sompptx framing, by angelahack1</a:t>
+            </a:r>
+            <a:endParaRPr sz="1300" b="0" i="0">
+              <a:latin typeface="Calibri"/>
+            </a:endParaRPr>
           </a:p>
           <a:p>
             <a:pPr>
@@ -9143,8 +9070,11 @@
               <a:rPr sz="1300" b="0" i="0">
                 <a:latin typeface="Calibri"/>
               </a:rPr>
-              <a:t>2026-04-16 | 0249c76 | Improving multiturn, tested for installing assets, and added a new video, by angelahack1</a:t>
-            </a:r>
+              <a:t>2026-04-17 | 4e2a51b | Documentation updates, with automation, by angelahack1</a:t>
+            </a:r>
+            <a:endParaRPr sz="1300" b="0" i="0">
+              <a:latin typeface="Calibri"/>
+            </a:endParaRPr>
           </a:p>
           <a:p>
             <a:pPr>
@@ -9162,8 +9092,11 @@
               <a:rPr sz="1300" b="0" i="0">
                 <a:latin typeface="Calibri"/>
               </a:rPr>
-              <a:t>2026-04-15 | 9abade4 | Adding video links to README.md, by angelahack1</a:t>
-            </a:r>
+              <a:t>2026-04-17 | 3b6eb8e | Way too improving the execution chain with now "Exec report"!!, by angelahack1</a:t>
+            </a:r>
+            <a:endParaRPr sz="1300" b="0" i="0">
+              <a:latin typeface="Calibri"/>
+            </a:endParaRPr>
           </a:p>
         </p:txBody>
       </p:sp>
@@ -9176,7 +9109,7 @@
 </file>
 
 <file path=ppt/slides/slide17.xml><?xml version="1.0" encoding="utf-8"?>
-<p:sld xmlns:a="http://schemas.openxmlformats.org/drawingml/2006/main" xmlns:r="http://schemas.openxmlformats.org/officeDocument/2006/relationships" xmlns:p="http://schemas.openxmlformats.org/presentationml/2006/main">
+<p:sld xmlns:a="http://schemas.openxmlformats.org/drawingml/2006/main" xmlns:p="http://schemas.openxmlformats.org/presentationml/2006/main" xmlns:r="http://schemas.openxmlformats.org/officeDocument/2006/relationships">
   <p:cSld>
     <p:spTree>
       <p:nvGrpSpPr>
@@ -9184,14 +9117,7 @@
         <p:cNvGrpSpPr/>
         <p:nvPr/>
       </p:nvGrpSpPr>
-      <p:grpSpPr>
-        <a:xfrm>
-          <a:off x="0" y="0"/>
-          <a:ext cx="0" cy="0"/>
-          <a:chOff x="0" y="0"/>
-          <a:chExt cx="0" cy="0"/>
-        </a:xfrm>
-      </p:grpSpPr>
+      <p:grpSpPr/>
       <p:sp>
         <p:nvSpPr>
           <p:cNvPr id="2" name="Rectangle 1"/>
@@ -9232,7 +9158,6 @@
           <a:lstStyle/>
           <a:p>
             <a:pPr algn="ctr"/>
-            <a:endParaRPr/>
           </a:p>
         </p:txBody>
       </p:sp>
@@ -9276,7 +9201,6 @@
           <a:lstStyle/>
           <a:p>
             <a:pPr algn="ctr"/>
-            <a:endParaRPr/>
           </a:p>
         </p:txBody>
       </p:sp>
@@ -9320,7 +9244,6 @@
           <a:lstStyle/>
           <a:p>
             <a:pPr algn="ctr"/>
-            <a:endParaRPr/>
           </a:p>
         </p:txBody>
       </p:sp>
@@ -9364,7 +9287,6 @@
           <a:lstStyle/>
           <a:p>
             <a:pPr algn="ctr"/>
-            <a:endParaRPr/>
           </a:p>
         </p:txBody>
       </p:sp>
@@ -9408,7 +9330,6 @@
           <a:lstStyle/>
           <a:p>
             <a:pPr algn="ctr"/>
-            <a:endParaRPr/>
           </a:p>
         </p:txBody>
       </p:sp>
@@ -9525,6 +9446,7 @@
 |-- install.py
 |-- LICENSE
 |-- mouse_mover.py
+|-- multi-turn-flowFMODInstallation.flw
 |-- NEW_AGENT_RECOMMENDATIONS.md
 |-- package.json
 |-- prompts_example.txt
@@ -9541,8 +9463,7 @@
 |-- uninstall.py
 |-- unregister_flw.ps1
 |-- .codex/
-|   `-- skills/
-|       |-- full-project-pdf-dossier/</a:t>
+|   `-- skills/</a:t>
             </a:r>
           </a:p>
         </p:txBody>
@@ -9556,7 +9477,7 @@
 </file>
 
 <file path=ppt/slides/slide18.xml><?xml version="1.0" encoding="utf-8"?>
-<p:sld xmlns:a="http://schemas.openxmlformats.org/drawingml/2006/main" xmlns:r="http://schemas.openxmlformats.org/officeDocument/2006/relationships" xmlns:p="http://schemas.openxmlformats.org/presentationml/2006/main">
+<p:sld xmlns:a="http://schemas.openxmlformats.org/drawingml/2006/main" xmlns:p="http://schemas.openxmlformats.org/presentationml/2006/main" xmlns:r="http://schemas.openxmlformats.org/officeDocument/2006/relationships">
   <p:cSld>
     <p:spTree>
       <p:nvGrpSpPr>
@@ -9564,14 +9485,7 @@
         <p:cNvGrpSpPr/>
         <p:nvPr/>
       </p:nvGrpSpPr>
-      <p:grpSpPr>
-        <a:xfrm>
-          <a:off x="0" y="0"/>
-          <a:ext cx="0" cy="0"/>
-          <a:chOff x="0" y="0"/>
-          <a:chExt cx="0" cy="0"/>
-        </a:xfrm>
-      </p:grpSpPr>
+      <p:grpSpPr/>
       <p:sp>
         <p:nvSpPr>
           <p:cNvPr id="2" name="Rectangle 1"/>
@@ -9612,7 +9526,6 @@
           <a:lstStyle/>
           <a:p>
             <a:pPr algn="ctr"/>
-            <a:endParaRPr/>
           </a:p>
         </p:txBody>
       </p:sp>
@@ -9656,7 +9569,6 @@
           <a:lstStyle/>
           <a:p>
             <a:pPr algn="ctr"/>
-            <a:endParaRPr/>
           </a:p>
         </p:txBody>
       </p:sp>
@@ -9700,7 +9612,6 @@
           <a:lstStyle/>
           <a:p>
             <a:pPr algn="ctr"/>
-            <a:endParaRPr/>
           </a:p>
         </p:txBody>
       </p:sp>
@@ -9744,7 +9655,6 @@
           <a:lstStyle/>
           <a:p>
             <a:pPr algn="ctr"/>
-            <a:endParaRPr/>
           </a:p>
         </p:txBody>
       </p:sp>
@@ -9788,7 +9698,6 @@
           <a:lstStyle/>
           <a:p>
             <a:pPr algn="ctr"/>
-            <a:endParaRPr/>
           </a:p>
         </p:txBody>
       </p:sp>
@@ -9892,7 +9801,8 @@
                 </a:solidFill>
                 <a:latin typeface="Cascadia Mono"/>
               </a:rPr>
-              <a:t>|       |   `-- SKILL.md
+              <a:t>|       |-- full-project-pdf-dossier/
+|       |   `-- SKILL.md
 |       `-- overlap-safe-pptx-dossier/
 |           `-- SKILL.md
 |-- pyinstaller_hooks/
@@ -9921,8 +9831,7 @@
     |   |-- constants.py
     |   |-- consumers.py
     |   |-- filesearch.proto
-    |   |-- filesearch_pb2.py
-    |   |-- filesearch_pb2_grpc.py</a:t>
+    |   |-- filesearch_pb2.py</a:t>
             </a:r>
           </a:p>
         </p:txBody>
@@ -9936,7 +9845,7 @@
 </file>
 
 <file path=ppt/slides/slide19.xml><?xml version="1.0" encoding="utf-8"?>
-<p:sld xmlns:a="http://schemas.openxmlformats.org/drawingml/2006/main" xmlns:r="http://schemas.openxmlformats.org/officeDocument/2006/relationships" xmlns:p="http://schemas.openxmlformats.org/presentationml/2006/main">
+<p:sld xmlns:a="http://schemas.openxmlformats.org/drawingml/2006/main" xmlns:p="http://schemas.openxmlformats.org/presentationml/2006/main" xmlns:r="http://schemas.openxmlformats.org/officeDocument/2006/relationships">
   <p:cSld>
     <p:spTree>
       <p:nvGrpSpPr>
@@ -9944,14 +9853,7 @@
         <p:cNvGrpSpPr/>
         <p:nvPr/>
       </p:nvGrpSpPr>
-      <p:grpSpPr>
-        <a:xfrm>
-          <a:off x="0" y="0"/>
-          <a:ext cx="0" cy="0"/>
-          <a:chOff x="0" y="0"/>
-          <a:chExt cx="0" cy="0"/>
-        </a:xfrm>
-      </p:grpSpPr>
+      <p:grpSpPr/>
       <p:sp>
         <p:nvSpPr>
           <p:cNvPr id="2" name="Rectangle 1"/>
@@ -9992,7 +9894,6 @@
           <a:lstStyle/>
           <a:p>
             <a:pPr algn="ctr"/>
-            <a:endParaRPr/>
           </a:p>
         </p:txBody>
       </p:sp>
@@ -10036,7 +9937,6 @@
           <a:lstStyle/>
           <a:p>
             <a:pPr algn="ctr"/>
-            <a:endParaRPr/>
           </a:p>
         </p:txBody>
       </p:sp>
@@ -10080,7 +9980,6 @@
           <a:lstStyle/>
           <a:p>
             <a:pPr algn="ctr"/>
-            <a:endParaRPr/>
           </a:p>
         </p:txBody>
       </p:sp>
@@ -10124,7 +10023,6 @@
           <a:lstStyle/>
           <a:p>
             <a:pPr algn="ctr"/>
-            <a:endParaRPr/>
           </a:p>
         </p:txBody>
       </p:sp>
@@ -10168,7 +10066,6 @@
           <a:lstStyle/>
           <a:p>
             <a:pPr algn="ctr"/>
-            <a:endParaRPr/>
           </a:p>
         </p:txBody>
       </p:sp>
@@ -10272,7 +10169,8 @@
                 </a:solidFill>
                 <a:latin typeface="Cascadia Mono"/>
               </a:rPr>
-              <a:t>    |   |-- global_execution_planner.py
+              <a:t>    |   |-- filesearch_pb2_grpc.py
+    |   |-- global_execution_planner.py
     |   |-- global_state.py
     |   |-- inet_determiner.py
     |   |-- mcp_agent.py
@@ -10301,8 +10199,7 @@
     |   |   |   |-- asker.py
     |   |   |   `-- config.yaml
     |   |   |-- barrier/
-    |   |   |   |-- barrier.py
-    |   |   |   |-- config.yaml</a:t>
+    |   |   |   |-- barrier.py</a:t>
             </a:r>
           </a:p>
         </p:txBody>
@@ -10316,7 +10213,7 @@
 </file>
 
 <file path=ppt/slides/slide2.xml><?xml version="1.0" encoding="utf-8"?>
-<p:sld xmlns:a="http://schemas.openxmlformats.org/drawingml/2006/main" xmlns:r="http://schemas.openxmlformats.org/officeDocument/2006/relationships" xmlns:p="http://schemas.openxmlformats.org/presentationml/2006/main">
+<p:sld xmlns:a="http://schemas.openxmlformats.org/drawingml/2006/main" xmlns:p="http://schemas.openxmlformats.org/presentationml/2006/main" xmlns:r="http://schemas.openxmlformats.org/officeDocument/2006/relationships">
   <p:cSld>
     <p:spTree>
       <p:nvGrpSpPr>
@@ -10324,14 +10221,7 @@
         <p:cNvGrpSpPr/>
         <p:nvPr/>
       </p:nvGrpSpPr>
-      <p:grpSpPr>
-        <a:xfrm>
-          <a:off x="0" y="0"/>
-          <a:ext cx="0" cy="0"/>
-          <a:chOff x="0" y="0"/>
-          <a:chExt cx="0" cy="0"/>
-        </a:xfrm>
-      </p:grpSpPr>
+      <p:grpSpPr/>
       <p:sp>
         <p:nvSpPr>
           <p:cNvPr id="2" name="Rectangle 1"/>
@@ -10372,7 +10262,6 @@
           <a:lstStyle/>
           <a:p>
             <a:pPr algn="ctr"/>
-            <a:endParaRPr/>
           </a:p>
         </p:txBody>
       </p:sp>
@@ -10416,7 +10305,6 @@
           <a:lstStyle/>
           <a:p>
             <a:pPr algn="ctr"/>
-            <a:endParaRPr/>
           </a:p>
         </p:txBody>
       </p:sp>
@@ -10460,7 +10348,6 @@
           <a:lstStyle/>
           <a:p>
             <a:pPr algn="ctr"/>
-            <a:endParaRPr/>
           </a:p>
         </p:txBody>
       </p:sp>
@@ -10504,7 +10391,6 @@
           <a:lstStyle/>
           <a:p>
             <a:pPr algn="ctr"/>
-            <a:endParaRPr/>
           </a:p>
         </p:txBody>
       </p:sp>
@@ -10548,7 +10434,6 @@
           <a:lstStyle/>
           <a:p>
             <a:pPr algn="ctr"/>
-            <a:endParaRPr/>
           </a:p>
         </p:txBody>
       </p:sp>
@@ -10664,7 +10549,6 @@
           <a:lstStyle/>
           <a:p>
             <a:pPr algn="ctr"/>
-            <a:endParaRPr/>
           </a:p>
         </p:txBody>
       </p:sp>
@@ -10708,7 +10592,6 @@
           <a:lstStyle/>
           <a:p>
             <a:pPr algn="ctr"/>
-            <a:endParaRPr/>
           </a:p>
         </p:txBody>
       </p:sp>
@@ -10764,7 +10647,7 @@
           <a:noFill/>
         </p:spPr>
         <p:txBody>
-          <a:bodyPr wrap="square" lIns="38100" tIns="25400" rIns="38100" bIns="25400" anchor="t">
+          <a:bodyPr wrap="square" anchor="t" lIns="38100" rIns="38100" tIns="25400" bIns="25400">
             <a:noAutofit/>
           </a:bodyPr>
           <a:lstStyle/>
@@ -10786,6 +10669,9 @@
               </a:rPr>
               <a:t>Tlamatini is a local-first AI developer assistant built with Django, Django Channels, LangChain, LangGraph, FAISS/BM25 retrieval, and a large in-repository agent application.</a:t>
             </a:r>
+            <a:endParaRPr sz="1600" b="0" i="0">
+              <a:latin typeface="Calibri"/>
+            </a:endParaRPr>
           </a:p>
           <a:p>
             <a:pPr>
@@ -10805,6 +10691,9 @@
               </a:rPr>
               <a:t>It combines a browser chat surface, a Retrieval-Augmented Generation stack, a Multi-Turn tool executor, MCP-backed context providers, wrapped chat-agent runtimes, and a visual Agentic Control Panel for workflow design.</a:t>
             </a:r>
+            <a:endParaRPr sz="1600" b="0" i="0">
+              <a:latin typeface="Calibri"/>
+            </a:endParaRPr>
           </a:p>
           <a:p>
             <a:pPr>
@@ -10824,6 +10713,9 @@
               </a:rPr>
               <a:t>The platform is designed for development operations: codebase analysis, file and directory context, command execution, Python execution, screenshots, web/search helpers, notifications, DevOps tools, local model operation, and Windows packaging.</a:t>
             </a:r>
+            <a:endParaRPr sz="1600" b="0" i="0">
+              <a:latin typeface="Calibri"/>
+            </a:endParaRPr>
           </a:p>
         </p:txBody>
       </p:sp>
@@ -10869,7 +10761,6 @@
           <a:lstStyle/>
           <a:p>
             <a:pPr algn="ctr"/>
-            <a:endParaRPr/>
           </a:p>
         </p:txBody>
       </p:sp>
@@ -10913,7 +10804,6 @@
           <a:lstStyle/>
           <a:p>
             <a:pPr algn="ctr"/>
-            <a:endParaRPr/>
           </a:p>
         </p:txBody>
       </p:sp>
@@ -10969,7 +10859,7 @@
           <a:noFill/>
         </p:spPr>
         <p:txBody>
-          <a:bodyPr wrap="square" lIns="38100" tIns="25400" rIns="38100" bIns="25400" anchor="t">
+          <a:bodyPr wrap="square" anchor="t" lIns="38100" rIns="38100" tIns="25400" bIns="25400">
             <a:noAutofit/>
           </a:bodyPr>
           <a:lstStyle/>
@@ -10991,6 +10881,9 @@
               </a:rPr>
               <a:t>Chat page at `/agent/` for context-grounded Q&amp;A, code generation, tool calls, and Multi-Turn execution.</a:t>
             </a:r>
+            <a:endParaRPr sz="1600" b="0" i="0">
+              <a:latin typeface="Calibri"/>
+            </a:endParaRPr>
           </a:p>
           <a:p>
             <a:pPr>
@@ -11010,6 +10903,9 @@
               </a:rPr>
               <a:t>Agentic Control Panel at `/agentic_control_panel/` for visual workflow design.</a:t>
             </a:r>
+            <a:endParaRPr sz="1600" b="0" i="0">
+              <a:latin typeface="Calibri"/>
+            </a:endParaRPr>
           </a:p>
           <a:p>
             <a:pPr>
@@ -11029,6 +10925,9 @@
               </a:rPr>
               <a:t>Django admin and config dialogs for MCPs, tools, agents, users, and persistent settings.</a:t>
             </a:r>
+            <a:endParaRPr sz="1600" b="0" i="0">
+              <a:latin typeface="Calibri"/>
+            </a:endParaRPr>
           </a:p>
         </p:txBody>
       </p:sp>
@@ -11041,7 +10940,7 @@
 </file>
 
 <file path=ppt/slides/slide20.xml><?xml version="1.0" encoding="utf-8"?>
-<p:sld xmlns:a="http://schemas.openxmlformats.org/drawingml/2006/main" xmlns:r="http://schemas.openxmlformats.org/officeDocument/2006/relationships" xmlns:p="http://schemas.openxmlformats.org/presentationml/2006/main">
+<p:sld xmlns:a="http://schemas.openxmlformats.org/drawingml/2006/main" xmlns:p="http://schemas.openxmlformats.org/presentationml/2006/main" xmlns:r="http://schemas.openxmlformats.org/officeDocument/2006/relationships">
   <p:cSld>
     <p:spTree>
       <p:nvGrpSpPr>
@@ -11049,14 +10948,7 @@
         <p:cNvGrpSpPr/>
         <p:nvPr/>
       </p:nvGrpSpPr>
-      <p:grpSpPr>
-        <a:xfrm>
-          <a:off x="0" y="0"/>
-          <a:ext cx="0" cy="0"/>
-          <a:chOff x="0" y="0"/>
-          <a:chExt cx="0" cy="0"/>
-        </a:xfrm>
-      </p:grpSpPr>
+      <p:grpSpPr/>
       <p:sp>
         <p:nvSpPr>
           <p:cNvPr id="2" name="Rectangle 1"/>
@@ -11097,7 +10989,6 @@
           <a:lstStyle/>
           <a:p>
             <a:pPr algn="ctr"/>
-            <a:endParaRPr/>
           </a:p>
         </p:txBody>
       </p:sp>
@@ -11141,7 +11032,6 @@
           <a:lstStyle/>
           <a:p>
             <a:pPr algn="ctr"/>
-            <a:endParaRPr/>
           </a:p>
         </p:txBody>
       </p:sp>
@@ -11185,7 +11075,6 @@
           <a:lstStyle/>
           <a:p>
             <a:pPr algn="ctr"/>
-            <a:endParaRPr/>
           </a:p>
         </p:txBody>
       </p:sp>
@@ -11229,7 +11118,6 @@
           <a:lstStyle/>
           <a:p>
             <a:pPr algn="ctr"/>
-            <a:endParaRPr/>
           </a:p>
         </p:txBody>
       </p:sp>
@@ -11273,7 +11161,6 @@
           <a:lstStyle/>
           <a:p>
             <a:pPr algn="ctr"/>
-            <a:endParaRPr/>
           </a:p>
         </p:txBody>
       </p:sp>
@@ -11377,7 +11264,8 @@
                 </a:solidFill>
                 <a:latin typeface="Cascadia Mono"/>
               </a:rPr>
-              <a:t>    |   |   |   `-- test_barrier.py
+              <a:t>    |   |   |   |-- config.yaml
+    |   |   |   `-- test_barrier.py
     |   |   |-- cleaner/
     |   |   |   |-- __init__.py
     |   |   |   |-- cleaner.py
@@ -11406,8 +11294,7 @@
     |   |   |-- executer/
     |   |   |   |-- config.yaml
     |   |   |   `-- executer.py
-    |   |   |-- file_creator/
-    |   |   |   |-- config.yaml</a:t>
+    |   |   |-- file_creator/</a:t>
             </a:r>
           </a:p>
         </p:txBody>
@@ -11421,7 +11308,7 @@
 </file>
 
 <file path=ppt/slides/slide21.xml><?xml version="1.0" encoding="utf-8"?>
-<p:sld xmlns:a="http://schemas.openxmlformats.org/drawingml/2006/main" xmlns:r="http://schemas.openxmlformats.org/officeDocument/2006/relationships" xmlns:p="http://schemas.openxmlformats.org/presentationml/2006/main">
+<p:sld xmlns:a="http://schemas.openxmlformats.org/drawingml/2006/main" xmlns:p="http://schemas.openxmlformats.org/presentationml/2006/main" xmlns:r="http://schemas.openxmlformats.org/officeDocument/2006/relationships">
   <p:cSld>
     <p:spTree>
       <p:nvGrpSpPr>
@@ -11429,14 +11316,7 @@
         <p:cNvGrpSpPr/>
         <p:nvPr/>
       </p:nvGrpSpPr>
-      <p:grpSpPr>
-        <a:xfrm>
-          <a:off x="0" y="0"/>
-          <a:ext cx="0" cy="0"/>
-          <a:chOff x="0" y="0"/>
-          <a:chExt cx="0" cy="0"/>
-        </a:xfrm>
-      </p:grpSpPr>
+      <p:grpSpPr/>
       <p:sp>
         <p:nvSpPr>
           <p:cNvPr id="2" name="Rectangle 1"/>
@@ -11477,7 +11357,6 @@
           <a:lstStyle/>
           <a:p>
             <a:pPr algn="ctr"/>
-            <a:endParaRPr/>
           </a:p>
         </p:txBody>
       </p:sp>
@@ -11521,7 +11400,6 @@
           <a:lstStyle/>
           <a:p>
             <a:pPr algn="ctr"/>
-            <a:endParaRPr/>
           </a:p>
         </p:txBody>
       </p:sp>
@@ -11565,7 +11443,6 @@
           <a:lstStyle/>
           <a:p>
             <a:pPr algn="ctr"/>
-            <a:endParaRPr/>
           </a:p>
         </p:txBody>
       </p:sp>
@@ -11609,7 +11486,6 @@
           <a:lstStyle/>
           <a:p>
             <a:pPr algn="ctr"/>
-            <a:endParaRPr/>
           </a:p>
         </p:txBody>
       </p:sp>
@@ -11653,7 +11529,6 @@
           <a:lstStyle/>
           <a:p>
             <a:pPr algn="ctr"/>
-            <a:endParaRPr/>
           </a:p>
         </p:txBody>
       </p:sp>
@@ -11757,7 +11632,8 @@
                 </a:solidFill>
                 <a:latin typeface="Cascadia Mono"/>
               </a:rPr>
-              <a:t>    |   |   |   `-- file_creator.py
+              <a:t>    |   |   |   |-- config.yaml
+    |   |   |   `-- file_creator.py
     |   |   |-- file_extractor/
     |   |   |   |-- config.yaml
     |   |   |   `-- file_extractor.py
@@ -11786,8 +11662,7 @@
     |   |   |-- gatewayer/
     |   |   |   |-- config.yaml
     |   |   |   |-- gatewayer.md
-    |   |   |   |-- gatewayer.py
-    |   |   |   `-- gatewayer_explanation.md</a:t>
+    |   |   |   |-- gatewayer.py</a:t>
             </a:r>
           </a:p>
         </p:txBody>
@@ -11801,7 +11676,7 @@
 </file>
 
 <file path=ppt/slides/slide22.xml><?xml version="1.0" encoding="utf-8"?>
-<p:sld xmlns:a="http://schemas.openxmlformats.org/drawingml/2006/main" xmlns:r="http://schemas.openxmlformats.org/officeDocument/2006/relationships" xmlns:p="http://schemas.openxmlformats.org/presentationml/2006/main">
+<p:sld xmlns:a="http://schemas.openxmlformats.org/drawingml/2006/main" xmlns:p="http://schemas.openxmlformats.org/presentationml/2006/main" xmlns:r="http://schemas.openxmlformats.org/officeDocument/2006/relationships">
   <p:cSld>
     <p:spTree>
       <p:nvGrpSpPr>
@@ -11809,14 +11684,7 @@
         <p:cNvGrpSpPr/>
         <p:nvPr/>
       </p:nvGrpSpPr>
-      <p:grpSpPr>
-        <a:xfrm>
-          <a:off x="0" y="0"/>
-          <a:ext cx="0" cy="0"/>
-          <a:chOff x="0" y="0"/>
-          <a:chExt cx="0" cy="0"/>
-        </a:xfrm>
-      </p:grpSpPr>
+      <p:grpSpPr/>
       <p:sp>
         <p:nvSpPr>
           <p:cNvPr id="2" name="Rectangle 1"/>
@@ -11857,7 +11725,6 @@
           <a:lstStyle/>
           <a:p>
             <a:pPr algn="ctr"/>
-            <a:endParaRPr/>
           </a:p>
         </p:txBody>
       </p:sp>
@@ -11901,7 +11768,6 @@
           <a:lstStyle/>
           <a:p>
             <a:pPr algn="ctr"/>
-            <a:endParaRPr/>
           </a:p>
         </p:txBody>
       </p:sp>
@@ -11945,7 +11811,6 @@
           <a:lstStyle/>
           <a:p>
             <a:pPr algn="ctr"/>
-            <a:endParaRPr/>
           </a:p>
         </p:txBody>
       </p:sp>
@@ -11989,7 +11854,6 @@
           <a:lstStyle/>
           <a:p>
             <a:pPr algn="ctr"/>
-            <a:endParaRPr/>
           </a:p>
         </p:txBody>
       </p:sp>
@@ -12033,7 +11897,6 @@
           <a:lstStyle/>
           <a:p>
             <a:pPr algn="ctr"/>
-            <a:endParaRPr/>
           </a:p>
         </p:txBody>
       </p:sp>
@@ -12137,7 +12000,8 @@
                 </a:solidFill>
                 <a:latin typeface="Cascadia Mono"/>
               </a:rPr>
-              <a:t>    |   |   |-- gitter/
+              <a:t>    |   |   |   `-- gatewayer_explanation.md
+    |   |   |-- gitter/
     |   |   |   |-- config.yaml
     |   |   |   `-- gitter.py
     |   |   |-- googler/
@@ -12166,8 +12030,7 @@
     |   |   |   `-- kyber_decipher.py
     |   |   |-- kyber_keygen/
     |   |   |   |-- config.yaml
-    |   |   |   `-- kyber_keygen.py
-    |   |   |-- mongoxer/</a:t>
+    |   |   |   `-- kyber_keygen.py</a:t>
             </a:r>
           </a:p>
         </p:txBody>
@@ -12181,7 +12044,7 @@
 </file>
 
 <file path=ppt/slides/slide23.xml><?xml version="1.0" encoding="utf-8"?>
-<p:sld xmlns:a="http://schemas.openxmlformats.org/drawingml/2006/main" xmlns:r="http://schemas.openxmlformats.org/officeDocument/2006/relationships" xmlns:p="http://schemas.openxmlformats.org/presentationml/2006/main">
+<p:sld xmlns:a="http://schemas.openxmlformats.org/drawingml/2006/main" xmlns:p="http://schemas.openxmlformats.org/presentationml/2006/main" xmlns:r="http://schemas.openxmlformats.org/officeDocument/2006/relationships">
   <p:cSld>
     <p:spTree>
       <p:nvGrpSpPr>
@@ -12189,14 +12052,7 @@
         <p:cNvGrpSpPr/>
         <p:nvPr/>
       </p:nvGrpSpPr>
-      <p:grpSpPr>
-        <a:xfrm>
-          <a:off x="0" y="0"/>
-          <a:ext cx="0" cy="0"/>
-          <a:chOff x="0" y="0"/>
-          <a:chExt cx="0" cy="0"/>
-        </a:xfrm>
-      </p:grpSpPr>
+      <p:grpSpPr/>
       <p:sp>
         <p:nvSpPr>
           <p:cNvPr id="2" name="Rectangle 1"/>
@@ -12237,7 +12093,6 @@
           <a:lstStyle/>
           <a:p>
             <a:pPr algn="ctr"/>
-            <a:endParaRPr/>
           </a:p>
         </p:txBody>
       </p:sp>
@@ -12281,7 +12136,6 @@
           <a:lstStyle/>
           <a:p>
             <a:pPr algn="ctr"/>
-            <a:endParaRPr/>
           </a:p>
         </p:txBody>
       </p:sp>
@@ -12325,7 +12179,6 @@
           <a:lstStyle/>
           <a:p>
             <a:pPr algn="ctr"/>
-            <a:endParaRPr/>
           </a:p>
         </p:txBody>
       </p:sp>
@@ -12369,7 +12222,6 @@
           <a:lstStyle/>
           <a:p>
             <a:pPr algn="ctr"/>
-            <a:endParaRPr/>
           </a:p>
         </p:txBody>
       </p:sp>
@@ -12413,7 +12265,6 @@
           <a:lstStyle/>
           <a:p>
             <a:pPr algn="ctr"/>
-            <a:endParaRPr/>
           </a:p>
         </p:txBody>
       </p:sp>
@@ -12517,7 +12368,8 @@
                 </a:solidFill>
                 <a:latin typeface="Cascadia Mono"/>
               </a:rPr>
-              <a:t>    |   |   |   |-- config.yaml
+              <a:t>    |   |   |-- mongoxer/
+    |   |   |   |-- config.yaml
     |   |   |   `-- mongoxer.py
     |   |   |-- monitor_log/
     |   |   |   |-- config.yaml
@@ -12546,8 +12398,7 @@
     |   |   |-- parametrizer/
     |   |   |   |-- config.yaml
     |   |   |   `-- parametrizer.py
-    |   |   |-- prompter/
-    |   |   |   |-- config.yaml</a:t>
+    |   |   |-- prompter/</a:t>
             </a:r>
           </a:p>
         </p:txBody>
@@ -12561,7 +12412,7 @@
 </file>
 
 <file path=ppt/slides/slide24.xml><?xml version="1.0" encoding="utf-8"?>
-<p:sld xmlns:a="http://schemas.openxmlformats.org/drawingml/2006/main" xmlns:r="http://schemas.openxmlformats.org/officeDocument/2006/relationships" xmlns:p="http://schemas.openxmlformats.org/presentationml/2006/main">
+<p:sld xmlns:a="http://schemas.openxmlformats.org/drawingml/2006/main" xmlns:p="http://schemas.openxmlformats.org/presentationml/2006/main" xmlns:r="http://schemas.openxmlformats.org/officeDocument/2006/relationships">
   <p:cSld>
     <p:spTree>
       <p:nvGrpSpPr>
@@ -12569,14 +12420,7 @@
         <p:cNvGrpSpPr/>
         <p:nvPr/>
       </p:nvGrpSpPr>
-      <p:grpSpPr>
-        <a:xfrm>
-          <a:off x="0" y="0"/>
-          <a:ext cx="0" cy="0"/>
-          <a:chOff x="0" y="0"/>
-          <a:chExt cx="0" cy="0"/>
-        </a:xfrm>
-      </p:grpSpPr>
+      <p:grpSpPr/>
       <p:sp>
         <p:nvSpPr>
           <p:cNvPr id="2" name="Rectangle 1"/>
@@ -12617,7 +12461,6 @@
           <a:lstStyle/>
           <a:p>
             <a:pPr algn="ctr"/>
-            <a:endParaRPr/>
           </a:p>
         </p:txBody>
       </p:sp>
@@ -12661,7 +12504,6 @@
           <a:lstStyle/>
           <a:p>
             <a:pPr algn="ctr"/>
-            <a:endParaRPr/>
           </a:p>
         </p:txBody>
       </p:sp>
@@ -12705,7 +12547,6 @@
           <a:lstStyle/>
           <a:p>
             <a:pPr algn="ctr"/>
-            <a:endParaRPr/>
           </a:p>
         </p:txBody>
       </p:sp>
@@ -12749,7 +12590,6 @@
           <a:lstStyle/>
           <a:p>
             <a:pPr algn="ctr"/>
-            <a:endParaRPr/>
           </a:p>
         </p:txBody>
       </p:sp>
@@ -12793,7 +12633,6 @@
           <a:lstStyle/>
           <a:p>
             <a:pPr algn="ctr"/>
-            <a:endParaRPr/>
           </a:p>
         </p:txBody>
       </p:sp>
@@ -12897,7 +12736,8 @@
                 </a:solidFill>
                 <a:latin typeface="Cascadia Mono"/>
               </a:rPr>
-              <a:t>    |   |   |   `-- prompter.py
+              <a:t>    |   |   |   |-- config.yaml
+    |   |   |   `-- prompter.py
     |   |   |-- pser/
     |   |   |   |-- config.yaml
     |   |   |   `-- pser.py
@@ -12926,8 +12766,7 @@
     |   |   |   |-- config.yaml
     |   |   |   `-- ssher.py
     |   |   |-- starter/
-    |   |   |   |-- config.yaml
-    |   |   |   `-- starter.py</a:t>
+    |   |   |   |-- config.yaml</a:t>
             </a:r>
           </a:p>
         </p:txBody>
@@ -12941,7 +12780,7 @@
 </file>
 
 <file path=ppt/slides/slide25.xml><?xml version="1.0" encoding="utf-8"?>
-<p:sld xmlns:a="http://schemas.openxmlformats.org/drawingml/2006/main" xmlns:r="http://schemas.openxmlformats.org/officeDocument/2006/relationships" xmlns:p="http://schemas.openxmlformats.org/presentationml/2006/main">
+<p:sld xmlns:a="http://schemas.openxmlformats.org/drawingml/2006/main" xmlns:p="http://schemas.openxmlformats.org/presentationml/2006/main" xmlns:r="http://schemas.openxmlformats.org/officeDocument/2006/relationships">
   <p:cSld>
     <p:spTree>
       <p:nvGrpSpPr>
@@ -12949,14 +12788,7 @@
         <p:cNvGrpSpPr/>
         <p:nvPr/>
       </p:nvGrpSpPr>
-      <p:grpSpPr>
-        <a:xfrm>
-          <a:off x="0" y="0"/>
-          <a:ext cx="0" cy="0"/>
-          <a:chOff x="0" y="0"/>
-          <a:chExt cx="0" cy="0"/>
-        </a:xfrm>
-      </p:grpSpPr>
+      <p:grpSpPr/>
       <p:sp>
         <p:nvSpPr>
           <p:cNvPr id="2" name="Rectangle 1"/>
@@ -12997,7 +12829,6 @@
           <a:lstStyle/>
           <a:p>
             <a:pPr algn="ctr"/>
-            <a:endParaRPr/>
           </a:p>
         </p:txBody>
       </p:sp>
@@ -13041,7 +12872,6 @@
           <a:lstStyle/>
           <a:p>
             <a:pPr algn="ctr"/>
-            <a:endParaRPr/>
           </a:p>
         </p:txBody>
       </p:sp>
@@ -13085,7 +12915,6 @@
           <a:lstStyle/>
           <a:p>
             <a:pPr algn="ctr"/>
-            <a:endParaRPr/>
           </a:p>
         </p:txBody>
       </p:sp>
@@ -13129,7 +12958,6 @@
           <a:lstStyle/>
           <a:p>
             <a:pPr algn="ctr"/>
-            <a:endParaRPr/>
           </a:p>
         </p:txBody>
       </p:sp>
@@ -13173,7 +13001,6 @@
           <a:lstStyle/>
           <a:p>
             <a:pPr algn="ctr"/>
-            <a:endParaRPr/>
           </a:p>
         </p:txBody>
       </p:sp>
@@ -13277,7 +13104,8 @@
                 </a:solidFill>
                 <a:latin typeface="Cascadia Mono"/>
               </a:rPr>
-              <a:t>    |   |   |-- stopper/
+              <a:t>    |   |   |   `-- starter.py
+    |   |   |-- stopper/
     |   |   |   |-- config.yaml
     |   |   |   `-- stopper.py
     |   |   |-- summarizer/
@@ -13306,8 +13134,7 @@
     |   |   |-- image_interpreter.py
     |   |   `-- screenshot.py
     |   |-- management/
-    |   |   |-- __init__.py
-    |   |   `-- commands/</a:t>
+    |   |   |-- __init__.py</a:t>
             </a:r>
           </a:p>
         </p:txBody>
@@ -13321,7 +13148,7 @@
 </file>
 
 <file path=ppt/slides/slide26.xml><?xml version="1.0" encoding="utf-8"?>
-<p:sld xmlns:a="http://schemas.openxmlformats.org/drawingml/2006/main" xmlns:r="http://schemas.openxmlformats.org/officeDocument/2006/relationships" xmlns:p="http://schemas.openxmlformats.org/presentationml/2006/main">
+<p:sld xmlns:a="http://schemas.openxmlformats.org/drawingml/2006/main" xmlns:p="http://schemas.openxmlformats.org/presentationml/2006/main" xmlns:r="http://schemas.openxmlformats.org/officeDocument/2006/relationships">
   <p:cSld>
     <p:spTree>
       <p:nvGrpSpPr>
@@ -13329,14 +13156,7 @@
         <p:cNvGrpSpPr/>
         <p:nvPr/>
       </p:nvGrpSpPr>
-      <p:grpSpPr>
-        <a:xfrm>
-          <a:off x="0" y="0"/>
-          <a:ext cx="0" cy="0"/>
-          <a:chOff x="0" y="0"/>
-          <a:chExt cx="0" cy="0"/>
-        </a:xfrm>
-      </p:grpSpPr>
+      <p:grpSpPr/>
       <p:sp>
         <p:nvSpPr>
           <p:cNvPr id="2" name="Rectangle 1"/>
@@ -13377,7 +13197,6 @@
           <a:lstStyle/>
           <a:p>
             <a:pPr algn="ctr"/>
-            <a:endParaRPr/>
           </a:p>
         </p:txBody>
       </p:sp>
@@ -13421,7 +13240,6 @@
           <a:lstStyle/>
           <a:p>
             <a:pPr algn="ctr"/>
-            <a:endParaRPr/>
           </a:p>
         </p:txBody>
       </p:sp>
@@ -13465,7 +13283,6 @@
           <a:lstStyle/>
           <a:p>
             <a:pPr algn="ctr"/>
-            <a:endParaRPr/>
           </a:p>
         </p:txBody>
       </p:sp>
@@ -13509,7 +13326,6 @@
           <a:lstStyle/>
           <a:p>
             <a:pPr algn="ctr"/>
-            <a:endParaRPr/>
           </a:p>
         </p:txBody>
       </p:sp>
@@ -13553,7 +13369,6 @@
           <a:lstStyle/>
           <a:p>
             <a:pPr algn="ctr"/>
-            <a:endParaRPr/>
           </a:p>
         </p:txBody>
       </p:sp>
@@ -13657,7 +13472,8 @@
                 </a:solidFill>
                 <a:latin typeface="Cascadia Mono"/>
               </a:rPr>
-              <a:t>    |   |       `-- startserver.py
+              <a:t>    |   |   `-- commands/
+    |   |       `-- startserver.py
     |   |-- migrations/
     |   |   |-- 0001_initial.py
     |   |   |-- 0002_populate_db.py
@@ -13686,8 +13502,7 @@
     |   |   |-- 0025_add_telegramer.py
     |   |   |-- 0026_repopulate_all_agents.py
     |   |   |-- 0027_add_sqler.py
-    |   |   |-- 0028_repopulate_all_agents.py
-    |   |   |-- 0029_add_prompter.py</a:t>
+    |   |   |-- 0028_repopulate_all_agents.py</a:t>
             </a:r>
           </a:p>
         </p:txBody>
@@ -13701,7 +13516,7 @@
 </file>
 
 <file path=ppt/slides/slide27.xml><?xml version="1.0" encoding="utf-8"?>
-<p:sld xmlns:a="http://schemas.openxmlformats.org/drawingml/2006/main" xmlns:r="http://schemas.openxmlformats.org/officeDocument/2006/relationships" xmlns:p="http://schemas.openxmlformats.org/presentationml/2006/main">
+<p:sld xmlns:a="http://schemas.openxmlformats.org/drawingml/2006/main" xmlns:p="http://schemas.openxmlformats.org/presentationml/2006/main" xmlns:r="http://schemas.openxmlformats.org/officeDocument/2006/relationships">
   <p:cSld>
     <p:spTree>
       <p:nvGrpSpPr>
@@ -13709,14 +13524,7 @@
         <p:cNvGrpSpPr/>
         <p:nvPr/>
       </p:nvGrpSpPr>
-      <p:grpSpPr>
-        <a:xfrm>
-          <a:off x="0" y="0"/>
-          <a:ext cx="0" cy="0"/>
-          <a:chOff x="0" y="0"/>
-          <a:chExt cx="0" cy="0"/>
-        </a:xfrm>
-      </p:grpSpPr>
+      <p:grpSpPr/>
       <p:sp>
         <p:nvSpPr>
           <p:cNvPr id="2" name="Rectangle 1"/>
@@ -13757,7 +13565,6 @@
           <a:lstStyle/>
           <a:p>
             <a:pPr algn="ctr"/>
-            <a:endParaRPr/>
           </a:p>
         </p:txBody>
       </p:sp>
@@ -13801,7 +13608,6 @@
           <a:lstStyle/>
           <a:p>
             <a:pPr algn="ctr"/>
-            <a:endParaRPr/>
           </a:p>
         </p:txBody>
       </p:sp>
@@ -13845,7 +13651,6 @@
           <a:lstStyle/>
           <a:p>
             <a:pPr algn="ctr"/>
-            <a:endParaRPr/>
           </a:p>
         </p:txBody>
       </p:sp>
@@ -13889,7 +13694,6 @@
           <a:lstStyle/>
           <a:p>
             <a:pPr algn="ctr"/>
-            <a:endParaRPr/>
           </a:p>
         </p:txBody>
       </p:sp>
@@ -13933,7 +13737,6 @@
           <a:lstStyle/>
           <a:p>
             <a:pPr algn="ctr"/>
-            <a:endParaRPr/>
           </a:p>
         </p:txBody>
       </p:sp>
@@ -14037,7 +13840,8 @@
                 </a:solidFill>
                 <a:latin typeface="Cascadia Mono"/>
               </a:rPr>
-              <a:t>    |   |   |-- 0030_repopulate_all_agents.py
+              <a:t>    |   |   |-- 0029_add_prompter.py
+    |   |   |-- 0030_repopulate_all_agents.py
     |   |   |-- 0031_add_flowcreator.py
     |   |   |-- 0032_repopulate_all_agents.py
     |   |   |-- 0033_add_gitter.py
@@ -14066,8 +13870,7 @@
     |   |   |-- 0056_add_parametrizer.py
     |   |   |-- 0057_add_flowbacker.py
     |   |   |-- 0058_add_barrier.py
-    |   |   |-- 0059_add_j_decompiler.py
-    |   |   |-- 0060_add_agent_parametrizer_tool.py</a:t>
+    |   |   |-- 0059_add_j_decompiler.py</a:t>
             </a:r>
           </a:p>
         </p:txBody>
@@ -14081,7 +13884,7 @@
 </file>
 
 <file path=ppt/slides/slide28.xml><?xml version="1.0" encoding="utf-8"?>
-<p:sld xmlns:a="http://schemas.openxmlformats.org/drawingml/2006/main" xmlns:r="http://schemas.openxmlformats.org/officeDocument/2006/relationships" xmlns:p="http://schemas.openxmlformats.org/presentationml/2006/main">
+<p:sld xmlns:a="http://schemas.openxmlformats.org/drawingml/2006/main" xmlns:p="http://schemas.openxmlformats.org/presentationml/2006/main" xmlns:r="http://schemas.openxmlformats.org/officeDocument/2006/relationships">
   <p:cSld>
     <p:spTree>
       <p:nvGrpSpPr>
@@ -14089,14 +13892,7 @@
         <p:cNvGrpSpPr/>
         <p:nvPr/>
       </p:nvGrpSpPr>
-      <p:grpSpPr>
-        <a:xfrm>
-          <a:off x="0" y="0"/>
-          <a:ext cx="0" cy="0"/>
-          <a:chOff x="0" y="0"/>
-          <a:chExt cx="0" cy="0"/>
-        </a:xfrm>
-      </p:grpSpPr>
+      <p:grpSpPr/>
       <p:sp>
         <p:nvSpPr>
           <p:cNvPr id="2" name="Rectangle 1"/>
@@ -14137,7 +13933,6 @@
           <a:lstStyle/>
           <a:p>
             <a:pPr algn="ctr"/>
-            <a:endParaRPr/>
           </a:p>
         </p:txBody>
       </p:sp>
@@ -14181,7 +13976,6 @@
           <a:lstStyle/>
           <a:p>
             <a:pPr algn="ctr"/>
-            <a:endParaRPr/>
           </a:p>
         </p:txBody>
       </p:sp>
@@ -14225,7 +14019,6 @@
           <a:lstStyle/>
           <a:p>
             <a:pPr algn="ctr"/>
-            <a:endParaRPr/>
           </a:p>
         </p:txBody>
       </p:sp>
@@ -14269,7 +14062,6 @@
           <a:lstStyle/>
           <a:p>
             <a:pPr algn="ctr"/>
-            <a:endParaRPr/>
           </a:p>
         </p:txBody>
       </p:sp>
@@ -14313,7 +14105,6 @@
           <a:lstStyle/>
           <a:p>
             <a:pPr algn="ctr"/>
-            <a:endParaRPr/>
           </a:p>
         </p:txBody>
       </p:sp>
@@ -14417,7 +14208,8 @@
                 </a:solidFill>
                 <a:latin typeface="Cascadia Mono"/>
               </a:rPr>
-              <a:t>    |   |   |-- 0061_add_agent_starter_tool.py
+              <a:t>    |   |   |-- 0060_add_agent_parametrizer_tool.py
+    |   |   |-- 0061_add_agent_starter_tool.py
     |   |   |-- 0062_sync_agent_control_tools_and_prompts.py
     |   |   |-- 0063_add_agent_parametrizer_prompt.py
     |   |   |-- 0064_add_chat_agent_run_model.py
@@ -14446,8 +14238,7 @@
     |   |   |-- utils.py
     |   |   `-- chains/
     |   |       |-- base.py
-    |   |       |-- basic.py
-    |   |       |-- history_aware.py</a:t>
+    |   |       |-- basic.py</a:t>
             </a:r>
           </a:p>
         </p:txBody>
@@ -14461,7 +14252,7 @@
 </file>
 
 <file path=ppt/slides/slide29.xml><?xml version="1.0" encoding="utf-8"?>
-<p:sld xmlns:a="http://schemas.openxmlformats.org/drawingml/2006/main" xmlns:r="http://schemas.openxmlformats.org/officeDocument/2006/relationships" xmlns:p="http://schemas.openxmlformats.org/presentationml/2006/main">
+<p:sld xmlns:a="http://schemas.openxmlformats.org/drawingml/2006/main" xmlns:p="http://schemas.openxmlformats.org/presentationml/2006/main" xmlns:r="http://schemas.openxmlformats.org/officeDocument/2006/relationships">
   <p:cSld>
     <p:spTree>
       <p:nvGrpSpPr>
@@ -14469,14 +14260,7 @@
         <p:cNvGrpSpPr/>
         <p:nvPr/>
       </p:nvGrpSpPr>
-      <p:grpSpPr>
-        <a:xfrm>
-          <a:off x="0" y="0"/>
-          <a:ext cx="0" cy="0"/>
-          <a:chOff x="0" y="0"/>
-          <a:chExt cx="0" cy="0"/>
-        </a:xfrm>
-      </p:grpSpPr>
+      <p:grpSpPr/>
       <p:sp>
         <p:nvSpPr>
           <p:cNvPr id="2" name="Rectangle 1"/>
@@ -14517,7 +14301,6 @@
           <a:lstStyle/>
           <a:p>
             <a:pPr algn="ctr"/>
-            <a:endParaRPr/>
           </a:p>
         </p:txBody>
       </p:sp>
@@ -14561,7 +14344,6 @@
           <a:lstStyle/>
           <a:p>
             <a:pPr algn="ctr"/>
-            <a:endParaRPr/>
           </a:p>
         </p:txBody>
       </p:sp>
@@ -14605,7 +14387,6 @@
           <a:lstStyle/>
           <a:p>
             <a:pPr algn="ctr"/>
-            <a:endParaRPr/>
           </a:p>
         </p:txBody>
       </p:sp>
@@ -14649,7 +14430,6 @@
           <a:lstStyle/>
           <a:p>
             <a:pPr algn="ctr"/>
-            <a:endParaRPr/>
           </a:p>
         </p:txBody>
       </p:sp>
@@ -14693,7 +14473,6 @@
           <a:lstStyle/>
           <a:p>
             <a:pPr algn="ctr"/>
-            <a:endParaRPr/>
           </a:p>
         </p:txBody>
       </p:sp>
@@ -14797,7 +14576,8 @@
                 </a:solidFill>
                 <a:latin typeface="Cascadia Mono"/>
               </a:rPr>
-              <a:t>    |   |       `-- unified.py
+              <a:t>    |   |       |-- history_aware.py
+    |   |       `-- unified.py
     |   |-- services/
     |   |   |-- __init__.py
     |   |   |-- answer_analizer.py
@@ -14826,8 +14606,7 @@
     |   |       |   |-- acp-session.js
     |   |       |   |-- acp-undo-manager.js
     |   |       |   |-- acp-validate.js
-    |   |       |   |-- agent_page_canvas.js
-    |   |       |   |-- agent_page_chat.js</a:t>
+    |   |       |   |-- agent_page_canvas.js</a:t>
             </a:r>
           </a:p>
         </p:txBody>
@@ -14841,7 +14620,7 @@
 </file>
 
 <file path=ppt/slides/slide3.xml><?xml version="1.0" encoding="utf-8"?>
-<p:sld xmlns:a="http://schemas.openxmlformats.org/drawingml/2006/main" xmlns:r="http://schemas.openxmlformats.org/officeDocument/2006/relationships" xmlns:p="http://schemas.openxmlformats.org/presentationml/2006/main">
+<p:sld xmlns:a="http://schemas.openxmlformats.org/drawingml/2006/main" xmlns:p="http://schemas.openxmlformats.org/presentationml/2006/main" xmlns:r="http://schemas.openxmlformats.org/officeDocument/2006/relationships">
   <p:cSld>
     <p:spTree>
       <p:nvGrpSpPr>
@@ -14849,14 +14628,7 @@
         <p:cNvGrpSpPr/>
         <p:nvPr/>
       </p:nvGrpSpPr>
-      <p:grpSpPr>
-        <a:xfrm>
-          <a:off x="0" y="0"/>
-          <a:ext cx="0" cy="0"/>
-          <a:chOff x="0" y="0"/>
-          <a:chExt cx="0" cy="0"/>
-        </a:xfrm>
-      </p:grpSpPr>
+      <p:grpSpPr/>
       <p:sp>
         <p:nvSpPr>
           <p:cNvPr id="2" name="Rectangle 1"/>
@@ -14897,7 +14669,6 @@
           <a:lstStyle/>
           <a:p>
             <a:pPr algn="ctr"/>
-            <a:endParaRPr/>
           </a:p>
         </p:txBody>
       </p:sp>
@@ -14941,7 +14712,6 @@
           <a:lstStyle/>
           <a:p>
             <a:pPr algn="ctr"/>
-            <a:endParaRPr/>
           </a:p>
         </p:txBody>
       </p:sp>
@@ -14985,7 +14755,6 @@
           <a:lstStyle/>
           <a:p>
             <a:pPr algn="ctr"/>
-            <a:endParaRPr/>
           </a:p>
         </p:txBody>
       </p:sp>
@@ -15029,7 +14798,6 @@
           <a:lstStyle/>
           <a:p>
             <a:pPr algn="ctr"/>
-            <a:endParaRPr/>
           </a:p>
         </p:txBody>
       </p:sp>
@@ -15073,7 +14841,6 @@
           <a:lstStyle/>
           <a:p>
             <a:pPr algn="ctr"/>
-            <a:endParaRPr/>
           </a:p>
         </p:txBody>
       </p:sp>
@@ -15189,7 +14956,6 @@
           <a:lstStyle/>
           <a:p>
             <a:pPr algn="ctr"/>
-            <a:endParaRPr/>
           </a:p>
         </p:txBody>
       </p:sp>
@@ -15233,7 +14999,6 @@
           <a:lstStyle/>
           <a:p>
             <a:pPr algn="ctr"/>
-            <a:endParaRPr/>
           </a:p>
         </p:txBody>
       </p:sp>
@@ -15289,7 +15054,7 @@
           <a:noFill/>
         </p:spPr>
         <p:txBody>
-          <a:bodyPr wrap="square" lIns="38100" tIns="25400" rIns="38100" bIns="25400" anchor="t">
+          <a:bodyPr wrap="square" anchor="t" lIns="38100" rIns="38100" tIns="25400" bIns="25400">
             <a:noAutofit/>
           </a:bodyPr>
           <a:lstStyle/>
@@ -15311,6 +15076,9 @@
               </a:rPr>
               <a:t>Answers codebase questions with loaded file or directory context.</a:t>
             </a:r>
+            <a:endParaRPr sz="1500" b="0" i="0">
+              <a:latin typeface="Calibri"/>
+            </a:endParaRPr>
           </a:p>
           <a:p>
             <a:pPr>
@@ -15330,6 +15098,9 @@
               </a:rPr>
               <a:t>Uses hybrid retrieval to extract metadata, split content, rank source chunks, and respect context budgets.</a:t>
             </a:r>
+            <a:endParaRPr sz="1500" b="0" i="0">
+              <a:latin typeface="Calibri"/>
+            </a:endParaRPr>
           </a:p>
           <a:p>
             <a:pPr>
@@ -15349,6 +15120,9 @@
               </a:rPr>
               <a:t>Runs checked Multi-Turn requests through request-scoped planning, capability selection, tool calls, observations, monitoring, and final synthesis.</a:t>
             </a:r>
+            <a:endParaRPr sz="1500" b="0" i="0">
+              <a:latin typeface="Calibri"/>
+            </a:endParaRPr>
           </a:p>
         </p:txBody>
       </p:sp>
@@ -15394,7 +15168,6 @@
           <a:lstStyle/>
           <a:p>
             <a:pPr algn="ctr"/>
-            <a:endParaRPr/>
           </a:p>
         </p:txBody>
       </p:sp>
@@ -15438,7 +15211,6 @@
           <a:lstStyle/>
           <a:p>
             <a:pPr algn="ctr"/>
-            <a:endParaRPr/>
           </a:p>
         </p:txBody>
       </p:sp>
@@ -15494,7 +15266,7 @@
           <a:noFill/>
         </p:spPr>
         <p:txBody>
-          <a:bodyPr wrap="square" lIns="38100" tIns="25400" rIns="38100" bIns="25400" anchor="t">
+          <a:bodyPr wrap="square" anchor="t" lIns="38100" rIns="38100" tIns="25400" bIns="25400">
             <a:noAutofit/>
           </a:bodyPr>
           <a:lstStyle/>
@@ -15516,6 +15288,9 @@
               </a:rPr>
               <a:t>Launches wrapped copies of selected workflow agents in isolated runtime folders without mutating templates.</a:t>
             </a:r>
+            <a:endParaRPr sz="1500" b="0" i="0">
+              <a:latin typeface="Calibri"/>
+            </a:endParaRPr>
           </a:p>
           <a:p>
             <a:pPr>
@@ -15535,6 +15310,9 @@
               </a:rPr>
               <a:t>Lets users design, validate, save, pause, resume, and stop visual workflows through the Agentic Control Panel.</a:t>
             </a:r>
+            <a:endParaRPr sz="1500" b="0" i="0">
+              <a:latin typeface="Calibri"/>
+            </a:endParaRPr>
           </a:p>
         </p:txBody>
       </p:sp>
@@ -15580,7 +15358,6 @@
           <a:lstStyle/>
           <a:p>
             <a:pPr algn="ctr"/>
-            <a:endParaRPr/>
           </a:p>
         </p:txBody>
       </p:sp>
@@ -15624,7 +15401,6 @@
           <a:lstStyle/>
           <a:p>
             <a:pPr algn="ctr"/>
-            <a:endParaRPr/>
           </a:p>
         </p:txBody>
       </p:sp>
@@ -15680,7 +15456,7 @@
           <a:noFill/>
         </p:spPr>
         <p:txBody>
-          <a:bodyPr wrap="square" lIns="38100" tIns="25400" rIns="38100" bIns="25400" anchor="t">
+          <a:bodyPr wrap="square" anchor="t" lIns="38100" rIns="38100" tIns="25400" bIns="25400">
             <a:noAutofit/>
           </a:bodyPr>
           <a:lstStyle/>
@@ -15702,6 +15478,9 @@
               </a:rPr>
               <a:t>Turns successful Multi-Turn tool executions into starter `.flw` workflows that can be inspected and validated in ACP.</a:t>
             </a:r>
+            <a:endParaRPr sz="1500" b="0" i="0">
+              <a:latin typeface="Calibri"/>
+            </a:endParaRPr>
           </a:p>
           <a:p>
             <a:pPr>
@@ -15721,6 +15500,9 @@
               </a:rPr>
               <a:t>Packages the project into a distributable Windows release with installer and uninstaller tooling.</a:t>
             </a:r>
+            <a:endParaRPr sz="1500" b="0" i="0">
+              <a:latin typeface="Calibri"/>
+            </a:endParaRPr>
           </a:p>
         </p:txBody>
       </p:sp>
@@ -15733,7 +15515,7 @@
 </file>
 
 <file path=ppt/slides/slide30.xml><?xml version="1.0" encoding="utf-8"?>
-<p:sld xmlns:a="http://schemas.openxmlformats.org/drawingml/2006/main" xmlns:r="http://schemas.openxmlformats.org/officeDocument/2006/relationships" xmlns:p="http://schemas.openxmlformats.org/presentationml/2006/main">
+<p:sld xmlns:a="http://schemas.openxmlformats.org/drawingml/2006/main" xmlns:p="http://schemas.openxmlformats.org/presentationml/2006/main" xmlns:r="http://schemas.openxmlformats.org/officeDocument/2006/relationships">
   <p:cSld>
     <p:spTree>
       <p:nvGrpSpPr>
@@ -15741,14 +15523,7 @@
         <p:cNvGrpSpPr/>
         <p:nvPr/>
       </p:nvGrpSpPr>
-      <p:grpSpPr>
-        <a:xfrm>
-          <a:off x="0" y="0"/>
-          <a:ext cx="0" cy="0"/>
-          <a:chOff x="0" y="0"/>
-          <a:chExt cx="0" cy="0"/>
-        </a:xfrm>
-      </p:grpSpPr>
+      <p:grpSpPr/>
       <p:sp>
         <p:nvSpPr>
           <p:cNvPr id="2" name="Rectangle 1"/>
@@ -15789,7 +15564,6 @@
           <a:lstStyle/>
           <a:p>
             <a:pPr algn="ctr"/>
-            <a:endParaRPr/>
           </a:p>
         </p:txBody>
       </p:sp>
@@ -15833,7 +15607,6 @@
           <a:lstStyle/>
           <a:p>
             <a:pPr algn="ctr"/>
-            <a:endParaRPr/>
           </a:p>
         </p:txBody>
       </p:sp>
@@ -15877,7 +15650,6 @@
           <a:lstStyle/>
           <a:p>
             <a:pPr algn="ctr"/>
-            <a:endParaRPr/>
           </a:p>
         </p:txBody>
       </p:sp>
@@ -15921,7 +15693,6 @@
           <a:lstStyle/>
           <a:p>
             <a:pPr algn="ctr"/>
-            <a:endParaRPr/>
           </a:p>
         </p:txBody>
       </p:sp>
@@ -15965,7 +15736,6 @@
           <a:lstStyle/>
           <a:p>
             <a:pPr algn="ctr"/>
-            <a:endParaRPr/>
           </a:p>
         </p:txBody>
       </p:sp>
@@ -16069,7 +15839,8 @@
                 </a:solidFill>
                 <a:latin typeface="Cascadia Mono"/>
               </a:rPr>
-              <a:t>    |   |       |   |-- agent_page_context.js
+              <a:t>    |   |       |   |-- agent_page_chat.js
+    |   |       |   |-- agent_page_context.js
     |   |       |   |-- agent_page_dialogs.js
     |   |       |   |-- agent_page_init.js
     |   |       |   |-- agent_page_layout.js
@@ -16098,8 +15869,7 @@
     |   |-- jd-cli.bat
     |   `-- jd-cli.jar
     `-- tlamatini/
-        |-- __init__.py
-        |-- asgi.py</a:t>
+        |-- __init__.py</a:t>
             </a:r>
           </a:p>
         </p:txBody>
@@ -16113,7 +15883,7 @@
 </file>
 
 <file path=ppt/slides/slide31.xml><?xml version="1.0" encoding="utf-8"?>
-<p:sld xmlns:a="http://schemas.openxmlformats.org/drawingml/2006/main" xmlns:r="http://schemas.openxmlformats.org/officeDocument/2006/relationships" xmlns:p="http://schemas.openxmlformats.org/presentationml/2006/main">
+<p:sld xmlns:a="http://schemas.openxmlformats.org/drawingml/2006/main" xmlns:p="http://schemas.openxmlformats.org/presentationml/2006/main" xmlns:r="http://schemas.openxmlformats.org/officeDocument/2006/relationships">
   <p:cSld>
     <p:spTree>
       <p:nvGrpSpPr>
@@ -16121,14 +15891,7 @@
         <p:cNvGrpSpPr/>
         <p:nvPr/>
       </p:nvGrpSpPr>
-      <p:grpSpPr>
-        <a:xfrm>
-          <a:off x="0" y="0"/>
-          <a:ext cx="0" cy="0"/>
-          <a:chOff x="0" y="0"/>
-          <a:chExt cx="0" cy="0"/>
-        </a:xfrm>
-      </p:grpSpPr>
+      <p:grpSpPr/>
       <p:sp>
         <p:nvSpPr>
           <p:cNvPr id="2" name="Rectangle 1"/>
@@ -16169,7 +15932,6 @@
           <a:lstStyle/>
           <a:p>
             <a:pPr algn="ctr"/>
-            <a:endParaRPr/>
           </a:p>
         </p:txBody>
       </p:sp>
@@ -16213,7 +15975,6 @@
           <a:lstStyle/>
           <a:p>
             <a:pPr algn="ctr"/>
-            <a:endParaRPr/>
           </a:p>
         </p:txBody>
       </p:sp>
@@ -16257,7 +16018,6 @@
           <a:lstStyle/>
           <a:p>
             <a:pPr algn="ctr"/>
-            <a:endParaRPr/>
           </a:p>
         </p:txBody>
       </p:sp>
@@ -16301,7 +16061,6 @@
           <a:lstStyle/>
           <a:p>
             <a:pPr algn="ctr"/>
-            <a:endParaRPr/>
           </a:p>
         </p:txBody>
       </p:sp>
@@ -16345,7 +16104,6 @@
           <a:lstStyle/>
           <a:p>
             <a:pPr algn="ctr"/>
-            <a:endParaRPr/>
           </a:p>
         </p:txBody>
       </p:sp>
@@ -16449,7 +16207,8 @@
                 </a:solidFill>
                 <a:latin typeface="Cascadia Mono"/>
               </a:rPr>
-              <a:t>        |-- context_processors.py
+              <a:t>        |-- asgi.py
+        |-- context_processors.py
         |-- middleware.py
         |-- settings.py
         |-- urls.py
@@ -16467,7 +16226,7 @@
 </file>
 
 <file path=ppt/slides/slide32.xml><?xml version="1.0" encoding="utf-8"?>
-<p:sld xmlns:a="http://schemas.openxmlformats.org/drawingml/2006/main" xmlns:r="http://schemas.openxmlformats.org/officeDocument/2006/relationships" xmlns:p="http://schemas.openxmlformats.org/presentationml/2006/main">
+<p:sld xmlns:a="http://schemas.openxmlformats.org/drawingml/2006/main" xmlns:p="http://schemas.openxmlformats.org/presentationml/2006/main" xmlns:r="http://schemas.openxmlformats.org/officeDocument/2006/relationships">
   <p:cSld>
     <p:spTree>
       <p:nvGrpSpPr>
@@ -16475,14 +16234,7 @@
         <p:cNvGrpSpPr/>
         <p:nvPr/>
       </p:nvGrpSpPr>
-      <p:grpSpPr>
-        <a:xfrm>
-          <a:off x="0" y="0"/>
-          <a:ext cx="0" cy="0"/>
-          <a:chOff x="0" y="0"/>
-          <a:chExt cx="0" cy="0"/>
-        </a:xfrm>
-      </p:grpSpPr>
+      <p:grpSpPr/>
       <p:sp>
         <p:nvSpPr>
           <p:cNvPr id="2" name="Rectangle 1"/>
@@ -16523,7 +16275,6 @@
           <a:lstStyle/>
           <a:p>
             <a:pPr algn="ctr"/>
-            <a:endParaRPr/>
           </a:p>
         </p:txBody>
       </p:sp>
@@ -16567,7 +16318,6 @@
           <a:lstStyle/>
           <a:p>
             <a:pPr algn="ctr"/>
-            <a:endParaRPr/>
           </a:p>
         </p:txBody>
       </p:sp>
@@ -16611,7 +16361,6 @@
           <a:lstStyle/>
           <a:p>
             <a:pPr algn="ctr"/>
-            <a:endParaRPr/>
           </a:p>
         </p:txBody>
       </p:sp>
@@ -16655,7 +16404,6 @@
           <a:lstStyle/>
           <a:p>
             <a:pPr algn="ctr"/>
-            <a:endParaRPr/>
           </a:p>
         </p:txBody>
       </p:sp>
@@ -16699,7 +16447,6 @@
           <a:lstStyle/>
           <a:p>
             <a:pPr algn="ctr"/>
-            <a:endParaRPr/>
           </a:p>
         </p:txBody>
       </p:sp>
@@ -16815,7 +16562,6 @@
           <a:lstStyle/>
           <a:p>
             <a:pPr algn="ctr"/>
-            <a:endParaRPr/>
           </a:p>
         </p:txBody>
       </p:sp>
@@ -16859,7 +16605,6 @@
           <a:lstStyle/>
           <a:p>
             <a:pPr algn="ctr"/>
-            <a:endParaRPr/>
           </a:p>
         </p:txBody>
       </p:sp>
@@ -16915,7 +16660,7 @@
           <a:noFill/>
         </p:spPr>
         <p:txBody>
-          <a:bodyPr wrap="square" lIns="38100" tIns="25400" rIns="38100" bIns="25400" anchor="t">
+          <a:bodyPr wrap="square" anchor="t" lIns="38100" rIns="38100" tIns="25400" bIns="25400">
             <a:noAutofit/>
           </a:bodyPr>
           <a:lstStyle/>
@@ -16937,6 +16682,9 @@
               </a:rPr>
               <a:t>Regenerate the PDF and deck whenever README, architecture, agent catalog, line inventory, or packaging behavior changes.</a:t>
             </a:r>
+            <a:endParaRPr sz="1700" b="0" i="0">
+              <a:latin typeface="Calibri"/>
+            </a:endParaRPr>
           </a:p>
           <a:p>
             <a:pPr>
@@ -16956,6 +16704,9 @@
               </a:rPr>
               <a:t>Keep the PDF exhaustive and evidence-heavy; keep the PPT visual, split dense appendices, and audit geometry before delivery.</a:t>
             </a:r>
+            <a:endParaRPr sz="1700" b="0" i="0">
+              <a:latin typeface="Calibri"/>
+            </a:endParaRPr>
           </a:p>
           <a:p>
             <a:pPr>
@@ -16975,6 +16726,9 @@
               </a:rPr>
               <a:t>Use the new Skills in `.codex/skills/` so future refreshes follow the same no-overlap and full-dossier rules.</a:t>
             </a:r>
+            <a:endParaRPr sz="1700" b="0" i="0">
+              <a:latin typeface="Calibri"/>
+            </a:endParaRPr>
           </a:p>
         </p:txBody>
       </p:sp>
@@ -16987,7 +16741,7 @@
 </file>
 
 <file path=ppt/slides/slide4.xml><?xml version="1.0" encoding="utf-8"?>
-<p:sld xmlns:a="http://schemas.openxmlformats.org/drawingml/2006/main" xmlns:r="http://schemas.openxmlformats.org/officeDocument/2006/relationships" xmlns:p="http://schemas.openxmlformats.org/presentationml/2006/main">
+<p:sld xmlns:a="http://schemas.openxmlformats.org/drawingml/2006/main" xmlns:p="http://schemas.openxmlformats.org/presentationml/2006/main" xmlns:r="http://schemas.openxmlformats.org/officeDocument/2006/relationships">
   <p:cSld>
     <p:spTree>
       <p:nvGrpSpPr>
@@ -16995,14 +16749,7 @@
         <p:cNvGrpSpPr/>
         <p:nvPr/>
       </p:nvGrpSpPr>
-      <p:grpSpPr>
-        <a:xfrm>
-          <a:off x="0" y="0"/>
-          <a:ext cx="0" cy="0"/>
-          <a:chOff x="0" y="0"/>
-          <a:chExt cx="0" cy="0"/>
-        </a:xfrm>
-      </p:grpSpPr>
+      <p:grpSpPr/>
       <p:sp>
         <p:nvSpPr>
           <p:cNvPr id="2" name="Rectangle 1"/>
@@ -17043,7 +16790,6 @@
           <a:lstStyle/>
           <a:p>
             <a:pPr algn="ctr"/>
-            <a:endParaRPr/>
           </a:p>
         </p:txBody>
       </p:sp>
@@ -17087,7 +16833,6 @@
           <a:lstStyle/>
           <a:p>
             <a:pPr algn="ctr"/>
-            <a:endParaRPr/>
           </a:p>
         </p:txBody>
       </p:sp>
@@ -17131,7 +16876,6 @@
           <a:lstStyle/>
           <a:p>
             <a:pPr algn="ctr"/>
-            <a:endParaRPr/>
           </a:p>
         </p:txBody>
       </p:sp>
@@ -17175,7 +16919,6 @@
           <a:lstStyle/>
           <a:p>
             <a:pPr algn="ctr"/>
-            <a:endParaRPr/>
           </a:p>
         </p:txBody>
       </p:sp>
@@ -17219,7 +16962,6 @@
           <a:lstStyle/>
           <a:p>
             <a:pPr algn="ctr"/>
-            <a:endParaRPr/>
           </a:p>
         </p:txBody>
       </p:sp>
@@ -17335,7 +17077,6 @@
           <a:lstStyle/>
           <a:p>
             <a:pPr algn="ctr"/>
-            <a:endParaRPr/>
           </a:p>
         </p:txBody>
       </p:sp>
@@ -17451,7 +17192,6 @@
           <a:lstStyle/>
           <a:p>
             <a:pPr algn="ctr"/>
-            <a:endParaRPr/>
           </a:p>
         </p:txBody>
       </p:sp>
@@ -17567,7 +17307,6 @@
           <a:lstStyle/>
           <a:p>
             <a:pPr algn="ctr"/>
-            <a:endParaRPr/>
           </a:p>
         </p:txBody>
       </p:sp>
@@ -17683,7 +17422,6 @@
           <a:lstStyle/>
           <a:p>
             <a:pPr algn="ctr"/>
-            <a:endParaRPr/>
           </a:p>
         </p:txBody>
       </p:sp>
@@ -17799,7 +17537,6 @@
           <a:lstStyle/>
           <a:p>
             <a:pPr algn="ctr"/>
-            <a:endParaRPr/>
           </a:p>
         </p:txBody>
       </p:sp>
@@ -17915,7 +17652,6 @@
           <a:lstStyle/>
           <a:p>
             <a:pPr algn="ctr"/>
-            <a:endParaRPr/>
           </a:p>
         </p:txBody>
       </p:sp>
@@ -17962,8 +17698,8 @@
         </p:nvSpPr>
         <p:spPr>
           <a:xfrm>
-            <a:off x="713232" y="2991026"/>
-            <a:ext cx="5349240" cy="3053157"/>
+            <a:off x="713232" y="2971800"/>
+            <a:ext cx="5349240" cy="2788920"/>
           </a:xfrm>
           <a:prstGeom prst="roundRect">
             <a:avLst/>
@@ -17996,7 +17732,6 @@
           <a:lstStyle/>
           <a:p>
             <a:pPr algn="ctr"/>
-            <a:endParaRPr/>
           </a:p>
         </p:txBody>
       </p:sp>
@@ -18040,7 +17775,6 @@
           <a:lstStyle/>
           <a:p>
             <a:pPr algn="ctr"/>
-            <a:endParaRPr/>
           </a:p>
         </p:txBody>
       </p:sp>
@@ -18087,7 +17821,7 @@
         </p:nvSpPr>
         <p:spPr>
           <a:xfrm>
-            <a:off x="914400" y="3685032"/>
+            <a:off x="914400" y="3630168"/>
             <a:ext cx="4946903" cy="1984248"/>
           </a:xfrm>
           <a:prstGeom prst="rect">
@@ -18096,7 +17830,7 @@
           <a:noFill/>
         </p:spPr>
         <p:txBody>
-          <a:bodyPr wrap="square" lIns="38100" tIns="25400" rIns="38100" bIns="25400" anchor="t">
+          <a:bodyPr wrap="square" anchor="t" lIns="38100" rIns="38100" tIns="25400" bIns="25400">
             <a:noAutofit/>
           </a:bodyPr>
           <a:lstStyle/>
@@ -18118,6 +17852,9 @@
               </a:rPr>
               <a:t>Browser UI sends chat and workflow requests through Django views and Channels WebSockets.</a:t>
             </a:r>
+            <a:endParaRPr sz="1500" b="0" i="0">
+              <a:latin typeface="Calibri"/>
+            </a:endParaRPr>
           </a:p>
           <a:p>
             <a:pPr>
@@ -18137,6 +17874,9 @@
               </a:rPr>
               <a:t>RAG chains load selected file/directory context, retrieve relevant chunks, and build answer prompts.</a:t>
             </a:r>
+            <a:endParaRPr sz="1500" b="0" i="0">
+              <a:latin typeface="Calibri"/>
+            </a:endParaRPr>
           </a:p>
           <a:p>
             <a:pPr>
@@ -18156,6 +17896,9 @@
               </a:rPr>
               <a:t>When Multi-Turn is enabled, the global planner selects context and tool stages before the executor binds only the relevant tools.</a:t>
             </a:r>
+            <a:endParaRPr sz="1500" b="0" i="0">
+              <a:latin typeface="Calibri"/>
+            </a:endParaRPr>
           </a:p>
         </p:txBody>
       </p:sp>
@@ -18168,7 +17911,7 @@
         <p:spPr>
           <a:xfrm>
             <a:off x="6327648" y="2971800"/>
-            <a:ext cx="5074920" cy="3072384"/>
+            <a:ext cx="5074920" cy="2788920"/>
           </a:xfrm>
           <a:prstGeom prst="roundRect">
             <a:avLst/>
@@ -18201,7 +17944,6 @@
           <a:lstStyle/>
           <a:p>
             <a:pPr algn="ctr"/>
-            <a:endParaRPr/>
           </a:p>
         </p:txBody>
       </p:sp>
@@ -18245,7 +17987,6 @@
           <a:lstStyle/>
           <a:p>
             <a:pPr algn="ctr"/>
-            <a:endParaRPr/>
           </a:p>
         </p:txBody>
       </p:sp>
@@ -18301,7 +18042,7 @@
           <a:noFill/>
         </p:spPr>
         <p:txBody>
-          <a:bodyPr wrap="square" lIns="38100" tIns="25400" rIns="38100" bIns="25400" anchor="t">
+          <a:bodyPr wrap="square" anchor="t" lIns="38100" rIns="38100" tIns="25400" bIns="25400">
             <a:noAutofit/>
           </a:bodyPr>
           <a:lstStyle/>
@@ -18318,23 +18059,14 @@
               </a:defRPr>
             </a:pPr>
             <a:r>
-              <a:rPr sz="1500" b="0" i="0" dirty="0">
+              <a:rPr sz="1500" b="0" i="0">
                 <a:latin typeface="Calibri"/>
               </a:rPr>
-              <a:t>Tool calls execute in the backend, append observations, and may create wrapped runtime copies under `agent/agents/pools/_</a:t>
-            </a:r>
-            <a:r>
-              <a:rPr sz="1500" b="0" i="0" dirty="0" err="1">
-                <a:latin typeface="Calibri"/>
-              </a:rPr>
-              <a:t>chat_runs</a:t>
-            </a:r>
-            <a:r>
-              <a:rPr sz="1500" b="0" i="0" dirty="0">
-                <a:latin typeface="Calibri"/>
-              </a:rPr>
-              <a:t>_/`.</a:t>
-            </a:r>
+              <a:t>Tool calls execute in the backend, append observations, and may create wrapped runtime copies under `agent/agents/pools/_chat_runs_/`.</a:t>
+            </a:r>
+            <a:endParaRPr sz="1500" b="0" i="0">
+              <a:latin typeface="Calibri"/>
+            </a:endParaRPr>
           </a:p>
           <a:p>
             <a:pPr>
@@ -18349,23 +18081,14 @@
               </a:defRPr>
             </a:pPr>
             <a:r>
-              <a:rPr sz="1500" b="0" i="0" dirty="0">
+              <a:rPr sz="1500" b="0" i="0">
                 <a:latin typeface="Calibri"/>
               </a:rPr>
-              <a:t>ACP flows deploy session-scoped pool instances, wire config values, validate </a:t>
-            </a:r>
-            <a:r>
-              <a:rPr sz="1500" b="0" i="0" dirty="0" err="1">
-                <a:latin typeface="Calibri"/>
-              </a:rPr>
-              <a:t>NxN</a:t>
-            </a:r>
-            <a:r>
-              <a:rPr sz="1500" b="0" i="0" dirty="0">
-                <a:latin typeface="Calibri"/>
-              </a:rPr>
-              <a:t> graph rules, and execute through Starter-driven flow semantics.</a:t>
-            </a:r>
+              <a:t>ACP flows deploy session-scoped pool instances, wire config values, validate NxN graph rules, and execute through Starter-driven flow semantics.</a:t>
+            </a:r>
+            <a:endParaRPr sz="1500" b="0" i="0">
+              <a:latin typeface="Calibri"/>
+            </a:endParaRPr>
           </a:p>
           <a:p>
             <a:pPr>
@@ -18380,35 +18103,14 @@
               </a:defRPr>
             </a:pPr>
             <a:r>
-              <a:rPr sz="1500" b="0" i="0" dirty="0">
+              <a:rPr sz="1500" b="0" i="0">
                 <a:latin typeface="Calibri"/>
               </a:rPr>
-              <a:t>Build scripts collect static assets, bundle Django/Python resources, add agent templates, and assemble `pkg.zip`, `Uninstaller.exe`, and `</a:t>
-            </a:r>
-            <a:r>
-              <a:rPr sz="1500" b="0" i="0" dirty="0" err="1">
-                <a:latin typeface="Calibri"/>
-              </a:rPr>
-              <a:t>dist</a:t>
-            </a:r>
-            <a:r>
-              <a:rPr sz="1500" b="0" i="0" dirty="0">
-                <a:latin typeface="Calibri"/>
-              </a:rPr>
-              <a:t>/</a:t>
-            </a:r>
-            <a:r>
-              <a:rPr sz="1500" b="0" i="0" dirty="0" err="1">
-                <a:latin typeface="Calibri"/>
-              </a:rPr>
-              <a:t>Tlamatini_Release</a:t>
-            </a:r>
-            <a:r>
-              <a:rPr sz="1500" b="0" i="0" dirty="0">
-                <a:latin typeface="Calibri"/>
-              </a:rPr>
-              <a:t>/`.</a:t>
-            </a:r>
+              <a:t>Build scripts collect static assets, bundle Django/Python resources, add agent templates, and assemble `pkg.zip`, `Uninstaller.exe`, and `dist/Tlamatini_Release/`.</a:t>
+            </a:r>
+            <a:endParaRPr sz="1500" b="0" i="0">
+              <a:latin typeface="Calibri"/>
+            </a:endParaRPr>
           </a:p>
         </p:txBody>
       </p:sp>
@@ -18421,7 +18123,7 @@
 </file>
 
 <file path=ppt/slides/slide5.xml><?xml version="1.0" encoding="utf-8"?>
-<p:sld xmlns:a="http://schemas.openxmlformats.org/drawingml/2006/main" xmlns:r="http://schemas.openxmlformats.org/officeDocument/2006/relationships" xmlns:p="http://schemas.openxmlformats.org/presentationml/2006/main">
+<p:sld xmlns:a="http://schemas.openxmlformats.org/drawingml/2006/main" xmlns:p="http://schemas.openxmlformats.org/presentationml/2006/main" xmlns:r="http://schemas.openxmlformats.org/officeDocument/2006/relationships">
   <p:cSld>
     <p:spTree>
       <p:nvGrpSpPr>
@@ -18429,14 +18131,7 @@
         <p:cNvGrpSpPr/>
         <p:nvPr/>
       </p:nvGrpSpPr>
-      <p:grpSpPr>
-        <a:xfrm>
-          <a:off x="0" y="0"/>
-          <a:ext cx="0" cy="0"/>
-          <a:chOff x="0" y="0"/>
-          <a:chExt cx="0" cy="0"/>
-        </a:xfrm>
-      </p:grpSpPr>
+      <p:grpSpPr/>
       <p:sp>
         <p:nvSpPr>
           <p:cNvPr id="2" name="Rectangle 1"/>
@@ -18477,7 +18172,6 @@
           <a:lstStyle/>
           <a:p>
             <a:pPr algn="ctr"/>
-            <a:endParaRPr/>
           </a:p>
         </p:txBody>
       </p:sp>
@@ -18521,7 +18215,6 @@
           <a:lstStyle/>
           <a:p>
             <a:pPr algn="ctr"/>
-            <a:endParaRPr/>
           </a:p>
         </p:txBody>
       </p:sp>
@@ -18565,7 +18258,6 @@
           <a:lstStyle/>
           <a:p>
             <a:pPr algn="ctr"/>
-            <a:endParaRPr/>
           </a:p>
         </p:txBody>
       </p:sp>
@@ -18609,7 +18301,6 @@
           <a:lstStyle/>
           <a:p>
             <a:pPr algn="ctr"/>
-            <a:endParaRPr/>
           </a:p>
         </p:txBody>
       </p:sp>
@@ -18653,7 +18344,6 @@
           <a:lstStyle/>
           <a:p>
             <a:pPr algn="ctr"/>
-            <a:endParaRPr/>
           </a:p>
         </p:txBody>
       </p:sp>
@@ -18769,7 +18459,6 @@
           <a:lstStyle/>
           <a:p>
             <a:pPr algn="ctr"/>
-            <a:endParaRPr/>
           </a:p>
         </p:txBody>
       </p:sp>
@@ -18813,7 +18502,6 @@
           <a:lstStyle/>
           <a:p>
             <a:pPr algn="ctr"/>
-            <a:endParaRPr/>
           </a:p>
         </p:txBody>
       </p:sp>
@@ -18869,7 +18557,7 @@
           <a:noFill/>
         </p:spPr>
         <p:txBody>
-          <a:bodyPr wrap="square" lIns="38100" tIns="25400" rIns="38100" bIns="25400" anchor="t">
+          <a:bodyPr wrap="square" anchor="t" lIns="38100" rIns="38100" tIns="25400" bIns="25400">
             <a:noAutofit/>
           </a:bodyPr>
           <a:lstStyle/>
@@ -18891,6 +18579,9 @@
               </a:rPr>
               <a:t>Load selected file or directory context from the chat interface.</a:t>
             </a:r>
+            <a:endParaRPr sz="1500" b="0" i="0">
+              <a:latin typeface="Calibri"/>
+            </a:endParaRPr>
           </a:p>
           <a:p>
             <a:pPr>
@@ -18910,6 +18601,9 @@
               </a:rPr>
               <a:t>Extract metadata, split text, rank chunks with hybrid retrieval, and respect context budgets.</a:t>
             </a:r>
+            <a:endParaRPr sz="1500" b="0" i="0">
+              <a:latin typeface="Calibri"/>
+            </a:endParaRPr>
           </a:p>
           <a:p>
             <a:pPr>
@@ -18929,6 +18623,9 @@
               </a:rPr>
               <a:t>Fallback to explicit loaded files when retrieval cannot provide enough memory.</a:t>
             </a:r>
+            <a:endParaRPr sz="1500" b="0" i="0">
+              <a:latin typeface="Calibri"/>
+            </a:endParaRPr>
           </a:p>
           <a:p>
             <a:pPr>
@@ -18948,6 +18645,9 @@
               </a:rPr>
               <a:t>Preserve the difference between direct one-shot chat and checked Multi-Turn orchestration.</a:t>
             </a:r>
+            <a:endParaRPr sz="1500" b="0" i="0">
+              <a:latin typeface="Calibri"/>
+            </a:endParaRPr>
           </a:p>
         </p:txBody>
       </p:sp>
@@ -18993,7 +18693,6 @@
           <a:lstStyle/>
           <a:p>
             <a:pPr algn="ctr"/>
-            <a:endParaRPr/>
           </a:p>
         </p:txBody>
       </p:sp>
@@ -19037,7 +18736,6 @@
           <a:lstStyle/>
           <a:p>
             <a:pPr algn="ctr"/>
-            <a:endParaRPr/>
           </a:p>
         </p:txBody>
       </p:sp>
@@ -19093,7 +18791,7 @@
           <a:noFill/>
         </p:spPr>
         <p:txBody>
-          <a:bodyPr wrap="square" lIns="38100" tIns="25400" rIns="38100" bIns="25400" anchor="t">
+          <a:bodyPr wrap="square" anchor="t" lIns="38100" rIns="38100" tIns="25400" bIns="25400">
             <a:noAutofit/>
           </a:bodyPr>
           <a:lstStyle/>
@@ -19115,6 +18813,9 @@
               </a:rPr>
               <a:t>The assistant answers from project evidence instead of generic memory.</a:t>
             </a:r>
+            <a:endParaRPr sz="1600" b="0" i="0">
+              <a:latin typeface="Calibri"/>
+            </a:endParaRPr>
           </a:p>
           <a:p>
             <a:pPr>
@@ -19134,6 +18835,9 @@
               </a:rPr>
               <a:t>Large codebases remain navigable without injecting the whole repository into every prompt.</a:t>
             </a:r>
+            <a:endParaRPr sz="1600" b="0" i="0">
+              <a:latin typeface="Calibri"/>
+            </a:endParaRPr>
           </a:p>
           <a:p>
             <a:pPr>
@@ -19153,6 +18857,9 @@
               </a:rPr>
               <a:t>Multi-Turn can prefetch only the contexts required by the current execution plan.</a:t>
             </a:r>
+            <a:endParaRPr sz="1600" b="0" i="0">
+              <a:latin typeface="Calibri"/>
+            </a:endParaRPr>
           </a:p>
         </p:txBody>
       </p:sp>
@@ -19165,7 +18872,7 @@
 </file>
 
 <file path=ppt/slides/slide6.xml><?xml version="1.0" encoding="utf-8"?>
-<p:sld xmlns:a="http://schemas.openxmlformats.org/drawingml/2006/main" xmlns:r="http://schemas.openxmlformats.org/officeDocument/2006/relationships" xmlns:p="http://schemas.openxmlformats.org/presentationml/2006/main">
+<p:sld xmlns:a="http://schemas.openxmlformats.org/drawingml/2006/main" xmlns:p="http://schemas.openxmlformats.org/presentationml/2006/main" xmlns:r="http://schemas.openxmlformats.org/officeDocument/2006/relationships">
   <p:cSld>
     <p:spTree>
       <p:nvGrpSpPr>
@@ -19173,14 +18880,7 @@
         <p:cNvGrpSpPr/>
         <p:nvPr/>
       </p:nvGrpSpPr>
-      <p:grpSpPr>
-        <a:xfrm>
-          <a:off x="0" y="0"/>
-          <a:ext cx="0" cy="0"/>
-          <a:chOff x="0" y="0"/>
-          <a:chExt cx="0" cy="0"/>
-        </a:xfrm>
-      </p:grpSpPr>
+      <p:grpSpPr/>
       <p:sp>
         <p:nvSpPr>
           <p:cNvPr id="2" name="Rectangle 1"/>
@@ -19221,7 +18921,6 @@
           <a:lstStyle/>
           <a:p>
             <a:pPr algn="ctr"/>
-            <a:endParaRPr/>
           </a:p>
         </p:txBody>
       </p:sp>
@@ -19265,7 +18964,6 @@
           <a:lstStyle/>
           <a:p>
             <a:pPr algn="ctr"/>
-            <a:endParaRPr/>
           </a:p>
         </p:txBody>
       </p:sp>
@@ -19309,7 +19007,6 @@
           <a:lstStyle/>
           <a:p>
             <a:pPr algn="ctr"/>
-            <a:endParaRPr/>
           </a:p>
         </p:txBody>
       </p:sp>
@@ -19353,7 +19050,6 @@
           <a:lstStyle/>
           <a:p>
             <a:pPr algn="ctr"/>
-            <a:endParaRPr/>
           </a:p>
         </p:txBody>
       </p:sp>
@@ -19397,7 +19093,6 @@
           <a:lstStyle/>
           <a:p>
             <a:pPr algn="ctr"/>
-            <a:endParaRPr/>
           </a:p>
         </p:txBody>
       </p:sp>
@@ -19513,7 +19208,6 @@
           <a:lstStyle/>
           <a:p>
             <a:pPr algn="ctr"/>
-            <a:endParaRPr/>
           </a:p>
         </p:txBody>
       </p:sp>
@@ -19557,7 +19251,6 @@
           <a:lstStyle/>
           <a:p>
             <a:pPr algn="ctr"/>
-            <a:endParaRPr/>
           </a:p>
         </p:txBody>
       </p:sp>
@@ -19613,7 +19306,7 @@
           <a:noFill/>
         </p:spPr>
         <p:txBody>
-          <a:bodyPr wrap="square" lIns="38100" tIns="25400" rIns="38100" bIns="25400" anchor="t">
+          <a:bodyPr wrap="square" anchor="t" lIns="38100" rIns="38100" tIns="25400" bIns="25400">
             <a:noAutofit/>
           </a:bodyPr>
           <a:lstStyle/>
@@ -19635,6 +19328,9 @@
               </a:rPr>
               <a:t>Capability registry scores context providers, tools, and wrapped agents for the current request.</a:t>
             </a:r>
+            <a:endParaRPr sz="1500" b="0" i="0">
+              <a:latin typeface="Calibri"/>
+            </a:endParaRPr>
           </a:p>
           <a:p>
             <a:pPr>
@@ -19654,6 +19350,9 @@
               </a:rPr>
               <a:t>Global planner builds prefetch, execute, monitor, and answer stages.</a:t>
             </a:r>
+            <a:endParaRPr sz="1500" b="0" i="0">
+              <a:latin typeface="Calibri"/>
+            </a:endParaRPr>
           </a:p>
           <a:p>
             <a:pPr>
@@ -19673,6 +19372,9 @@
               </a:rPr>
               <a:t>Explicit tool loop runs tool calls, appends observations, and asks again until final answer or limit.</a:t>
             </a:r>
+            <a:endParaRPr sz="1500" b="0" i="0">
+              <a:latin typeface="Calibri"/>
+            </a:endParaRPr>
           </a:p>
           <a:p>
             <a:pPr>
@@ -19692,6 +19394,9 @@
               </a:rPr>
               <a:t>Answer Analizer classifies success so the UI can expose Create Flow only when useful.</a:t>
             </a:r>
+            <a:endParaRPr sz="1500" b="0" i="0">
+              <a:latin typeface="Calibri"/>
+            </a:endParaRPr>
           </a:p>
         </p:txBody>
       </p:sp>
@@ -19737,7 +19442,6 @@
           <a:lstStyle/>
           <a:p>
             <a:pPr algn="ctr"/>
-            <a:endParaRPr/>
           </a:p>
         </p:txBody>
       </p:sp>
@@ -19781,7 +19485,6 @@
           <a:lstStyle/>
           <a:p>
             <a:pPr algn="ctr"/>
-            <a:endParaRPr/>
           </a:p>
         </p:txBody>
       </p:sp>
@@ -19837,7 +19540,7 @@
           <a:noFill/>
         </p:spPr>
         <p:txBody>
-          <a:bodyPr wrap="square" lIns="38100" tIns="25400" rIns="38100" bIns="25400" anchor="t">
+          <a:bodyPr wrap="square" anchor="t" lIns="38100" rIns="38100" tIns="25400" bIns="25400">
             <a:noAutofit/>
           </a:bodyPr>
           <a:lstStyle/>
@@ -19859,6 +19562,9 @@
               </a:rPr>
               <a:t>Keeps the original prompt validation and legacy prefetch behavior.</a:t>
             </a:r>
+            <a:endParaRPr sz="1600" b="0" i="0">
+              <a:latin typeface="Calibri"/>
+            </a:endParaRPr>
           </a:p>
           <a:p>
             <a:pPr>
@@ -19878,6 +19584,9 @@
               </a:rPr>
               <a:t>Maintains compatibility for fast Q&amp;A and simple context-grounded answers.</a:t>
             </a:r>
+            <a:endParaRPr sz="1600" b="0" i="0">
+              <a:latin typeface="Calibri"/>
+            </a:endParaRPr>
           </a:p>
           <a:p>
             <a:pPr>
@@ -19897,6 +19606,9 @@
               </a:rPr>
               <a:t>Avoids forcing every chat request into agentic execution.</a:t>
             </a:r>
+            <a:endParaRPr sz="1600" b="0" i="0">
+              <a:latin typeface="Calibri"/>
+            </a:endParaRPr>
           </a:p>
         </p:txBody>
       </p:sp>
@@ -19909,7 +19621,7 @@
 </file>
 
 <file path=ppt/slides/slide7.xml><?xml version="1.0" encoding="utf-8"?>
-<p:sld xmlns:a="http://schemas.openxmlformats.org/drawingml/2006/main" xmlns:r="http://schemas.openxmlformats.org/officeDocument/2006/relationships" xmlns:p="http://schemas.openxmlformats.org/presentationml/2006/main">
+<p:sld xmlns:a="http://schemas.openxmlformats.org/drawingml/2006/main" xmlns:p="http://schemas.openxmlformats.org/presentationml/2006/main" xmlns:r="http://schemas.openxmlformats.org/officeDocument/2006/relationships">
   <p:cSld>
     <p:spTree>
       <p:nvGrpSpPr>
@@ -19917,14 +19629,7 @@
         <p:cNvGrpSpPr/>
         <p:nvPr/>
       </p:nvGrpSpPr>
-      <p:grpSpPr>
-        <a:xfrm>
-          <a:off x="0" y="0"/>
-          <a:ext cx="0" cy="0"/>
-          <a:chOff x="0" y="0"/>
-          <a:chExt cx="0" cy="0"/>
-        </a:xfrm>
-      </p:grpSpPr>
+      <p:grpSpPr/>
       <p:sp>
         <p:nvSpPr>
           <p:cNvPr id="2" name="Rectangle 1"/>
@@ -19965,7 +19670,6 @@
           <a:lstStyle/>
           <a:p>
             <a:pPr algn="ctr"/>
-            <a:endParaRPr/>
           </a:p>
         </p:txBody>
       </p:sp>
@@ -20009,7 +19713,6 @@
           <a:lstStyle/>
           <a:p>
             <a:pPr algn="ctr"/>
-            <a:endParaRPr/>
           </a:p>
         </p:txBody>
       </p:sp>
@@ -20053,7 +19756,6 @@
           <a:lstStyle/>
           <a:p>
             <a:pPr algn="ctr"/>
-            <a:endParaRPr/>
           </a:p>
         </p:txBody>
       </p:sp>
@@ -20097,7 +19799,6 @@
           <a:lstStyle/>
           <a:p>
             <a:pPr algn="ctr"/>
-            <a:endParaRPr/>
           </a:p>
         </p:txBody>
       </p:sp>
@@ -20141,7 +19842,6 @@
           <a:lstStyle/>
           <a:p>
             <a:pPr algn="ctr"/>
-            <a:endParaRPr/>
           </a:p>
         </p:txBody>
       </p:sp>
@@ -20257,7 +19957,6 @@
           <a:lstStyle/>
           <a:p>
             <a:pPr algn="ctr"/>
-            <a:endParaRPr/>
           </a:p>
         </p:txBody>
       </p:sp>
@@ -20301,7 +20000,6 @@
           <a:lstStyle/>
           <a:p>
             <a:pPr algn="ctr"/>
-            <a:endParaRPr/>
           </a:p>
         </p:txBody>
       </p:sp>
@@ -20357,7 +20055,7 @@
           <a:noFill/>
         </p:spPr>
         <p:txBody>
-          <a:bodyPr wrap="square" lIns="38100" tIns="25400" rIns="38100" bIns="25400" anchor="t">
+          <a:bodyPr wrap="square" anchor="t" lIns="38100" rIns="38100" tIns="25400" bIns="25400">
             <a:noAutofit/>
           </a:bodyPr>
           <a:lstStyle/>
@@ -20379,6 +20077,9 @@
               </a:rPr>
               <a:t>Drag prebuilt agents onto the canvas and connect them visually.</a:t>
             </a:r>
+            <a:endParaRPr sz="1500" b="0" i="0">
+              <a:latin typeface="Calibri"/>
+            </a:endParaRPr>
           </a:p>
           <a:p>
             <a:pPr>
@@ -20398,6 +20099,9 @@
               </a:rPr>
               <a:t>Configure deployed pool instances, not only static template folders.</a:t>
             </a:r>
+            <a:endParaRPr sz="1500" b="0" i="0">
+              <a:latin typeface="Calibri"/>
+            </a:endParaRPr>
           </a:p>
           <a:p>
             <a:pPr>
@@ -20417,6 +20121,9 @@
               </a:rPr>
               <a:t>Validate structural rules before execution.</a:t>
             </a:r>
+            <a:endParaRPr sz="1500" b="0" i="0">
+              <a:latin typeface="Calibri"/>
+            </a:endParaRPr>
           </a:p>
           <a:p>
             <a:pPr>
@@ -20436,6 +20143,9 @@
               </a:rPr>
               <a:t>Start through Starter, pause/resume through reanimation state, and stop through Ender semantics.</a:t>
             </a:r>
+            <a:endParaRPr sz="1500" b="0" i="0">
+              <a:latin typeface="Calibri"/>
+            </a:endParaRPr>
           </a:p>
         </p:txBody>
       </p:sp>
@@ -20481,7 +20191,6 @@
           <a:lstStyle/>
           <a:p>
             <a:pPr algn="ctr"/>
-            <a:endParaRPr/>
           </a:p>
         </p:txBody>
       </p:sp>
@@ -20525,7 +20234,6 @@
           <a:lstStyle/>
           <a:p>
             <a:pPr algn="ctr"/>
-            <a:endParaRPr/>
           </a:p>
         </p:txBody>
       </p:sp>
@@ -20581,7 +20289,7 @@
           <a:noFill/>
         </p:spPr>
         <p:txBody>
-          <a:bodyPr wrap="square" lIns="38100" tIns="25400" rIns="38100" bIns="25400" anchor="t">
+          <a:bodyPr wrap="square" anchor="t" lIns="38100" rIns="38100" tIns="25400" bIns="25400">
             <a:noAutofit/>
           </a:bodyPr>
           <a:lstStyle/>
@@ -20603,6 +20311,9 @@
               </a:rPr>
               <a:t>Workflows save and load as `.flw` files.</a:t>
             </a:r>
+            <a:endParaRPr sz="1600" b="0" i="0">
+              <a:latin typeface="Calibri"/>
+            </a:endParaRPr>
           </a:p>
           <a:p>
             <a:pPr>
@@ -20622,6 +20333,9 @@
               </a:rPr>
               <a:t>Generated flows from chat are starter drafts, not a replacement for ACP validation.</a:t>
             </a:r>
+            <a:endParaRPr sz="1600" b="0" i="0">
+              <a:latin typeface="Calibri"/>
+            </a:endParaRPr>
           </a:p>
           <a:p>
             <a:pPr>
@@ -20641,6 +20355,9 @@
               </a:rPr>
               <a:t>LED indicators and logs show runtime health across the session pool.</a:t>
             </a:r>
+            <a:endParaRPr sz="1600" b="0" i="0">
+              <a:latin typeface="Calibri"/>
+            </a:endParaRPr>
           </a:p>
         </p:txBody>
       </p:sp>
@@ -20653,7 +20370,7 @@
 </file>
 
 <file path=ppt/slides/slide8.xml><?xml version="1.0" encoding="utf-8"?>
-<p:sld xmlns:a="http://schemas.openxmlformats.org/drawingml/2006/main" xmlns:r="http://schemas.openxmlformats.org/officeDocument/2006/relationships" xmlns:p="http://schemas.openxmlformats.org/presentationml/2006/main">
+<p:sld xmlns:a="http://schemas.openxmlformats.org/drawingml/2006/main" xmlns:p="http://schemas.openxmlformats.org/presentationml/2006/main" xmlns:r="http://schemas.openxmlformats.org/officeDocument/2006/relationships">
   <p:cSld>
     <p:spTree>
       <p:nvGrpSpPr>
@@ -20661,14 +20378,7 @@
         <p:cNvGrpSpPr/>
         <p:nvPr/>
       </p:nvGrpSpPr>
-      <p:grpSpPr>
-        <a:xfrm>
-          <a:off x="0" y="0"/>
-          <a:ext cx="0" cy="0"/>
-          <a:chOff x="0" y="0"/>
-          <a:chExt cx="0" cy="0"/>
-        </a:xfrm>
-      </p:grpSpPr>
+      <p:grpSpPr/>
       <p:sp>
         <p:nvSpPr>
           <p:cNvPr id="2" name="Rectangle 1"/>
@@ -20709,7 +20419,6 @@
           <a:lstStyle/>
           <a:p>
             <a:pPr algn="ctr"/>
-            <a:endParaRPr/>
           </a:p>
         </p:txBody>
       </p:sp>
@@ -20753,7 +20462,6 @@
           <a:lstStyle/>
           <a:p>
             <a:pPr algn="ctr"/>
-            <a:endParaRPr/>
           </a:p>
         </p:txBody>
       </p:sp>
@@ -20797,7 +20505,6 @@
           <a:lstStyle/>
           <a:p>
             <a:pPr algn="ctr"/>
-            <a:endParaRPr/>
           </a:p>
         </p:txBody>
       </p:sp>
@@ -20841,7 +20548,6 @@
           <a:lstStyle/>
           <a:p>
             <a:pPr algn="ctr"/>
-            <a:endParaRPr/>
           </a:p>
         </p:txBody>
       </p:sp>
@@ -20885,7 +20591,6 @@
           <a:lstStyle/>
           <a:p>
             <a:pPr algn="ctr"/>
-            <a:endParaRPr/>
           </a:p>
         </p:txBody>
       </p:sp>
@@ -21001,7 +20706,6 @@
           <a:lstStyle/>
           <a:p>
             <a:pPr algn="ctr"/>
-            <a:endParaRPr/>
           </a:p>
         </p:txBody>
       </p:sp>
@@ -21045,7 +20749,6 @@
           <a:lstStyle/>
           <a:p>
             <a:pPr algn="ctr"/>
-            <a:endParaRPr/>
           </a:p>
         </p:txBody>
       </p:sp>
@@ -21101,7 +20804,7 @@
           <a:noFill/>
         </p:spPr>
         <p:txBody>
-          <a:bodyPr wrap="square" lIns="38100" tIns="25400" rIns="38100" bIns="25400" anchor="t">
+          <a:bodyPr wrap="square" anchor="t" lIns="38100" rIns="38100" tIns="25400" bIns="25400">
             <a:noAutofit/>
           </a:bodyPr>
           <a:lstStyle/>
@@ -21123,6 +20826,9 @@
               </a:rPr>
               <a:t>Control: starter, ender, stopper, cleaner, barrier, flowbacker</a:t>
             </a:r>
+            <a:endParaRPr sz="1300" b="0" i="0">
+              <a:latin typeface="Calibri"/>
+            </a:endParaRPr>
           </a:p>
           <a:p>
             <a:pPr>
@@ -21142,6 +20848,9 @@
               </a:rPr>
               <a:t>Execution and files: executer, pythonxer, pser, file_creator, file_extractor, file_interpreter, mover, deleter</a:t>
             </a:r>
+            <a:endParaRPr sz="1300" b="0" i="0">
+              <a:latin typeface="Calibri"/>
+            </a:endParaRPr>
           </a:p>
           <a:p>
             <a:pPr>
@@ -21161,6 +20870,9 @@
               </a:rPr>
               <a:t>DevOps and infra: gitter, dockerer, kuberneter, jenkinser, ssher, scper</a:t>
             </a:r>
+            <a:endParaRPr sz="1300" b="0" i="0">
+              <a:latin typeface="Calibri"/>
+            </a:endParaRPr>
           </a:p>
           <a:p>
             <a:pPr>
@@ -21180,6 +20892,9 @@
               </a:rPr>
               <a:t>Data and APIs: sqler, mongoxer, apirer, crawler, googler</a:t>
             </a:r>
+            <a:endParaRPr sz="1300" b="0" i="0">
+              <a:latin typeface="Calibri"/>
+            </a:endParaRPr>
           </a:p>
         </p:txBody>
       </p:sp>
@@ -21225,7 +20940,6 @@
           <a:lstStyle/>
           <a:p>
             <a:pPr algn="ctr"/>
-            <a:endParaRPr/>
           </a:p>
         </p:txBody>
       </p:sp>
@@ -21269,7 +20983,6 @@
           <a:lstStyle/>
           <a:p>
             <a:pPr algn="ctr"/>
-            <a:endParaRPr/>
           </a:p>
         </p:txBody>
       </p:sp>
@@ -21325,7 +21038,7 @@
           <a:noFill/>
         </p:spPr>
         <p:txBody>
-          <a:bodyPr wrap="square" lIns="38100" tIns="25400" rIns="38100" bIns="25400" anchor="t">
+          <a:bodyPr wrap="square" anchor="t" lIns="38100" rIns="38100" tIns="25400" bIns="25400">
             <a:noAutofit/>
           </a:bodyPr>
           <a:lstStyle/>
@@ -21347,6 +21060,9 @@
               </a:rPr>
               <a:t>Monitoring and routing: monitor_log, monitor_netstat, flowhypervisor, forker, asker, counter, and, or</a:t>
             </a:r>
+            <a:endParaRPr sz="1300" b="0" i="0">
+              <a:latin typeface="Calibri"/>
+            </a:endParaRPr>
           </a:p>
           <a:p>
             <a:pPr>
@@ -21366,6 +21082,9 @@
               </a:rPr>
               <a:t>Communication: notifier, emailer, recmailer, telegramer, telegramrx, whatsapper</a:t>
             </a:r>
+            <a:endParaRPr sz="1300" b="0" i="0">
+              <a:latin typeface="Calibri"/>
+            </a:endParaRPr>
           </a:p>
           <a:p>
             <a:pPr>
@@ -21385,6 +21104,9 @@
               </a:rPr>
               <a:t>Security and media: kyber_keygen, kyber_cipher, kyber_decipher, image_interpreter, shoter, j_decompiler</a:t>
             </a:r>
+            <a:endParaRPr sz="1300" b="0" i="0">
+              <a:latin typeface="Calibri"/>
+            </a:endParaRPr>
           </a:p>
           <a:p>
             <a:pPr>
@@ -21404,6 +21126,9 @@
               </a:rPr>
               <a:t>Workflow intelligence: flowcreator, gatewayer, gateway_relayer, node_manager, parametrizer, prompter, summarizer</a:t>
             </a:r>
+            <a:endParaRPr sz="1300" b="0" i="0">
+              <a:latin typeface="Calibri"/>
+            </a:endParaRPr>
           </a:p>
         </p:txBody>
       </p:sp>
@@ -21416,7 +21141,7 @@
 </file>
 
 <file path=ppt/slides/slide9.xml><?xml version="1.0" encoding="utf-8"?>
-<p:sld xmlns:a="http://schemas.openxmlformats.org/drawingml/2006/main" xmlns:r="http://schemas.openxmlformats.org/officeDocument/2006/relationships" xmlns:p="http://schemas.openxmlformats.org/presentationml/2006/main">
+<p:sld xmlns:a="http://schemas.openxmlformats.org/drawingml/2006/main" xmlns:p="http://schemas.openxmlformats.org/presentationml/2006/main" xmlns:r="http://schemas.openxmlformats.org/officeDocument/2006/relationships">
   <p:cSld>
     <p:spTree>
       <p:nvGrpSpPr>
@@ -21424,14 +21149,7 @@
         <p:cNvGrpSpPr/>
         <p:nvPr/>
       </p:nvGrpSpPr>
-      <p:grpSpPr>
-        <a:xfrm>
-          <a:off x="0" y="0"/>
-          <a:ext cx="0" cy="0"/>
-          <a:chOff x="0" y="0"/>
-          <a:chExt cx="0" cy="0"/>
-        </a:xfrm>
-      </p:grpSpPr>
+      <p:grpSpPr/>
       <p:sp>
         <p:nvSpPr>
           <p:cNvPr id="2" name="Rectangle 1"/>
@@ -21472,7 +21190,6 @@
           <a:lstStyle/>
           <a:p>
             <a:pPr algn="ctr"/>
-            <a:endParaRPr/>
           </a:p>
         </p:txBody>
       </p:sp>
@@ -21516,7 +21233,6 @@
           <a:lstStyle/>
           <a:p>
             <a:pPr algn="ctr"/>
-            <a:endParaRPr/>
           </a:p>
         </p:txBody>
       </p:sp>
@@ -21560,7 +21276,6 @@
           <a:lstStyle/>
           <a:p>
             <a:pPr algn="ctr"/>
-            <a:endParaRPr/>
           </a:p>
         </p:txBody>
       </p:sp>
@@ -21604,7 +21319,6 @@
           <a:lstStyle/>
           <a:p>
             <a:pPr algn="ctr"/>
-            <a:endParaRPr/>
           </a:p>
         </p:txBody>
       </p:sp>
@@ -21648,7 +21362,6 @@
           <a:lstStyle/>
           <a:p>
             <a:pPr algn="ctr"/>
-            <a:endParaRPr/>
           </a:p>
         </p:txBody>
       </p:sp>
@@ -21764,7 +21477,6 @@
           <a:lstStyle/>
           <a:p>
             <a:pPr algn="ctr"/>
-            <a:endParaRPr/>
           </a:p>
         </p:txBody>
       </p:sp>
@@ -21808,7 +21520,6 @@
           <a:lstStyle/>
           <a:p>
             <a:pPr algn="ctr"/>
-            <a:endParaRPr/>
           </a:p>
         </p:txBody>
       </p:sp>
@@ -21864,7 +21575,7 @@
           <a:noFill/>
         </p:spPr>
         <p:txBody>
-          <a:bodyPr wrap="square" lIns="38100" tIns="25400" rIns="38100" bIns="25400" anchor="t">
+          <a:bodyPr wrap="square" anchor="t" lIns="38100" rIns="38100" tIns="25400" bIns="25400">
             <a:noAutofit/>
           </a:bodyPr>
           <a:lstStyle/>
@@ -21886,6 +21597,9 @@
               </a:rPr>
               <a:t>Receives HTTP webhook events or optional folder-drop files.</a:t>
             </a:r>
+            <a:endParaRPr sz="1500" b="0" i="0">
+              <a:latin typeface="Calibri"/>
+            </a:endParaRPr>
           </a:p>
           <a:p>
             <a:pPr>
@@ -21905,6 +21619,9 @@
               </a:rPr>
               <a:t>Normalizes, persists, queues, and dispatches events into downstream workflow agents.</a:t>
             </a:r>
+            <a:endParaRPr sz="1500" b="0" i="0">
+              <a:latin typeface="Calibri"/>
+            </a:endParaRPr>
           </a:p>
           <a:p>
             <a:pPr>
@@ -21924,6 +21641,9 @@
               </a:rPr>
               <a:t>Supports bearer/HMAC-style auth patterns, IP allowlists, dedup files, and crash recovery state.</a:t>
             </a:r>
+            <a:endParaRPr sz="1500" b="0" i="0">
+              <a:latin typeface="Calibri"/>
+            </a:endParaRPr>
           </a:p>
         </p:txBody>
       </p:sp>
@@ -21969,7 +21689,6 @@
           <a:lstStyle/>
           <a:p>
             <a:pPr algn="ctr"/>
-            <a:endParaRPr/>
           </a:p>
         </p:txBody>
       </p:sp>
@@ -22013,7 +21732,6 @@
           <a:lstStyle/>
           <a:p>
             <a:pPr algn="ctr"/>
-            <a:endParaRPr/>
           </a:p>
         </p:txBody>
       </p:sp>
@@ -22069,7 +21787,7 @@
           <a:noFill/>
         </p:spPr>
         <p:txBody>
-          <a:bodyPr wrap="square" lIns="38100" tIns="25400" rIns="38100" bIns="25400" anchor="t">
+          <a:bodyPr wrap="square" anchor="t" lIns="38100" rIns="38100" tIns="25400" bIns="25400">
             <a:noAutofit/>
           </a:bodyPr>
           <a:lstStyle/>
@@ -22091,6 +21809,9 @@
               </a:rPr>
               <a:t>Gatewayer is a workflow trigger, not a chat-router clone.</a:t>
             </a:r>
+            <a:endParaRPr sz="1600" b="0" i="0">
+              <a:latin typeface="Calibri"/>
+            </a:endParaRPr>
           </a:p>
           <a:p>
             <a:pPr>
@@ -22110,6 +21831,9 @@
               </a:rPr>
               <a:t>Declared config fields are now documented with clear caveats where enforcement is not complete.</a:t>
             </a:r>
+            <a:endParaRPr sz="1600" b="0" i="0">
+              <a:latin typeface="Calibri"/>
+            </a:endParaRPr>
           </a:p>
           <a:p>
             <a:pPr>
@@ -22129,6 +21853,9 @@
               </a:rPr>
               <a:t>Stable log markers let Monitor Log and Summarizer watch gateway health.</a:t>
             </a:r>
+            <a:endParaRPr sz="1600" b="0" i="0">
+              <a:latin typeface="Calibri"/>
+            </a:endParaRPr>
           </a:p>
         </p:txBody>
       </p:sp>

</xml_diff>

<commit_message>
Updating version in all the documentation and installing/uninstalling windows, by angelahack1
</commit_message>
<xml_diff>
--- a/Tlamatini_eXtended_Artificial_Intelligence_Humanly_Tempered.pptx
+++ b/Tlamatini_eXtended_Artificial_Intelligence_Humanly_Tempered.pptx
@@ -3834,7 +3834,7 @@
                 </a:solidFill>
                 <a:latin typeface="Aptos"/>
               </a:rPr>
-              <a:t>98,593</a:t>
+              <a:t>98,624</a:t>
             </a:r>
           </a:p>
         </p:txBody>
@@ -3869,7 +3869,7 @@
                 </a:solidFill>
                 <a:latin typeface="Aptos"/>
               </a:rPr>
-              <a:t>Generated May 17, 2026 07:27 PM UTC-0600 at HEAD b4d29c0</a:t>
+              <a:t>Generated May 18, 2026 12:52 AM UTC-0600 at HEAD 2c707e3</a:t>
             </a:r>
           </a:p>
         </p:txBody>
@@ -8954,7 +8954,7 @@
                 </a:solidFill>
                 <a:latin typeface="Cascadia Mono"/>
               </a:rPr>
-              <a:t>Resolved current version: 1.3.0 | build: 1.3.0</a:t>
+              <a:t>Resolved current version: 1.3.1 | build: 1.3.1</a:t>
             </a:r>
           </a:p>
         </p:txBody>
@@ -19120,7 +19120,7 @@
               <a:rPr sz="1500" b="0" i="0">
                 <a:latin typeface="Calibri"/>
               </a:rPr>
-              <a:t>b4d29c0 - Caping gaps in number and descriptions of agents in markdowns and monitoring_prompt, by angelahack1</a:t>
+              <a:t>2c707e3 - Patching Ruff availability all along Multi-turn execution., by angelahack1</a:t>
             </a:r>
             <a:endParaRPr sz="1500" b="0" i="0">
               <a:latin typeface="Calibri"/>
@@ -19142,7 +19142,7 @@
               <a:rPr sz="1500" b="0" i="0">
                 <a:latin typeface="Calibri"/>
               </a:rPr>
-              <a:t>Resolved version: 1.3.0 (git)</a:t>
+              <a:t>Resolved version: 1.3.1 (git)</a:t>
             </a:r>
             <a:endParaRPr sz="1500" b="0" i="0">
               <a:latin typeface="Calibri"/>
@@ -19164,7 +19164,7 @@
               <a:rPr sz="1500" b="0" i="0">
                 <a:latin typeface="Calibri"/>
               </a:rPr>
-              <a:t>Generated on May 17, 2026 07:27 PM UTC-0600</a:t>
+              <a:t>Generated on May 18, 2026 12:52 AM UTC-0600</a:t>
             </a:r>
             <a:endParaRPr sz="1500" b="0" i="0">
               <a:latin typeface="Calibri"/>
@@ -19629,7 +19629,7 @@
                 </a:solidFill>
                 <a:latin typeface="Aptos"/>
               </a:rPr>
-              <a:t>98,593</a:t>
+              <a:t>98,624</a:t>
             </a:r>
           </a:p>
         </p:txBody>
@@ -19744,7 +19744,7 @@
                 </a:solidFill>
                 <a:latin typeface="Aptos"/>
               </a:rPr>
-              <a:t>134,198</a:t>
+              <a:t>134,246</a:t>
             </a:r>
           </a:p>
         </p:txBody>
@@ -19895,7 +19895,7 @@
                 <a:latin typeface="Cascadia Mono"/>
               </a:rPr>
               <a:t>LANGUAGE                 FILES   EFFECTIVE      TOTAL   SHARE
-Python                   262      65,822     91,851  66.8%
+Python                   262      65,853     91,899  66.8%
 JavaScript                28      12,824     16,161  13.0%
 Markdown                  50      11,708     15,104  11.9%
 CSS                        6       3,338      4,183   3.4%
@@ -21254,7 +21254,7 @@
               <a:t>PATH                                                     LANGUAGE     EFFECTIVE   TOTAL
 Tlamatini/agent/views.py                                Python         6,917   9,972
 Tlamatini/agent/tests.py                                Python         4,034   5,153
-Tlamatini/agent/tools.py                                Python         2,201   3,094
+Tlamatini/agent/tools.py                                Python         2,201   3,097
 BookOfTlamatini.md                                      Markdown       1,884   2,654
 Tlamatini/agent/agents/flowcreator/agentic_skill.md     Markdown       1,825   2,031
 ...ini/agent/static/agent/css/agentic_control_panel.css CSS            1,653   2,187
@@ -21733,51 +21733,7 @@
               <a:rPr sz="1500" b="0" i="0">
                 <a:latin typeface="Calibri"/>
               </a:rPr>
-              <a:t>Today’s headline change is agent-catalog consistency: the live count, the markdown bestiaries, the flow-creator skill catalog, and the sidebar-description source were brought back into alignment around the same 62-agent inventory.</a:t>
-            </a:r>
-            <a:endParaRPr sz="1500" b="0" i="0">
-              <a:latin typeface="Calibri"/>
-            </a:endParaRPr>
-          </a:p>
-          <a:p>
-            <a:pPr>
-              <a:spcAft>
-                <a:spcPts val="600"/>
-              </a:spcAft>
-              <a:defRPr sz="1500">
-                <a:solidFill>
-                  <a:srgbClr val="B4BAAE"/>
-                </a:solidFill>
-                <a:latin typeface="Aptos"/>
-              </a:defRPr>
-            </a:pPr>
-            <a:r>
-              <a:rPr sz="1500" b="0" i="0">
-                <a:latin typeface="Calibri"/>
-              </a:rPr>
-              <a:t>Today’s headline change is Unreal MCP support: the new Unrealer agent, a chat-wrapped `chat_agent_unrealer` tool, canvas wiring, a seeded end-to-end demo prompt, and a direct TCP bridge into a live Unreal Engine 5 editor.</a:t>
-            </a:r>
-            <a:endParaRPr sz="1500" b="0" i="0">
-              <a:latin typeface="Calibri"/>
-            </a:endParaRPr>
-          </a:p>
-          <a:p>
-            <a:pPr>
-              <a:spcAft>
-                <a:spcPts val="600"/>
-              </a:spcAft>
-              <a:defRPr sz="1500">
-                <a:solidFill>
-                  <a:srgbClr val="B4BAAE"/>
-                </a:solidFill>
-                <a:latin typeface="Aptos"/>
-              </a:defRPr>
-            </a:pPr>
-            <a:r>
-              <a:rPr sz="1500" b="0" i="0">
-                <a:latin typeface="Calibri"/>
-              </a:rPr>
-              <a:t>ACPX-related work remained visible during the today: runtime, documentation, or operator-surface changes were still part of the active maintenance stream.</a:t>
+              <a:t>Multi-Turn behavior kept evolving across the period through quota tuning, execution-table persistence, autonomous-action improvements, and broader tool enablement.</a:t>
             </a:r>
             <a:endParaRPr sz="1500" b="0" i="0">
               <a:latin typeface="Calibri"/>
@@ -22248,117 +22204,7 @@
               <a:rPr sz="1200" b="0" i="0">
                 <a:latin typeface="Calibri"/>
               </a:rPr>
-              <a:t>2026-05-17 | b4d29c0 | Caping gaps in number and descriptions of agents in markdowns and monitoring_prompt, by angelahack1</a:t>
-            </a:r>
-            <a:endParaRPr sz="1200" b="0" i="0">
-              <a:latin typeface="Calibri"/>
-            </a:endParaRPr>
-          </a:p>
-          <a:p>
-            <a:pPr>
-              <a:spcAft>
-                <a:spcPts val="600"/>
-              </a:spcAft>
-              <a:defRPr sz="1200">
-                <a:solidFill>
-                  <a:srgbClr val="B4BAAE"/>
-                </a:solidFill>
-                <a:latin typeface="Aptos"/>
-              </a:defRPr>
-            </a:pPr>
-            <a:r>
-              <a:rPr sz="1200" b="0" i="0">
-                <a:latin typeface="Calibri"/>
-              </a:rPr>
-              <a:t>2026-05-17 | 221d20f | Caping gaps in number and descriptions of agents in agentic_skill.md, by angelahack1</a:t>
-            </a:r>
-            <a:endParaRPr sz="1200" b="0" i="0">
-              <a:latin typeface="Calibri"/>
-            </a:endParaRPr>
-          </a:p>
-          <a:p>
-            <a:pPr>
-              <a:spcAft>
-                <a:spcPts val="600"/>
-              </a:spcAft>
-              <a:defRPr sz="1200">
-                <a:solidFill>
-                  <a:srgbClr val="B4BAAE"/>
-                </a:solidFill>
-                <a:latin typeface="Aptos"/>
-              </a:defRPr>
-            </a:pPr>
-            <a:r>
-              <a:rPr sz="1200" b="0" i="0">
-                <a:latin typeface="Calibri"/>
-              </a:rPr>
-              <a:t>2026-05-17 | 27dd4d5 | Caping gaps in number and descriptions of agents, by angelahack1</a:t>
-            </a:r>
-            <a:endParaRPr sz="1200" b="0" i="0">
-              <a:latin typeface="Calibri"/>
-            </a:endParaRPr>
-          </a:p>
-          <a:p>
-            <a:pPr>
-              <a:spcAft>
-                <a:spcPts val="600"/>
-              </a:spcAft>
-              <a:defRPr sz="1200">
-                <a:solidFill>
-                  <a:srgbClr val="B4BAAE"/>
-                </a:solidFill>
-                <a:latin typeface="Aptos"/>
-              </a:defRPr>
-            </a:pPr>
-            <a:r>
-              <a:rPr sz="1200" b="0" i="0">
-                <a:latin typeface="Calibri"/>
-              </a:rPr>
-              <a:t>2026-05-17 | 05060c3 | Implementing configuration menu entry of ACPX-Skills, by angelahack1</a:t>
-            </a:r>
-            <a:endParaRPr sz="1200" b="0" i="0">
-              <a:latin typeface="Calibri"/>
-            </a:endParaRPr>
-          </a:p>
-          <a:p>
-            <a:pPr>
-              <a:spcAft>
-                <a:spcPts val="600"/>
-              </a:spcAft>
-              <a:defRPr sz="1200">
-                <a:solidFill>
-                  <a:srgbClr val="B4BAAE"/>
-                </a:solidFill>
-                <a:latin typeface="Aptos"/>
-              </a:defRPr>
-            </a:pPr>
-            <a:r>
-              <a:rPr sz="1200" b="0" i="0">
-                <a:latin typeface="Calibri"/>
-              </a:rPr>
-              <a:t>2026-05-17 | 6be0102 | Some improvements in Unrealer agent in sending commands and normalization, by angelahack1</a:t>
-            </a:r>
-            <a:endParaRPr sz="1200" b="0" i="0">
-              <a:latin typeface="Calibri"/>
-            </a:endParaRPr>
-          </a:p>
-          <a:p>
-            <a:pPr>
-              <a:spcAft>
-                <a:spcPts val="600"/>
-              </a:spcAft>
-              <a:defRPr sz="1200">
-                <a:solidFill>
-                  <a:srgbClr val="B4BAAE"/>
-                </a:solidFill>
-                <a:latin typeface="Aptos"/>
-              </a:defRPr>
-            </a:pPr>
-            <a:r>
-              <a:rPr sz="1200" b="0" i="0">
-                <a:latin typeface="Calibri"/>
-              </a:rPr>
-              <a:t>2026-05-17 | f39104f | Just a fix into Unrealer yaml, by angelahack1</a:t>
+              <a:t>2026-05-18 | 2c707e3 | Patching Ruff availability all along Multi-turn execution., by angelahack1</a:t>
             </a:r>
             <a:endParaRPr sz="1200" b="0" i="0">
               <a:latin typeface="Calibri"/>

</xml_diff>

<commit_message>
Updating to version 1.6.0 the visual assets (PDF, PPTX), by Tlamatini's-AutoBot.
</commit_message>
<xml_diff>
--- a/Tlamatini_eXtended_Artificial_Intelligence_Humanly_Tempered.pptx
+++ b/Tlamatini_eXtended_Artificial_Intelligence_Humanly_Tempered.pptx
@@ -3612,7 +3612,7 @@
                 </a:solidFill>
                 <a:latin typeface="Aptos"/>
               </a:rPr>
-              <a:t>469</a:t>
+              <a:t>476</a:t>
             </a:r>
           </a:p>
         </p:txBody>
@@ -3842,7 +3842,7 @@
                 </a:solidFill>
                 <a:latin typeface="Aptos"/>
               </a:rPr>
-              <a:t>102,103</a:t>
+              <a:t>103,895</a:t>
             </a:r>
           </a:p>
         </p:txBody>
@@ -3877,7 +3877,7 @@
                 </a:solidFill>
                 <a:latin typeface="Aptos"/>
               </a:rPr>
-              <a:t>Generated May 21, 2026 04:26 PM UTC-0600 at HEAD d05e6a9</a:t>
+              <a:t>Generated May 21, 2026 04:54 PM UTC-0600 at HEAD 82e2fd4</a:t>
             </a:r>
           </a:p>
         </p:txBody>
@@ -13330,7 +13330,7 @@
               <a:rPr sz="1300" b="0" i="0">
                 <a:latin typeface="Calibri"/>
               </a:rPr>
-              <a:t>Those readability rules remain in force in the current documentation set, and the newer `v1.5.0` release state keeps the version badge, runtime surfaces, and operator handbook aligned.</a:t>
+              <a:t>Those readability rules remain in force in the current documentation set, and the newer `v1.6.0` release state keeps the version badge, runtime surfaces, and operator handbook aligned.</a:t>
             </a:r>
             <a:endParaRPr sz="1300" b="0" i="0">
               <a:latin typeface="Calibri"/>
@@ -14844,7 +14844,7 @@
                 </a:solidFill>
                 <a:latin typeface="Cascadia Mono"/>
               </a:rPr>
-              <a:t>Resolved current version: 1.5.0 | build: 1.5.0</a:t>
+              <a:t>Resolved current version: 1.6.0 | build: 1.6.0</a:t>
             </a:r>
           </a:p>
         </p:txBody>
@@ -24592,7 +24592,7 @@
                 </a:solidFill>
                 <a:latin typeface="Aptos"/>
               </a:rPr>
-              <a:t>469</a:t>
+              <a:t>476</a:t>
             </a:r>
           </a:p>
         </p:txBody>
@@ -25332,7 +25332,7 @@
               <a:rPr sz="1500" b="0" i="0">
                 <a:latin typeface="Calibri"/>
               </a:rPr>
-              <a:t>d05e6a9 - Updating visual assets, by angelahack1</a:t>
+              <a:t>82e2fd4 - Updating to version 1.6.0 of Tlamatini, by Tlamatini's-AutoBot.</a:t>
             </a:r>
             <a:endParaRPr sz="1500" b="0" i="0">
               <a:latin typeface="Calibri"/>
@@ -25354,7 +25354,7 @@
               <a:rPr sz="1500" b="0" i="0">
                 <a:latin typeface="Calibri"/>
               </a:rPr>
-              <a:t>Resolved version: 1.5.0 (git)</a:t>
+              <a:t>Resolved version: 1.6.0 (git)</a:t>
             </a:r>
             <a:endParaRPr sz="1500" b="0" i="0">
               <a:latin typeface="Calibri"/>
@@ -25376,7 +25376,7 @@
               <a:rPr sz="1500" b="0" i="0">
                 <a:latin typeface="Calibri"/>
               </a:rPr>
-              <a:t>Generated on May 21, 2026 04:26 PM UTC-0600</a:t>
+              <a:t>Generated on May 21, 2026 04:54 PM UTC-0600</a:t>
             </a:r>
             <a:endParaRPr sz="1500" b="0" i="0">
               <a:latin typeface="Calibri"/>
@@ -25841,7 +25841,7 @@
                 </a:solidFill>
                 <a:latin typeface="Aptos"/>
               </a:rPr>
-              <a:t>102,103</a:t>
+              <a:t>103,895</a:t>
             </a:r>
           </a:p>
         </p:txBody>
@@ -25956,7 +25956,7 @@
                 </a:solidFill>
                 <a:latin typeface="Aptos"/>
               </a:rPr>
-              <a:t>139,073</a:t>
+              <a:t>141,579</a:t>
             </a:r>
           </a:p>
         </p:txBody>
@@ -26107,11 +26107,11 @@
                 <a:latin typeface="Cascadia Mono"/>
               </a:rPr>
               <a:t>LANGUAGE                 FILES   EFFECTIVE      TOTAL   SHARE
-Python                   272      68,475     95,619  67.1%
-JavaScript                28      13,028     16,393  12.8%
-Markdown                  52      12,069     15,512  11.8%
+Python                   278      70,255     98,048  67.6%
+JavaScript                28      13,028     16,393  12.5%
+Markdown                  52      12,069     15,512  11.6%
 CSS                        6       3,398      4,282   3.3%
-YAML                      69       1,420      2,879   1.4%
+YAML                      70       1,432      2,956   1.4%
 HTML                       4         823        841   0.8%
 Other text                 3         789        967   0.8%
 Prompt template            2         607        719   0.6%
@@ -26940,7 +26940,73 @@
               <a:rPr sz="1500" b="0" i="0">
                 <a:latin typeface="Calibri"/>
               </a:rPr>
-              <a:t>Git history today shows focused maintenance across the operator surface, release mechanics, and runtime behavior.</a:t>
+              <a:t>Today’s headline change is the new Windower agent: Tlamatini now reaches 66 workflow agents and adds a deterministic Win32 window-manager surface for focusing, tiling, resizing, listing, and closing windows from both Multi-Turn chat and the visual canvas.</a:t>
+            </a:r>
+            <a:endParaRPr sz="1500" b="0" i="0">
+              <a:latin typeface="Calibri"/>
+            </a:endParaRPr>
+          </a:p>
+          <a:p>
+            <a:pPr>
+              <a:spcAft>
+                <a:spcPts val="600"/>
+              </a:spcAft>
+              <a:defRPr sz="1500">
+                <a:solidFill>
+                  <a:srgbClr val="B4BAAE"/>
+                </a:solidFill>
+                <a:latin typeface="Aptos"/>
+              </a:defRPr>
+            </a:pPr>
+            <a:r>
+              <a:rPr sz="1500" b="0" i="0">
+                <a:latin typeface="Calibri"/>
+              </a:rPr>
+              <a:t>Today’s headline change is the new Playwrighter agent in `v1.5.0`: Tlamatini now adds its 65th workflow agent and a real-browser automation surface for scripted Playwright flows from both Multi-Turn chat and the visual canvas.</a:t>
+            </a:r>
+            <a:endParaRPr sz="1500" b="0" i="0">
+              <a:latin typeface="Calibri"/>
+            </a:endParaRPr>
+          </a:p>
+          <a:p>
+            <a:pPr>
+              <a:spcAft>
+                <a:spcPts val="600"/>
+              </a:spcAft>
+              <a:defRPr sz="1500">
+                <a:solidFill>
+                  <a:srgbClr val="B4BAAE"/>
+                </a:solidFill>
+                <a:latin typeface="Aptos"/>
+              </a:defRPr>
+            </a:pPr>
+            <a:r>
+              <a:rPr sz="1500" b="0" i="0">
+                <a:latin typeface="Calibri"/>
+              </a:rPr>
+              <a:t>Today’s headline change is the new versioning system: SemVer policy, git-tag sourcing, runtime version surfaces, and build-time embedding across the Windows artefacts.</a:t>
+            </a:r>
+            <a:endParaRPr sz="1500" b="0" i="0">
+              <a:latin typeface="Calibri"/>
+            </a:endParaRPr>
+          </a:p>
+          <a:p>
+            <a:pPr>
+              <a:spcAft>
+                <a:spcPts val="600"/>
+              </a:spcAft>
+              <a:defRPr sz="1500">
+                <a:solidFill>
+                  <a:srgbClr val="B4BAAE"/>
+                </a:solidFill>
+                <a:latin typeface="Aptos"/>
+              </a:defRPr>
+            </a:pPr>
+            <a:r>
+              <a:rPr sz="1500" b="0" i="0">
+                <a:latin typeface="Calibri"/>
+              </a:rPr>
+              <a:t>Documentation itself changed today, so the regenerated dossier is part of the tracked operator surface rather than an external afterthought.</a:t>
             </a:r>
             <a:endParaRPr sz="1500" b="0" i="0">
               <a:latin typeface="Calibri"/>
@@ -27395,6 +27461,50 @@
             <a:noAutofit/>
           </a:bodyPr>
           <a:lstStyle/>
+          <a:p>
+            <a:pPr>
+              <a:spcAft>
+                <a:spcPts val="600"/>
+              </a:spcAft>
+              <a:defRPr sz="1200">
+                <a:solidFill>
+                  <a:srgbClr val="B4BAAE"/>
+                </a:solidFill>
+                <a:latin typeface="Aptos"/>
+              </a:defRPr>
+            </a:pPr>
+            <a:r>
+              <a:rPr sz="1200" b="0" i="0">
+                <a:latin typeface="Calibri"/>
+              </a:rPr>
+              <a:t>2026-05-21 | 82e2fd4 | Updating to version 1.6.0 of Tlamatini, by Tlamatini's-AutoBot.</a:t>
+            </a:r>
+            <a:endParaRPr sz="1200" b="0" i="0">
+              <a:latin typeface="Calibri"/>
+            </a:endParaRPr>
+          </a:p>
+          <a:p>
+            <a:pPr>
+              <a:spcAft>
+                <a:spcPts val="600"/>
+              </a:spcAft>
+              <a:defRPr sz="1200">
+                <a:solidFill>
+                  <a:srgbClr val="B4BAAE"/>
+                </a:solidFill>
+                <a:latin typeface="Aptos"/>
+              </a:defRPr>
+            </a:pPr>
+            <a:r>
+              <a:rPr sz="1200" b="0" i="0">
+                <a:latin typeface="Calibri"/>
+              </a:rPr>
+              <a:t>2026-05-21 | b8fd51e | Implementing Playwrighter and Windower completely in source code and documentation, by Tlamatini's-AutoBot.</a:t>
+            </a:r>
+            <a:endParaRPr sz="1200" b="0" i="0">
+              <a:latin typeface="Calibri"/>
+            </a:endParaRPr>
+          </a:p>
           <a:p>
             <a:pPr>
               <a:spcAft>
@@ -30427,6 +30537,8 @@
     |   |-- test_native_dialogs.py
     |   |-- test_orphan_reaper.py
     |   |-- test_password_quoting.py
+    |   |-- test_playwrighter_agent.py
+    |   |-- test_windower_agent.py
     |   |-- tests.py
     |   |-- tools.py
     |   |-- urls.py
@@ -30442,9 +30554,7 @@
     |   |   |-- service.py
     |   |   |-- session_store.py
     |   |   |-- tests.py
-    |   |   |-- tools.py
-    |   |   `-- windows_spawn.py
-    |   |-- agents/</a:t>
+    |   |   |-- tools.py</a:t>
             </a:r>
           </a:p>
         </p:txBody>
@@ -30782,7 +30892,9 @@
                 </a:solidFill>
                 <a:latin typeface="Cascadia Mono"/>
               </a:rPr>
-              <a:t>    |   |   |-- acpxer/
+              <a:t>    |   |   `-- windows_spawn.py
+    |   |-- agents/
+    |   |   |-- acpxer/
     |   |   |   |-- acpxer.py
     |   |   |   `-- config.yaml
     |   |   |-- analyzer/
@@ -30810,9 +30922,7 @@
     |   |   |   `-- counter.py
     |   |   |-- crawler/
     |   |   |   |-- config.yaml
-    |   |   |   `-- crawler.py
-    |   |   |-- croner/
-    |   |   |   |-- config.yaml</a:t>
+    |   |   |   `-- crawler.py</a:t>
             </a:r>
           </a:p>
         </p:txBody>
@@ -31150,7 +31260,9 @@
                 </a:solidFill>
                 <a:latin typeface="Cascadia Mono"/>
               </a:rPr>
-              <a:t>    |   |   |   `-- croner.py
+              <a:t>    |   |   |-- croner/
+    |   |   |   |-- config.yaml
+    |   |   |   `-- croner.py
     |   |   |-- de_compresser/
     |   |   |   |-- config.yaml
     |   |   |   `-- de_compresser.py
@@ -31178,9 +31290,7 @@
     |   |   |-- file_interpreter/
     |   |   |   |-- config.yaml
     |   |   |   `-- file_interpreter.py
-    |   |   |-- flowbacker/
-    |   |   |   |-- config.yaml
-    |   |   |   `-- flowbacker.py</a:t>
+    |   |   |-- flowbacker/</a:t>
             </a:r>
           </a:p>
         </p:txBody>
@@ -31518,7 +31628,9 @@
                 </a:solidFill>
                 <a:latin typeface="Cascadia Mono"/>
               </a:rPr>
-              <a:t>    |   |   |-- flowcreator/
+              <a:t>    |   |   |   |-- config.yaml
+    |   |   |   `-- flowbacker.py
+    |   |   |-- flowcreator/
     |   |   |   |-- agentic_skill.md
     |   |   |   |-- config.yaml
     |   |   |   `-- flowcreator.py
@@ -31546,9 +31658,7 @@
     |   |   |   |-- config.yaml
     |   |   |   `-- googler.py
     |   |   |-- image_interpreter/
-    |   |   |   |-- config.yaml
-    |   |   |   `-- image_interpreter.py
-    |   |   |-- j_decompiler/</a:t>
+    |   |   |   |-- config.yaml</a:t>
             </a:r>
           </a:p>
         </p:txBody>
@@ -31886,7 +31996,9 @@
                 </a:solidFill>
                 <a:latin typeface="Cascadia Mono"/>
               </a:rPr>
-              <a:t>    |   |   |   |-- config.yaml
+              <a:t>    |   |   |   `-- image_interpreter.py
+    |   |   |-- j_decompiler/
+    |   |   |   |-- config.yaml
     |   |   |   `-- j_decompiler.py
     |   |   |-- jenkinser/
     |   |   |   |-- config.yaml
@@ -31914,9 +32026,7 @@
     |   |   |   `-- monitor_log.py
     |   |   |-- monitor_netstat/
     |   |   |   |-- config.yaml
-    |   |   |   `-- monitor_netstat.py
-    |   |   |-- mouser/
-    |   |   |   |-- config.yaml</a:t>
+    |   |   |   `-- monitor_netstat.py</a:t>
             </a:r>
           </a:p>
         </p:txBody>
@@ -32254,7 +32364,9 @@
                 </a:solidFill>
                 <a:latin typeface="Cascadia Mono"/>
               </a:rPr>
-              <a:t>    |   |   |   `-- mouser.py
+              <a:t>    |   |   |-- mouser/
+    |   |   |   |-- config.yaml
+    |   |   |   `-- mouser.py
     |   |   |-- mover/
     |   |   |   |-- config.yaml
     |   |   |   `-- mover.py
@@ -32282,9 +32394,7 @@
     |   |   |-- pser/
     |   |   |   |-- config.yaml
     |   |   |   `-- pser.py
-    |   |   |-- pythonxer/
-    |   |   |   |-- config.yaml
-    |   |   |   `-- pythonxer.py</a:t>
+    |   |   |-- pythonxer/</a:t>
             </a:r>
           </a:p>
         </p:txBody>
@@ -32622,7 +32732,9 @@
                 </a:solidFill>
                 <a:latin typeface="Cascadia Mono"/>
               </a:rPr>
-              <a:t>    |   |   |-- raiser/
+              <a:t>    |   |   |   |-- config.yaml
+    |   |   |   `-- pythonxer.py
+    |   |   |-- raiser/
     |   |   |   |-- config.yaml
     |   |   |   `-- raiser.py
     |   |   |-- recmailer/
@@ -32650,9 +32762,7 @@
     |   |   |   |-- config.yaml
     |   |   |   `-- starter.py
     |   |   |-- stopper/
-    |   |   |   |-- config.yaml
-    |   |   |   `-- stopper.py
-    |   |   |-- summarizer/</a:t>
+    |   |   |   |-- config.yaml</a:t>
             </a:r>
           </a:p>
         </p:txBody>
@@ -33571,7 +33681,9 @@
                 </a:solidFill>
                 <a:latin typeface="Cascadia Mono"/>
               </a:rPr>
-              <a:t>    |   |   |   |-- config.yaml
+              <a:t>    |   |   |   `-- stopper.py
+    |   |   |-- summarizer/
+    |   |   |   |-- config.yaml
     |   |   |   `-- summarizer.py
     |   |   |-- telegramer/
     |   |   |   |-- config.yaml
@@ -33588,20 +33700,18 @@
     |   |   |-- whatsapper/
     |   |   |   |-- config.yaml
     |   |   |   `-- whatsapper.py
-    |   |   `-- whatstlamatini/
+    |   |   |-- whatstlamatini/
+    |   |   |   |-- config.yaml
+    |   |   |   `-- whatstlamatini.py
+    |   |   `-- windower/
     |   |       |-- config.yaml
-    |   |       `-- whatstlamatini.py
+    |   |       `-- windower.py
     |   |-- doc_generation/
     |   |   |-- complete_project_docs.py
     |   |   |-- mardown_to_pdf.py
     |   |   |-- refresh_project_docs.py
     |   |   `-- test_output.pdf
-    |   |-- images/
-    |   |   |-- mockup.jpg
-    |   |   |-- TlamatiniAbout.jpg
-    |   |   `-- XAIHT-Tlamatini.mp4
-    |   |-- imaging/
-    |   |   |-- converter.py</a:t>
+    |   |-- images/</a:t>
             </a:r>
           </a:p>
         </p:txBody>
@@ -33939,7 +34049,12 @@
                 </a:solidFill>
                 <a:latin typeface="Cascadia Mono"/>
               </a:rPr>
-              <a:t>    |   |   |-- image_interpreter.py
+              <a:t>    |   |   |-- mockup.jpg
+    |   |   |-- TlamatiniAbout.jpg
+    |   |   `-- XAIHT-Tlamatini.mp4
+    |   |-- imaging/
+    |   |   |-- converter.py
+    |   |   |-- image_interpreter.py
     |   |   `-- screenshot.py
     |   |-- management/
     |   |   |-- __init__.py
@@ -33964,12 +34079,7 @@
     |   |   |-- 0015_add_shoter.py
     |   |   |-- 0016_repopulate_all_agents.py
     |   |   |-- 0017_add_ssher.py
-    |   |   |-- 0018_repopulate_all_agents.py
-    |   |   |-- 0019_add_scper.py
-    |   |   |-- 0020_repopulate_all_agents.py
-    |   |   |-- 0021_add_telegramrx.py
-    |   |   |-- 0022_repopulate_all_agents.py
-    |   |   |-- 0023_add_mongoxer.py</a:t>
+    |   |   |-- 0018_repopulate_all_agents.py</a:t>
             </a:r>
           </a:p>
         </p:txBody>
@@ -34307,7 +34417,12 @@
                 </a:solidFill>
                 <a:latin typeface="Cascadia Mono"/>
               </a:rPr>
-              <a:t>    |   |   |-- 0024_repopulate_all_agents.py
+              <a:t>    |   |   |-- 0019_add_scper.py
+    |   |   |-- 0020_repopulate_all_agents.py
+    |   |   |-- 0021_add_telegramrx.py
+    |   |   |-- 0022_repopulate_all_agents.py
+    |   |   |-- 0023_add_mongoxer.py
+    |   |   |-- 0024_repopulate_all_agents.py
     |   |   |-- 0025_add_telegramer.py
     |   |   |-- 0026_repopulate_all_agents.py
     |   |   |-- 0027_add_sqler.py
@@ -34332,12 +34447,7 @@
     |   |   |-- 0046_add_image_interpreter.py
     |   |   |-- 0047_add_gatewayer.py
     |   |   |-- 0048_add_gateway_relayer.py
-    |   |   |-- 0049_add_node_manager.py
-    |   |   |-- 0050_add_file_creator.py
-    |   |   |-- 0051_add_file_extractor.py
-    |   |   |-- 0052_add_kyber_keygen.py
-    |   |   |-- 0053_add_kyber_cipher.py
-    |   |   |-- 0054_add_kyber_decipher.py</a:t>
+    |   |   |-- 0049_add_node_manager.py</a:t>
             </a:r>
           </a:p>
         </p:txBody>
@@ -34675,7 +34785,12 @@
                 </a:solidFill>
                 <a:latin typeface="Cascadia Mono"/>
               </a:rPr>
-              <a:t>    |   |   |-- 0055_fix_kyber_cipher_names.py
+              <a:t>    |   |   |-- 0050_add_file_creator.py
+    |   |   |-- 0051_add_file_extractor.py
+    |   |   |-- 0052_add_kyber_keygen.py
+    |   |   |-- 0053_add_kyber_cipher.py
+    |   |   |-- 0054_add_kyber_decipher.py
+    |   |   |-- 0055_fix_kyber_cipher_names.py
     |   |   |-- 0056_add_parametrizer.py
     |   |   |-- 0057_add_flowbacker.py
     |   |   |-- 0058_add_barrier.py
@@ -34700,12 +34815,7 @@
     |   |   |-- 0077_add_whatstlamatini.py
     |   |   |-- 0078_add_chat_agent_keyboarder_tool.py
     |   |   |-- 0079_add_chat_agent_mouser_tool.py
-    |   |   |-- 0080_add_chat_agent_sleeper_tool.py
-    |   |   |-- 0081_add_window_present_and_run_wait_tools.py
-    |   |   |-- 0082_add_chat_agent_j_decompiler_tool.py
-    |   |   |-- 0083_add_de_compresser.py
-    |   |   |-- 0084_add_chat_agent_de_compresser_tool.py
-    |   |   |-- 0085_add_unrealer.py</a:t>
+    |   |   |-- 0080_add_chat_agent_sleeper_tool.py</a:t>
             </a:r>
           </a:p>
         </p:txBody>
@@ -35043,13 +35153,21 @@
                 </a:solidFill>
                 <a:latin typeface="Cascadia Mono"/>
               </a:rPr>
-              <a:t>    |   |   |-- 0086_add_chat_agent_unrealer_tool.py
+              <a:t>    |   |   |-- 0081_add_window_present_and_run_wait_tools.py
+    |   |   |-- 0082_add_chat_agent_j_decompiler_tool.py
+    |   |   |-- 0083_add_de_compresser.py
+    |   |   |-- 0084_add_chat_agent_de_compresser_tool.py
+    |   |   |-- 0085_add_unrealer.py
+    |   |   |-- 0086_add_chat_agent_unrealer_tool.py
     |   |   |-- 0087_add_unrealer_demo_prompt.py
     |   |   |-- 0088_add_reviewer.py
     |   |   |-- 0089_add_analyzer.py
     |   |   |-- 0090_add_reviewer_analyzer_demo_prompts.py
     |   |   |-- 0091_add_playwrighter.py
     |   |   |-- 0092_add_chat_agent_playwrighter_tool.py
+    |   |   |-- 0093_add_windower.py
+    |   |   |-- 0094_add_chat_agent_windower_tool.py
+    |   |   |-- 0095_add_windower_playwrighter_demo_prompts.py
     |   |   `-- __init__.py
     |   |-- monitors/
     |   |   `-- monitor_sql.py
@@ -35065,15 +35183,7 @@
     |   |   |-- interface.py
     |   |   |-- loaders.py
     |   |   |-- prompts.py
-    |   |   |-- retrieval.py
-    |   |   |-- splitters.py
-    |   |   |-- utils.py
-    |   |   `-- chains/
-    |   |       |-- base.py
-    |   |       |-- basic.py
-    |   |       |-- history_aware.py
-    |   |       `-- unified.py
-    |   |-- services/</a:t>
+    |   |   |-- retrieval.py</a:t>
             </a:r>
           </a:p>
         </p:txBody>
@@ -35411,7 +35521,15 @@
                 </a:solidFill>
                 <a:latin typeface="Cascadia Mono"/>
               </a:rPr>
-              <a:t>    |   |   |-- __init__.py
+              <a:t>    |   |   |-- splitters.py
+    |   |   |-- utils.py
+    |   |   `-- chains/
+    |   |       |-- base.py
+    |   |       |-- basic.py
+    |   |       |-- history_aware.py
+    |   |       `-- unified.py
+    |   |-- services/
+    |   |   |-- __init__.py
     |   |   |-- agent_contracts.py
     |   |   |-- agent_paths.py
     |   |   |-- answer_analizer.py
@@ -35433,15 +35551,7 @@
     |   |   |   `-- SKILL.md
     |   |   |-- code_review/
     |   |   |   `-- SKILL.md
-    |   |   |-- github/
-    |   |   |   `-- SKILL.md
-    |   |   |-- gmail/
-    |   |   |   `-- SKILL.md
-    |   |   |-- hello_world/
-    |   |   |   `-- SKILL.md
-    |   |   |-- jira/
-    |   |   |   `-- SKILL.md
-    |   |   |-- notion/</a:t>
+    |   |   |-- github/</a:t>
             </a:r>
           </a:p>
         </p:txBody>
@@ -35780,6 +35890,14 @@
                 <a:latin typeface="Cascadia Mono"/>
               </a:rPr>
               <a:t>    |   |   |   `-- SKILL.md
+    |   |   |-- gmail/
+    |   |   |   `-- SKILL.md
+    |   |   |-- hello_world/
+    |   |   |   `-- SKILL.md
+    |   |   |-- jira/
+    |   |   |   `-- SKILL.md
+    |   |   |-- notion/
+    |   |   |   `-- SKILL.md
     |   |   |-- security_audit/
     |   |   |   `-- SKILL.md
     |   |   |-- setup_new_acpx_key/
@@ -35801,14 +35919,6 @@
     |   |   |-- tlamatini_flow_from_objective/
     |   |   |   `-- SKILL.md
     |   |   |-- tlamatini_flw_doctor/
-    |   |   |   `-- SKILL.md
-    |   |   |-- tlamatini_new_acp_agent/
-    |   |   |   `-- SKILL.md
-    |   |   |-- tlamatini_planner_trace_replay/
-    |   |   |   `-- SKILL.md
-    |   |   |-- tlamatini_static_version_bumper/
-    |   |   |   `-- SKILL.md
-    |   |   |-- todoist/
     |   |   |   `-- SKILL.md</a:t>
             </a:r>
           </a:p>
@@ -36147,7 +36257,15 @@
                 </a:solidFill>
                 <a:latin typeface="Cascadia Mono"/>
               </a:rPr>
-              <a:t>    |   |   |-- trello/
+              <a:t>    |   |   |-- tlamatini_new_acp_agent/
+    |   |   |   `-- SKILL.md
+    |   |   |-- tlamatini_planner_trace_replay/
+    |   |   |   `-- SKILL.md
+    |   |   |-- tlamatini_static_version_bumper/
+    |   |   |   `-- SKILL.md
+    |   |   |-- todoist/
+    |   |   |   `-- SKILL.md
+    |   |   |-- trello/
     |   |   |   `-- SKILL.md
     |   |   `-- weather/
     |   |       `-- SKILL.md
@@ -36169,15 +36287,7 @@
     |   |       |   |-- acp-canvas-undo.js
     |   |       |   |-- acp-control-buttons.js
     |   |       |   |-- acp-file-io.js
-    |   |       |   |-- acp-flow-snapshot.js
-    |   |       |   |-- acp-globals.js
-    |   |       |   |-- acp-layout.js
-    |   |       |   |-- acp-parametrizer-dialog.js
-    |   |       |   |-- acp-running-state.js
-    |   |       |   |-- acp-session.js
-    |   |       |   |-- acp-undo-manager.js
-    |   |       |   |-- acp-validate.js
-    |   |       |   |-- agent_page_canvas.js</a:t>
+    |   |       |   |-- acp-flow-snapshot.js</a:t>
             </a:r>
           </a:p>
         </p:txBody>
@@ -36515,7 +36625,15 @@
                 </a:solidFill>
                 <a:latin typeface="Cascadia Mono"/>
               </a:rPr>
-              <a:t>    |   |       |   |-- agent_page_chat.js
+              <a:t>    |   |       |   |-- acp-globals.js
+    |   |       |   |-- acp-layout.js
+    |   |       |   |-- acp-parametrizer-dialog.js
+    |   |       |   |-- acp-running-state.js
+    |   |       |   |-- acp-session.js
+    |   |       |   |-- acp-undo-manager.js
+    |   |       |   |-- acp-validate.js
+    |   |       |   |-- agent_page_canvas.js
+    |   |       |   |-- agent_page_chat.js
     |   |       |   |-- agent_page_context.js
     |   |       |   |-- agent_page_dialogs.js
     |   |       |   |-- agent_page_init.js
@@ -36537,15 +36655,7 @@
     |   |-- telegram/
     |   |   |-- AztecTlamatini.txt
     |   |   |-- config.yaml
-    |   |   `-- telegram_receiver.py
-    |   `-- templates/
-    |       `-- agent/
-    |           |-- agent_page.html
-    |           |-- agentic_control_panel.html
-    |           |-- login.html
-    |           `-- welcome.html
-    |-- DB/
-    |   |-- Older/</a:t>
+    |   |   `-- telegram_receiver.py</a:t>
             </a:r>
           </a:p>
         </p:txBody>
@@ -36883,7 +36993,15 @@
                 </a:solidFill>
                 <a:latin typeface="Cascadia Mono"/>
               </a:rPr>
-              <a:t>    |   |   `-- README.md
+              <a:t>    |   `-- templates/
+    |       `-- agent/
+    |           |-- agent_page.html
+    |           |-- agentic_control_panel.html
+    |           |-- login.html
+    |           `-- welcome.html
+    |-- DB/
+    |   |-- Older/
+    |   |   `-- README.md
     |   `-- ToLoad/
     |       `-- README.md
     |-- jd-cli/

</xml_diff>

<commit_message>
Updating graphical documentation to v1.7.1, by angelahack1
</commit_message>
<xml_diff>
--- a/Tlamatini_eXtended_Artificial_Intelligence_Humanly_Tempered.pptx
+++ b/Tlamatini_eXtended_Artificial_Intelligence_Humanly_Tempered.pptx
@@ -3614,7 +3614,7 @@
                 </a:solidFill>
                 <a:latin typeface="Aptos"/>
               </a:rPr>
-              <a:t>485</a:t>
+              <a:t>487</a:t>
             </a:r>
           </a:p>
         </p:txBody>
@@ -3844,7 +3844,7 @@
                 </a:solidFill>
                 <a:latin typeface="Aptos"/>
               </a:rPr>
-              <a:t>105,973</a:t>
+              <a:t>107,128</a:t>
             </a:r>
           </a:p>
         </p:txBody>
@@ -3879,7 +3879,7 @@
                 </a:solidFill>
                 <a:latin typeface="Aptos"/>
               </a:rPr>
-              <a:t>Generated May 22, 2026 09:20 PM UTC-0600 at HEAD e908dc9</a:t>
+              <a:t>Generated May 24, 2026 11:16 AM UTC-0600 at HEAD 413b1eb</a:t>
             </a:r>
           </a:p>
         </p:txBody>
@@ -5845,7 +5845,7 @@
               <a:rPr sz="1300" b="0" i="0">
                 <a:latin typeface="Calibri"/>
               </a:rPr>
-              <a:t>Some README lines still show the pre-Kalier 73-tool figure, so this dossier prefers the newer Book/git/live-registry state while preserving the rest of the README operator guidance.</a:t>
+              <a:t>README.md and BookOfTlamatini.md now agree on those counts, so the dossier can mirror the docs and the live registry without reconciliation footnotes.</a:t>
             </a:r>
             <a:endParaRPr sz="1300" b="0" i="0">
               <a:latin typeface="Calibri"/>
@@ -6350,7 +6350,7 @@
                 </a:solidFill>
                 <a:latin typeface="Aptos"/>
               </a:rPr>
-              <a:t>KALI LINUX CONTROL FOR CHAT AND CANVAS</a:t>
+              <a:t>EMBEDDED-CLIENT KALI LINUX CONTROL FOR CHAT AND CANVAS</a:t>
             </a:r>
           </a:p>
         </p:txBody>
@@ -6385,7 +6385,7 @@
                 </a:solidFill>
                 <a:latin typeface="Aptos Display"/>
               </a:rPr>
-              <a:t>Kalier In v1.7.0</a:t>
+              <a:t>Kalier In v1.7.1</a:t>
             </a:r>
           </a:p>
         </p:txBody>
@@ -6550,7 +6550,7 @@
               <a:rPr sz="1300" b="0" i="0">
                 <a:latin typeface="Calibri"/>
               </a:rPr>
-              <a:t>Kalier is the new 67th workflow agent in `v1.7.0`: a deterministic bridge from Tlamatini into Kali Linux offensive-security tooling through MCP-Kali-Server.</a:t>
+              <a:t>Kalier remains the 67th workflow agent in `v1.7.1`, but its newest upgrade is usability: Tlamatini now acts as the embedded MCP-Kali-Server client for chat-side runs.</a:t>
             </a:r>
             <a:endParaRPr sz="1300" b="0" i="0">
               <a:latin typeface="Calibri"/>
@@ -6600,152 +6600,6 @@
               <a:latin typeface="Calibri"/>
             </a:endParaRPr>
           </a:p>
-        </p:txBody>
-      </p:sp>
-      <p:sp>
-        <p:nvSpPr>
-          <p:cNvPr id="13" name="Rounded Rectangle 12"/>
-          <p:cNvSpPr/>
-          <p:nvPr/>
-        </p:nvSpPr>
-        <p:spPr>
-          <a:xfrm>
-            <a:off x="6355080" y="1463040"/>
-            <a:ext cx="5074920" cy="4526280"/>
-          </a:xfrm>
-          <a:prstGeom prst="roundRect">
-            <a:avLst/>
-          </a:prstGeom>
-          <a:solidFill>
-            <a:srgbClr val="161A19"/>
-          </a:solidFill>
-          <a:ln>
-            <a:solidFill>
-              <a:srgbClr val="595F56"/>
-            </a:solidFill>
-          </a:ln>
-        </p:spPr>
-        <p:style>
-          <a:lnRef idx="1">
-            <a:schemeClr val="accent1"/>
-          </a:lnRef>
-          <a:fillRef idx="3">
-            <a:schemeClr val="accent1"/>
-          </a:fillRef>
-          <a:effectRef idx="2">
-            <a:schemeClr val="accent1"/>
-          </a:effectRef>
-          <a:fontRef idx="minor">
-            <a:schemeClr val="lt1"/>
-          </a:fontRef>
-        </p:style>
-        <p:txBody>
-          <a:bodyPr rtlCol="0" anchor="ctr"/>
-          <a:lstStyle/>
-          <a:p>
-            <a:pPr algn="ctr"/>
-          </a:p>
-        </p:txBody>
-      </p:sp>
-      <p:sp>
-        <p:nvSpPr>
-          <p:cNvPr id="14" name="Rectangle 13"/>
-          <p:cNvSpPr/>
-          <p:nvPr/>
-        </p:nvSpPr>
-        <p:spPr>
-          <a:xfrm>
-            <a:off x="6355080" y="1463040"/>
-            <a:ext cx="5074920" cy="109728"/>
-          </a:xfrm>
-          <a:prstGeom prst="rect">
-            <a:avLst/>
-          </a:prstGeom>
-          <a:solidFill>
-            <a:srgbClr val="E0AB5D"/>
-          </a:solidFill>
-          <a:ln>
-            <a:noFill/>
-          </a:ln>
-        </p:spPr>
-        <p:style>
-          <a:lnRef idx="1">
-            <a:schemeClr val="accent1"/>
-          </a:lnRef>
-          <a:fillRef idx="3">
-            <a:schemeClr val="accent1"/>
-          </a:fillRef>
-          <a:effectRef idx="2">
-            <a:schemeClr val="accent1"/>
-          </a:effectRef>
-          <a:fontRef idx="minor">
-            <a:schemeClr val="lt1"/>
-          </a:fontRef>
-        </p:style>
-        <p:txBody>
-          <a:bodyPr rtlCol="0" anchor="ctr"/>
-          <a:lstStyle/>
-          <a:p>
-            <a:pPr algn="ctr"/>
-          </a:p>
-        </p:txBody>
-      </p:sp>
-      <p:sp>
-        <p:nvSpPr>
-          <p:cNvPr id="15" name="TextBox 14"/>
-          <p:cNvSpPr txBox="1"/>
-          <p:nvPr/>
-        </p:nvSpPr>
-        <p:spPr>
-          <a:xfrm>
-            <a:off x="6556248" y="1664208"/>
-            <a:ext cx="4672583" cy="310896"/>
-          </a:xfrm>
-          <a:prstGeom prst="rect">
-            <a:avLst/>
-          </a:prstGeom>
-          <a:noFill/>
-        </p:spPr>
-        <p:txBody>
-          <a:bodyPr wrap="square" anchor="t">
-            <a:spAutoFit/>
-          </a:bodyPr>
-          <a:lstStyle/>
-          <a:p>
-            <a:pPr algn="l"/>
-            <a:r>
-              <a:rPr sz="1400" b="1">
-                <a:solidFill>
-                  <a:srgbClr val="E0AB5D"/>
-                </a:solidFill>
-                <a:latin typeface="Aptos"/>
-              </a:rPr>
-              <a:t>How operators reach it</a:t>
-            </a:r>
-          </a:p>
-        </p:txBody>
-      </p:sp>
-      <p:sp>
-        <p:nvSpPr>
-          <p:cNvPr id="16" name="TextBox 15"/>
-          <p:cNvSpPr txBox="1"/>
-          <p:nvPr/>
-        </p:nvSpPr>
-        <p:spPr>
-          <a:xfrm>
-            <a:off x="6556248" y="2121408"/>
-            <a:ext cx="4672583" cy="3721608"/>
-          </a:xfrm>
-          <a:prstGeom prst="rect">
-            <a:avLst/>
-          </a:prstGeom>
-          <a:noFill/>
-        </p:spPr>
-        <p:txBody>
-          <a:bodyPr wrap="square" anchor="t" lIns="38100" rIns="38100" tIns="25400" bIns="25400">
-            <a:noAutofit/>
-          </a:bodyPr>
-          <a:lstStyle/>
           <a:p>
             <a:pPr>
               <a:spcAft>
@@ -6762,12 +6616,158 @@
               <a:rPr sz="1300" b="0" i="0">
                 <a:latin typeface="Calibri"/>
               </a:rPr>
-              <a:t>Two operator surfaces ship in lock-step: the wrapped Multi-Turn tool `chat_agent_kalier` accepts free-form key=value requests, while the visual Kalier canvas node stores the same operation fields in YAML.</a:t>
+              <a:t>The practical operator result is simpler prompts: after the Kali box URL is configured once, normal Multi-Turn requests no longer repeat `server_url` unless you intentionally override it for a one-off target.</a:t>
             </a:r>
             <a:endParaRPr sz="1300" b="0" i="0">
               <a:latin typeface="Calibri"/>
             </a:endParaRPr>
           </a:p>
+        </p:txBody>
+      </p:sp>
+      <p:sp>
+        <p:nvSpPr>
+          <p:cNvPr id="13" name="Rounded Rectangle 12"/>
+          <p:cNvSpPr/>
+          <p:nvPr/>
+        </p:nvSpPr>
+        <p:spPr>
+          <a:xfrm>
+            <a:off x="6355080" y="1463040"/>
+            <a:ext cx="5074920" cy="4526280"/>
+          </a:xfrm>
+          <a:prstGeom prst="roundRect">
+            <a:avLst/>
+          </a:prstGeom>
+          <a:solidFill>
+            <a:srgbClr val="161A19"/>
+          </a:solidFill>
+          <a:ln>
+            <a:solidFill>
+              <a:srgbClr val="595F56"/>
+            </a:solidFill>
+          </a:ln>
+        </p:spPr>
+        <p:style>
+          <a:lnRef idx="1">
+            <a:schemeClr val="accent1"/>
+          </a:lnRef>
+          <a:fillRef idx="3">
+            <a:schemeClr val="accent1"/>
+          </a:fillRef>
+          <a:effectRef idx="2">
+            <a:schemeClr val="accent1"/>
+          </a:effectRef>
+          <a:fontRef idx="minor">
+            <a:schemeClr val="lt1"/>
+          </a:fontRef>
+        </p:style>
+        <p:txBody>
+          <a:bodyPr rtlCol="0" anchor="ctr"/>
+          <a:lstStyle/>
+          <a:p>
+            <a:pPr algn="ctr"/>
+          </a:p>
+        </p:txBody>
+      </p:sp>
+      <p:sp>
+        <p:nvSpPr>
+          <p:cNvPr id="14" name="Rectangle 13"/>
+          <p:cNvSpPr/>
+          <p:nvPr/>
+        </p:nvSpPr>
+        <p:spPr>
+          <a:xfrm>
+            <a:off x="6355080" y="1463040"/>
+            <a:ext cx="5074920" cy="109728"/>
+          </a:xfrm>
+          <a:prstGeom prst="rect">
+            <a:avLst/>
+          </a:prstGeom>
+          <a:solidFill>
+            <a:srgbClr val="E0AB5D"/>
+          </a:solidFill>
+          <a:ln>
+            <a:noFill/>
+          </a:ln>
+        </p:spPr>
+        <p:style>
+          <a:lnRef idx="1">
+            <a:schemeClr val="accent1"/>
+          </a:lnRef>
+          <a:fillRef idx="3">
+            <a:schemeClr val="accent1"/>
+          </a:fillRef>
+          <a:effectRef idx="2">
+            <a:schemeClr val="accent1"/>
+          </a:effectRef>
+          <a:fontRef idx="minor">
+            <a:schemeClr val="lt1"/>
+          </a:fontRef>
+        </p:style>
+        <p:txBody>
+          <a:bodyPr rtlCol="0" anchor="ctr"/>
+          <a:lstStyle/>
+          <a:p>
+            <a:pPr algn="ctr"/>
+          </a:p>
+        </p:txBody>
+      </p:sp>
+      <p:sp>
+        <p:nvSpPr>
+          <p:cNvPr id="15" name="TextBox 14"/>
+          <p:cNvSpPr txBox="1"/>
+          <p:nvPr/>
+        </p:nvSpPr>
+        <p:spPr>
+          <a:xfrm>
+            <a:off x="6556248" y="1664208"/>
+            <a:ext cx="4672583" cy="310896"/>
+          </a:xfrm>
+          <a:prstGeom prst="rect">
+            <a:avLst/>
+          </a:prstGeom>
+          <a:noFill/>
+        </p:spPr>
+        <p:txBody>
+          <a:bodyPr wrap="square" anchor="t">
+            <a:spAutoFit/>
+          </a:bodyPr>
+          <a:lstStyle/>
+          <a:p>
+            <a:pPr algn="l"/>
+            <a:r>
+              <a:rPr sz="1400" b="1">
+                <a:solidFill>
+                  <a:srgbClr val="E0AB5D"/>
+                </a:solidFill>
+                <a:latin typeface="Aptos"/>
+              </a:rPr>
+              <a:t>How operators reach it</a:t>
+            </a:r>
+          </a:p>
+        </p:txBody>
+      </p:sp>
+      <p:sp>
+        <p:nvSpPr>
+          <p:cNvPr id="16" name="TextBox 15"/>
+          <p:cNvSpPr txBox="1"/>
+          <p:nvPr/>
+        </p:nvSpPr>
+        <p:spPr>
+          <a:xfrm>
+            <a:off x="6556248" y="2121408"/>
+            <a:ext cx="4672583" cy="3721608"/>
+          </a:xfrm>
+          <a:prstGeom prst="rect">
+            <a:avLst/>
+          </a:prstGeom>
+          <a:noFill/>
+        </p:spPr>
+        <p:txBody>
+          <a:bodyPr wrap="square" anchor="t" lIns="38100" rIns="38100" tIns="25400" bIns="25400">
+            <a:noAutofit/>
+          </a:bodyPr>
+          <a:lstStyle/>
           <a:p>
             <a:pPr>
               <a:spcAft>
@@ -6784,7 +6784,7 @@
               <a:rPr sz="1300" b="0" i="0">
                 <a:latin typeface="Calibri"/>
               </a:rPr>
-              <a:t>Kalier talks straight to the Kali-side Flask API over HTTP using Python-stdlib `urllib`, so it stays self-contained in the pool subprocess and works the same in source or frozen builds.</a:t>
+              <a:t>Two operator surfaces ship in lock-step: the wrapped Multi-Turn tool `chat_agent_kalier` now auto-injects the configured `kali_server_url`, while the visual Kalier canvas node still stores `server_url` explicitly in YAML per node.</a:t>
             </a:r>
             <a:endParaRPr sz="1300" b="0" i="0">
               <a:latin typeface="Calibri"/>
@@ -6806,7 +6806,29 @@
               <a:rPr sz="1300" b="0" i="0">
                 <a:latin typeface="Calibri"/>
               </a:rPr>
-              <a:t>Authorized use only: the intended operator flow is an in-scope lab, CTF, or permitted engagement, often with `ssh -L 5000:localhost:5000 user@KALI_IP` tunneling a remote Kali box back to `http://127.0.0.1:5000`.</a:t>
+              <a:t>Kalier talks straight to the Kali-side Flask API over HTTP using Python-stdlib `urllib`, so it stays self-contained in the pool subprocess and works the same in source or frozen builds; the embedded-client injection fails open if the config value is blank or unreadable.</a:t>
+            </a:r>
+            <a:endParaRPr sz="1300" b="0" i="0">
+              <a:latin typeface="Calibri"/>
+            </a:endParaRPr>
+          </a:p>
+          <a:p>
+            <a:pPr>
+              <a:spcAft>
+                <a:spcPts val="600"/>
+              </a:spcAft>
+              <a:defRPr sz="1300">
+                <a:solidFill>
+                  <a:srgbClr val="B4BAAE"/>
+                </a:solidFill>
+                <a:latin typeface="Aptos"/>
+              </a:defRPr>
+            </a:pPr>
+            <a:r>
+              <a:rPr sz="1300" b="0" i="0">
+                <a:latin typeface="Calibri"/>
+              </a:rPr>
+              <a:t>Authorized use only: the intended operator flow is an in-scope lab, CTF, or permitted engagement, often with `ssh -L 5000:localhost:5000 user@KALI_IP` tunneling a remote Kali box back to `http://127.0.0.1:5000`, and the repo now includes `Tlamatini-Kali-Setup.md` for the zero-client walkthrough.</a:t>
             </a:r>
             <a:endParaRPr sz="1300" b="0" i="0">
               <a:latin typeface="Calibri"/>
@@ -11124,7 +11146,7 @@
               <a:rPr sz="1300" b="0" i="0">
                 <a:latin typeface="Calibri"/>
               </a:rPr>
-              <a:t>For authorized Kali Linux assessments, run MCP-Kali-Server on the Kali box, expose it locally or through an SSH tunnel, and call `chat_agent_kalier` from Multi-Turn with the desired `action`, `target`, and `server_url`.</a:t>
+              <a:t>For authorized Kali Linux assessments, run MCP-Kali-Server on the Kali box, set `Config -&gt; URLs -&gt; Kali server (Kalier)` once, and then call `chat_agent_kalier` from Multi-Turn with the desired `action` and `target` without repeating the box URL each turn.</a:t>
             </a:r>
             <a:endParaRPr sz="1300" b="0" i="0">
               <a:latin typeface="Calibri"/>
@@ -13310,6 +13332,28 @@
               <a:rPr sz="1500" b="0" i="0">
                 <a:latin typeface="Calibri"/>
               </a:rPr>
+              <a:t>URL configuration now also includes `kali_server_url`, edited from `Config -&gt; URLs -&gt; Kali server (Kalier)`, which is the default box that chat-side Kalier runs inherit automatically.</a:t>
+            </a:r>
+            <a:endParaRPr sz="1500" b="0" i="0">
+              <a:latin typeface="Calibri"/>
+            </a:endParaRPr>
+          </a:p>
+          <a:p>
+            <a:pPr>
+              <a:spcAft>
+                <a:spcPts val="600"/>
+              </a:spcAft>
+              <a:defRPr sz="1500">
+                <a:solidFill>
+                  <a:srgbClr val="B4BAAE"/>
+                </a:solidFill>
+                <a:latin typeface="Aptos"/>
+              </a:defRPr>
+            </a:pPr>
+            <a:r>
+              <a:rPr sz="1500" b="0" i="0">
+                <a:latin typeface="Calibri"/>
+              </a:rPr>
               <a:t>The chat-side Config -&gt; Models and Config -&gt; URLs dialogs are now first-class configuration surfaces, and they can explicitly ask the operator to reconnect when saved values change live-session assumptions.</a:t>
             </a:r>
             <a:endParaRPr sz="1500" b="0" i="0">
@@ -14103,7 +14147,7 @@
               <a:rPr sz="1300" b="0" i="0">
                 <a:latin typeface="Calibri"/>
               </a:rPr>
-              <a:t>Those readability rules remain in force in the current documentation set, and the newer `v1.7.0` release state keeps the version badge, runtime surfaces, and operator handbook aligned.</a:t>
+              <a:t>Those readability rules remain in force in the current documentation set, and the newer `v1.7.1` release state keeps the version badge, runtime surfaces, and operator handbook aligned.</a:t>
             </a:r>
             <a:endParaRPr sz="1300" b="0" i="0">
               <a:latin typeface="Calibri"/>
@@ -15617,7 +15661,7 @@
                 </a:solidFill>
                 <a:latin typeface="Cascadia Mono"/>
               </a:rPr>
-              <a:t>Resolved current version: 1.7.0 | build: 1.7.0</a:t>
+              <a:t>Resolved current version: 1.7.1 | build: 1.7.1</a:t>
             </a:r>
           </a:p>
         </p:txBody>
@@ -25387,7 +25431,7 @@
                 </a:solidFill>
                 <a:latin typeface="Aptos"/>
               </a:rPr>
-              <a:t>485</a:t>
+              <a:t>487</a:t>
             </a:r>
           </a:p>
         </p:txBody>
@@ -26127,7 +26171,7 @@
               <a:rPr sz="1500" b="0" i="0">
                 <a:latin typeface="Calibri"/>
               </a:rPr>
-              <a:t>e908dc9 - Setting version to documentation as 1.7.0, by Tlamatini's-AutoBot.</a:t>
+              <a:t>413b1eb - Updating markdown documentation to align them to v1.7.1, by angelahack1</a:t>
             </a:r>
             <a:endParaRPr sz="1500" b="0" i="0">
               <a:latin typeface="Calibri"/>
@@ -26149,7 +26193,7 @@
               <a:rPr sz="1500" b="0" i="0">
                 <a:latin typeface="Calibri"/>
               </a:rPr>
-              <a:t>Resolved version: 1.7.0 (git)</a:t>
+              <a:t>Resolved version: 1.7.1 (git)</a:t>
             </a:r>
             <a:endParaRPr sz="1500" b="0" i="0">
               <a:latin typeface="Calibri"/>
@@ -26171,7 +26215,7 @@
               <a:rPr sz="1500" b="0" i="0">
                 <a:latin typeface="Calibri"/>
               </a:rPr>
-              <a:t>Generated on May 22, 2026 09:20 PM UTC-0600</a:t>
+              <a:t>Generated on May 24, 2026 11:16 AM UTC-0600</a:t>
             </a:r>
             <a:endParaRPr sz="1500" b="0" i="0">
               <a:latin typeface="Calibri"/>
@@ -26658,7 +26702,7 @@
                 </a:solidFill>
                 <a:latin typeface="Aptos"/>
               </a:rPr>
-              <a:t>105,973</a:t>
+              <a:t>107,128</a:t>
             </a:r>
           </a:p>
         </p:txBody>
@@ -26773,7 +26817,7 @@
                 </a:solidFill>
                 <a:latin typeface="Aptos"/>
               </a:rPr>
-              <a:t>144,418</a:t>
+              <a:t>145,853</a:t>
             </a:r>
           </a:p>
         </p:txBody>
@@ -26924,17 +26968,17 @@
                 <a:latin typeface="Cascadia Mono"/>
               </a:rPr>
               <a:t>LANGUAGE                 FILES   EFFECTIVE      TOTAL   SHARE
-Python                   284      72,022    100,448  68.0%
-JavaScript                28      13,092     16,465  12.4%
-Markdown                  54      12,250     15,726  11.6%
+Python                   284      72,246    100,776  67.4%
+Markdown                  56      13,173     16,819  12.3%
+JavaScript                28      13,092     16,465  12.2%
 CSS                        6       3,414      4,317   3.2%
-YAML                      71       1,457      3,048   1.4%
-HTML                       4         823        841   0.8%
+YAML                      71       1,457      3,054   1.4%
+HTML                       4         829        847   0.8%
 Other text                 3         789        967   0.7%
 Prompt template            2         632        745   0.6%
 PowerShell                 5         506        752   0.5%
 JavaScript module          1         393        460   0.4%
-JSON                       5         383        383   0.4%
+JSON                       5         385        385   0.4%
 Text                       5         179        209   0.2%
 Protocol Buffers           1          20         33   0.0%
 Batch                      1          13         24   0.0%</a:t>
@@ -27276,12 +27320,12 @@
                 <a:latin typeface="Cascadia Mono"/>
               </a:rPr>
               <a:t>PATH                                                     LANGUAGE     EFFECTIVE   TOTAL
-Tlamatini/agent/views.py                                Python         7,218  10,426
+Tlamatini/agent/views.py                                Python         7,220  10,431
 Tlamatini/agent/tests.py                                Python         4,034   5,153
-Tlamatini/agent/tools.py                                Python         2,201   3,121
+Tlamatini/agent/tools.py                                Python         2,219   3,158
 Tlamatini/agent/agents/flowcreator/agentic_skill.md     Markdown       1,936   2,148
-BookOfTlamatini.md                                      Markdown       1,903   2,683
-Tlamatini/agent/doc_generation/complete_project_docs.py Python         1,816   2,048
+BookOfTlamatini.md                                      Markdown       1,905   2,686
+Tlamatini/agent/doc_generation/complete_project_docs.py Python         1,818   2,050
 ...ini/agent/static/agent/css/agentic_control_panel.css CSS            1,709   2,279
 Tlamatini/agent/static/agent/js/agent_page_init.js      JavaScript     1,374   1,591
 Tlamatini/agent/static/agent/js/acp-canvas-core.js      JavaScript     1,299   1,609
@@ -27757,94 +27801,6 @@
               <a:rPr sz="1500" b="0" i="0">
                 <a:latin typeface="Calibri"/>
               </a:rPr>
-              <a:t>Today’s headline change is the new Kalier agent in `v1.7.0`: Tlamatini now reaches 67 workflow agents and adds a direct bridge into Kali Linux offensive-security tooling through MCP-Kali-Server, available from both Multi-Turn chat and the visual canvas.</a:t>
-            </a:r>
-            <a:endParaRPr sz="1500" b="0" i="0">
-              <a:latin typeface="Calibri"/>
-            </a:endParaRPr>
-          </a:p>
-          <a:p>
-            <a:pPr>
-              <a:spcAft>
-                <a:spcPts val="600"/>
-              </a:spcAft>
-              <a:defRPr sz="1500">
-                <a:solidFill>
-                  <a:srgbClr val="B4BAAE"/>
-                </a:solidFill>
-                <a:latin typeface="Aptos"/>
-              </a:defRPr>
-            </a:pPr>
-            <a:r>
-              <a:rPr sz="1500" b="0" i="0">
-                <a:latin typeface="Calibri"/>
-              </a:rPr>
-              <a:t>Today’s headline change is the new Windower agent: Tlamatini now reaches 66 workflow agents and adds a deterministic Win32 window-manager surface for focusing, tiling, resizing, listing, and closing windows from both Multi-Turn chat and the visual canvas.</a:t>
-            </a:r>
-            <a:endParaRPr sz="1500" b="0" i="0">
-              <a:latin typeface="Calibri"/>
-            </a:endParaRPr>
-          </a:p>
-          <a:p>
-            <a:pPr>
-              <a:spcAft>
-                <a:spcPts val="600"/>
-              </a:spcAft>
-              <a:defRPr sz="1500">
-                <a:solidFill>
-                  <a:srgbClr val="B4BAAE"/>
-                </a:solidFill>
-                <a:latin typeface="Aptos"/>
-              </a:defRPr>
-            </a:pPr>
-            <a:r>
-              <a:rPr sz="1500" b="0" i="0">
-                <a:latin typeface="Calibri"/>
-              </a:rPr>
-              <a:t>Today’s headline change is the new Playwrighter agent in `v1.5.0`: Tlamatini now adds its 65th workflow agent and a real-browser automation surface for scripted Playwright flows from both Multi-Turn chat and the visual canvas.</a:t>
-            </a:r>
-            <a:endParaRPr sz="1500" b="0" i="0">
-              <a:latin typeface="Calibri"/>
-            </a:endParaRPr>
-          </a:p>
-          <a:p>
-            <a:pPr>
-              <a:spcAft>
-                <a:spcPts val="600"/>
-              </a:spcAft>
-              <a:defRPr sz="1500">
-                <a:solidFill>
-                  <a:srgbClr val="B4BAAE"/>
-                </a:solidFill>
-                <a:latin typeface="Aptos"/>
-              </a:defRPr>
-            </a:pPr>
-            <a:r>
-              <a:rPr sz="1500" b="0" i="0">
-                <a:latin typeface="Calibri"/>
-              </a:rPr>
-              <a:t>Today’s headline change is the new versioning system: SemVer policy, git-tag sourcing, runtime version surfaces, and build-time embedding across the Windows artefacts.</a:t>
-            </a:r>
-            <a:endParaRPr sz="1500" b="0" i="0">
-              <a:latin typeface="Calibri"/>
-            </a:endParaRPr>
-          </a:p>
-          <a:p>
-            <a:pPr>
-              <a:spcAft>
-                <a:spcPts val="600"/>
-              </a:spcAft>
-              <a:defRPr sz="1500">
-                <a:solidFill>
-                  <a:srgbClr val="B4BAAE"/>
-                </a:solidFill>
-                <a:latin typeface="Aptos"/>
-              </a:defRPr>
-            </a:pPr>
-            <a:r>
-              <a:rPr sz="1500" b="0" i="0">
-                <a:latin typeface="Calibri"/>
-              </a:rPr>
               <a:t>Documentation itself changed today, so the regenerated dossier is part of the tracked operator surface rather than an external afterthought.</a:t>
             </a:r>
             <a:endParaRPr sz="1500" b="0" i="0">
@@ -29180,12 +29136,12 @@
               </a:defRPr>
             </a:pPr>
             <a:r>
-              <a:rPr sz="800" b="0" i="0">
+              <a:rPr sz="700" b="0" i="0">
                 <a:latin typeface="Calibri"/>
               </a:rPr>
               <a:t>Before a heavy directory embedding run on supported NVIDIA hosts, a fail-open pre-flight guard can estimate VRAM pressure and surface a non-blocking warning in chat.</a:t>
             </a:r>
-            <a:endParaRPr sz="800" b="0" i="0">
+            <a:endParaRPr sz="700" b="0" i="0">
               <a:latin typeface="Calibri"/>
             </a:endParaRPr>
           </a:p>
@@ -29202,12 +29158,12 @@
               </a:defRPr>
             </a:pPr>
             <a:r>
-              <a:rPr sz="800" b="0" i="0">
+              <a:rPr sz="700" b="0" i="0">
                 <a:latin typeface="Calibri"/>
               </a:rPr>
               <a:t>Version resolution now flows through git tags, a runtime resolver module, generated build artefacts, and an open `/agent/version/` endpoint.</a:t>
             </a:r>
-            <a:endParaRPr sz="800" b="0" i="0">
+            <a:endParaRPr sz="700" b="0" i="0">
               <a:latin typeface="Calibri"/>
             </a:endParaRPr>
           </a:p>
@@ -29224,12 +29180,12 @@
               </a:defRPr>
             </a:pPr>
             <a:r>
-              <a:rPr sz="800" b="0" i="0">
+              <a:rPr sz="700" b="0" i="0">
                 <a:latin typeface="Calibri"/>
               </a:rPr>
               <a:t>When Multi-Turn is enabled, the global planner selects context and tool stages before the executor binds only the relevant tools, including wrapped deterministic agents such as De-Compresser.</a:t>
             </a:r>
-            <a:endParaRPr sz="800" b="0" i="0">
+            <a:endParaRPr sz="700" b="0" i="0">
               <a:latin typeface="Calibri"/>
             </a:endParaRPr>
           </a:p>
@@ -29246,12 +29202,12 @@
               </a:defRPr>
             </a:pPr>
             <a:r>
-              <a:rPr sz="800" b="0" i="0">
+              <a:rPr sz="700" b="0" i="0">
                 <a:latin typeface="Calibri"/>
               </a:rPr>
-              <a:t>The Kalier path talks directly to the MCP-Kali-Server Flask API over HTTP with Python-stdlib `urllib`, choosing one offensive-security capability per call and capturing the result in one atomic `INI_SECTION_KALIER` block.</a:t>
-            </a:r>
-            <a:endParaRPr sz="800" b="0" i="0">
+              <a:t>The Kalier path talks directly to the MCP-Kali-Server Flask API over HTTP with Python-stdlib `urllib`, auto-seeding the default box from `kali_server_url` in Config -&gt; URLs before any one-off per-call override is applied, and captures one atomic `INI_SECTION_KALIER` block per run.</a:t>
+            </a:r>
+            <a:endParaRPr sz="700" b="0" i="0">
               <a:latin typeface="Calibri"/>
             </a:endParaRPr>
           </a:p>
@@ -29268,12 +29224,12 @@
               </a:defRPr>
             </a:pPr>
             <a:r>
-              <a:rPr sz="800" b="0" i="0">
+              <a:rPr sz="700" b="0" i="0">
                 <a:latin typeface="Calibri"/>
               </a:rPr>
               <a:t>The Windower path uses Win32 APIs plus the cross-process `AttachThreadInput` focus-transfer dance to locate windows by title and apply one lifecycle action while still returning structured geometry/state fields.</a:t>
             </a:r>
-            <a:endParaRPr sz="800" b="0" i="0">
+            <a:endParaRPr sz="700" b="0" i="0">
               <a:latin typeface="Calibri"/>
             </a:endParaRPr>
           </a:p>
@@ -29290,12 +29246,12 @@
               </a:defRPr>
             </a:pPr>
             <a:r>
-              <a:rPr sz="800" b="0" i="0">
+              <a:rPr sz="700" b="0" i="0">
                 <a:latin typeface="Calibri"/>
               </a:rPr>
               <a:t>The Playwrighter path loads a declarative step list, drives Playwright against Chromium/Firefox/WebKit, and emits one atomic `INI_SECTION_PLAYWRIGHTER` block with status, assertions, extracted values, and the final URL.</a:t>
             </a:r>
-            <a:endParaRPr sz="800" b="0" i="0">
+            <a:endParaRPr sz="700" b="0" i="0">
               <a:latin typeface="Calibri"/>
             </a:endParaRPr>
           </a:p>
@@ -29312,12 +29268,12 @@
               </a:defRPr>
             </a:pPr>
             <a:r>
-              <a:rPr sz="800" b="0" i="0">
+              <a:rPr sz="700" b="0" i="0">
                 <a:latin typeface="Calibri"/>
               </a:rPr>
               <a:t>The Unrealer path opens a TCP socket to the Unreal MCP plugin, sends one `{"type": command, "params": {...}}` payload, captures the JSON reply, and emits one `INI_SECTION_UNREALER` block for downstream logic.</a:t>
             </a:r>
-            <a:endParaRPr sz="800" b="0" i="0">
+            <a:endParaRPr sz="700" b="0" i="0">
               <a:latin typeface="Calibri"/>
             </a:endParaRPr>
           </a:p>
@@ -29334,12 +29290,12 @@
               </a:defRPr>
             </a:pPr>
             <a:r>
-              <a:rPr sz="800" b="0" i="0">
+              <a:rPr sz="700" b="0" i="0">
                 <a:latin typeface="Calibri"/>
               </a:rPr>
               <a:t>After spawn-capable tool calls and again after the final answer, the orphan reaper can sweep dead descendants, orphaned `conhost.exe` companions, and stale pool-linked processes without ever raising into the chat path.</a:t>
             </a:r>
-            <a:endParaRPr sz="800" b="0" i="0">
+            <a:endParaRPr sz="700" b="0" i="0">
               <a:latin typeface="Calibri"/>
             </a:endParaRPr>
           </a:p>
@@ -29356,12 +29312,12 @@
               </a:defRPr>
             </a:pPr>
             <a:r>
-              <a:rPr sz="800" b="0" i="0">
+              <a:rPr sz="700" b="0" i="0">
                 <a:latin typeface="Calibri"/>
               </a:rPr>
               <a:t>Tool calls execute in the backend, append observations, and may create wrapped runtime copies under `agent/agents/pools/_chat_runs_/`.</a:t>
             </a:r>
-            <a:endParaRPr sz="800" b="0" i="0">
+            <a:endParaRPr sz="700" b="0" i="0">
               <a:latin typeface="Calibri"/>
             </a:endParaRPr>
           </a:p>
@@ -29378,12 +29334,12 @@
               </a:defRPr>
             </a:pPr>
             <a:r>
-              <a:rPr sz="800" b="0" i="0">
+              <a:rPr sz="700" b="0" i="0">
                 <a:latin typeface="Calibri"/>
               </a:rPr>
               <a:t>On the next full start-up, `manage.py` can swap a staged database into place before Django imports, while archiving the previous live database under `DB/Older/&lt;timestamp&gt;/`.</a:t>
             </a:r>
-            <a:endParaRPr sz="800" b="0" i="0">
+            <a:endParaRPr sz="700" b="0" i="0">
               <a:latin typeface="Calibri"/>
             </a:endParaRPr>
           </a:p>
@@ -29400,12 +29356,12 @@
               </a:defRPr>
             </a:pPr>
             <a:r>
-              <a:rPr sz="800" b="0" i="0">
+              <a:rPr sz="700" b="0" i="0">
                 <a:latin typeface="Calibri"/>
               </a:rPr>
               <a:t>ACP flows deploy session-scoped pool instances, wire config values, validate NxN graph rules, and execute through Starter-driven flow semantics.</a:t>
             </a:r>
-            <a:endParaRPr sz="800" b="0" i="0">
+            <a:endParaRPr sz="700" b="0" i="0">
               <a:latin typeface="Calibri"/>
             </a:endParaRPr>
           </a:p>
@@ -29422,12 +29378,12 @@
               </a:defRPr>
             </a:pPr>
             <a:r>
-              <a:rPr sz="800" b="0" i="0">
+              <a:rPr sz="700" b="0" i="0">
                 <a:latin typeface="Calibri"/>
               </a:rPr>
               <a:t>Build scripts collect static assets, bundle Django/Python resources, add agent templates, and assemble `pkg.zip`, `Uninstaller.exe`, and `dist/Tlamatini_Release/`.</a:t>
             </a:r>
-            <a:endParaRPr sz="800" b="0" i="0">
+            <a:endParaRPr sz="700" b="0" i="0">
               <a:latin typeface="Calibri"/>
             </a:endParaRPr>
           </a:p>
@@ -29896,51 +29852,7 @@
               <a:rPr sz="1200" b="0" i="0">
                 <a:latin typeface="Calibri"/>
               </a:rPr>
-              <a:t>2026-05-22 | e908dc9 | Setting version to documentation as 1.7.0, by Tlamatini's-AutoBot.</a:t>
-            </a:r>
-            <a:endParaRPr sz="1200" b="0" i="0">
-              <a:latin typeface="Calibri"/>
-            </a:endParaRPr>
-          </a:p>
-          <a:p>
-            <a:pPr>
-              <a:spcAft>
-                <a:spcPts val="600"/>
-              </a:spcAft>
-              <a:defRPr sz="1200">
-                <a:solidFill>
-                  <a:srgbClr val="B4BAAE"/>
-                </a:solidFill>
-                <a:latin typeface="Aptos"/>
-              </a:defRPr>
-            </a:pPr>
-            <a:r>
-              <a:rPr sz="1200" b="0" i="0">
-                <a:latin typeface="Calibri"/>
-              </a:rPr>
-              <a:t>2026-05-22 | adca0b7 | Kalier agent added to make strong a powerfull assessments with Kali Linux!!!, by Tlamatini's-AutoBot.</a:t>
-            </a:r>
-            <a:endParaRPr sz="1200" b="0" i="0">
-              <a:latin typeface="Calibri"/>
-            </a:endParaRPr>
-          </a:p>
-          <a:p>
-            <a:pPr>
-              <a:spcAft>
-                <a:spcPts val="600"/>
-              </a:spcAft>
-              <a:defRPr sz="1200">
-                <a:solidFill>
-                  <a:srgbClr val="B4BAAE"/>
-                </a:solidFill>
-                <a:latin typeface="Aptos"/>
-              </a:defRPr>
-            </a:pPr>
-            <a:r>
-              <a:rPr sz="1200" b="0" i="0">
-                <a:latin typeface="Calibri"/>
-              </a:rPr>
-              <a:t>2026-05-22 | d697e7e | Some new sample prompts for Playwrighter and Windower, by Tlamatini's-AutoBot.</a:t>
+              <a:t>2026-05-24 | 413b1eb | Updating markdown documentation to align them to v1.7.1, by angelahack1</a:t>
             </a:r>
             <a:endParaRPr sz="1200" b="0" i="0">
               <a:latin typeface="Calibri"/>
@@ -30290,6 +30202,7 @@
 |-- build.py
 |-- build_installer.py
 |-- build_uninstaller.py
+|-- Claude-Desktop-KALI-MCP-Session.md
 |-- CLAUDE.md
 |-- CreateShortcut.json
 |-- CreateShortcut.ps1
@@ -30307,11 +30220,10 @@
 |-- register_flw.ps1
 |-- RemoveShortcut.ps1
 |-- requirements.txt
+|-- Tlamatini-Kali-Setup.md
 |-- Tlamatini.ico
 |-- Tlamatini.jpg
-|-- Tlamatini.ps1
-|-- tlamatini_app_summary.pdf
-|-- Tlamatini_eXtended_Artificial_Intelligence_Humanly_Tempered.pptx</a:t>
+|-- Tlamatini.ps1</a:t>
             </a:r>
           </a:p>
         </p:txBody>
@@ -30649,7 +30561,9 @@
                 </a:solidFill>
                 <a:latin typeface="Cascadia Mono"/>
               </a:rPr>
-              <a:t>|-- uninstall.py
+              <a:t>|-- tlamatini_app_summary.pdf
+|-- Tlamatini_eXtended_Artificial_Intelligence_Humanly_Tempered.pptx
+|-- uninstall.py
 |-- unregister_flw.ps1
 |-- VERSIONING.md
 |-- versioning.py
@@ -30677,9 +30591,7 @@
 |-- pyinstaller_hooks/
 |   `-- hook-numpy.py
 `-- Tlamatini/
-    |-- cat_art.py
-    |-- manage.py
-    |-- .agents/</a:t>
+    |-- cat_art.py</a:t>
             </a:r>
           </a:p>
         </p:txBody>
@@ -31017,7 +30929,9 @@
                 </a:solidFill>
                 <a:latin typeface="Cascadia Mono"/>
               </a:rPr>
-              <a:t>    |   `-- workflows/
+              <a:t>    |-- manage.py
+    |-- .agents/
+    |   `-- workflows/
     |       `-- create_new_agent.md
     |-- .mcps/
     |   `-- create_new_mcp.md
@@ -31045,9 +30959,7 @@
     |   |-- gpu_perf.py
     |   |-- inet_determiner.py
     |   |-- mcp_agent.py
-    |   |-- mcp_files_search_client.py
-    |   |-- mcp_files_search_server.py
-    |   |-- mcp_system_client.py</a:t>
+    |   |-- mcp_files_search_client.py</a:t>
             </a:r>
           </a:p>
         </p:txBody>
@@ -31385,7 +31297,9 @@
                 </a:solidFill>
                 <a:latin typeface="Cascadia Mono"/>
               </a:rPr>
-              <a:t>    |   |-- mcp_system_server.py
+              <a:t>    |   |-- mcp_files_search_server.py
+    |   |-- mcp_system_client.py
+    |   |-- mcp_system_server.py
     |   |-- models.py
     |   |-- native_dialogs.py
     |   |-- orphan_reaper.py
@@ -31413,9 +31327,7 @@
     |   |   |-- agent_registry.py
     |   |   |-- config.py
     |   |   |-- permissions.py
-    |   |   |-- runtime.py
-    |   |   |-- service.py
-    |   |   |-- session_store.py</a:t>
+    |   |   |-- runtime.py</a:t>
             </a:r>
           </a:p>
         </p:txBody>
@@ -31753,7 +31665,9 @@
                 </a:solidFill>
                 <a:latin typeface="Cascadia Mono"/>
               </a:rPr>
-              <a:t>    |   |   |-- tests.py
+              <a:t>    |   |   |-- service.py
+    |   |   |-- session_store.py
+    |   |   |-- tests.py
     |   |   |-- tools.py
     |   |   `-- windows_spawn.py
     |   |-- agents/
@@ -31781,9 +31695,7 @@
     |   |   |   |-- cleaner.py
     |   |   |   `-- config.yaml
     |   |   |-- counter/
-    |   |   |   |-- config.yaml
-    |   |   |   `-- counter.py
-    |   |   |-- crawler/</a:t>
+    |   |   |   |-- config.yaml</a:t>
             </a:r>
           </a:p>
         </p:txBody>
@@ -32121,7 +32033,9 @@
                 </a:solidFill>
                 <a:latin typeface="Cascadia Mono"/>
               </a:rPr>
-              <a:t>    |   |   |   |-- config.yaml
+              <a:t>    |   |   |   `-- counter.py
+    |   |   |-- crawler/
+    |   |   |   |-- config.yaml
     |   |   |   `-- crawler.py
     |   |   |-- croner/
     |   |   |   |-- config.yaml
@@ -32149,9 +32063,7 @@
     |   |   |   `-- file_creator.py
     |   |   |-- file_extractor/
     |   |   |   |-- config.yaml
-    |   |   |   `-- file_extractor.py
-    |   |   |-- file_interpreter/
-    |   |   |   |-- config.yaml</a:t>
+    |   |   |   `-- file_extractor.py</a:t>
             </a:r>
           </a:p>
         </p:txBody>
@@ -32489,7 +32401,9 @@
                 </a:solidFill>
                 <a:latin typeface="Cascadia Mono"/>
               </a:rPr>
-              <a:t>    |   |   |   `-- file_interpreter.py
+              <a:t>    |   |   |-- file_interpreter/
+    |   |   |   |-- config.yaml
+    |   |   |   `-- file_interpreter.py
     |   |   |-- flowbacker/
     |   |   |   |-- config.yaml
     |   |   |   `-- flowbacker.py
@@ -32517,9 +32431,7 @@
     |   |   |-- gitter/
     |   |   |   |-- config.yaml
     |   |   |   `-- gitter.py
-    |   |   |-- googler/
-    |   |   |   |-- config.yaml
-    |   |   |   `-- googler.py</a:t>
+    |   |   |-- googler/</a:t>
             </a:r>
           </a:p>
         </p:txBody>
@@ -32857,7 +32769,9 @@
                 </a:solidFill>
                 <a:latin typeface="Cascadia Mono"/>
               </a:rPr>
-              <a:t>    |   |   |-- image_interpreter/
+              <a:t>    |   |   |   |-- config.yaml
+    |   |   |   `-- googler.py
+    |   |   |-- image_interpreter/
     |   |   |   |-- config.yaml
     |   |   |   `-- image_interpreter.py
     |   |   |-- j_decompiler/
@@ -32885,9 +32799,7 @@
     |   |   |   |-- config.yaml
     |   |   |   `-- kyber_keygen.py
     |   |   |-- mongoxer/
-    |   |   |   |-- config.yaml
-    |   |   |   `-- mongoxer.py
-    |   |   |-- monitor_log/</a:t>
+    |   |   |   |-- config.yaml</a:t>
             </a:r>
           </a:p>
         </p:txBody>
@@ -33225,7 +33137,9 @@
                 </a:solidFill>
                 <a:latin typeface="Cascadia Mono"/>
               </a:rPr>
-              <a:t>    |   |   |   |-- config.yaml
+              <a:t>    |   |   |   `-- mongoxer.py
+    |   |   |-- monitor_log/
+    |   |   |   |-- config.yaml
     |   |   |   `-- monitor_log.py
     |   |   |-- monitor_netstat/
     |   |   |   |-- config.yaml
@@ -33253,9 +33167,7 @@
     |   |   |   `-- parametrizer.py
     |   |   |-- playwrighter/
     |   |   |   |-- config.yaml
-    |   |   |   `-- playwrighter.py
-    |   |   |-- prompter/
-    |   |   |   |-- config.yaml</a:t>
+    |   |   |   `-- playwrighter.py</a:t>
             </a:r>
           </a:p>
         </p:txBody>
@@ -34174,7 +34086,9 @@
                 </a:solidFill>
                 <a:latin typeface="Cascadia Mono"/>
               </a:rPr>
-              <a:t>    |   |   |   `-- prompter.py
+              <a:t>    |   |   |-- prompter/
+    |   |   |   |-- config.yaml
+    |   |   |   `-- prompter.py
     |   |   |-- pser/
     |   |   |   |-- config.yaml
     |   |   |   `-- pser.py
@@ -34202,9 +34116,7 @@
     |   |   |-- sqler/
     |   |   |   |-- config.yaml
     |   |   |   `-- sqler.py
-    |   |   |-- ssher/
-    |   |   |   |-- config.yaml
-    |   |   |   `-- ssher.py</a:t>
+    |   |   |-- ssher/</a:t>
             </a:r>
           </a:p>
         </p:txBody>
@@ -34542,7 +34454,9 @@
                 </a:solidFill>
                 <a:latin typeface="Cascadia Mono"/>
               </a:rPr>
-              <a:t>    |   |   |-- starter/
+              <a:t>    |   |   |   |-- config.yaml
+    |   |   |   `-- ssher.py
+    |   |   |-- starter/
     |   |   |   |-- config.yaml
     |   |   |   `-- starter.py
     |   |   |-- stopper/
@@ -34570,9 +34484,7 @@
     |   |   |   |-- config.yaml
     |   |   |   `-- whatstlamatini.py
     |   |   `-- windower/
-    |   |       |-- config.yaml
-    |   |       `-- windower.py
-    |   |-- doc_generation/</a:t>
+    |   |       |-- config.yaml</a:t>
             </a:r>
           </a:p>
         </p:txBody>
@@ -34910,7 +34822,9 @@
                 </a:solidFill>
                 <a:latin typeface="Cascadia Mono"/>
               </a:rPr>
-              <a:t>    |   |   |-- complete_project_docs.py
+              <a:t>    |   |       `-- windower.py
+    |   |-- doc_generation/
+    |   |   |-- complete_project_docs.py
     |   |   |-- mardown_to_pdf.py
     |   |   |-- refresh_project_docs.py
     |   |   `-- test_output.pdf
@@ -34938,9 +34852,7 @@
     |   |   |-- 0008_add_recmailer.py
     |   |   |-- 0009_add_whatsapper.py
     |   |   |-- 0010_add_pythonxer.py
-    |   |   |-- 0011_add_asker.py
-    |   |   |-- 0012_repopulate_all_agents.py
-    |   |   |-- 0013_add_forker.py</a:t>
+    |   |   |-- 0011_add_asker.py</a:t>
             </a:r>
           </a:p>
         </p:txBody>
@@ -35278,7 +35190,9 @@
                 </a:solidFill>
                 <a:latin typeface="Cascadia Mono"/>
               </a:rPr>
-              <a:t>    |   |   |-- 0014_repopulate_all_agents.py
+              <a:t>    |   |   |-- 0012_repopulate_all_agents.py
+    |   |   |-- 0013_add_forker.py
+    |   |   |-- 0014_repopulate_all_agents.py
     |   |   |-- 0015_add_shoter.py
     |   |   |-- 0016_repopulate_all_agents.py
     |   |   |-- 0017_add_ssher.py
@@ -35306,9 +35220,7 @@
     |   |   |-- 0039_add_crawler.py
     |   |   |-- 0040_add_summarizer.py
     |   |   |-- 0041_add_flowhypervisor.py
-    |   |   |-- 0042_add_mouser.py
-    |   |   |-- 0043_agentmessage_conversation_user.py
-    |   |   |-- 0044_add_counter.py</a:t>
+    |   |   |-- 0042_add_mouser.py</a:t>
             </a:r>
           </a:p>
         </p:txBody>
@@ -35646,7 +35558,9 @@
                 </a:solidFill>
                 <a:latin typeface="Cascadia Mono"/>
               </a:rPr>
-              <a:t>    |   |   |-- 0045_add_file_interpreter.py
+              <a:t>    |   |   |-- 0043_agentmessage_conversation_user.py
+    |   |   |-- 0044_add_counter.py
+    |   |   |-- 0045_add_file_interpreter.py
     |   |   |-- 0046_add_image_interpreter.py
     |   |   |-- 0047_add_gatewayer.py
     |   |   |-- 0048_add_gateway_relayer.py
@@ -35674,9 +35588,7 @@
     |   |   |-- 0070_add_teletlamatini.py
     |   |   |-- 0071_acpx_skills.py
     |   |   |-- 0072_add_acpx_demo_prompts.py
-    |   |   |-- 0073_acpx_demo_gemini_uplift.py
-    |   |   |-- 0074_simplify_demo_prompts.py
-    |   |   |-- 0075_add_acpx_tool_surface.py</a:t>
+    |   |   |-- 0073_acpx_demo_gemini_uplift.py</a:t>
             </a:r>
           </a:p>
         </p:txBody>
@@ -36014,7 +35926,9 @@
                 </a:solidFill>
                 <a:latin typeface="Cascadia Mono"/>
               </a:rPr>
-              <a:t>    |   |   |-- 0076_add_acpxer.py
+              <a:t>    |   |   |-- 0074_simplify_demo_prompts.py
+    |   |   |-- 0075_add_acpx_tool_surface.py
+    |   |   |-- 0076_add_acpxer.py
     |   |   |-- 0077_add_whatstlamatini.py
     |   |   |-- 0078_add_chat_agent_keyboarder_tool.py
     |   |   |-- 0079_add_chat_agent_mouser_tool.py
@@ -36042,9 +35956,7 @@
     |   |-- monitors/
     |   |   `-- monitor_sql.py
     |   |-- opus_client/
-    |   |   |-- claude_opus_client.py
-    |   |   |-- examples.py
-    |   |   `-- README.md</a:t>
+    |   |   |-- claude_opus_client.py</a:t>
             </a:r>
           </a:p>
         </p:txBody>
@@ -36382,7 +36294,9 @@
                 </a:solidFill>
                 <a:latin typeface="Cascadia Mono"/>
               </a:rPr>
-              <a:t>    |   |-- rag/
+              <a:t>    |   |   |-- examples.py
+    |   |   `-- README.md
+    |   |-- rag/
     |   |   |-- __init__.py
     |   |   |-- config.py
     |   |   |-- factory.py
@@ -36410,9 +36324,7 @@
     |   |-- skills/
     |   |   |-- __init__.py
     |   |   |-- frontmatter.py
-    |   |   |-- harness.py
-    |   |   |-- io_contract.py
-    |   |   `-- registry.py</a:t>
+    |   |   |-- harness.py</a:t>
             </a:r>
           </a:p>
         </p:txBody>
@@ -36750,7 +36662,9 @@
                 </a:solidFill>
                 <a:latin typeface="Cascadia Mono"/>
               </a:rPr>
-              <a:t>    |   |-- skills_pkg/
+              <a:t>    |   |   |-- io_contract.py
+    |   |   `-- registry.py
+    |   |-- skills_pkg/
     |   |   |-- _meta/
     |   |   |   |-- lint.py
     |   |   |   `-- schema.json
@@ -36778,9 +36692,7 @@
     |   |   |   |-- SKILL.md
     |   |   |   `-- scripts/
     |   |   |       `-- quick_validate.py
-    |   |   |-- slack/
-    |   |   |   `-- SKILL.md
-    |   |   |-- summarize/</a:t>
+    |   |   |-- slack/</a:t>
             </a:r>
           </a:p>
         </p:txBody>
@@ -37119,6 +37031,8 @@
                 <a:latin typeface="Cascadia Mono"/>
               </a:rPr>
               <a:t>    |   |   |   `-- SKILL.md
+    |   |   |-- summarize/
+    |   |   |   `-- SKILL.md
     |   |   |-- tlamatini_allowed_hosts_tighten/
     |   |   |   `-- SKILL.md
     |   |   |-- tlamatini_csrf_exempt_audit/
@@ -37146,9 +37060,7 @@
     |   |       |-- css/
     |   |       |   |-- agent_page.css
     |   |       |   |-- agentic_control_panel.css
-    |   |       |   |-- login.css
-    |   |       |   |-- skills_dialog.css
-    |   |       |   |-- tools_dialog.css</a:t>
+    |   |       |   |-- login.css</a:t>
             </a:r>
           </a:p>
         </p:txBody>
@@ -37486,7 +37398,9 @@
                 </a:solidFill>
                 <a:latin typeface="Cascadia Mono"/>
               </a:rPr>
-              <a:t>    |   |       |   `-- welcome.css
+              <a:t>    |   |       |   |-- skills_dialog.css
+    |   |       |   |-- tools_dialog.css
+    |   |       |   `-- welcome.css
     |   |       |-- img/
     |   |       |   |-- spinner.svg
     |   |       |   `-- Tlamatini.ico
@@ -37514,9 +37428,7 @@
     |   |       |   |-- agent_page_ui.js
     |   |       |   |-- agentic_control_panel.js
     |   |       |   |-- canvas_item_dialog.js
-    |   |       |   |-- chat_page_runtime_poller.js
-    |   |       |   |-- contextual_menus.js
-    |   |       |   |-- shared-runtime-dialogs.js</a:t>
+    |   |       |   |-- chat_page_runtime_poller.js</a:t>
             </a:r>
           </a:p>
         </p:txBody>
@@ -38603,7 +38515,9 @@
                 </a:solidFill>
                 <a:latin typeface="Cascadia Mono"/>
               </a:rPr>
-              <a:t>    |   |       |   |-- skills_dialog.js
+              <a:t>    |   |       |   |-- contextual_menus.js
+    |   |       |   |-- shared-runtime-dialogs.js
+    |   |       |   |-- skills_dialog.js
     |   |       |   `-- tools_dialog.js
     |   |       |-- sounds/
     |   |       |   |-- hypervisor_alert.wav
@@ -38631,9 +38545,7 @@
     `-- tlamatini/
         |-- __init__.py
         |-- asgi.py
-        |-- context_processors.py
-        |-- logging_filters.py
-        |-- middleware.py</a:t>
+        |-- context_processors.py</a:t>
             </a:r>
           </a:p>
         </p:txBody>
@@ -38971,7 +38883,9 @@
                 </a:solidFill>
                 <a:latin typeface="Cascadia Mono"/>
               </a:rPr>
-              <a:t>        |-- settings.py
+              <a:t>        |-- logging_filters.py
+        |-- middleware.py
+        |-- settings.py
         |-- urls.py
         `-- wsgi.py</a:t>
             </a:r>

</xml_diff>

<commit_message>
Updating all of thedocs to v1.15.0, by Tlamatini's-AutoBot.
</commit_message>
<xml_diff>
--- a/Tlamatini_eXtended_Artificial_Intelligence_Humanly_Tempered.pptx
+++ b/Tlamatini_eXtended_Artificial_Intelligence_Humanly_Tempered.pptx
@@ -5580,7 +5580,7 @@
                 </a:solidFill>
                 <a:latin typeface="Aptos"/>
               </a:rPr>
-              <a:t>V1.10.0 SAFETY MODIFIER STILL ACTIVE IN V1.14.0</a:t>
+              <a:t>V1.10.0 SAFETY MODIFIER STILL ACTIVE IN V1.15.0</a:t>
             </a:r>
           </a:p>
         </p:txBody>
@@ -5777,7 +5777,7 @@
               </a:defRPr>
             </a:pPr>
             <a:r>
-              <a:t>Introduced in `v1.10.0` and still part of the current `v1.14.0` surface, `Ask Execs` is the Multi-Turn-only safety modifier that makes Tlamatini ask before each state-changing Tool, MCP, wrapped agent, or skill-backed execution instead of running it immediately.</a:t>
+              <a:t>Introduced in `v1.10.0` and still part of the current `v1.15.0` surface, `Ask Execs` is the Multi-Turn-only safety modifier that makes Tlamatini ask before each state-changing Tool, MCP, wrapped agent, or skill-backed execution instead of running it immediately.</a:t>
             </a:r>
           </a:p>
           <a:p>
@@ -6962,7 +6962,7 @@
                 </a:solidFill>
                 <a:latin typeface="Aptos"/>
               </a:rPr>
-              <a:t>V1.11.0 UNINSTALL INTEGRATION CARRIED INTO V1.14.0</a:t>
+              <a:t>V1.11.0 UNINSTALL INTEGRATION CARRIED INTO V1.15.0</a:t>
             </a:r>
           </a:p>
         </p:txBody>
@@ -7159,7 +7159,7 @@
               </a:defRPr>
             </a:pPr>
             <a:r>
-              <a:t>Introduced in `v1.11.0` and still carried by the current `v1.14.0` release, the frozen install now behaves like a real Windows application: `install.py` writes a per-user HKCU Add/Remove Programs entry so Tlamatini appears in Settings -&gt; Apps -&gt; Installed apps and in the legacy Programs and Features list.</a:t>
+              <a:t>Introduced in `v1.11.0` and still carried by the current `v1.15.0` release, the frozen install now behaves like a real Windows application: `install.py` writes a per-user HKCU Add/Remove Programs entry so Tlamatini appears in Settings -&gt; Apps -&gt; Installed apps and in the legacy Programs and Features list.</a:t>
             </a:r>
           </a:p>
           <a:p>
@@ -23461,7 +23461,7 @@
               </a:defRPr>
             </a:pPr>
             <a:r>
-              <a:t>Those readability rules remain in force in the current documentation set, and the current `v1.14.0` release state keeps the version badge, runtime surfaces, self-knowledge wording, STM32er/ESP32er demo prompts, and operator handbook aligned.</a:t>
+              <a:t>Those readability rules remain in force in the current documentation set, and the current `v1.15.0` release state keeps the version badge, runtime surfaces, self-knowledge wording, STM32er/ESP32er demo prompts, and operator handbook aligned.</a:t>
             </a:r>
           </a:p>
         </p:txBody>
@@ -24910,7 +24910,7 @@
                 </a:solidFill>
                 <a:latin typeface="Cascadia Mono"/>
               </a:rPr>
-              <a:t>Resolved current version: 1.16.0 | build: 1.16.0</a:t>
+              <a:t>Resolved current version: 1.15.0 | build: 1.15.0</a:t>
             </a:r>
           </a:p>
         </p:txBody>
@@ -36343,7 +36343,7 @@
               </a:defRPr>
             </a:pPr>
             <a:r>
-              <a:t>Resolved version: 1.16.0 (env)</a:t>
+              <a:t>Resolved version: 1.15.0 (env)</a:t>
             </a:r>
           </a:p>
           <a:p>

</xml_diff>

<commit_message>
Official release of documentation as Tlamatini v1.17.0, by angelahack1
</commit_message>
<xml_diff>
--- a/Tlamatini_eXtended_Artificial_Intelligence_Humanly_Tempered.pptx
+++ b/Tlamatini_eXtended_Artificial_Intelligence_Humanly_Tempered.pptx
@@ -86,6 +86,7 @@
     <p:sldId id="334" r:id="rId85"/>
     <p:sldId id="335" r:id="rId86"/>
     <p:sldId id="336" r:id="rId87"/>
+    <p:sldId id="337" r:id="rId88"/>
   </p:sldIdLst>
   <p:sldSz cx="12191695" cy="6858000" type="screen4x3"/>
   <p:notesSz cx="6858000" cy="9144000"/>
@@ -3633,7 +3634,7 @@
                 </a:solidFill>
                 <a:latin typeface="Aptos"/>
               </a:rPr>
-              <a:t>549</a:t>
+              <a:t>560</a:t>
             </a:r>
           </a:p>
         </p:txBody>
@@ -3863,7 +3864,7 @@
                 </a:solidFill>
                 <a:latin typeface="Aptos"/>
               </a:rPr>
-              <a:t>123,488</a:t>
+              <a:t>127,034</a:t>
             </a:r>
           </a:p>
         </p:txBody>
@@ -3898,7 +3899,7 @@
                 </a:solidFill>
                 <a:latin typeface="Aptos"/>
               </a:rPr>
-              <a:t>Generated June 04, 2026 09:56 PM UTC-0600 at HEAD 2563081</a:t>
+              <a:t>Generated June 05, 2026 11:48 PM UTC-0600 at HEAD 8eec7d0</a:t>
             </a:r>
           </a:p>
         </p:txBody>
@@ -5580,7 +5581,7 @@
                 </a:solidFill>
                 <a:latin typeface="Aptos"/>
               </a:rPr>
-              <a:t>V1.10.0 SAFETY MODIFIER STILL ACTIVE IN V1.15.0</a:t>
+              <a:t>V1.10.0 SAFETY MODIFIER STILL ACTIVE IN V1.17.0</a:t>
             </a:r>
           </a:p>
         </p:txBody>
@@ -5777,7 +5778,7 @@
               </a:defRPr>
             </a:pPr>
             <a:r>
-              <a:t>Introduced in `v1.10.0` and still part of the current `v1.15.0` surface, `Ask Execs` is the Multi-Turn-only safety modifier that makes Tlamatini ask before each state-changing Tool, MCP, wrapped agent, or skill-backed execution instead of running it immediately.</a:t>
+              <a:t>Introduced in `v1.10.0` and still part of the current `v1.17.0` surface, `Ask Execs` is the Multi-Turn-only safety modifier that makes Tlamatini ask before each state-changing Tool, MCP, wrapped agent, or skill-backed execution instead of running it immediately.</a:t>
             </a:r>
           </a:p>
           <a:p>
@@ -6962,7 +6963,7 @@
                 </a:solidFill>
                 <a:latin typeface="Aptos"/>
               </a:rPr>
-              <a:t>V1.11.0 UNINSTALL INTEGRATION CARRIED INTO V1.15.0</a:t>
+              <a:t>V1.11.0 UNINSTALL INTEGRATION CARRIED INTO V1.17.0</a:t>
             </a:r>
           </a:p>
         </p:txBody>
@@ -7159,7 +7160,7 @@
               </a:defRPr>
             </a:pPr>
             <a:r>
-              <a:t>Introduced in `v1.11.0` and still carried by the current `v1.15.0` release, the frozen install now behaves like a real Windows application: `install.py` writes a per-user HKCU Add/Remove Programs entry so Tlamatini appears in Settings -&gt; Apps -&gt; Installed apps and in the legacy Programs and Features list.</a:t>
+              <a:t>Introduced in `v1.11.0` and still carried by the current `v1.17.0` release, the frozen install now behaves like a real Windows application: `install.py` writes a per-user HKCU Add/Remove Programs entry so Tlamatini appears in Settings -&gt; Apps -&gt; Installed apps and in the legacy Programs and Features list.</a:t>
             </a:r>
           </a:p>
           <a:p>
@@ -23461,7 +23462,7 @@
               </a:defRPr>
             </a:pPr>
             <a:r>
-              <a:t>Those readability rules remain in force in the current documentation set, and the current `v1.15.0` release state keeps the version badge, runtime surfaces, self-knowledge wording, STM32er/ESP32er demo prompts, and operator handbook aligned.</a:t>
+              <a:t>Those readability rules remain in force in the current documentation set, and the current `v1.17.0` release state keeps the version badge, runtime surfaces, self-knowledge wording, STM32er/ESP32er demo prompts, and operator handbook aligned.</a:t>
             </a:r>
           </a:p>
         </p:txBody>
@@ -24910,7 +24911,7 @@
                 </a:solidFill>
                 <a:latin typeface="Cascadia Mono"/>
               </a:rPr>
-              <a:t>Resolved current version: 1.15.0 | build: 1.15.0</a:t>
+              <a:t>Resolved current version: 1.17.0 | build: 1.17.0</a:t>
             </a:r>
           </a:p>
         </p:txBody>
@@ -35590,7 +35591,7 @@
                 </a:solidFill>
                 <a:latin typeface="Aptos"/>
               </a:rPr>
-              <a:t>549</a:t>
+              <a:t>560</a:t>
             </a:r>
           </a:p>
         </p:txBody>
@@ -36327,7 +36328,7 @@
               </a:defRPr>
             </a:pPr>
             <a:r>
-              <a:t>2563081 - Teletlamatini and WhatsTlamatini are now updated with all the capabilities of ACPX and AskExecs non-gated, by Tlamatini's-AutoBot.</a:t>
+              <a:t>8eec7d0 - Re-engineered the installing process of Tlamatini to be bullet-proof, by angelahack1</a:t>
             </a:r>
           </a:p>
           <a:p>
@@ -36343,7 +36344,7 @@
               </a:defRPr>
             </a:pPr>
             <a:r>
-              <a:t>Resolved version: 1.15.0 (env)</a:t>
+              <a:t>Resolved version: 1.17.0 (env)</a:t>
             </a:r>
           </a:p>
           <a:p>
@@ -36359,7 +36360,7 @@
               </a:defRPr>
             </a:pPr>
             <a:r>
-              <a:t>Generated on June 04, 2026 09:56 PM UTC-0600</a:t>
+              <a:t>Generated on June 05, 2026 11:48 PM UTC-0600</a:t>
             </a:r>
           </a:p>
           <a:p>
@@ -36407,7 +36408,7 @@
               </a:defRPr>
             </a:pPr>
             <a:r>
-              <a:t>Binary or asset tracked files skipped from line count: 23</a:t>
+              <a:t>Binary or asset tracked files skipped from line count: 24</a:t>
             </a:r>
           </a:p>
         </p:txBody>
@@ -36872,7 +36873,7 @@
               </a:defRPr>
             </a:pPr>
             <a:r>
-              <a:t>65c66a4 on 2026-06-04</a:t>
+              <a:t>8079490 on 2026-06-04</a:t>
             </a:r>
           </a:p>
           <a:p>
@@ -36888,7 +36889,7 @@
               </a:defRPr>
             </a:pPr>
             <a:r>
-              <a:t>Updating to latets version and Camcorder+Recorder, by Tlamatini's-AutoBot.</a:t>
+              <a:t>Updating all of thedocs to v1.15.0, by Tlamatini's-AutoBot.</a:t>
             </a:r>
           </a:p>
           <a:p>
@@ -36904,7 +36905,7 @@
               </a:defRPr>
             </a:pPr>
             <a:r>
-              <a:t>Commits since then: 1</a:t>
+              <a:t>Commits since then: 3</a:t>
             </a:r>
           </a:p>
         </p:txBody>
@@ -38223,7 +38224,7 @@
                 </a:solidFill>
                 <a:latin typeface="Aptos"/>
               </a:rPr>
-              <a:t>123,488</a:t>
+              <a:t>127,034</a:t>
             </a:r>
           </a:p>
         </p:txBody>
@@ -38338,7 +38339,7 @@
                 </a:solidFill>
                 <a:latin typeface="Aptos"/>
               </a:rPr>
-              <a:t>169,308</a:t>
+              <a:t>174,809</a:t>
             </a:r>
           </a:p>
         </p:txBody>
@@ -38489,20 +38490,20 @@
                 <a:latin typeface="Cascadia Mono"/>
               </a:rPr>
               <a:t>LANGUAGE                 FILES   EFFECTIVE      TOTAL   SHARE
-Python                   320      85,751    120,215  69.4%
-Markdown                  65      14,602     18,587  11.8%
-JavaScript                28      13,754     17,309  11.1%
-CSS                        6       3,669      4,662   3.0%
-YAML                      77       1,596      3,716   1.3%
+Python                   328      89,189    125,415  70.2%
+Markdown                  65      14,670     18,684  11.5%
+JavaScript                28      13,770     17,337  10.8%
+CSS                        6       3,717      4,731   2.9%
+YAML                      79       1,614      3,875   1.3%
 Other text                 6         894      1,089   0.7%
 HTML                       4         858        876   0.7%
-Prompt template            2         803        924   0.7%
+Prompt template            2         759        867   0.6%
 PowerShell                 5         508        754   0.4%
 JavaScript module          1         403        472   0.3%
 JSON                       5         398        398   0.3%
 Text                       5         219        249   0.2%
 Protocol Buffers           1          20         33   0.0%
-Batch                      1          13         24   0.0%</a:t>
+Batch                      1          15         29   0.0%</a:t>
             </a:r>
           </a:p>
         </p:txBody>
@@ -38841,20 +38842,20 @@
                 <a:latin typeface="Cascadia Mono"/>
               </a:rPr>
               <a:t>PATH                                                     LANGUAGE     EFFECTIVE   TOTAL
-Tlamatini/agent/views.py                                Python         7,640  11,123
-Tlamatini/agent/tests.py                                Python         5,036   6,473
-Tlamatini/agent/tools.py                                Python         2,630   3,772
-Tlamatini/agent/doc_generation/complete_project_docs.py Python         2,305   2,603
-BookOfTlamatini.md                                      Markdown       2,115   2,975
+Tlamatini/agent/views.py                                Python         7,648  11,139
+Tlamatini/agent/tests.py                                Python         5,118   6,583
+Tlamatini/agent/tools.py                                Python         2,632   3,777
+Tlamatini/agent/doc_generation/complete_project_docs.py Python         2,322   2,629
+BookOfTlamatini.md                                      Markdown       2,116   2,977
 Tlamatini/agent/agents/flowcreator/agentic_skill.md     Markdown       2,070   2,290
 ...ini/agent/static/agent/css/agentic_control_panel.css CSS            1,794   2,400
 Tlamatini/agent/static/agent/js/agent_page_init.js      JavaScript     1,435   1,687
+Tlamatini/agent/static/agent/css/agent_page.css         CSS            1,362   1,671
+README.md                                               Markdown       1,351   1,922
 Tlamatini/agent/static/agent/js/acp-canvas-core.js      JavaScript     1,327   1,637
 Tlamatini/agent/static/agent/js/acp-agent-connectors.js JavaScript     1,325   1,477
-Tlamatini/agent/static/agent/css/agent_page.css         CSS            1,314   1,602
 Tlamatini/agent/consumers.py                            Python         1,300   1,638
-README.md                                               Markdown       1,299   1,851
-Tlamatini/agent/static/agent/js/agent_page_chat.js      JavaScript     1,278   1,741</a:t>
+Tlamatini/agent/static/agent/js/agent_page_chat.js      JavaScript     1,294   1,769</a:t>
             </a:r>
           </a:p>
         </p:txBody>
@@ -39319,55 +39320,7 @@
               </a:defRPr>
             </a:pPr>
             <a:r>
-              <a:t>New observational capture pair: Camcorder (webcam photo/video via OpenCV) and Recorder (microphone WAV via sounddevice) — read-only siblings of Shoter, on the canvas and as wrapped chat_agent_camcorder / chat_agent_recorder tools.</a:t>
-            </a:r>
-          </a:p>
-          <a:p>
-            <a:pPr>
-              <a:spcAft>
-                <a:spcPts val="400"/>
-              </a:spcAft>
-              <a:defRPr sz="1500">
-                <a:solidFill>
-                  <a:srgbClr val="B4BAAE"/>
-                </a:solidFill>
-                <a:latin typeface="Aptos"/>
-              </a:defRPr>
-            </a:pPr>
-            <a:r>
-              <a:t>Today’s headline change is the new versioning system: SemVer policy, git-tag sourcing, runtime version surfaces, and build-time embedding across the Windows artefacts.</a:t>
-            </a:r>
-          </a:p>
-          <a:p>
-            <a:pPr>
-              <a:spcAft>
-                <a:spcPts val="400"/>
-              </a:spcAft>
-              <a:defRPr sz="1500">
-                <a:solidFill>
-                  <a:srgbClr val="B4BAAE"/>
-                </a:solidFill>
-                <a:latin typeface="Aptos"/>
-              </a:defRPr>
-            </a:pPr>
-            <a:r>
-              <a:t>ACPX-related work remained visible during the today: runtime, documentation, or operator-surface changes were still part of the active maintenance stream.</a:t>
-            </a:r>
-          </a:p>
-          <a:p>
-            <a:pPr>
-              <a:spcAft>
-                <a:spcPts val="400"/>
-              </a:spcAft>
-              <a:defRPr sz="1500">
-                <a:solidFill>
-                  <a:srgbClr val="B4BAAE"/>
-                </a:solidFill>
-                <a:latin typeface="Aptos"/>
-              </a:defRPr>
-            </a:pPr>
-            <a:r>
-              <a:t>TeleTlamatini grew throughout the window, including agent/runtime updates, config movement, FlowCreator/ACPX integration, and related documentation changes.</a:t>
+              <a:t>Git history today shows focused maintenance across the operator surface, release mechanics, and runtime behavior.</a:t>
             </a:r>
           </a:p>
         </p:txBody>
@@ -39832,7 +39785,39 @@
               </a:defRPr>
             </a:pPr>
             <a:r>
-              <a:t>2026-06-04 | 2563081 | Teletlamatini and WhatsTlamatini are now updated with all the capabilities of ACPX and AskExecs non-gated, by Tlamatini's-AutoBot.</a:t>
+              <a:t>2026-06-05 | 8eec7d0 | Re-engineered the installing process of Tlamatini to be bullet-proof, by angelahack1</a:t>
+            </a:r>
+          </a:p>
+          <a:p>
+            <a:pPr>
+              <a:spcAft>
+                <a:spcPts val="400"/>
+              </a:spcAft>
+              <a:defRPr sz="1200">
+                <a:solidFill>
+                  <a:srgbClr val="B4BAAE"/>
+                </a:solidFill>
+                <a:latin typeface="Aptos"/>
+              </a:defRPr>
+            </a:pPr>
+            <a:r>
+              <a:t>2026-06-05 | db5df7f | Improvement to the prompting chain, by Tlamatini's-AutoBot.</a:t>
+            </a:r>
+          </a:p>
+          <a:p>
+            <a:pPr>
+              <a:spcAft>
+                <a:spcPts val="400"/>
+              </a:spcAft>
+              <a:defRPr sz="1200">
+                <a:solidFill>
+                  <a:srgbClr val="B4BAAE"/>
+                </a:solidFill>
+                <a:latin typeface="Aptos"/>
+              </a:defRPr>
+            </a:pPr>
+            <a:r>
+              <a:t>2026-06-05 | 013428c | Some improvements to README.md, by angelahack1</a:t>
             </a:r>
           </a:p>
         </p:txBody>
@@ -40297,7 +40282,7 @@
               </a:defRPr>
             </a:pPr>
             <a:r>
-              <a:t>2026-06-04 | 2563081 | Teletlamatini and WhatsTlamatini are now updated with all the capabilities of ACPX and AskExecs non-gated, by Tlamatini's-AutoBot.</a:t>
+              <a:t>2026-06-05 | 8eec7d0 | Re-engineered the installing process of Tlamatini to be bullet-proof, by angelahack1</a:t>
             </a:r>
           </a:p>
           <a:p>
@@ -40313,7 +40298,7 @@
               </a:defRPr>
             </a:pPr>
             <a:r>
-              <a:t>2026-06-04 | 65c66a4 | Updating to latets version and Camcorder+Recorder, by Tlamatini's-AutoBot.</a:t>
+              <a:t>2026-06-05 | db5df7f | Improvement to the prompting chain, by Tlamatini's-AutoBot.</a:t>
             </a:r>
           </a:p>
           <a:p>
@@ -40329,7 +40314,7 @@
               </a:defRPr>
             </a:pPr>
             <a:r>
-              <a:t>2026-06-04 | e58ed54 | Recorder agent implemented, by Tlamatini's-AutoBot.</a:t>
+              <a:t>2026-06-05 | 013428c | Some improvements to README.md, by angelahack1</a:t>
             </a:r>
           </a:p>
         </p:txBody>
@@ -40632,7 +40617,7 @@
                 </a:solidFill>
                 <a:latin typeface="Aptos Display"/>
               </a:rPr>
-              <a:t>Tracked File Tree Appendix 1/23</a:t>
+              <a:t>Tracked File Tree Appendix 1/24</a:t>
             </a:r>
           </a:p>
         </p:txBody>
@@ -40682,6 +40667,7 @@
 |-- CreateShortcut.ps1
 |-- eslint.config.mjs
 |-- example_of_prompt_to_make_de-compresser_agent.txt
+|-- image copy.png
 |-- image.png
 |-- install.py
 |-- KIMI.md
@@ -40696,8 +40682,7 @@
 |-- register_flw.ps1
 |-- RemoveShortcut.ps1
 |-- requirements.txt
-|-- Tlamatini-Kali-Setup.md
-|-- Tlamatini.ico</a:t>
+|-- Tlamatini-Kali-Setup.md</a:t>
             </a:r>
           </a:p>
         </p:txBody>
@@ -41000,7 +40985,7 @@
                 </a:solidFill>
                 <a:latin typeface="Aptos Display"/>
               </a:rPr>
-              <a:t>Tracked File Tree Appendix 2/23</a:t>
+              <a:t>Tracked File Tree Appendix 2/24</a:t>
             </a:r>
           </a:p>
         </p:txBody>
@@ -41035,7 +41020,8 @@
                 </a:solidFill>
                 <a:latin typeface="Cascadia Mono"/>
               </a:rPr>
-              <a:t>|-- Tlamatini.jpg
+              <a:t>|-- Tlamatini.ico
+|-- Tlamatini.jpg
 |-- Tlamatini.ps1
 |-- tlamatini_app_summary.pdf
 |-- Tlamatini_eXtended_Artificial_Intelligence_Humanly_Tempered.pptx
@@ -41064,8 +41050,7 @@
 |       |-- mcp-tools.md
 |       |-- multi-turn.md
 |       `-- recent-fixes.md
-|-- pyinstaller_hooks/
-|   `-- hook-numpy.py</a:t>
+|-- pyinstaller_hooks/</a:t>
             </a:r>
           </a:p>
         </p:txBody>
@@ -42504,7 +42489,7 @@
                 </a:solidFill>
                 <a:latin typeface="Aptos Display"/>
               </a:rPr>
-              <a:t>Tracked File Tree Appendix 3/23</a:t>
+              <a:t>Tracked File Tree Appendix 3/24</a:t>
             </a:r>
           </a:p>
         </p:txBody>
@@ -42539,7 +42524,8 @@
                 </a:solidFill>
                 <a:latin typeface="Cascadia Mono"/>
               </a:rPr>
-              <a:t>`-- Tlamatini/
+              <a:t>|   `-- hook-numpy.py
+`-- Tlamatini/
     |-- cat_art.py
     |-- manage.py
     |-- .agents/
@@ -42568,8 +42554,7 @@
     |   |-- exec_permission.py
     |   |-- filesearch.proto
     |   |-- filesearch_pb2.py
-    |   |-- filesearch_pb2_grpc.py
-    |   |-- global_execution_planner.py</a:t>
+    |   |-- filesearch_pb2_grpc.py</a:t>
             </a:r>
           </a:p>
         </p:txBody>
@@ -42872,7 +42857,7 @@
                 </a:solidFill>
                 <a:latin typeface="Aptos Display"/>
               </a:rPr>
-              <a:t>Tracked File Tree Appendix 4/23</a:t>
+              <a:t>Tracked File Tree Appendix 4/24</a:t>
             </a:r>
           </a:p>
         </p:txBody>
@@ -42907,7 +42892,8 @@
                 </a:solidFill>
                 <a:latin typeface="Cascadia Mono"/>
               </a:rPr>
-              <a:t>    |   |-- global_state.py
+              <a:t>    |   |-- global_execution_planner.py
+    |   |-- global_state.py
     |   |-- gpu_perf.py
     |   |-- inet_determiner.py
     |   |-- mcp_agent.py
@@ -42923,6 +42909,7 @@
     |   |-- rag_enhancements.py
     |   |-- routing.py
     |   |-- test_arduiner_agent.py
+    |   |-- test_audioplayer_agent.py
     |   |-- test_build_scripts.py
     |   |-- test_camcorder_agent.py
     |   |-- test_chat_bridge_bots.py
@@ -42935,9 +42922,7 @@
     |   |-- test_orphan_reaper.py
     |   |-- test_password_quoting.py
     |   |-- test_playwrighter_agent.py
-    |   |-- test_recorder_agent.py
-    |   |-- test_stm32er_agent.py
-    |   |-- test_temp_dir_policy.py</a:t>
+    |   |-- test_recorder_agent.py</a:t>
             </a:r>
           </a:p>
         </p:txBody>
@@ -43240,7 +43225,7 @@
                 </a:solidFill>
                 <a:latin typeface="Aptos Display"/>
               </a:rPr>
-              <a:t>Tracked File Tree Appendix 5/23</a:t>
+              <a:t>Tracked File Tree Appendix 5/24</a:t>
             </a:r>
           </a:p>
         </p:txBody>
@@ -43275,7 +43260,10 @@
                 </a:solidFill>
                 <a:latin typeface="Cascadia Mono"/>
               </a:rPr>
-              <a:t>    |   |-- test_unrealer_agent.py
+              <a:t>    |   |-- test_stm32er_agent.py
+    |   |-- test_temp_dir_policy.py
+    |   |-- test_unrealer_agent.py
+    |   |-- test_videoplayer_agent.py
     |   |-- test_windower_agent.py
     |   |-- test_windows_app_registration.py
     |   |-- tests.py
@@ -43302,10 +43290,7 @@
     |   |   |-- acpxer/
     |   |   |   |-- acpxer.py
     |   |   |   `-- config.yaml
-    |   |   |-- analyzer/
-    |   |   |   |-- analyzer.py
-    |   |   |   `-- config.yaml
-    |   |   |-- and/</a:t>
+    |   |   |-- analyzer/</a:t>
             </a:r>
           </a:p>
         </p:txBody>
@@ -43608,7 +43593,7 @@
                 </a:solidFill>
                 <a:latin typeface="Aptos Display"/>
               </a:rPr>
-              <a:t>Tracked File Tree Appendix 6/23</a:t>
+              <a:t>Tracked File Tree Appendix 6/24</a:t>
             </a:r>
           </a:p>
         </p:txBody>
@@ -43643,7 +43628,10 @@
                 </a:solidFill>
                 <a:latin typeface="Cascadia Mono"/>
               </a:rPr>
-              <a:t>    |   |   |   |-- and.py
+              <a:t>    |   |   |   |-- analyzer.py
+    |   |   |   `-- config.yaml
+    |   |   |-- and/
+    |   |   |   |-- and.py
     |   |   |   `-- config.yaml
     |   |   |-- apirer/
     |   |   |   |-- apirer.py
@@ -43661,19 +43649,16 @@
     |   |   |-- asker/
     |   |   |   |-- asker.py
     |   |   |   `-- config.yaml
+    |   |   |-- audioplayer/
+    |   |   |   |-- audioplayer.py
+    |   |   |   `-- config.yaml
     |   |   |-- barrier/
     |   |   |   |-- barrier.py
     |   |   |   |-- config.yaml
     |   |   |   `-- test_barrier.py
     |   |   |-- camcorder/
     |   |   |   |-- camcorder.py
-    |   |   |   `-- config.yaml
-    |   |   |-- cleaner/
-    |   |   |   |-- __init__.py
-    |   |   |   |-- cleaner.py
-    |   |   |   `-- config.yaml
-    |   |   |-- counter/
-    |   |   |   |-- config.yaml</a:t>
+    |   |   |   `-- config.yaml</a:t>
             </a:r>
           </a:p>
         </p:txBody>
@@ -43976,7 +43961,7 @@
                 </a:solidFill>
                 <a:latin typeface="Aptos Display"/>
               </a:rPr>
-              <a:t>Tracked File Tree Appendix 7/23</a:t>
+              <a:t>Tracked File Tree Appendix 7/24</a:t>
             </a:r>
           </a:p>
         </p:txBody>
@@ -44011,7 +43996,13 @@
                 </a:solidFill>
                 <a:latin typeface="Cascadia Mono"/>
               </a:rPr>
-              <a:t>    |   |   |   `-- counter.py
+              <a:t>    |   |   |-- cleaner/
+    |   |   |   |-- __init__.py
+    |   |   |   |-- cleaner.py
+    |   |   |   `-- config.yaml
+    |   |   |-- counter/
+    |   |   |   |-- config.yaml
+    |   |   |   `-- counter.py
     |   |   |-- crawler/
     |   |   |   |-- config.yaml
     |   |   |   `-- crawler.py
@@ -44035,13 +44026,7 @@
     |   |   |   `-- ender.py
     |   |   |-- esp32er/
     |   |   |   |-- config.yaml
-    |   |   |   `-- esp32er.py
-    |   |   |-- executer/
-    |   |   |   |-- config.yaml
-    |   |   |   `-- executer.py
-    |   |   |-- file_creator/
-    |   |   |   |-- config.yaml
-    |   |   |   `-- file_creator.py</a:t>
+    |   |   |   `-- esp32er.py</a:t>
             </a:r>
           </a:p>
         </p:txBody>
@@ -44344,7 +44329,7 @@
                 </a:solidFill>
                 <a:latin typeface="Aptos Display"/>
               </a:rPr>
-              <a:t>Tracked File Tree Appendix 8/23</a:t>
+              <a:t>Tracked File Tree Appendix 8/24</a:t>
             </a:r>
           </a:p>
         </p:txBody>
@@ -44379,7 +44364,13 @@
                 </a:solidFill>
                 <a:latin typeface="Cascadia Mono"/>
               </a:rPr>
-              <a:t>    |   |   |-- file_extractor/
+              <a:t>    |   |   |-- executer/
+    |   |   |   |-- config.yaml
+    |   |   |   `-- executer.py
+    |   |   |-- file_creator/
+    |   |   |   |-- config.yaml
+    |   |   |   `-- file_creator.py
+    |   |   |-- file_extractor/
     |   |   |   |-- config.yaml
     |   |   |   `-- file_extractor.py
     |   |   |-- file_interpreter/
@@ -44403,13 +44394,7 @@
     |   |   |-- gateway_relayer/
     |   |   |   |-- config.yaml
     |   |   |   |-- gateway_relayer.md
-    |   |   |   `-- gateway_relayer.py
-    |   |   |-- gatewayer/
-    |   |   |   |-- config.yaml
-    |   |   |   |-- gatewayer.md
-    |   |   |   |-- gatewayer.py
-    |   |   |   `-- gatewayer_explanation.md
-    |   |   |-- gitter/</a:t>
+    |   |   |   `-- gateway_relayer.py</a:t>
             </a:r>
           </a:p>
         </p:txBody>
@@ -44712,7 +44697,7 @@
                 </a:solidFill>
                 <a:latin typeface="Aptos Display"/>
               </a:rPr>
-              <a:t>Tracked File Tree Appendix 9/23</a:t>
+              <a:t>Tracked File Tree Appendix 9/24</a:t>
             </a:r>
           </a:p>
         </p:txBody>
@@ -44747,7 +44732,13 @@
                 </a:solidFill>
                 <a:latin typeface="Cascadia Mono"/>
               </a:rPr>
-              <a:t>    |   |   |   |-- config.yaml
+              <a:t>    |   |   |-- gatewayer/
+    |   |   |   |-- config.yaml
+    |   |   |   |-- gatewayer.md
+    |   |   |   |-- gatewayer.py
+    |   |   |   `-- gatewayer_explanation.md
+    |   |   |-- gitter/
+    |   |   |   |-- config.yaml
     |   |   |   `-- gitter.py
     |   |   |-- googler/
     |   |   |   |-- config.yaml
@@ -44771,12 +44762,6 @@
     |   |   |   |-- config.yaml
     |   |   |   `-- kuberneter.py
     |   |   |-- kyber_cipher/
-    |   |   |   |-- config.yaml
-    |   |   |   `-- kyber_cipher.py
-    |   |   |-- kyber_decipher/
-    |   |   |   |-- config.yaml
-    |   |   |   `-- kyber_decipher.py
-    |   |   |-- kyber_keygen/
     |   |   |   |-- config.yaml</a:t>
             </a:r>
           </a:p>
@@ -45080,7 +45065,7 @@
                 </a:solidFill>
                 <a:latin typeface="Aptos Display"/>
               </a:rPr>
-              <a:t>Tracked File Tree Appendix 10/23</a:t>
+              <a:t>Tracked File Tree Appendix 10/24</a:t>
             </a:r>
           </a:p>
         </p:txBody>
@@ -45115,7 +45100,13 @@
                 </a:solidFill>
                 <a:latin typeface="Cascadia Mono"/>
               </a:rPr>
-              <a:t>    |   |   |   `-- kyber_keygen.py
+              <a:t>    |   |   |   `-- kyber_cipher.py
+    |   |   |-- kyber_decipher/
+    |   |   |   |-- config.yaml
+    |   |   |   `-- kyber_decipher.py
+    |   |   |-- kyber_keygen/
+    |   |   |   |-- config.yaml
+    |   |   |   `-- kyber_keygen.py
     |   |   |-- mongoxer/
     |   |   |   |-- config.yaml
     |   |   |   `-- mongoxer.py
@@ -45139,13 +45130,7 @@
     |   |   |   `-- nodes_example.yaml
     |   |   |-- notifier/
     |   |   |   |-- config.yaml
-    |   |   |   `-- notifier.py
-    |   |   |-- or/
-    |   |   |   |-- config.yaml
-    |   |   |   `-- or.py
-    |   |   |-- parametrizer/
-    |   |   |   |-- config.yaml
-    |   |   |   `-- parametrizer.py</a:t>
+    |   |   |   `-- notifier.py</a:t>
             </a:r>
           </a:p>
         </p:txBody>
@@ -45448,7 +45433,7 @@
                 </a:solidFill>
                 <a:latin typeface="Aptos Display"/>
               </a:rPr>
-              <a:t>Tracked File Tree Appendix 11/23</a:t>
+              <a:t>Tracked File Tree Appendix 11/24</a:t>
             </a:r>
           </a:p>
         </p:txBody>
@@ -45483,7 +45468,13 @@
                 </a:solidFill>
                 <a:latin typeface="Cascadia Mono"/>
               </a:rPr>
-              <a:t>    |   |   |-- playwrighter/
+              <a:t>    |   |   |-- or/
+    |   |   |   |-- config.yaml
+    |   |   |   `-- or.py
+    |   |   |-- parametrizer/
+    |   |   |   |-- config.yaml
+    |   |   |   `-- parametrizer.py
+    |   |   |-- playwrighter/
     |   |   |   |-- config.yaml
     |   |   |   `-- playwrighter.py
     |   |   |-- prompter/
@@ -45507,13 +45498,7 @@
     |   |   |-- reviewer/
     |   |   |   |-- config.yaml
     |   |   |   `-- reviewer.py
-    |   |   |-- scper/
-    |   |   |   |-- config.yaml
-    |   |   |   `-- scper.py
-    |   |   |-- shoter/
-    |   |   |   |-- config.yaml
-    |   |   |   `-- shoter.py
-    |   |   |-- sleeper/</a:t>
+    |   |   |-- scper/</a:t>
             </a:r>
           </a:p>
         </p:txBody>
@@ -45816,7 +45801,7 @@
                 </a:solidFill>
                 <a:latin typeface="Aptos Display"/>
               </a:rPr>
-              <a:t>Tracked File Tree Appendix 12/23</a:t>
+              <a:t>Tracked File Tree Appendix 12/24</a:t>
             </a:r>
           </a:p>
         </p:txBody>
@@ -45852,6 +45837,12 @@
                 <a:latin typeface="Cascadia Mono"/>
               </a:rPr>
               <a:t>    |   |   |   |-- config.yaml
+    |   |   |   `-- scper.py
+    |   |   |-- shoter/
+    |   |   |   |-- config.yaml
+    |   |   |   `-- shoter.py
+    |   |   |-- sleeper/
+    |   |   |   |-- config.yaml
     |   |   |   `-- sleeper.py
     |   |   |-- sqler/
     |   |   |   |-- config.yaml
@@ -45875,12 +45866,6 @@
     |   |   |   |-- config.yaml
     |   |   |   `-- telegramer.py
     |   |   |-- telegramrx/
-    |   |   |   |-- config.yaml
-    |   |   |   `-- telegramrx.py
-    |   |   |-- teletlamatini/
-    |   |   |   |-- config.yaml
-    |   |   |   `-- teletlamatini.py
-    |   |   |-- unrealer/
     |   |   |   |-- config.yaml</a:t>
             </a:r>
           </a:p>
@@ -46971,7 +46956,7 @@
                 </a:solidFill>
                 <a:latin typeface="Aptos Display"/>
               </a:rPr>
-              <a:t>Tracked File Tree Appendix 13/23</a:t>
+              <a:t>Tracked File Tree Appendix 13/24</a:t>
             </a:r>
           </a:p>
         </p:txBody>
@@ -47006,7 +46991,16 @@
                 </a:solidFill>
                 <a:latin typeface="Cascadia Mono"/>
               </a:rPr>
-              <a:t>    |   |   |   `-- unrealer.py
+              <a:t>    |   |   |   `-- telegramrx.py
+    |   |   |-- teletlamatini/
+    |   |   |   |-- config.yaml
+    |   |   |   `-- teletlamatini.py
+    |   |   |-- unrealer/
+    |   |   |   |-- config.yaml
+    |   |   |   `-- unrealer.py
+    |   |   |-- videoplayer/
+    |   |   |   |-- config.yaml
+    |   |   |   `-- videoplayer.py
     |   |   |-- whatsapper/
     |   |   |   |-- config.yaml
     |   |   |   `-- whatsapper.py
@@ -47027,16 +47021,7 @@
     |   |   |-- RealisticTlamatini.png
     |   |   |-- ShouldersUoTlamatini.png
     |   |   |-- Tlamatini AI Agentic Advisor Video.mp4
-    |   |   |-- TlamatiniAbout.jpg
-    |   |   |-- TlamatiniDrawings.png
-    |   |   |-- TlammatiniLetsMakeSomeMagic.mp4
-    |   |   |-- TorsoTlamatini.png
-    |   |   `-- XAIHT-Tlamatini.mp4
-    |   |-- imaging/
-    |   |   |-- converter.py
-    |   |   |-- image_interpreter.py
-    |   |   `-- screenshot.py
-    |   |-- management/</a:t>
+    |   |   |-- TlamatiniAbout.jpg</a:t>
             </a:r>
           </a:p>
         </p:txBody>
@@ -47339,7 +47324,7 @@
                 </a:solidFill>
                 <a:latin typeface="Aptos Display"/>
               </a:rPr>
-              <a:t>Tracked File Tree Appendix 14/23</a:t>
+              <a:t>Tracked File Tree Appendix 14/24</a:t>
             </a:r>
           </a:p>
         </p:txBody>
@@ -47374,7 +47359,16 @@
                 </a:solidFill>
                 <a:latin typeface="Cascadia Mono"/>
               </a:rPr>
-              <a:t>    |   |   |-- __init__.py
+              <a:t>    |   |   |-- TlamatiniDrawings.png
+    |   |   |-- TlammatiniLetsMakeSomeMagic.mp4
+    |   |   |-- TorsoTlamatini.png
+    |   |   `-- XAIHT-Tlamatini.mp4
+    |   |-- imaging/
+    |   |   |-- converter.py
+    |   |   |-- image_interpreter.py
+    |   |   `-- screenshot.py
+    |   |-- management/
+    |   |   |-- __init__.py
     |   |   `-- commands/
     |   |       |-- acpx_lint.py
     |   |       `-- startserver.py
@@ -47395,16 +47389,7 @@
     |   |   |-- 0014_repopulate_all_agents.py
     |   |   |-- 0015_add_shoter.py
     |   |   |-- 0016_repopulate_all_agents.py
-    |   |   |-- 0017_add_ssher.py
-    |   |   |-- 0018_repopulate_all_agents.py
-    |   |   |-- 0019_add_scper.py
-    |   |   |-- 0020_repopulate_all_agents.py
-    |   |   |-- 0021_add_telegramrx.py
-    |   |   |-- 0022_repopulate_all_agents.py
-    |   |   |-- 0023_add_mongoxer.py
-    |   |   |-- 0024_repopulate_all_agents.py
-    |   |   |-- 0025_add_telegramer.py
-    |   |   |-- 0026_repopulate_all_agents.py</a:t>
+    |   |   |-- 0017_add_ssher.py</a:t>
             </a:r>
           </a:p>
         </p:txBody>
@@ -47707,7 +47692,7 @@
                 </a:solidFill>
                 <a:latin typeface="Aptos Display"/>
               </a:rPr>
-              <a:t>Tracked File Tree Appendix 15/23</a:t>
+              <a:t>Tracked File Tree Appendix 15/24</a:t>
             </a:r>
           </a:p>
         </p:txBody>
@@ -47742,7 +47727,16 @@
                 </a:solidFill>
                 <a:latin typeface="Cascadia Mono"/>
               </a:rPr>
-              <a:t>    |   |   |-- 0027_add_sqler.py
+              <a:t>    |   |   |-- 0018_repopulate_all_agents.py
+    |   |   |-- 0019_add_scper.py
+    |   |   |-- 0020_repopulate_all_agents.py
+    |   |   |-- 0021_add_telegramrx.py
+    |   |   |-- 0022_repopulate_all_agents.py
+    |   |   |-- 0023_add_mongoxer.py
+    |   |   |-- 0024_repopulate_all_agents.py
+    |   |   |-- 0025_add_telegramer.py
+    |   |   |-- 0026_repopulate_all_agents.py
+    |   |   |-- 0027_add_sqler.py
     |   |   |-- 0028_repopulate_all_agents.py
     |   |   |-- 0029_add_prompter.py
     |   |   |-- 0030_repopulate_all_agents.py
@@ -47763,16 +47757,7 @@
     |   |   |-- 0045_add_file_interpreter.py
     |   |   |-- 0046_add_image_interpreter.py
     |   |   |-- 0047_add_gatewayer.py
-    |   |   |-- 0048_add_gateway_relayer.py
-    |   |   |-- 0049_add_node_manager.py
-    |   |   |-- 0050_add_file_creator.py
-    |   |   |-- 0051_add_file_extractor.py
-    |   |   |-- 0052_add_kyber_keygen.py
-    |   |   |-- 0053_add_kyber_cipher.py
-    |   |   |-- 0054_add_kyber_decipher.py
-    |   |   |-- 0055_fix_kyber_cipher_names.py
-    |   |   |-- 0056_add_parametrizer.py
-    |   |   |-- 0057_add_flowbacker.py</a:t>
+    |   |   |-- 0048_add_gateway_relayer.py</a:t>
             </a:r>
           </a:p>
         </p:txBody>
@@ -48075,7 +48060,7 @@
                 </a:solidFill>
                 <a:latin typeface="Aptos Display"/>
               </a:rPr>
-              <a:t>Tracked File Tree Appendix 16/23</a:t>
+              <a:t>Tracked File Tree Appendix 16/24</a:t>
             </a:r>
           </a:p>
         </p:txBody>
@@ -48110,7 +48095,16 @@
                 </a:solidFill>
                 <a:latin typeface="Cascadia Mono"/>
               </a:rPr>
-              <a:t>    |   |   |-- 0058_add_barrier.py
+              <a:t>    |   |   |-- 0049_add_node_manager.py
+    |   |   |-- 0050_add_file_creator.py
+    |   |   |-- 0051_add_file_extractor.py
+    |   |   |-- 0052_add_kyber_keygen.py
+    |   |   |-- 0053_add_kyber_cipher.py
+    |   |   |-- 0054_add_kyber_decipher.py
+    |   |   |-- 0055_fix_kyber_cipher_names.py
+    |   |   |-- 0056_add_parametrizer.py
+    |   |   |-- 0057_add_flowbacker.py
+    |   |   |-- 0058_add_barrier.py
     |   |   |-- 0059_add_j_decompiler.py
     |   |   |-- 0060_add_agent_parametrizer_tool.py
     |   |   |-- 0061_add_agent_starter_tool.py
@@ -48131,16 +48125,7 @@
     |   |   |-- 0076_add_acpxer.py
     |   |   |-- 0077_add_whatstlamatini.py
     |   |   |-- 0078_add_chat_agent_keyboarder_tool.py
-    |   |   |-- 0079_add_chat_agent_mouser_tool.py
-    |   |   |-- 0080_add_chat_agent_sleeper_tool.py
-    |   |   |-- 0081_add_window_present_and_run_wait_tools.py
-    |   |   |-- 0082_add_chat_agent_j_decompiler_tool.py
-    |   |   |-- 0083_add_de_compresser.py
-    |   |   |-- 0084_add_chat_agent_de_compresser_tool.py
-    |   |   |-- 0085_add_unrealer.py
-    |   |   |-- 0086_add_chat_agent_unrealer_tool.py
-    |   |   |-- 0087_add_unrealer_demo_prompt.py
-    |   |   |-- 0088_add_reviewer.py</a:t>
+    |   |   |-- 0079_add_chat_agent_mouser_tool.py</a:t>
             </a:r>
           </a:p>
         </p:txBody>
@@ -48443,7 +48428,7 @@
                 </a:solidFill>
                 <a:latin typeface="Aptos Display"/>
               </a:rPr>
-              <a:t>Tracked File Tree Appendix 17/23</a:t>
+              <a:t>Tracked File Tree Appendix 17/24</a:t>
             </a:r>
           </a:p>
         </p:txBody>
@@ -48478,7 +48463,16 @@
                 </a:solidFill>
                 <a:latin typeface="Cascadia Mono"/>
               </a:rPr>
-              <a:t>    |   |   |-- 0089_add_analyzer.py
+              <a:t>    |   |   |-- 0080_add_chat_agent_sleeper_tool.py
+    |   |   |-- 0081_add_window_present_and_run_wait_tools.py
+    |   |   |-- 0082_add_chat_agent_j_decompiler_tool.py
+    |   |   |-- 0083_add_de_compresser.py
+    |   |   |-- 0084_add_chat_agent_de_compresser_tool.py
+    |   |   |-- 0085_add_unrealer.py
+    |   |   |-- 0086_add_chat_agent_unrealer_tool.py
+    |   |   |-- 0087_add_unrealer_demo_prompt.py
+    |   |   |-- 0088_add_reviewer.py
+    |   |   |-- 0089_add_analyzer.py
     |   |   |-- 0090_add_reviewer_analyzer_demo_prompts.py
     |   |   |-- 0091_add_playwrighter.py
     |   |   |-- 0092_add_chat_agent_playwrighter_tool.py
@@ -48499,16 +48493,7 @@
     |   |   |-- 0107_add_esp32er_demo_prompts.py
     |   |   |-- 0108_add_flow_making_demo_prompt.py
     |   |   |-- 0109_add_arduiner.py
-    |   |   |-- 0110_add_chat_agent_arduiner_tool.py
-    |   |   |-- 0111_add_arduiner_demo_prompts.py
-    |   |   |-- 0112_add_camcorder.py
-    |   |   |-- 0113_add_chat_agent_camcorder_tool.py
-    |   |   |-- 0114_add_recorder.py
-    |   |   |-- 0115_add_chat_agent_recorder_tool.py
-    |   |   `-- __init__.py
-    |   |-- monitors/
-    |   |   `-- monitor_sql.py
-    |   |-- opus_client/</a:t>
+    |   |   |-- 0110_add_chat_agent_arduiner_tool.py</a:t>
             </a:r>
           </a:p>
         </p:txBody>
@@ -48811,7 +48796,7 @@
                 </a:solidFill>
                 <a:latin typeface="Aptos Display"/>
               </a:rPr>
-              <a:t>Tracked File Tree Appendix 18/23</a:t>
+              <a:t>Tracked File Tree Appendix 18/24</a:t>
             </a:r>
           </a:p>
         </p:txBody>
@@ -48846,7 +48831,20 @@
                 </a:solidFill>
                 <a:latin typeface="Cascadia Mono"/>
               </a:rPr>
-              <a:t>    |   |   |-- claude_opus_client.py
+              <a:t>    |   |   |-- 0111_add_arduiner_demo_prompts.py
+    |   |   |-- 0112_add_camcorder.py
+    |   |   |-- 0113_add_chat_agent_camcorder_tool.py
+    |   |   |-- 0114_add_recorder.py
+    |   |   |-- 0115_add_chat_agent_recorder_tool.py
+    |   |   |-- 0116_add_audioplayer.py
+    |   |   |-- 0117_add_chat_agent_audioplayer_tool.py
+    |   |   |-- 0118_add_videoplayer.py
+    |   |   |-- 0119_add_chat_agent_videoplayer_tool.py
+    |   |   `-- __init__.py
+    |   |-- monitors/
+    |   |   `-- monitor_sql.py
+    |   |-- opus_client/
+    |   |   |-- claude_opus_client.py
     |   |   |-- examples.py
     |   |   `-- README.md
     |   |-- rag/
@@ -48863,20 +48861,7 @@
     |   |   `-- chains/
     |   |       |-- base.py
     |   |       |-- basic.py
-    |   |       |-- history_aware.py
-    |   |       `-- unified.py
-    |   |-- services/
-    |   |   |-- __init__.py
-    |   |   |-- agent_contracts.py
-    |   |   |-- agent_paths.py
-    |   |   |-- answer_analizer.py
-    |   |   |-- filesystem.py
-    |   |   |-- flow_compiler.py
-    |   |   |-- flow_spec.py
-    |   |   `-- response_parser.py
-    |   |-- skills/
-    |   |   |-- __init__.py
-    |   |   |-- frontmatter.py</a:t>
+    |   |       |-- history_aware.py</a:t>
             </a:r>
           </a:p>
         </p:txBody>
@@ -49179,7 +49164,7 @@
                 </a:solidFill>
                 <a:latin typeface="Aptos Display"/>
               </a:rPr>
-              <a:t>Tracked File Tree Appendix 19/23</a:t>
+              <a:t>Tracked File Tree Appendix 19/24</a:t>
             </a:r>
           </a:p>
         </p:txBody>
@@ -49214,7 +49199,20 @@
                 </a:solidFill>
                 <a:latin typeface="Cascadia Mono"/>
               </a:rPr>
-              <a:t>    |   |   |-- harness.py
+              <a:t>    |   |       `-- unified.py
+    |   |-- services/
+    |   |   |-- __init__.py
+    |   |   |-- agent_contracts.py
+    |   |   |-- agent_paths.py
+    |   |   |-- answer_analizer.py
+    |   |   |-- filesystem.py
+    |   |   |-- flow_compiler.py
+    |   |   |-- flow_spec.py
+    |   |   `-- response_parser.py
+    |   |-- skills/
+    |   |   |-- __init__.py
+    |   |   |-- frontmatter.py
+    |   |   |-- harness.py
     |   |   |-- io_contract.py
     |   |   `-- registry.py
     |   |-- skills_pkg/
@@ -49231,20 +49229,7 @@
     |   |   |   `-- SKILL.md
     |   |   |-- flow_making/
     |   |   |   |-- SKILL.md
-    |   |   |   |-- references/
-    |   |   |   |   `-- flw_schema.md
-    |   |   |   `-- scripts/
-    |   |   |       |-- make_flow.py
-    |   |   |       `-- result_to_flw.py
-    |   |   |-- github/
-    |   |   |   `-- SKILL.md
-    |   |   |-- gmail/
-    |   |   |   `-- SKILL.md
-    |   |   |-- hello_world/
-    |   |   |   `-- SKILL.md
-    |   |   |-- jira/
-    |   |   |   `-- SKILL.md
-    |   |   |-- kali_pentest/</a:t>
+    |   |   |   |-- references/</a:t>
             </a:r>
           </a:p>
         </p:txBody>
@@ -49547,7 +49532,7 @@
                 </a:solidFill>
                 <a:latin typeface="Aptos Display"/>
               </a:rPr>
-              <a:t>Tracked File Tree Appendix 20/23</a:t>
+              <a:t>Tracked File Tree Appendix 20/24</a:t>
             </a:r>
           </a:p>
         </p:txBody>
@@ -49582,7 +49567,20 @@
                 </a:solidFill>
                 <a:latin typeface="Cascadia Mono"/>
               </a:rPr>
-              <a:t>    |   |   |   `-- SKILL.md
+              <a:t>    |   |   |   |   `-- flw_schema.md
+    |   |   |   `-- scripts/
+    |   |   |       |-- make_flow.py
+    |   |   |       `-- result_to_flw.py
+    |   |   |-- github/
+    |   |   |   `-- SKILL.md
+    |   |   |-- gmail/
+    |   |   |   `-- SKILL.md
+    |   |   |-- hello_world/
+    |   |   |   `-- SKILL.md
+    |   |   |-- jira/
+    |   |   |   `-- SKILL.md
+    |   |   |-- kali_pentest/
+    |   |   |   `-- SKILL.md
     |   |   |-- notion/
     |   |   |   `-- SKILL.md
     |   |   |-- security_audit/
@@ -49599,20 +49597,7 @@
     |   |   |   `-- SKILL.md
     |   |   |-- tlamatini_allowed_hosts_tighten/
     |   |   |   `-- SKILL.md
-    |   |   |-- tlamatini_csrf_exempt_audit/
-    |   |   |   `-- SKILL.md
-    |   |   |-- tlamatini_exec_report_row_adder/
-    |   |   |   `-- SKILL.md
-    |   |   |-- tlamatini_flow_from_objective/
-    |   |   |   `-- SKILL.md
-    |   |   |-- tlamatini_flw_doctor/
-    |   |   |   `-- SKILL.md
-    |   |   |-- tlamatini_new_acp_agent/
-    |   |   |   `-- SKILL.md
-    |   |   |-- tlamatini_planner_trace_replay/
-    |   |   |   `-- SKILL.md
-    |   |   |-- tlamatini_static_version_bumper/
-    |   |   |   `-- SKILL.md</a:t>
+    |   |   |-- tlamatini_csrf_exempt_audit/</a:t>
             </a:r>
           </a:p>
         </p:txBody>
@@ -49915,7 +49900,7 @@
                 </a:solidFill>
                 <a:latin typeface="Aptos Display"/>
               </a:rPr>
-              <a:t>Tracked File Tree Appendix 21/23</a:t>
+              <a:t>Tracked File Tree Appendix 21/24</a:t>
             </a:r>
           </a:p>
         </p:txBody>
@@ -49950,7 +49935,20 @@
                 </a:solidFill>
                 <a:latin typeface="Cascadia Mono"/>
               </a:rPr>
-              <a:t>    |   |   |-- todoist/
+              <a:t>    |   |   |   `-- SKILL.md
+    |   |   |-- tlamatini_exec_report_row_adder/
+    |   |   |   `-- SKILL.md
+    |   |   |-- tlamatini_flow_from_objective/
+    |   |   |   `-- SKILL.md
+    |   |   |-- tlamatini_flw_doctor/
+    |   |   |   `-- SKILL.md
+    |   |   |-- tlamatini_new_acp_agent/
+    |   |   |   `-- SKILL.md
+    |   |   |-- tlamatini_planner_trace_replay/
+    |   |   |   `-- SKILL.md
+    |   |   |-- tlamatini_static_version_bumper/
+    |   |   |   `-- SKILL.md
+    |   |   |-- todoist/
     |   |   |   `-- SKILL.md
     |   |   |-- trello/
     |   |   |   `-- SKILL.md
@@ -49967,20 +49965,7 @@
     |   |       |   `-- welcome.css
     |   |       |-- img/
     |   |       |   |-- spinner.svg
-    |   |       |   `-- Tlamatini.ico
-    |   |       |-- js/
-    |   |       |   |-- acp-agent-connectors.js
-    |   |       |   |-- acp-canvas-core.js
-    |   |       |   |-- acp-canvas-undo.js
-    |   |       |   |-- acp-control-buttons.js
-    |   |       |   |-- acp-file-io.js
-    |   |       |   |-- acp-flow-snapshot.js
-    |   |       |   |-- acp-globals.js
-    |   |       |   |-- acp-layout.js
-    |   |       |   |-- acp-parametrizer-dialog.js
-    |   |       |   |-- acp-running-state.js
-    |   |       |   |-- acp-session.js
-    |   |       |   |-- acp-undo-manager.js</a:t>
+    |   |       |   `-- Tlamatini.ico</a:t>
             </a:r>
           </a:p>
         </p:txBody>
@@ -50283,7 +50268,7 @@
                 </a:solidFill>
                 <a:latin typeface="Aptos Display"/>
               </a:rPr>
-              <a:t>Tracked File Tree Appendix 22/23</a:t>
+              <a:t>Tracked File Tree Appendix 22/24</a:t>
             </a:r>
           </a:p>
         </p:txBody>
@@ -50318,7 +50303,20 @@
                 </a:solidFill>
                 <a:latin typeface="Cascadia Mono"/>
               </a:rPr>
-              <a:t>    |   |       |   |-- acp-validate.js
+              <a:t>    |   |       |-- js/
+    |   |       |   |-- acp-agent-connectors.js
+    |   |       |   |-- acp-canvas-core.js
+    |   |       |   |-- acp-canvas-undo.js
+    |   |       |   |-- acp-control-buttons.js
+    |   |       |   |-- acp-file-io.js
+    |   |       |   |-- acp-flow-snapshot.js
+    |   |       |   |-- acp-globals.js
+    |   |       |   |-- acp-layout.js
+    |   |       |   |-- acp-parametrizer-dialog.js
+    |   |       |   |-- acp-running-state.js
+    |   |       |   |-- acp-session.js
+    |   |       |   |-- acp-undo-manager.js
+    |   |       |   |-- acp-validate.js
     |   |       |   |-- agent_page_canvas.js
     |   |       |   |-- agent_page_chat.js
     |   |       |   |-- agent_page_context.js
@@ -50335,20 +50333,7 @@
     |   |       |   |-- skills_dialog.js
     |   |       |   `-- tools_dialog.js
     |   |       |-- sounds/
-    |   |       |   |-- hypervisor_alert.wav
-    |   |       |   `-- notification.wav
-    |   |       `-- video/
-    |   |           `-- XAIHT-Tlamatini.mp4
-    |   |-- telegram/
-    |   |   |-- AztecTlamatini.txt
-    |   |   |-- config.yaml
-    |   |   `-- telegram_receiver.py
-    |   |-- templates/
-    |   |   `-- agent/
-    |   |       |-- agent_page.html
-    |   |       |-- agentic_control_panel.html
-    |   |       |-- login.html
-    |   |       `-- welcome.html</a:t>
+    |   |       |   |-- hypervisor_alert.wav</a:t>
             </a:r>
           </a:p>
         </p:txBody>
@@ -51422,7 +51407,7 @@
                 </a:solidFill>
                 <a:latin typeface="Aptos Display"/>
               </a:rPr>
-              <a:t>Tracked File Tree Appendix 23/23</a:t>
+              <a:t>Tracked File Tree Appendix 23/24</a:t>
             </a:r>
           </a:p>
         </p:txBody>
@@ -51457,7 +51442,20 @@
                 </a:solidFill>
                 <a:latin typeface="Cascadia Mono"/>
               </a:rPr>
-              <a:t>    |   `-- TlamatiniSourceCode/
+              <a:t>    |   |       |   `-- notification.wav
+    |   |       `-- video/
+    |   |           `-- XAIHT-Tlamatini.mp4
+    |   |-- telegram/
+    |   |   |-- AztecTlamatini.txt
+    |   |   |-- config.yaml
+    |   |   `-- telegram_receiver.py
+    |   |-- templates/
+    |   |   `-- agent/
+    |   |       |-- agent_page.html
+    |   |       |-- agentic_control_panel.html
+    |   |       |-- login.html
+    |   |       `-- welcome.html
+    |   `-- TlamatiniSourceCode/
     |       `-- README.md
     |-- DB/
     |   |-- Older/
@@ -51474,8 +51472,7 @@
         |-- logging_filters.py
         |-- middleware.py
         |-- settings.py
-        |-- urls.py
-        `-- wsgi.py</a:t>
+        |-- urls.py</a:t>
             </a:r>
           </a:p>
         </p:txBody>
@@ -51489,6 +51486,344 @@
 </file>
 
 <file path=ppt/slides/slide81.xml><?xml version="1.0" encoding="utf-8"?>
+<p:sld xmlns:a="http://schemas.openxmlformats.org/drawingml/2006/main" xmlns:p="http://schemas.openxmlformats.org/presentationml/2006/main" xmlns:r="http://schemas.openxmlformats.org/officeDocument/2006/relationships">
+  <p:cSld>
+    <p:spTree>
+      <p:nvGrpSpPr>
+        <p:cNvPr id="1" name=""/>
+        <p:cNvGrpSpPr/>
+        <p:nvPr/>
+      </p:nvGrpSpPr>
+      <p:grpSpPr/>
+      <p:sp>
+        <p:nvSpPr>
+          <p:cNvPr id="2" name="Rectangle 1"/>
+          <p:cNvSpPr/>
+          <p:nvPr/>
+        </p:nvSpPr>
+        <p:spPr>
+          <a:xfrm>
+            <a:off x="0" y="0"/>
+            <a:ext cx="12191695" cy="6858000"/>
+          </a:xfrm>
+          <a:prstGeom prst="rect">
+            <a:avLst/>
+          </a:prstGeom>
+          <a:solidFill>
+            <a:srgbClr val="080D0D"/>
+          </a:solidFill>
+          <a:ln>
+            <a:noFill/>
+          </a:ln>
+        </p:spPr>
+        <p:style>
+          <a:lnRef idx="1">
+            <a:schemeClr val="accent1"/>
+          </a:lnRef>
+          <a:fillRef idx="3">
+            <a:schemeClr val="accent1"/>
+          </a:fillRef>
+          <a:effectRef idx="2">
+            <a:schemeClr val="accent1"/>
+          </a:effectRef>
+          <a:fontRef idx="minor">
+            <a:schemeClr val="lt1"/>
+          </a:fontRef>
+        </p:style>
+        <p:txBody>
+          <a:bodyPr rtlCol="0" anchor="ctr"/>
+          <a:lstStyle/>
+          <a:p>
+            <a:pPr algn="ctr"/>
+          </a:p>
+        </p:txBody>
+      </p:sp>
+      <p:sp>
+        <p:nvSpPr>
+          <p:cNvPr id="3" name="Rectangle 2"/>
+          <p:cNvSpPr/>
+          <p:nvPr/>
+        </p:nvSpPr>
+        <p:spPr>
+          <a:xfrm>
+            <a:off x="320040" y="384048"/>
+            <a:ext cx="36576" cy="6080760"/>
+          </a:xfrm>
+          <a:prstGeom prst="rect">
+            <a:avLst/>
+          </a:prstGeom>
+          <a:solidFill>
+            <a:srgbClr val="C48052"/>
+          </a:solidFill>
+          <a:ln>
+            <a:noFill/>
+          </a:ln>
+        </p:spPr>
+        <p:style>
+          <a:lnRef idx="1">
+            <a:schemeClr val="accent1"/>
+          </a:lnRef>
+          <a:fillRef idx="3">
+            <a:schemeClr val="accent1"/>
+          </a:fillRef>
+          <a:effectRef idx="2">
+            <a:schemeClr val="accent1"/>
+          </a:effectRef>
+          <a:fontRef idx="minor">
+            <a:schemeClr val="lt1"/>
+          </a:fontRef>
+        </p:style>
+        <p:txBody>
+          <a:bodyPr rtlCol="0" anchor="ctr"/>
+          <a:lstStyle/>
+          <a:p>
+            <a:pPr algn="ctr"/>
+          </a:p>
+        </p:txBody>
+      </p:sp>
+      <p:sp>
+        <p:nvSpPr>
+          <p:cNvPr id="4" name="Rectangle 3"/>
+          <p:cNvSpPr/>
+          <p:nvPr/>
+        </p:nvSpPr>
+        <p:spPr>
+          <a:xfrm>
+            <a:off x="11716207" y="384048"/>
+            <a:ext cx="36576" cy="6080760"/>
+          </a:xfrm>
+          <a:prstGeom prst="rect">
+            <a:avLst/>
+          </a:prstGeom>
+          <a:solidFill>
+            <a:srgbClr val="C48052"/>
+          </a:solidFill>
+          <a:ln>
+            <a:noFill/>
+          </a:ln>
+        </p:spPr>
+        <p:style>
+          <a:lnRef idx="1">
+            <a:schemeClr val="accent1"/>
+          </a:lnRef>
+          <a:fillRef idx="3">
+            <a:schemeClr val="accent1"/>
+          </a:fillRef>
+          <a:effectRef idx="2">
+            <a:schemeClr val="accent1"/>
+          </a:effectRef>
+          <a:fontRef idx="minor">
+            <a:schemeClr val="lt1"/>
+          </a:fontRef>
+        </p:style>
+        <p:txBody>
+          <a:bodyPr rtlCol="0" anchor="ctr"/>
+          <a:lstStyle/>
+          <a:p>
+            <a:pPr algn="ctr"/>
+          </a:p>
+        </p:txBody>
+      </p:sp>
+      <p:sp>
+        <p:nvSpPr>
+          <p:cNvPr id="5" name="Rectangle 4"/>
+          <p:cNvSpPr/>
+          <p:nvPr/>
+        </p:nvSpPr>
+        <p:spPr>
+          <a:xfrm>
+            <a:off x="502920" y="384048"/>
+            <a:ext cx="11155680" cy="27432"/>
+          </a:xfrm>
+          <a:prstGeom prst="rect">
+            <a:avLst/>
+          </a:prstGeom>
+          <a:solidFill>
+            <a:srgbClr val="C48052"/>
+          </a:solidFill>
+          <a:ln>
+            <a:noFill/>
+          </a:ln>
+        </p:spPr>
+        <p:style>
+          <a:lnRef idx="1">
+            <a:schemeClr val="accent1"/>
+          </a:lnRef>
+          <a:fillRef idx="3">
+            <a:schemeClr val="accent1"/>
+          </a:fillRef>
+          <a:effectRef idx="2">
+            <a:schemeClr val="accent1"/>
+          </a:effectRef>
+          <a:fontRef idx="minor">
+            <a:schemeClr val="lt1"/>
+          </a:fontRef>
+        </p:style>
+        <p:txBody>
+          <a:bodyPr rtlCol="0" anchor="ctr"/>
+          <a:lstStyle/>
+          <a:p>
+            <a:pPr algn="ctr"/>
+          </a:p>
+        </p:txBody>
+      </p:sp>
+      <p:sp>
+        <p:nvSpPr>
+          <p:cNvPr id="6" name="Rectangle 5"/>
+          <p:cNvSpPr/>
+          <p:nvPr/>
+        </p:nvSpPr>
+        <p:spPr>
+          <a:xfrm>
+            <a:off x="502920" y="6437376"/>
+            <a:ext cx="11155680" cy="27432"/>
+          </a:xfrm>
+          <a:prstGeom prst="rect">
+            <a:avLst/>
+          </a:prstGeom>
+          <a:solidFill>
+            <a:srgbClr val="C48052"/>
+          </a:solidFill>
+          <a:ln>
+            <a:noFill/>
+          </a:ln>
+        </p:spPr>
+        <p:style>
+          <a:lnRef idx="1">
+            <a:schemeClr val="accent1"/>
+          </a:lnRef>
+          <a:fillRef idx="3">
+            <a:schemeClr val="accent1"/>
+          </a:fillRef>
+          <a:effectRef idx="2">
+            <a:schemeClr val="accent1"/>
+          </a:effectRef>
+          <a:fontRef idx="minor">
+            <a:schemeClr val="lt1"/>
+          </a:fontRef>
+        </p:style>
+        <p:txBody>
+          <a:bodyPr rtlCol="0" anchor="ctr"/>
+          <a:lstStyle/>
+          <a:p>
+            <a:pPr algn="ctr"/>
+          </a:p>
+        </p:txBody>
+      </p:sp>
+      <p:sp>
+        <p:nvSpPr>
+          <p:cNvPr id="7" name="TextBox 6"/>
+          <p:cNvSpPr txBox="1"/>
+          <p:nvPr/>
+        </p:nvSpPr>
+        <p:spPr>
+          <a:xfrm>
+            <a:off x="713232" y="548640"/>
+            <a:ext cx="10698480" cy="301752"/>
+          </a:xfrm>
+          <a:prstGeom prst="rect">
+            <a:avLst/>
+          </a:prstGeom>
+          <a:noFill/>
+        </p:spPr>
+        <p:txBody>
+          <a:bodyPr wrap="square" anchor="t">
+            <a:spAutoFit/>
+          </a:bodyPr>
+          <a:lstStyle/>
+          <a:p>
+            <a:pPr algn="l"/>
+            <a:r>
+              <a:rPr sz="1000" b="1">
+                <a:solidFill>
+                  <a:srgbClr val="C48052"/>
+                </a:solidFill>
+                <a:latin typeface="Aptos"/>
+              </a:rPr>
+              <a:t>COMPLETE TRACKED FILE TREE, NO TRACKED FILE OMITTED</a:t>
+            </a:r>
+          </a:p>
+        </p:txBody>
+      </p:sp>
+      <p:sp>
+        <p:nvSpPr>
+          <p:cNvPr id="8" name="TextBox 7"/>
+          <p:cNvSpPr txBox="1"/>
+          <p:nvPr/>
+        </p:nvSpPr>
+        <p:spPr>
+          <a:xfrm>
+            <a:off x="694944" y="850392"/>
+            <a:ext cx="10881360" cy="566928"/>
+          </a:xfrm>
+          <a:prstGeom prst="rect">
+            <a:avLst/>
+          </a:prstGeom>
+          <a:noFill/>
+        </p:spPr>
+        <p:txBody>
+          <a:bodyPr wrap="square" anchor="t">
+            <a:spAutoFit/>
+          </a:bodyPr>
+          <a:lstStyle/>
+          <a:p>
+            <a:pPr algn="l"/>
+            <a:r>
+              <a:rPr sz="2700" b="0">
+                <a:solidFill>
+                  <a:srgbClr val="E8E8DE"/>
+                </a:solidFill>
+                <a:latin typeface="Aptos Display"/>
+              </a:rPr>
+              <a:t>Tracked File Tree Appendix 24/24</a:t>
+            </a:r>
+          </a:p>
+        </p:txBody>
+      </p:sp>
+      <p:sp>
+        <p:nvSpPr>
+          <p:cNvPr id="9" name="TextBox 8"/>
+          <p:cNvSpPr txBox="1"/>
+          <p:nvPr/>
+        </p:nvSpPr>
+        <p:spPr>
+          <a:xfrm>
+            <a:off x="658368" y="1426464"/>
+            <a:ext cx="10927080" cy="4956048"/>
+          </a:xfrm>
+          <a:prstGeom prst="rect">
+            <a:avLst/>
+          </a:prstGeom>
+          <a:noFill/>
+        </p:spPr>
+        <p:txBody>
+          <a:bodyPr wrap="square" anchor="t">
+            <a:spAutoFit/>
+          </a:bodyPr>
+          <a:lstStyle/>
+          <a:p>
+            <a:pPr algn="l"/>
+            <a:r>
+              <a:rPr sz="700" b="0">
+                <a:solidFill>
+                  <a:srgbClr val="E8E8DE"/>
+                </a:solidFill>
+                <a:latin typeface="Cascadia Mono"/>
+              </a:rPr>
+              <a:t>        `-- wsgi.py</a:t>
+            </a:r>
+          </a:p>
+        </p:txBody>
+      </p:sp>
+    </p:spTree>
+  </p:cSld>
+  <p:clrMapOvr>
+    <a:masterClrMapping/>
+  </p:clrMapOvr>
+</p:sld>
+</file>
+
+<file path=ppt/slides/slide82.xml><?xml version="1.0" encoding="utf-8"?>
 <p:sld xmlns:a="http://schemas.openxmlformats.org/drawingml/2006/main" xmlns:p="http://schemas.openxmlformats.org/presentationml/2006/main" xmlns:r="http://schemas.openxmlformats.org/officeDocument/2006/relationships">
   <p:cSld>
     <p:spTree>

</xml_diff>

<commit_message>
Updating info, by angelahack1
</commit_message>
<xml_diff>
--- a/Tlamatini_eXtended_Artificial_Intelligence_Humanly_Tempered.pptx
+++ b/Tlamatini_eXtended_Artificial_Intelligence_Humanly_Tempered.pptx
@@ -3524,7 +3524,7 @@
                 </a:solidFill>
                 <a:latin typeface="Aptos"/>
               </a:rPr>
-              <a:t>Local AI developer assistant with RAG, Multi-Turn orchestration, 74 agents, ACPX delegation, visual workflows, self-knowledge, and Windows packaging.</a:t>
+              <a:t>Self-hosted AI developer assistant (cloud LLMs by default) with RAG, Multi-Turn orchestration, 74 agents, ACPX delegation, visual workflows, self-knowledge, and Windows packaging.</a:t>
             </a:r>
           </a:p>
         </p:txBody>
@@ -11375,7 +11375,7 @@
               </a:defRPr>
             </a:pPr>
             <a:r>
-              <a:t>Tlamatini is a local-first AI developer assistant built with Django, Django Channels, LangChain, LangGraph, FAISS/BM25 retrieval, and a large in-repository agent application.</a:t>
+              <a:t>Tlamatini is a self-hosted AI developer assistant (cloud LLMs by default; app and RAG run locally) built with Django, Django Channels, LangChain, LangGraph, FAISS/BM25 retrieval, and a large in-repository agent application.</a:t>
             </a:r>
           </a:p>
           <a:p>

</xml_diff>

<commit_message>
Updating all of the documentation upgrading to Tlamatini's v1.19.3, by Tlamatini's-AutoBot.
</commit_message>
<xml_diff>
--- a/Tlamatini_eXtended_Artificial_Intelligence_Humanly_Tempered.pptx
+++ b/Tlamatini_eXtended_Artificial_Intelligence_Humanly_Tempered.pptx
@@ -90,6 +90,7 @@
     <p:sldId id="338" r:id="rId89"/>
     <p:sldId id="339" r:id="rId90"/>
     <p:sldId id="340" r:id="rId91"/>
+    <p:sldId id="341" r:id="rId92"/>
   </p:sldIdLst>
   <p:sldSz cx="12191695" cy="6858000" type="screen4x3"/>
   <p:notesSz cx="6858000" cy="9144000"/>
@@ -3637,7 +3638,7 @@
                 </a:solidFill>
                 <a:latin typeface="Aptos"/>
               </a:rPr>
-              <a:t>671</a:t>
+              <a:t>672</a:t>
             </a:r>
           </a:p>
         </p:txBody>
@@ -3867,7 +3868,7 @@
                 </a:solidFill>
                 <a:latin typeface="Aptos"/>
               </a:rPr>
-              <a:t>138,010</a:t>
+              <a:t>138,522</a:t>
             </a:r>
           </a:p>
         </p:txBody>
@@ -3902,7 +3903,7 @@
                 </a:solidFill>
                 <a:latin typeface="Aptos"/>
               </a:rPr>
-              <a:t>Generated June 08, 2026 11:27 PM UTC-0600 at HEAD d50cb98</a:t>
+              <a:t>Generated June 10, 2026 11:49 AM UTC-0600 at HEAD fc1eb10</a:t>
             </a:r>
           </a:p>
         </p:txBody>
@@ -5584,7 +5585,7 @@
                 </a:solidFill>
                 <a:latin typeface="Aptos"/>
               </a:rPr>
-              <a:t>V1.10.0 SAFETY MODIFIER STILL ACTIVE IN V1.19.0</a:t>
+              <a:t>V1.10.0 SAFETY MODIFIER STILL ACTIVE IN V1.19.3</a:t>
             </a:r>
           </a:p>
         </p:txBody>
@@ -5781,7 +5782,7 @@
               </a:defRPr>
             </a:pPr>
             <a:r>
-              <a:t>Introduced in `v1.10.0` and still part of the current `v1.19.0` surface, `Ask Execs` is the Multi-Turn-only safety modifier that makes Tlamatini ask before each state-changing Tool, MCP, wrapped agent, or skill-backed execution instead of running it immediately.</a:t>
+              <a:t>Introduced in `v1.10.0` and still part of the current `v1.19.3` surface, `Ask Execs` is the Multi-Turn-only safety modifier that makes Tlamatini ask before each state-changing Tool, MCP, wrapped agent, or skill-backed execution instead of running it immediately.</a:t>
             </a:r>
           </a:p>
           <a:p>
@@ -6966,7 +6967,7 @@
                 </a:solidFill>
                 <a:latin typeface="Aptos"/>
               </a:rPr>
-              <a:t>V1.11.0 UNINSTALL INTEGRATION CARRIED INTO V1.19.0</a:t>
+              <a:t>V1.11.0 UNINSTALL INTEGRATION CARRIED INTO V1.19.3</a:t>
             </a:r>
           </a:p>
         </p:txBody>
@@ -7163,7 +7164,7 @@
               </a:defRPr>
             </a:pPr>
             <a:r>
-              <a:t>Introduced in `v1.11.0` and still carried by the current `v1.19.0` release, the frozen install now behaves like a real Windows application: `install.py` writes a per-user HKCU Add/Remove Programs entry so Tlamatini appears in Settings -&gt; Apps -&gt; Installed apps and in the legacy Programs and Features list.</a:t>
+              <a:t>Introduced in `v1.11.0` and still carried by the current `v1.19.3` release, the frozen install now behaves like a real Windows application: `install.py` writes a per-user HKCU Add/Remove Programs entry so Tlamatini appears in Settings -&gt; Apps -&gt; Installed apps and in the legacy Programs and Features list.</a:t>
             </a:r>
           </a:p>
           <a:p>
@@ -10682,7 +10683,7 @@
               </a:defRPr>
             </a:pPr>
             <a:r>
-              <a:t>Source inspection confirms the newer total: 51 wrapped chat-agent tools in `chat_agent_registry.py`, which combines with 20 core Python tools and 12 ACPX/Skill tools for 83 Multi-Turn tools overall.</a:t>
+              <a:t>Source inspection confirms the total: 51 distinct wrapped chat-agent tools bound from `chat_agent_registry.py`, which combines with 20 core Python tools and 12 ACPX/Skill tools for 83 Multi-Turn tools overall.</a:t>
             </a:r>
           </a:p>
           <a:p>
@@ -23465,7 +23466,7 @@
               </a:defRPr>
             </a:pPr>
             <a:r>
-              <a:t>Those readability rules remain in force in the current documentation set, and the current `v1.19.0` release state keeps the version badge, runtime surfaces, self-knowledge wording, STM32er/ESP32er demo prompts, and operator handbook aligned.</a:t>
+              <a:t>Those readability rules remain in force in the current documentation set, and the current `v1.19.3` release state keeps the version badge, runtime surfaces, self-knowledge wording, STM32er/ESP32er demo prompts, and operator handbook aligned.</a:t>
             </a:r>
           </a:p>
         </p:txBody>
@@ -24914,7 +24915,7 @@
                 </a:solidFill>
                 <a:latin typeface="Cascadia Mono"/>
               </a:rPr>
-              <a:t>Resolved current version: 1.19.0 | build: 1.19.0</a:t>
+              <a:t>Resolved current version: 1.19.3 | build: 1.19.3</a:t>
             </a:r>
           </a:p>
         </p:txBody>
@@ -35610,7 +35611,7 @@
                 </a:solidFill>
                 <a:latin typeface="Aptos"/>
               </a:rPr>
-              <a:t>671</a:t>
+              <a:t>672</a:t>
             </a:r>
           </a:p>
         </p:txBody>
@@ -36347,7 +36348,7 @@
               </a:defRPr>
             </a:pPr>
             <a:r>
-              <a:t>d50cb98 - Improving test on building No-GPU/GPU round up, by angelahack1</a:t>
+              <a:t>fc1eb10 - Fixing out of playing reaper, by Tlamatini's-AutoBot.</a:t>
             </a:r>
           </a:p>
           <a:p>
@@ -36363,7 +36364,7 @@
               </a:defRPr>
             </a:pPr>
             <a:r>
-              <a:t>Resolved version: 1.19.0 (env)</a:t>
+              <a:t>Resolved version: 1.19.3 (git)</a:t>
             </a:r>
           </a:p>
           <a:p>
@@ -36379,7 +36380,7 @@
               </a:defRPr>
             </a:pPr>
             <a:r>
-              <a:t>Generated on June 08, 2026 11:27 PM UTC-0600</a:t>
+              <a:t>Generated on June 10, 2026 11:49 AM UTC-0600</a:t>
             </a:r>
           </a:p>
           <a:p>
@@ -36411,7 +36412,7 @@
               </a:defRPr>
             </a:pPr>
             <a:r>
-              <a:t>Python requirements: 77; authoritative agent-description rows: 76</a:t>
+              <a:t>Python requirements: 78; authoritative agent-description rows: 76</a:t>
             </a:r>
           </a:p>
           <a:p>
@@ -36892,7 +36893,7 @@
               </a:defRPr>
             </a:pPr>
             <a:r>
-              <a:t>91bf943 on 2026-06-07</a:t>
+              <a:t>ccb309a on 2026-06-08</a:t>
             </a:r>
           </a:p>
           <a:p>
@@ -36908,7 +36909,7 @@
               </a:defRPr>
             </a:pPr>
             <a:r>
-              <a:t>Updating info, by angelahack1</a:t>
+              <a:t>Setted documentation as 1.19.0, by angelahack1</a:t>
             </a:r>
           </a:p>
           <a:p>
@@ -36924,7 +36925,7 @@
               </a:defRPr>
             </a:pPr>
             <a:r>
-              <a:t>Commits since then: 6</a:t>
+              <a:t>Commits since then: 5</a:t>
             </a:r>
           </a:p>
         </p:txBody>
@@ -37086,7 +37087,7 @@
               </a:defRPr>
             </a:pPr>
             <a:r>
-              <a:t>New observational capture pair: Camcorder (webcam photo/video via OpenCV) and Recorder (microphone WAV via sounddevice) — read-only siblings of Shoter, on the canvas and as wrapped chat_agent_camcorder / chat_agent_recorder tools.</a:t>
+              <a:t>Since the last committed PDF/PPTX refresh, Git shows focused platform evolution across autonomy, operator ergonomics, runtime self-knowledge, and documentation fidelity.</a:t>
             </a:r>
           </a:p>
         </p:txBody>
@@ -38243,7 +38244,7 @@
                 </a:solidFill>
                 <a:latin typeface="Aptos"/>
               </a:rPr>
-              <a:t>138,010</a:t>
+              <a:t>138,522</a:t>
             </a:r>
           </a:p>
         </p:txBody>
@@ -38358,7 +38359,7 @@
                 </a:solidFill>
                 <a:latin typeface="Aptos"/>
               </a:rPr>
-              <a:t>190,241</a:t>
+              <a:t>191,116</a:t>
             </a:r>
           </a:p>
         </p:txBody>
@@ -38509,18 +38510,18 @@
                 <a:latin typeface="Cascadia Mono"/>
               </a:rPr>
               <a:t>LANGUAGE                 FILES   EFFECTIVE      TOTAL   SHARE
-Python                   354      97,248    137,008  70.5%
-Markdown                 144      17,262     21,895  12.5%
-JavaScript                28      13,895     17,486  10.1%
-CSS                        6       3,744      4,774   2.7%
-YAML                      81       1,685      4,207   1.2%
+Python                   355      97,732    137,830  70.6%
+Markdown                 144      17,266     21,899  12.5%
+JavaScript                28      13,895     17,486  10.0%
+CSS                        6       3,760      4,799   2.7%
+YAML                      81       1,687      4,225   1.2%
 Other text                 7         906      1,101   0.7%
 HTML                       4         858        876   0.6%
 Prompt template            2         797        907   0.6%
 PowerShell                 5         508        754   0.4%
 JSON                       7         422        422   0.3%
 JavaScript module          1         405        474   0.3%
-Text                       7         245        275   0.2%
+Text                       7         251        281   0.2%
 Protocol Buffers           1          20         33   0.0%
 Batch                      1          15         29   0.0%</a:t>
             </a:r>
@@ -38869,8 +38870,8 @@
 BookOfTlamatini.md                                      Markdown       2,121   2,985
 ...ini/agent/static/agent/css/agentic_control_panel.css CSS            1,820   2,436
 Tlamatini/agent/static/agent/js/agent_page_init.js      JavaScript     1,435   1,687
-README.md                                               Markdown       1,363   1,937
-Tlamatini/agent/static/agent/css/agent_page.css         CSS            1,363   1,678
+Tlamatini/agent/static/agent/css/agent_page.css         CSS            1,379   1,703
+README.md                                               Markdown       1,367   1,941
 Tlamatini/agent/static/agent/js/acp-agent-connectors.js JavaScript     1,361   1,515
 Tlamatini/agent/static/agent/js/agent_page_chat.js      JavaScript     1,361   1,858
 Tlamatini/agent/static/agent/js/acp-canvas-core.js      JavaScript     1,335   1,645
@@ -39339,23 +39340,7 @@
               </a:defRPr>
             </a:pPr>
             <a:r>
-              <a:t>New observational capture pair: Camcorder (webcam photo/video via OpenCV) and Recorder (microphone WAV via sounddevice) — read-only siblings of Shoter, on the canvas and as wrapped chat_agent_camcorder / chat_agent_recorder tools.</a:t>
-            </a:r>
-          </a:p>
-          <a:p>
-            <a:pPr>
-              <a:spcAft>
-                <a:spcPts val="400"/>
-              </a:spcAft>
-              <a:defRPr sz="1500">
-                <a:solidFill>
-                  <a:srgbClr val="B4BAAE"/>
-                </a:solidFill>
-                <a:latin typeface="Aptos"/>
-              </a:defRPr>
-            </a:pPr>
-            <a:r>
-              <a:t>GPU-host behavior changed during the today: performance hooks, model-pinning startup behavior, and autoload-at-restart reliability were all touched.</a:t>
+              <a:t>Git history today shows focused maintenance across the operator surface, release mechanics, and runtime behavior.</a:t>
             </a:r>
           </a:p>
         </p:txBody>
@@ -39820,7 +39805,7 @@
               </a:defRPr>
             </a:pPr>
             <a:r>
-              <a:t>2026-06-08 | d50cb98 | Improving test on building No-GPU/GPU round up, by angelahack1</a:t>
+              <a:t>2026-06-10 | fc1eb10 | Fixing out of playing reaper, by Tlamatini's-AutoBot.</a:t>
             </a:r>
           </a:p>
           <a:p>
@@ -39836,7 +39821,7 @@
               </a:defRPr>
             </a:pPr>
             <a:r>
-              <a:t>2026-06-08 | de8377d | Whisperer implemented, Recorder signaling improvement, and dorking caps. in Googler and Crawler, by angelahack1</a:t>
+              <a:t>2026-06-09 | dad4f7f | Fixing out of order Talker paged exxecution, by Tlamatini's-AutoBot.</a:t>
             </a:r>
           </a:p>
           <a:p>
@@ -39852,7 +39837,7 @@
               </a:defRPr>
             </a:pPr>
             <a:r>
-              <a:t>2026-06-08 | 8d84f4d | Improving Googler and Crawler agents to implement Google dorking capabilities, by Tlamatini's-AutoBot.</a:t>
+              <a:t>2026-06-09 | 4d12919 | Improving temp file location in media agents, by angelahack1</a:t>
             </a:r>
           </a:p>
           <a:p>
@@ -39868,7 +39853,7 @@
               </a:defRPr>
             </a:pPr>
             <a:r>
-              <a:t>2026-06-07 | a9f43b2 | Implemented Talker agent!, and some enabling disabling fixes and automated talking tests, by angelahack1</a:t>
+              <a:t>2026-06-09 | 648e6ae | Upgrading Talker to enable Tlamatini speak non-stop, by Tlamatini's-AutoBot.</a:t>
             </a:r>
           </a:p>
           <a:p>
@@ -39884,23 +39869,7 @@
               </a:defRPr>
             </a:pPr>
             <a:r>
-              <a:t>2026-06-07 | 4866a4f | Improving tests, given PR-1, preparing automation on solving, by Tlamatini's-AutoBot.</a:t>
-            </a:r>
-          </a:p>
-          <a:p>
-            <a:pPr>
-              <a:spcAft>
-                <a:spcPts val="400"/>
-              </a:spcAft>
-              <a:defRPr sz="1200">
-                <a:solidFill>
-                  <a:srgbClr val="B4BAAE"/>
-                </a:solidFill>
-                <a:latin typeface="Aptos"/>
-              </a:defRPr>
-            </a:pPr>
-            <a:r>
-              <a:t>2026-06-07 | b47945a | Inception of Claude's enabling to use Tlamatini's own Mcps and Agents, by angelahack1</a:t>
+              <a:t>2026-06-09 | fe803fb | Trying to fix Talker in token managing, by angelahack1</a:t>
             </a:r>
           </a:p>
         </p:txBody>
@@ -40365,39 +40334,7 @@
               </a:defRPr>
             </a:pPr>
             <a:r>
-              <a:t>2026-06-08 | d50cb98 | Improving test on building No-GPU/GPU round up, by angelahack1</a:t>
-            </a:r>
-          </a:p>
-          <a:p>
-            <a:pPr>
-              <a:spcAft>
-                <a:spcPts val="400"/>
-              </a:spcAft>
-              <a:defRPr sz="1200">
-                <a:solidFill>
-                  <a:srgbClr val="B4BAAE"/>
-                </a:solidFill>
-                <a:latin typeface="Aptos"/>
-              </a:defRPr>
-            </a:pPr>
-            <a:r>
-              <a:t>2026-06-08 | de8377d | Whisperer implemented, Recorder signaling improvement, and dorking caps. in Googler and Crawler, by angelahack1</a:t>
-            </a:r>
-          </a:p>
-          <a:p>
-            <a:pPr>
-              <a:spcAft>
-                <a:spcPts val="400"/>
-              </a:spcAft>
-              <a:defRPr sz="1200">
-                <a:solidFill>
-                  <a:srgbClr val="B4BAAE"/>
-                </a:solidFill>
-                <a:latin typeface="Aptos"/>
-              </a:defRPr>
-            </a:pPr>
-            <a:r>
-              <a:t>2026-06-08 | 8d84f4d | Improving Googler and Crawler agents to implement Google dorking capabilities, by Tlamatini's-AutoBot.</a:t>
+              <a:t>2026-06-10 | fc1eb10 | Fixing out of playing reaper, by Tlamatini's-AutoBot.</a:t>
             </a:r>
           </a:p>
         </p:txBody>
@@ -40700,7 +40637,7 @@
                 </a:solidFill>
                 <a:latin typeface="Aptos Display"/>
               </a:rPr>
-              <a:t>Tracked File Tree Appendix 1/27</a:t>
+              <a:t>Tracked File Tree Appendix 1/28</a:t>
             </a:r>
           </a:p>
         </p:txBody>
@@ -41068,7 +41005,7 @@
                 </a:solidFill>
                 <a:latin typeface="Aptos Display"/>
               </a:rPr>
-              <a:t>Tracked File Tree Appendix 2/27</a:t>
+              <a:t>Tracked File Tree Appendix 2/28</a:t>
             </a:r>
           </a:p>
         </p:txBody>
@@ -42572,7 +42509,7 @@
                 </a:solidFill>
                 <a:latin typeface="Aptos Display"/>
               </a:rPr>
-              <a:t>Tracked File Tree Appendix 3/27</a:t>
+              <a:t>Tracked File Tree Appendix 3/28</a:t>
             </a:r>
           </a:p>
         </p:txBody>
@@ -42940,7 +42877,7 @@
                 </a:solidFill>
                 <a:latin typeface="Aptos Display"/>
               </a:rPr>
-              <a:t>Tracked File Tree Appendix 4/27</a:t>
+              <a:t>Tracked File Tree Appendix 4/28</a:t>
             </a:r>
           </a:p>
         </p:txBody>
@@ -43308,7 +43245,7 @@
                 </a:solidFill>
                 <a:latin typeface="Aptos Display"/>
               </a:rPr>
-              <a:t>Tracked File Tree Appendix 5/27</a:t>
+              <a:t>Tracked File Tree Appendix 5/28</a:t>
             </a:r>
           </a:p>
         </p:txBody>
@@ -43357,6 +43294,7 @@
 |               |-- README.md
 |               |-- requirements.txt
 |               |-- run_test.py
+|               |-- talk_test.py
 |               `-- wrapped_questions.py
 |-- .codex/
 |   `-- skills/
@@ -43372,8 +43310,7 @@
 |-- docs/
 |   `-- claude/
 |       |-- acpx.md
-|       |-- agents.md
-|       |-- architecture.md</a:t>
+|       |-- agents.md</a:t>
             </a:r>
           </a:p>
         </p:txBody>
@@ -43676,7 +43613,7 @@
                 </a:solidFill>
                 <a:latin typeface="Aptos Display"/>
               </a:rPr>
-              <a:t>Tracked File Tree Appendix 6/27</a:t>
+              <a:t>Tracked File Tree Appendix 6/28</a:t>
             </a:r>
           </a:p>
         </p:txBody>
@@ -43711,7 +43648,8 @@
                 </a:solidFill>
                 <a:latin typeface="Cascadia Mono"/>
               </a:rPr>
-              <a:t>|       |-- exec-report.md
+              <a:t>|       |-- architecture.md
+|       |-- exec-report.md
 |       |-- frontend.md
 |       |-- gotchas.md
 |       |-- INDEX.md
@@ -43740,8 +43678,7 @@
     |   |-- chat_agent_registry.py
     |   |-- chat_agent_runtime.py
     |   |-- chat_history_loader.py
-    |   |-- command_togen_pb2.txt
-    |   |-- command_watchdog.py</a:t>
+    |   |-- command_togen_pb2.txt</a:t>
             </a:r>
           </a:p>
         </p:txBody>
@@ -44044,7 +43981,7 @@
                 </a:solidFill>
                 <a:latin typeface="Aptos Display"/>
               </a:rPr>
-              <a:t>Tracked File Tree Appendix 7/27</a:t>
+              <a:t>Tracked File Tree Appendix 7/28</a:t>
             </a:r>
           </a:p>
         </p:txBody>
@@ -44079,7 +44016,8 @@
                 </a:solidFill>
                 <a:latin typeface="Cascadia Mono"/>
               </a:rPr>
-              <a:t>    |   |-- config.json
+              <a:t>    |   |-- command_watchdog.py
+    |   |-- config.json
     |   |-- config_loader.py
     |   |-- constants.py
     |   |-- consumers.py
@@ -44108,8 +44046,7 @@
     |   |-- test_audioplayer_agent.py
     |   |-- test_build_scripts.py
     |   |-- test_camcorder_agent.py
-    |   |-- test_chat_bridge_bots.py
-    |   |-- test_command_watchdog.py</a:t>
+    |   |-- test_chat_bridge_bots.py</a:t>
             </a:r>
           </a:p>
         </p:txBody>
@@ -44412,7 +44349,7 @@
                 </a:solidFill>
                 <a:latin typeface="Aptos Display"/>
               </a:rPr>
-              <a:t>Tracked File Tree Appendix 8/27</a:t>
+              <a:t>Tracked File Tree Appendix 8/28</a:t>
             </a:r>
           </a:p>
         </p:txBody>
@@ -44447,7 +44384,8 @@
                 </a:solidFill>
                 <a:latin typeface="Cascadia Mono"/>
               </a:rPr>
-              <a:t>    |   |-- test_crawler_agent.py
+              <a:t>    |   |-- test_command_watchdog.py
+    |   |-- test_crawler_agent.py
     |   |-- test_de_compresser.py
     |   |-- test_embedding_memory_guard.py
     |   |-- test_esp32er_agent.py
@@ -44476,8 +44414,7 @@
     |   |-- version.py
     |   |-- views.py
     |   |-- web_search_llm.py
-    |   |-- window_flash.py
-    |   |-- windows_app_registration.py</a:t>
+    |   |-- window_flash.py</a:t>
             </a:r>
           </a:p>
         </p:txBody>
@@ -44780,7 +44717,7 @@
                 </a:solidFill>
                 <a:latin typeface="Aptos Display"/>
               </a:rPr>
-              <a:t>Tracked File Tree Appendix 9/27</a:t>
+              <a:t>Tracked File Tree Appendix 9/28</a:t>
             </a:r>
           </a:p>
         </p:txBody>
@@ -44815,7 +44752,8 @@
                 </a:solidFill>
                 <a:latin typeface="Cascadia Mono"/>
               </a:rPr>
-              <a:t>    |   |-- acpx/
+              <a:t>    |   |-- windows_app_registration.py
+    |   |-- acpx/
     |   |   |-- __init__.py
     |   |   |-- agent_registry.py
     |   |   |-- config.py
@@ -44844,8 +44782,7 @@
     |   |   |   |-- config.yaml
     |   |   |   `-- ArduinoTemplateProject/
     |   |   |       |-- ArduinoTemplateProject.ino
-    |   |   |       |-- README.md
-    |   |   |       |-- sketch.yaml</a:t>
+    |   |   |       |-- README.md</a:t>
             </a:r>
           </a:p>
         </p:txBody>
@@ -45148,7 +45085,7 @@
                 </a:solidFill>
                 <a:latin typeface="Aptos Display"/>
               </a:rPr>
-              <a:t>Tracked File Tree Appendix 10/27</a:t>
+              <a:t>Tracked File Tree Appendix 10/28</a:t>
             </a:r>
           </a:p>
         </p:txBody>
@@ -45183,7 +45120,8 @@
                 </a:solidFill>
                 <a:latin typeface="Cascadia Mono"/>
               </a:rPr>
-              <a:t>    |   |   |       `-- src/
+              <a:t>    |   |   |       |-- sketch.yaml
+    |   |   |       `-- src/
     |   |   |           |-- Heartbeat.cpp
     |   |   |           `-- Heartbeat.h
     |   |   |-- asker/
@@ -45212,8 +45150,7 @@
     |   |   |-- croner/
     |   |   |   |-- config.yaml
     |   |   |   `-- croner.py
-    |   |   |-- de_compresser/
-    |   |   |   |-- config.yaml</a:t>
+    |   |   |-- de_compresser/</a:t>
             </a:r>
           </a:p>
         </p:txBody>
@@ -45516,7 +45453,7 @@
                 </a:solidFill>
                 <a:latin typeface="Aptos Display"/>
               </a:rPr>
-              <a:t>Tracked File Tree Appendix 11/27</a:t>
+              <a:t>Tracked File Tree Appendix 11/28</a:t>
             </a:r>
           </a:p>
         </p:txBody>
@@ -45551,7 +45488,8 @@
                 </a:solidFill>
                 <a:latin typeface="Cascadia Mono"/>
               </a:rPr>
-              <a:t>    |   |   |   `-- de_compresser.py
+              <a:t>    |   |   |   |-- config.yaml
+    |   |   |   `-- de_compresser.py
     |   |   |-- deleter/
     |   |   |   |-- config.yaml
     |   |   |   `-- deleter.py
@@ -45580,8 +45518,7 @@
     |   |   |   |-- config.yaml
     |   |   |   `-- file_interpreter.py
     |   |   |-- flowbacker/
-    |   |   |   |-- config.yaml
-    |   |   |   `-- flowbacker.py</a:t>
+    |   |   |   |-- config.yaml</a:t>
             </a:r>
           </a:p>
         </p:txBody>
@@ -45884,7 +45821,7 @@
                 </a:solidFill>
                 <a:latin typeface="Aptos Display"/>
               </a:rPr>
-              <a:t>Tracked File Tree Appendix 12/27</a:t>
+              <a:t>Tracked File Tree Appendix 12/28</a:t>
             </a:r>
           </a:p>
         </p:txBody>
@@ -45919,7 +45856,8 @@
                 </a:solidFill>
                 <a:latin typeface="Cascadia Mono"/>
               </a:rPr>
-              <a:t>    |   |   |-- flowcreator/
+              <a:t>    |   |   |   `-- flowbacker.py
+    |   |   |-- flowcreator/
     |   |   |   |-- agentic_skill.md
     |   |   |   |-- config.yaml
     |   |   |   `-- flowcreator.py
@@ -45948,8 +45886,7 @@
     |   |   |   `-- googler.py
     |   |   |-- image_interpreter/
     |   |   |   |-- config.yaml
-    |   |   |   `-- image_interpreter.py
-    |   |   |-- j_decompiler/</a:t>
+    |   |   |   `-- image_interpreter.py</a:t>
             </a:r>
           </a:p>
         </p:txBody>
@@ -47039,7 +46976,7 @@
                 </a:solidFill>
                 <a:latin typeface="Aptos Display"/>
               </a:rPr>
-              <a:t>Tracked File Tree Appendix 13/27</a:t>
+              <a:t>Tracked File Tree Appendix 13/28</a:t>
             </a:r>
           </a:p>
         </p:txBody>
@@ -47074,7 +47011,8 @@
                 </a:solidFill>
                 <a:latin typeface="Cascadia Mono"/>
               </a:rPr>
-              <a:t>    |   |   |   |-- config.yaml
+              <a:t>    |   |   |-- j_decompiler/
+    |   |   |   |-- config.yaml
     |   |   |   `-- j_decompiler.py
     |   |   |-- jenkinser/
     |   |   |   |-- config.yaml
@@ -47103,8 +47041,7 @@
     |   |   |-- monitor_log/
     |   |   |   |-- config.yaml
     |   |   |   `-- monitor_log.py
-    |   |   |-- monitor_netstat/
-    |   |   |   |-- config.yaml</a:t>
+    |   |   |-- monitor_netstat/</a:t>
             </a:r>
           </a:p>
         </p:txBody>
@@ -47407,7 +47344,7 @@
                 </a:solidFill>
                 <a:latin typeface="Aptos Display"/>
               </a:rPr>
-              <a:t>Tracked File Tree Appendix 14/27</a:t>
+              <a:t>Tracked File Tree Appendix 14/28</a:t>
             </a:r>
           </a:p>
         </p:txBody>
@@ -47442,7 +47379,8 @@
                 </a:solidFill>
                 <a:latin typeface="Cascadia Mono"/>
               </a:rPr>
-              <a:t>    |   |   |   `-- monitor_netstat.py
+              <a:t>    |   |   |   |-- config.yaml
+    |   |   |   `-- monitor_netstat.py
     |   |   |-- mouser/
     |   |   |   |-- config.yaml
     |   |   |   `-- mouser.py
@@ -47471,8 +47409,7 @@
     |   |   |   |-- config.yaml
     |   |   |   `-- prompter.py
     |   |   |-- pser/
-    |   |   |   |-- config.yaml
-    |   |   |   `-- pser.py</a:t>
+    |   |   |   |-- config.yaml</a:t>
             </a:r>
           </a:p>
         </p:txBody>
@@ -47775,7 +47712,7 @@
                 </a:solidFill>
                 <a:latin typeface="Aptos Display"/>
               </a:rPr>
-              <a:t>Tracked File Tree Appendix 15/27</a:t>
+              <a:t>Tracked File Tree Appendix 15/28</a:t>
             </a:r>
           </a:p>
         </p:txBody>
@@ -47810,7 +47747,8 @@
                 </a:solidFill>
                 <a:latin typeface="Cascadia Mono"/>
               </a:rPr>
-              <a:t>    |   |   |-- pythonxer/
+              <a:t>    |   |   |   `-- pser.py
+    |   |   |-- pythonxer/
     |   |   |   |-- config.yaml
     |   |   |   `-- pythonxer.py
     |   |   |-- raiser/
@@ -47839,8 +47777,7 @@
     |   |   |   `-- sqler.py
     |   |   |-- ssher/
     |   |   |   |-- config.yaml
-    |   |   |   `-- ssher.py
-    |   |   |-- starter/</a:t>
+    |   |   |   `-- ssher.py</a:t>
             </a:r>
           </a:p>
         </p:txBody>
@@ -48143,7 +48080,7 @@
                 </a:solidFill>
                 <a:latin typeface="Aptos Display"/>
               </a:rPr>
-              <a:t>Tracked File Tree Appendix 16/27</a:t>
+              <a:t>Tracked File Tree Appendix 16/28</a:t>
             </a:r>
           </a:p>
         </p:txBody>
@@ -48178,7 +48115,8 @@
                 </a:solidFill>
                 <a:latin typeface="Cascadia Mono"/>
               </a:rPr>
-              <a:t>    |   |   |   |-- config.yaml
+              <a:t>    |   |   |-- starter/
+    |   |   |   |-- config.yaml
     |   |   |   `-- starter.py
     |   |   |-- stm32er/
     |   |   |   |-- config.yaml
@@ -48207,8 +48145,7 @@
     |   |   |-- videoplayer/
     |   |   |   |-- config.yaml
     |   |   |   `-- videoplayer.py
-    |   |   |-- whatsapper/
-    |   |   |   |-- config.yaml</a:t>
+    |   |   |-- whatsapper/</a:t>
             </a:r>
           </a:p>
         </p:txBody>
@@ -48511,7 +48448,7 @@
                 </a:solidFill>
                 <a:latin typeface="Aptos Display"/>
               </a:rPr>
-              <a:t>Tracked File Tree Appendix 17/27</a:t>
+              <a:t>Tracked File Tree Appendix 17/28</a:t>
             </a:r>
           </a:p>
         </p:txBody>
@@ -48546,7 +48483,8 @@
                 </a:solidFill>
                 <a:latin typeface="Cascadia Mono"/>
               </a:rPr>
-              <a:t>    |   |   |   `-- whatsapper.py
+              <a:t>    |   |   |   |-- config.yaml
+    |   |   |   `-- whatsapper.py
     |   |   |-- whatstlamatini/
     |   |   |   |-- config.yaml
     |   |   |   `-- whatstlamatini.py
@@ -48575,8 +48513,7 @@
     |   |-- imaging/
     |   |   |-- converter.py
     |   |   |-- image_interpreter.py
-    |   |   `-- screenshot.py
-    |   |-- management/</a:t>
+    |   |   `-- screenshot.py</a:t>
             </a:r>
           </a:p>
         </p:txBody>
@@ -48879,7 +48816,7 @@
                 </a:solidFill>
                 <a:latin typeface="Aptos Display"/>
               </a:rPr>
-              <a:t>Tracked File Tree Appendix 18/27</a:t>
+              <a:t>Tracked File Tree Appendix 18/28</a:t>
             </a:r>
           </a:p>
         </p:txBody>
@@ -48914,7 +48851,8 @@
                 </a:solidFill>
                 <a:latin typeface="Cascadia Mono"/>
               </a:rPr>
-              <a:t>    |   |   |-- __init__.py
+              <a:t>    |   |-- management/
+    |   |   |-- __init__.py
     |   |   `-- commands/
     |   |       |-- acpx_lint.py
     |   |       `-- startserver.py
@@ -48943,8 +48881,7 @@
     |   |   |-- 0022_repopulate_all_agents.py
     |   |   |-- 0023_add_mongoxer.py
     |   |   |-- 0024_repopulate_all_agents.py
-    |   |   |-- 0025_add_telegramer.py
-    |   |   |-- 0026_repopulate_all_agents.py</a:t>
+    |   |   |-- 0025_add_telegramer.py</a:t>
             </a:r>
           </a:p>
         </p:txBody>
@@ -49247,7 +49184,7 @@
                 </a:solidFill>
                 <a:latin typeface="Aptos Display"/>
               </a:rPr>
-              <a:t>Tracked File Tree Appendix 19/27</a:t>
+              <a:t>Tracked File Tree Appendix 19/28</a:t>
             </a:r>
           </a:p>
         </p:txBody>
@@ -49282,7 +49219,8 @@
                 </a:solidFill>
                 <a:latin typeface="Cascadia Mono"/>
               </a:rPr>
-              <a:t>    |   |   |-- 0027_add_sqler.py
+              <a:t>    |   |   |-- 0026_repopulate_all_agents.py
+    |   |   |-- 0027_add_sqler.py
     |   |   |-- 0028_repopulate_all_agents.py
     |   |   |-- 0029_add_prompter.py
     |   |   |-- 0030_repopulate_all_agents.py
@@ -49311,8 +49249,7 @@
     |   |   |-- 0053_add_kyber_cipher.py
     |   |   |-- 0054_add_kyber_decipher.py
     |   |   |-- 0055_fix_kyber_cipher_names.py
-    |   |   |-- 0056_add_parametrizer.py
-    |   |   |-- 0057_add_flowbacker.py</a:t>
+    |   |   |-- 0056_add_parametrizer.py</a:t>
             </a:r>
           </a:p>
         </p:txBody>
@@ -49615,7 +49552,7 @@
                 </a:solidFill>
                 <a:latin typeface="Aptos Display"/>
               </a:rPr>
-              <a:t>Tracked File Tree Appendix 20/27</a:t>
+              <a:t>Tracked File Tree Appendix 20/28</a:t>
             </a:r>
           </a:p>
         </p:txBody>
@@ -49650,7 +49587,8 @@
                 </a:solidFill>
                 <a:latin typeface="Cascadia Mono"/>
               </a:rPr>
-              <a:t>    |   |   |-- 0058_add_barrier.py
+              <a:t>    |   |   |-- 0057_add_flowbacker.py
+    |   |   |-- 0058_add_barrier.py
     |   |   |-- 0059_add_j_decompiler.py
     |   |   |-- 0060_add_agent_parametrizer_tool.py
     |   |   |-- 0061_add_agent_starter_tool.py
@@ -49679,8 +49617,7 @@
     |   |   |-- 0084_add_chat_agent_de_compresser_tool.py
     |   |   |-- 0085_add_unrealer.py
     |   |   |-- 0086_add_chat_agent_unrealer_tool.py
-    |   |   |-- 0087_add_unrealer_demo_prompt.py
-    |   |   |-- 0088_add_reviewer.py</a:t>
+    |   |   |-- 0087_add_unrealer_demo_prompt.py</a:t>
             </a:r>
           </a:p>
         </p:txBody>
@@ -49983,7 +49920,7 @@
                 </a:solidFill>
                 <a:latin typeface="Aptos Display"/>
               </a:rPr>
-              <a:t>Tracked File Tree Appendix 21/27</a:t>
+              <a:t>Tracked File Tree Appendix 21/28</a:t>
             </a:r>
           </a:p>
         </p:txBody>
@@ -50018,7 +49955,8 @@
                 </a:solidFill>
                 <a:latin typeface="Cascadia Mono"/>
               </a:rPr>
-              <a:t>    |   |   |-- 0089_add_analyzer.py
+              <a:t>    |   |   |-- 0088_add_reviewer.py
+    |   |   |-- 0089_add_analyzer.py
     |   |   |-- 0090_add_reviewer_analyzer_demo_prompts.py
     |   |   |-- 0091_add_playwrighter.py
     |   |   |-- 0092_add_chat_agent_playwrighter_tool.py
@@ -50047,8 +49985,7 @@
     |   |   |-- 0115_add_chat_agent_recorder_tool.py
     |   |   |-- 0116_add_audioplayer.py
     |   |   |-- 0117_add_chat_agent_audioplayer_tool.py
-    |   |   |-- 0118_add_videoplayer.py
-    |   |   |-- 0119_add_chat_agent_videoplayer_tool.py</a:t>
+    |   |   |-- 0118_add_videoplayer.py</a:t>
             </a:r>
           </a:p>
         </p:txBody>
@@ -50351,7 +50288,7 @@
                 </a:solidFill>
                 <a:latin typeface="Aptos Display"/>
               </a:rPr>
-              <a:t>Tracked File Tree Appendix 22/27</a:t>
+              <a:t>Tracked File Tree Appendix 22/28</a:t>
             </a:r>
           </a:p>
         </p:txBody>
@@ -50386,7 +50323,8 @@
                 </a:solidFill>
                 <a:latin typeface="Cascadia Mono"/>
               </a:rPr>
-              <a:t>    |   |   |-- 0120_add_talker.py
+              <a:t>    |   |   |-- 0119_add_chat_agent_videoplayer_tool.py
+    |   |   |-- 0120_add_talker.py
     |   |   |-- 0121_add_chat_agent_talker_tool.py
     |   |   |-- 0122_add_talker_demo_prompt.py
     |   |   |-- 0123_add_whisperer.py
@@ -50415,8 +50353,7 @@
     |   |       |-- basic.py
     |   |       |-- history_aware.py
     |   |       `-- unified.py
-    |   |-- services/
-    |   |   |-- __init__.py</a:t>
+    |   |-- services/</a:t>
             </a:r>
           </a:p>
         </p:txBody>
@@ -51490,7 +51427,7 @@
                 </a:solidFill>
                 <a:latin typeface="Aptos Display"/>
               </a:rPr>
-              <a:t>Tracked File Tree Appendix 23/27</a:t>
+              <a:t>Tracked File Tree Appendix 23/28</a:t>
             </a:r>
           </a:p>
         </p:txBody>
@@ -51525,7 +51462,8 @@
                 </a:solidFill>
                 <a:latin typeface="Cascadia Mono"/>
               </a:rPr>
-              <a:t>    |   |   |-- agent_contracts.py
+              <a:t>    |   |   |-- __init__.py
+    |   |   |-- agent_contracts.py
     |   |   |-- agent_paths.py
     |   |   |-- answer_analizer.py
     |   |   |-- filesystem.py
@@ -51554,8 +51492,7 @@
     |   |   |   |-- SKILL.md
     |   |   |   |-- references/
     |   |   |   |   `-- flw_schema.md
-    |   |   |   `-- scripts/
-    |   |   |       |-- make_flow.py</a:t>
+    |   |   |   `-- scripts/</a:t>
             </a:r>
           </a:p>
         </p:txBody>
@@ -51858,7 +51795,7 @@
                 </a:solidFill>
                 <a:latin typeface="Aptos Display"/>
               </a:rPr>
-              <a:t>Tracked File Tree Appendix 24/27</a:t>
+              <a:t>Tracked File Tree Appendix 24/28</a:t>
             </a:r>
           </a:p>
         </p:txBody>
@@ -51893,7 +51830,8 @@
                 </a:solidFill>
                 <a:latin typeface="Cascadia Mono"/>
               </a:rPr>
-              <a:t>    |   |   |       `-- result_to_flw.py
+              <a:t>    |   |   |       |-- make_flow.py
+    |   |   |       `-- result_to_flw.py
     |   |   |-- github/
     |   |   |   `-- SKILL.md
     |   |   |-- gmail/
@@ -51922,8 +51860,7 @@
     |   |   |   `-- SKILL.md
     |   |   |-- tlamatini_csrf_exempt_audit/
     |   |   |   `-- SKILL.md
-    |   |   |-- tlamatini_exec_report_row_adder/
-    |   |   |   `-- SKILL.md</a:t>
+    |   |   |-- tlamatini_exec_report_row_adder/</a:t>
             </a:r>
           </a:p>
         </p:txBody>
@@ -52226,7 +52163,7 @@
                 </a:solidFill>
                 <a:latin typeface="Aptos Display"/>
               </a:rPr>
-              <a:t>Tracked File Tree Appendix 25/27</a:t>
+              <a:t>Tracked File Tree Appendix 25/28</a:t>
             </a:r>
           </a:p>
         </p:txBody>
@@ -52261,7 +52198,8 @@
                 </a:solidFill>
                 <a:latin typeface="Cascadia Mono"/>
               </a:rPr>
-              <a:t>    |   |   |-- tlamatini_flow_from_objective/
+              <a:t>    |   |   |   `-- SKILL.md
+    |   |   |-- tlamatini_flow_from_objective/
     |   |   |   `-- SKILL.md
     |   |   |-- tlamatini_flw_doctor/
     |   |   |   `-- SKILL.md
@@ -52290,8 +52228,7 @@
     |   |       |   |-- spinner.svg
     |   |       |   `-- Tlamatini.ico
     |   |       |-- js/
-    |   |       |   |-- acp-agent-connectors.js
-    |   |       |   |-- acp-canvas-core.js</a:t>
+    |   |       |   |-- acp-agent-connectors.js</a:t>
             </a:r>
           </a:p>
         </p:txBody>
@@ -52594,7 +52531,7 @@
                 </a:solidFill>
                 <a:latin typeface="Aptos Display"/>
               </a:rPr>
-              <a:t>Tracked File Tree Appendix 26/27</a:t>
+              <a:t>Tracked File Tree Appendix 26/28</a:t>
             </a:r>
           </a:p>
         </p:txBody>
@@ -52629,7 +52566,8 @@
                 </a:solidFill>
                 <a:latin typeface="Cascadia Mono"/>
               </a:rPr>
-              <a:t>    |   |       |   |-- acp-canvas-undo.js
+              <a:t>    |   |       |   |-- acp-canvas-core.js
+    |   |       |   |-- acp-canvas-undo.js
     |   |       |   |-- acp-control-buttons.js
     |   |       |   |-- acp-file-io.js
     |   |       |   |-- acp-flow-snapshot.js
@@ -52658,8 +52596,7 @@
     |   |       |-- sounds/
     |   |       |   |-- hypervisor_alert.wav
     |   |       |   `-- notification.wav
-    |   |       `-- video/
-    |   |           `-- XAIHT-Tlamatini.mp4</a:t>
+    |   |       `-- video/</a:t>
             </a:r>
           </a:p>
         </p:txBody>
@@ -52962,7 +52899,7 @@
                 </a:solidFill>
                 <a:latin typeface="Aptos Display"/>
               </a:rPr>
-              <a:t>Tracked File Tree Appendix 27/27</a:t>
+              <a:t>Tracked File Tree Appendix 27/28</a:t>
             </a:r>
           </a:p>
         </p:txBody>
@@ -52997,7 +52934,8 @@
                 </a:solidFill>
                 <a:latin typeface="Cascadia Mono"/>
               </a:rPr>
-              <a:t>    |   |-- telegram/
+              <a:t>    |   |           `-- XAIHT-Tlamatini.mp4
+    |   |-- telegram/
     |   |   |-- AztecTlamatini.txt
     |   |   |-- config.yaml
     |   |   `-- telegram_receiver.py
@@ -53026,8 +52964,7 @@
         |-- logging_filters.py
         |-- middleware.py
         |-- settings.py
-        |-- urls.py
-        `-- wsgi.py</a:t>
+        |-- urls.py</a:t>
             </a:r>
           </a:p>
         </p:txBody>
@@ -53041,6 +52978,344 @@
 </file>
 
 <file path=ppt/slides/slide85.xml><?xml version="1.0" encoding="utf-8"?>
+<p:sld xmlns:a="http://schemas.openxmlformats.org/drawingml/2006/main" xmlns:p="http://schemas.openxmlformats.org/presentationml/2006/main" xmlns:r="http://schemas.openxmlformats.org/officeDocument/2006/relationships">
+  <p:cSld>
+    <p:spTree>
+      <p:nvGrpSpPr>
+        <p:cNvPr id="1" name=""/>
+        <p:cNvGrpSpPr/>
+        <p:nvPr/>
+      </p:nvGrpSpPr>
+      <p:grpSpPr/>
+      <p:sp>
+        <p:nvSpPr>
+          <p:cNvPr id="2" name="Rectangle 1"/>
+          <p:cNvSpPr/>
+          <p:nvPr/>
+        </p:nvSpPr>
+        <p:spPr>
+          <a:xfrm>
+            <a:off x="0" y="0"/>
+            <a:ext cx="12191695" cy="6858000"/>
+          </a:xfrm>
+          <a:prstGeom prst="rect">
+            <a:avLst/>
+          </a:prstGeom>
+          <a:solidFill>
+            <a:srgbClr val="080D0D"/>
+          </a:solidFill>
+          <a:ln>
+            <a:noFill/>
+          </a:ln>
+        </p:spPr>
+        <p:style>
+          <a:lnRef idx="1">
+            <a:schemeClr val="accent1"/>
+          </a:lnRef>
+          <a:fillRef idx="3">
+            <a:schemeClr val="accent1"/>
+          </a:fillRef>
+          <a:effectRef idx="2">
+            <a:schemeClr val="accent1"/>
+          </a:effectRef>
+          <a:fontRef idx="minor">
+            <a:schemeClr val="lt1"/>
+          </a:fontRef>
+        </p:style>
+        <p:txBody>
+          <a:bodyPr rtlCol="0" anchor="ctr"/>
+          <a:lstStyle/>
+          <a:p>
+            <a:pPr algn="ctr"/>
+          </a:p>
+        </p:txBody>
+      </p:sp>
+      <p:sp>
+        <p:nvSpPr>
+          <p:cNvPr id="3" name="Rectangle 2"/>
+          <p:cNvSpPr/>
+          <p:nvPr/>
+        </p:nvSpPr>
+        <p:spPr>
+          <a:xfrm>
+            <a:off x="320040" y="384048"/>
+            <a:ext cx="36576" cy="6080760"/>
+          </a:xfrm>
+          <a:prstGeom prst="rect">
+            <a:avLst/>
+          </a:prstGeom>
+          <a:solidFill>
+            <a:srgbClr val="C48052"/>
+          </a:solidFill>
+          <a:ln>
+            <a:noFill/>
+          </a:ln>
+        </p:spPr>
+        <p:style>
+          <a:lnRef idx="1">
+            <a:schemeClr val="accent1"/>
+          </a:lnRef>
+          <a:fillRef idx="3">
+            <a:schemeClr val="accent1"/>
+          </a:fillRef>
+          <a:effectRef idx="2">
+            <a:schemeClr val="accent1"/>
+          </a:effectRef>
+          <a:fontRef idx="minor">
+            <a:schemeClr val="lt1"/>
+          </a:fontRef>
+        </p:style>
+        <p:txBody>
+          <a:bodyPr rtlCol="0" anchor="ctr"/>
+          <a:lstStyle/>
+          <a:p>
+            <a:pPr algn="ctr"/>
+          </a:p>
+        </p:txBody>
+      </p:sp>
+      <p:sp>
+        <p:nvSpPr>
+          <p:cNvPr id="4" name="Rectangle 3"/>
+          <p:cNvSpPr/>
+          <p:nvPr/>
+        </p:nvSpPr>
+        <p:spPr>
+          <a:xfrm>
+            <a:off x="11716207" y="384048"/>
+            <a:ext cx="36576" cy="6080760"/>
+          </a:xfrm>
+          <a:prstGeom prst="rect">
+            <a:avLst/>
+          </a:prstGeom>
+          <a:solidFill>
+            <a:srgbClr val="C48052"/>
+          </a:solidFill>
+          <a:ln>
+            <a:noFill/>
+          </a:ln>
+        </p:spPr>
+        <p:style>
+          <a:lnRef idx="1">
+            <a:schemeClr val="accent1"/>
+          </a:lnRef>
+          <a:fillRef idx="3">
+            <a:schemeClr val="accent1"/>
+          </a:fillRef>
+          <a:effectRef idx="2">
+            <a:schemeClr val="accent1"/>
+          </a:effectRef>
+          <a:fontRef idx="minor">
+            <a:schemeClr val="lt1"/>
+          </a:fontRef>
+        </p:style>
+        <p:txBody>
+          <a:bodyPr rtlCol="0" anchor="ctr"/>
+          <a:lstStyle/>
+          <a:p>
+            <a:pPr algn="ctr"/>
+          </a:p>
+        </p:txBody>
+      </p:sp>
+      <p:sp>
+        <p:nvSpPr>
+          <p:cNvPr id="5" name="Rectangle 4"/>
+          <p:cNvSpPr/>
+          <p:nvPr/>
+        </p:nvSpPr>
+        <p:spPr>
+          <a:xfrm>
+            <a:off x="502920" y="384048"/>
+            <a:ext cx="11155680" cy="27432"/>
+          </a:xfrm>
+          <a:prstGeom prst="rect">
+            <a:avLst/>
+          </a:prstGeom>
+          <a:solidFill>
+            <a:srgbClr val="C48052"/>
+          </a:solidFill>
+          <a:ln>
+            <a:noFill/>
+          </a:ln>
+        </p:spPr>
+        <p:style>
+          <a:lnRef idx="1">
+            <a:schemeClr val="accent1"/>
+          </a:lnRef>
+          <a:fillRef idx="3">
+            <a:schemeClr val="accent1"/>
+          </a:fillRef>
+          <a:effectRef idx="2">
+            <a:schemeClr val="accent1"/>
+          </a:effectRef>
+          <a:fontRef idx="minor">
+            <a:schemeClr val="lt1"/>
+          </a:fontRef>
+        </p:style>
+        <p:txBody>
+          <a:bodyPr rtlCol="0" anchor="ctr"/>
+          <a:lstStyle/>
+          <a:p>
+            <a:pPr algn="ctr"/>
+          </a:p>
+        </p:txBody>
+      </p:sp>
+      <p:sp>
+        <p:nvSpPr>
+          <p:cNvPr id="6" name="Rectangle 5"/>
+          <p:cNvSpPr/>
+          <p:nvPr/>
+        </p:nvSpPr>
+        <p:spPr>
+          <a:xfrm>
+            <a:off x="502920" y="6437376"/>
+            <a:ext cx="11155680" cy="27432"/>
+          </a:xfrm>
+          <a:prstGeom prst="rect">
+            <a:avLst/>
+          </a:prstGeom>
+          <a:solidFill>
+            <a:srgbClr val="C48052"/>
+          </a:solidFill>
+          <a:ln>
+            <a:noFill/>
+          </a:ln>
+        </p:spPr>
+        <p:style>
+          <a:lnRef idx="1">
+            <a:schemeClr val="accent1"/>
+          </a:lnRef>
+          <a:fillRef idx="3">
+            <a:schemeClr val="accent1"/>
+          </a:fillRef>
+          <a:effectRef idx="2">
+            <a:schemeClr val="accent1"/>
+          </a:effectRef>
+          <a:fontRef idx="minor">
+            <a:schemeClr val="lt1"/>
+          </a:fontRef>
+        </p:style>
+        <p:txBody>
+          <a:bodyPr rtlCol="0" anchor="ctr"/>
+          <a:lstStyle/>
+          <a:p>
+            <a:pPr algn="ctr"/>
+          </a:p>
+        </p:txBody>
+      </p:sp>
+      <p:sp>
+        <p:nvSpPr>
+          <p:cNvPr id="7" name="TextBox 6"/>
+          <p:cNvSpPr txBox="1"/>
+          <p:nvPr/>
+        </p:nvSpPr>
+        <p:spPr>
+          <a:xfrm>
+            <a:off x="713232" y="548640"/>
+            <a:ext cx="10698480" cy="301752"/>
+          </a:xfrm>
+          <a:prstGeom prst="rect">
+            <a:avLst/>
+          </a:prstGeom>
+          <a:noFill/>
+        </p:spPr>
+        <p:txBody>
+          <a:bodyPr wrap="square" anchor="t">
+            <a:spAutoFit/>
+          </a:bodyPr>
+          <a:lstStyle/>
+          <a:p>
+            <a:pPr algn="l"/>
+            <a:r>
+              <a:rPr sz="1000" b="1">
+                <a:solidFill>
+                  <a:srgbClr val="C48052"/>
+                </a:solidFill>
+                <a:latin typeface="Aptos"/>
+              </a:rPr>
+              <a:t>COMPLETE TRACKED FILE TREE, NO TRACKED FILE OMITTED</a:t>
+            </a:r>
+          </a:p>
+        </p:txBody>
+      </p:sp>
+      <p:sp>
+        <p:nvSpPr>
+          <p:cNvPr id="8" name="TextBox 7"/>
+          <p:cNvSpPr txBox="1"/>
+          <p:nvPr/>
+        </p:nvSpPr>
+        <p:spPr>
+          <a:xfrm>
+            <a:off x="694944" y="850392"/>
+            <a:ext cx="10881360" cy="566928"/>
+          </a:xfrm>
+          <a:prstGeom prst="rect">
+            <a:avLst/>
+          </a:prstGeom>
+          <a:noFill/>
+        </p:spPr>
+        <p:txBody>
+          <a:bodyPr wrap="square" anchor="t">
+            <a:spAutoFit/>
+          </a:bodyPr>
+          <a:lstStyle/>
+          <a:p>
+            <a:pPr algn="l"/>
+            <a:r>
+              <a:rPr sz="2700" b="0">
+                <a:solidFill>
+                  <a:srgbClr val="E8E8DE"/>
+                </a:solidFill>
+                <a:latin typeface="Aptos Display"/>
+              </a:rPr>
+              <a:t>Tracked File Tree Appendix 28/28</a:t>
+            </a:r>
+          </a:p>
+        </p:txBody>
+      </p:sp>
+      <p:sp>
+        <p:nvSpPr>
+          <p:cNvPr id="9" name="TextBox 8"/>
+          <p:cNvSpPr txBox="1"/>
+          <p:nvPr/>
+        </p:nvSpPr>
+        <p:spPr>
+          <a:xfrm>
+            <a:off x="658368" y="1426464"/>
+            <a:ext cx="10927080" cy="4956048"/>
+          </a:xfrm>
+          <a:prstGeom prst="rect">
+            <a:avLst/>
+          </a:prstGeom>
+          <a:noFill/>
+        </p:spPr>
+        <p:txBody>
+          <a:bodyPr wrap="square" anchor="t">
+            <a:spAutoFit/>
+          </a:bodyPr>
+          <a:lstStyle/>
+          <a:p>
+            <a:pPr algn="l"/>
+            <a:r>
+              <a:rPr sz="700" b="0">
+                <a:solidFill>
+                  <a:srgbClr val="E8E8DE"/>
+                </a:solidFill>
+                <a:latin typeface="Cascadia Mono"/>
+              </a:rPr>
+              <a:t>        `-- wsgi.py</a:t>
+            </a:r>
+          </a:p>
+        </p:txBody>
+      </p:sp>
+    </p:spTree>
+  </p:cSld>
+  <p:clrMapOvr>
+    <a:masterClrMapping/>
+  </p:clrMapOvr>
+</p:sld>
+</file>
+
+<file path=ppt/slides/slide86.xml><?xml version="1.0" encoding="utf-8"?>
 <p:sld xmlns:a="http://schemas.openxmlformats.org/drawingml/2006/main" xmlns:p="http://schemas.openxmlformats.org/presentationml/2006/main" xmlns:r="http://schemas.openxmlformats.org/officeDocument/2006/relationships">
   <p:cSld>
     <p:spTree>

</xml_diff>